<commit_message>
Move Avatar-ID flow to slide 2, add technology logos and light/dark background schematic
Co-Authored-By: Claude Opus 5.5 <noreply@anthropic.com>
Claude-Session: https://claude.ai/code/session_01AnZDiX8uz3hSw1L6vhKaQS
</commit_message>
<xml_diff>
--- a/Soutenance_Stage_ENSI_Final.pptx
+++ b/Soutenance_Stage_ENSI_Final.pptx
@@ -532,13 +532,13 @@
           </a:p>
           <a:p>
             <a:r>
-              <a:t>Madame, Monsieur les membres du jury, bonjour. Je vais vous présenter le travail de mon stage d'été de six semaines chez Codingaholic, à La Marsa, encadré par M. Jendoubi : un module mobile qui détecte et capture automatiquement le recto puis le verso de la carte d'identité nationale tunisienne, pour l'application Avatar-ID. Je vais suivre le fil problème, conception, résultats, puis bilan, en une quinzaine de minutes.</a:t>
+              <a:t>Madame, Monsieur les membres du jury, bonjour. Je vais vous présenter le travail de mon stage d'été de six semaines chez Codingaholic, à La Marsa, encadré par M. Jendoubi : un module mobile qui détecte et capture automatiquement le recto puis le verso de la carte d'identité nationale tunisienne, pour l'application Avatar-ID. Je vais suivre le fil contexte, conception, résultats, puis bilan, en une quinzaine de minutes.</a:t>
             </a:r>
           </a:p>
           <a:p/>
           <a:p>
             <a:r>
-              <a:t>TRANSITION — « Partons du problème qu'il fallait résoudre. »</a:t>
+              <a:t>TRANSITION — « Commençons par situer le module dans Avatar-ID. »</a:t>
             </a:r>
           </a:p>
           <a:p/>
@@ -549,7 +549,7 @@
           </a:p>
           <a:p>
             <a:r>
-              <a:t>– « Quel était votre périmètre exact ? » → la capture : détection, contrôle de qualité, recto/verso, recadrage, amélioration. La vivacité, la comparaison des photos, l'OCR et l'enregistrement sont les étapes suivantes d'Avatar-ID (diapositive 3).</a:t>
+              <a:t>– « Quel était votre périmètre exact ? » → la capture : détection, contrôle de qualité, recto/verso, recadrage, amélioration. La vivacité, la comparaison des photos, l'OCR et l'enregistrement sont les étapes suivantes d'Avatar-ID (diapositive 2).</a:t>
             </a:r>
           </a:p>
         </p:txBody>
@@ -1533,7 +1533,7 @@
           <a:lstStyle/>
           <a:p>
             <a:r>
-              <a:t>⏱ 0:45 (cumul 1:15)</a:t>
+              <a:t>⏱ 0:40 (cumul 1:55)</a:t>
             </a:r>
           </a:p>
           <a:p/>
@@ -1544,24 +1544,29 @@
           </a:p>
           <a:p>
             <a:r>
-              <a:t>Avatar-ID est une application de vérification d'identité à distance, dans l'esprit du KYC des banques. L'utilisateur doit y fournir sa carte d'identité. Si on lui demande simplement une photo, on obtient trop souvent une image floue, une carte de travers, ou deux fois le recto à la place du verso. Chaque défaut coûte un contrôle humain ou une nouvelle saisie. La question que j'ai traitée est donc : comment détecter de manière fiable et en temps réel les contours de la carte dans le flux caméra, quel que soit l'éclairage ou l'arrière-plan, pour ne capturer que des images exploitables, une seule fois par face.</a:t>
+              <a:t>Avatar-ID est une application de vérification d'identité à distance, dans l'esprit du KYC des banques. Elle enchaîne plusieurs étapes. Mon module est la première : il capture le recto puis le verso de la carte. Ensuite, Avatar-ID réalise un test de vivacité, compare la photo de la carte avec le visage de l'utilisateur, lit les champs de la carte par OCR, puis enregistre le résultat. Mon module transmet donc le recto et le verso redressés et orientés. C'est pour cela que la qualité de capture est si importante : une image floue ou de travers dégrade directement la comparaison des visages et la lecture OCR.</a:t>
             </a:r>
           </a:p>
           <a:p/>
           <a:p>
             <a:r>
-              <a:t>TRANSITION — « Ce module s'inscrit dans un parcours plus large. »</a:t>
+              <a:t>TRANSITION — « Or, sans guidage, cette première étape échoue souvent. »</a:t>
             </a:r>
           </a:p>
           <a:p/>
           <a:p>
             <a:r>
-              <a:t>QUESTION PROBABLE</a:t>
-            </a:r>
-          </a:p>
-          <a:p>
-            <a:r>
-              <a:t>– « Pourquoi ne pas utiliser une plateforme KYC existante (Onfido, Jumio…) ? » → données d'identité envoyées à un tiers, coût de licence, dépendance réseau au moment de la capture, peu de personnalisation pour la CIN tunisienne (rapport, tableau 1.1). Avatar-ID a choisi un module interne, sur l'appareil.</a:t>
+              <a:t>QUESTIONS PROBABLES (préparation, ne pas lire)</a:t>
+            </a:r>
+          </a:p>
+          <a:p>
+            <a:r>
+              <a:t>– « Avez-vous développé la vivacité ou l'OCR ? » → non, ce sont les étapes suivantes d'Avatar-ID ; mon périmètre est la capture.</a:t>
+            </a:r>
+          </a:p>
+          <a:p>
+            <a:r>
+              <a:t>– « Sous quelle forme passez-vous les images ? » → deux images (Uint8List) et, le cas échéant, la page d'impression (rapport §8.2.5).</a:t>
             </a:r>
           </a:p>
         </p:txBody>
@@ -1706,7 +1711,7 @@
           <a:lstStyle/>
           <a:p>
             <a:r>
-              <a:t>⏱ 0:40 (cumul 1:55)</a:t>
+              <a:t>⏱ 0:45 (cumul 1:15)</a:t>
             </a:r>
           </a:p>
           <a:p/>
@@ -1717,29 +1722,24 @@
           </a:p>
           <a:p>
             <a:r>
-              <a:t>Pour situer mon travail : Avatar-ID enchaîne plusieurs étapes. Mon module est la première : il capture le recto puis le verso de la carte. Ensuite, Avatar-ID réalise un test de vivacité, compare la photo de la carte avec le visage de l'utilisateur, lit les champs de la carte par OCR, puis enregistre le résultat. Mon module transmet donc le recto et le verso redressés et orientés. C'est pour cela que la qualité de capture est si importante : une image floue ou de travers dégrade directement la comparaison des visages et la lecture OCR.</a:t>
+              <a:t>À la première étape, l'utilisateur doit fournir sa carte d'identité. Si on lui demande simplement une photo, on obtient trop souvent une image floue, une carte de travers, ou deux fois le recto à la place du verso. Chaque défaut coûte un contrôle humain, une nouvelle saisie, et dégrade la comparaison des photos et l'OCR qui suivent. La question que j'ai traitée est donc : comment détecter de manière fiable et en temps réel les contours de la carte dans le flux caméra, quel que soit l'éclairage ou l'arrière-plan, pour ne capturer que des images exploitables, une seule fois par face.</a:t>
             </a:r>
           </a:p>
           <a:p/>
           <a:p>
             <a:r>
-              <a:t>TRANSITION — « Voici ce que le module devait faire concrètement. »</a:t>
+              <a:t>TRANSITION — « Concrètement, voici ce que le module devait faire. »</a:t>
             </a:r>
           </a:p>
           <a:p/>
           <a:p>
             <a:r>
-              <a:t>QUESTIONS PROBABLES (préparation, ne pas lire)</a:t>
-            </a:r>
-          </a:p>
-          <a:p>
-            <a:r>
-              <a:t>– « Avez-vous développé la vivacité ou l'OCR ? » → non, ce sont les étapes suivantes d'Avatar-ID ; mon périmètre est la capture.</a:t>
-            </a:r>
-          </a:p>
-          <a:p>
-            <a:r>
-              <a:t>– « Sous quelle forme passez-vous les images ? » → deux images (Uint8List) et, le cas échéant, la page d'impression (rapport §8.2.5).</a:t>
+              <a:t>QUESTION PROBABLE</a:t>
+            </a:r>
+          </a:p>
+          <a:p>
+            <a:r>
+              <a:t>– « Pourquoi ne pas utiliser une plateforme KYC existante (Onfido, Jumio…) ? » → données d'identité envoyées à un tiers, coût de licence, dépendance réseau au moment de la capture, peu de personnalisation pour la CIN tunisienne (rapport, tableau 1.1). Avatar-ID a choisi un module interne, sur l'appareil.</a:t>
             </a:r>
           </a:p>
         </p:txBody>
@@ -14770,7 +14770,7 @@
                 </a:solidFill>
                 <a:latin typeface="Arial"/>
               </a:rPr>
-              <a:t>Une photo libre de CIN peut être floue, de travers ou envoyée deux fois</a:t>
+              <a:t>Mon module est la première étape du parcours Avatar-ID : sa qualité conditionne la suite</a:t>
             </a:r>
           </a:p>
         </p:txBody>
@@ -14783,8 +14783,216 @@
         </p:nvSpPr>
         <p:spPr>
           <a:xfrm>
-            <a:off x="548640" y="1874519"/>
-            <a:ext cx="3520440" cy="2057400"/>
+            <a:off x="548640" y="2331720"/>
+            <a:ext cx="2651760" cy="2103120"/>
+          </a:xfrm>
+          <a:prstGeom prst="rect">
+            <a:avLst/>
+          </a:prstGeom>
+          <a:solidFill>
+            <a:srgbClr val="FFFFFF"/>
+          </a:solidFill>
+          <a:ln w="28575">
+            <a:solidFill>
+              <a:srgbClr val="2E75B6"/>
+            </a:solidFill>
+          </a:ln>
+        </p:spPr>
+        <p:txBody>
+          <a:bodyPr rtlCol="0" anchor="ctr"/>
+          <a:lstStyle/>
+          <a:p/>
+        </p:txBody>
+      </p:sp>
+      <p:sp>
+        <p:nvSpPr>
+          <p:cNvPr id="8" name="TextBox 7"/>
+          <p:cNvSpPr txBox="1"/>
+          <p:nvPr/>
+        </p:nvSpPr>
+        <p:spPr>
+          <a:xfrm>
+            <a:off x="685800" y="2441448"/>
+            <a:ext cx="2377440" cy="274320"/>
+          </a:xfrm>
+          <a:prstGeom prst="rect">
+            <a:avLst/>
+          </a:prstGeom>
+          <a:noFill/>
+        </p:spPr>
+        <p:txBody>
+          <a:bodyPr wrap="square" lIns="0" rIns="0" tIns="0" bIns="0" anchor="t">
+            <a:spAutoFit/>
+          </a:bodyPr>
+          <a:lstStyle/>
+          <a:p>
+            <a:pPr algn="l"/>
+            <a:r>
+              <a:rPr sz="1400" b="1" i="0">
+                <a:solidFill>
+                  <a:srgbClr val="2E75B6"/>
+                </a:solidFill>
+                <a:latin typeface="Arial"/>
+              </a:rPr>
+              <a:t>1</a:t>
+            </a:r>
+          </a:p>
+        </p:txBody>
+      </p:sp>
+      <p:sp>
+        <p:nvSpPr>
+          <p:cNvPr id="9" name="TextBox 8"/>
+          <p:cNvSpPr txBox="1"/>
+          <p:nvPr/>
+        </p:nvSpPr>
+        <p:spPr>
+          <a:xfrm>
+            <a:off x="685800" y="2715768"/>
+            <a:ext cx="2468879" cy="685800"/>
+          </a:xfrm>
+          <a:prstGeom prst="rect">
+            <a:avLst/>
+          </a:prstGeom>
+          <a:noFill/>
+        </p:spPr>
+        <p:txBody>
+          <a:bodyPr wrap="square" lIns="0" rIns="0" tIns="0" bIns="0" anchor="t">
+            <a:spAutoFit/>
+          </a:bodyPr>
+          <a:lstStyle/>
+          <a:p>
+            <a:pPr algn="l"/>
+            <a:r>
+              <a:rPr sz="1700" b="1" i="0">
+                <a:solidFill>
+                  <a:srgbClr val="1F3A5F"/>
+                </a:solidFill>
+                <a:latin typeface="Arial"/>
+              </a:rPr>
+              <a:t>Capture de la CIN</a:t>
+            </a:r>
+          </a:p>
+        </p:txBody>
+      </p:sp>
+      <p:sp>
+        <p:nvSpPr>
+          <p:cNvPr id="10" name="TextBox 9"/>
+          <p:cNvSpPr txBox="1"/>
+          <p:nvPr/>
+        </p:nvSpPr>
+        <p:spPr>
+          <a:xfrm>
+            <a:off x="685800" y="3108960"/>
+            <a:ext cx="2377440" cy="1188720"/>
+          </a:xfrm>
+          <a:prstGeom prst="rect">
+            <a:avLst/>
+          </a:prstGeom>
+          <a:noFill/>
+        </p:spPr>
+        <p:txBody>
+          <a:bodyPr wrap="square" lIns="0" rIns="0" tIns="0" bIns="0" anchor="t">
+            <a:spAutoFit/>
+          </a:bodyPr>
+          <a:lstStyle/>
+          <a:p>
+            <a:pPr algn="l">
+              <a:spcAft>
+                <a:spcPts val="200"/>
+              </a:spcAft>
+            </a:pPr>
+            <a:r>
+              <a:rPr sz="1600" b="0" i="0">
+                <a:solidFill>
+                  <a:srgbClr val="1B2530"/>
+                </a:solidFill>
+                <a:latin typeface="Arial"/>
+              </a:rPr>
+              <a:t>détection</a:t>
+            </a:r>
+          </a:p>
+          <a:p>
+            <a:pPr algn="l">
+              <a:spcAft>
+                <a:spcPts val="200"/>
+              </a:spcAft>
+            </a:pPr>
+            <a:r>
+              <a:rPr sz="1600" b="0" i="0">
+                <a:solidFill>
+                  <a:srgbClr val="1B2530"/>
+                </a:solidFill>
+                <a:latin typeface="Arial"/>
+              </a:rPr>
+              <a:t>qualité d'image</a:t>
+            </a:r>
+          </a:p>
+          <a:p>
+            <a:pPr algn="l">
+              <a:spcAft>
+                <a:spcPts val="200"/>
+              </a:spcAft>
+            </a:pPr>
+            <a:r>
+              <a:rPr sz="1600" b="0" i="0">
+                <a:solidFill>
+                  <a:srgbClr val="1B2530"/>
+                </a:solidFill>
+                <a:latin typeface="Arial"/>
+              </a:rPr>
+              <a:t>recto puis verso</a:t>
+            </a:r>
+          </a:p>
+          <a:p>
+            <a:pPr algn="l">
+              <a:spcAft>
+                <a:spcPts val="200"/>
+              </a:spcAft>
+            </a:pPr>
+            <a:r>
+              <a:rPr sz="1600" b="0" i="0">
+                <a:solidFill>
+                  <a:srgbClr val="1B2530"/>
+                </a:solidFill>
+                <a:latin typeface="Arial"/>
+              </a:rPr>
+              <a:t>recadrage, amélioration</a:t>
+            </a:r>
+          </a:p>
+        </p:txBody>
+      </p:sp>
+      <p:cxnSp>
+        <p:nvCxnSpPr>
+          <p:cNvPr id="11" name="Connector 10"/>
+          <p:cNvCxnSpPr/>
+          <p:nvPr/>
+        </p:nvCxnSpPr>
+        <p:spPr>
+          <a:xfrm>
+            <a:off x="3236976" y="3383279"/>
+            <a:ext cx="162991" cy="0"/>
+          </a:xfrm>
+          <a:prstGeom prst="line">
+            <a:avLst/>
+          </a:prstGeom>
+          <a:ln w="19050">
+            <a:solidFill>
+              <a:srgbClr val="1F3A5F"/>
+            </a:solidFill>
+            <a:tailEnd type="triangle" w="med" h="med"/>
+          </a:ln>
+        </p:spPr>
+      </p:cxnSp>
+      <p:sp>
+        <p:nvSpPr>
+          <p:cNvPr id="12" name="Rectangle 11"/>
+          <p:cNvSpPr/>
+          <p:nvPr/>
+        </p:nvSpPr>
+        <p:spPr>
+          <a:xfrm>
+            <a:off x="3436543" y="2331720"/>
+            <a:ext cx="1874519" cy="2103120"/>
           </a:xfrm>
           <a:prstGeom prst="rect">
             <a:avLst/>
@@ -14792,33 +15000,6 @@
           <a:solidFill>
             <a:srgbClr val="EEF2F6"/>
           </a:solidFill>
-          <a:ln>
-            <a:noFill/>
-          </a:ln>
-        </p:spPr>
-        <p:txBody>
-          <a:bodyPr rtlCol="0" anchor="ctr"/>
-          <a:lstStyle/>
-          <a:p/>
-        </p:txBody>
-      </p:sp>
-      <p:sp>
-        <p:nvSpPr>
-          <p:cNvPr id="8" name="Rounded Rectangle 7"/>
-          <p:cNvSpPr/>
-          <p:nvPr/>
-        </p:nvSpPr>
-        <p:spPr>
-          <a:xfrm>
-            <a:off x="1563623" y="2328062"/>
-            <a:ext cx="1783080" cy="1124840"/>
-          </a:xfrm>
-          <a:prstGeom prst="roundRect">
-            <a:avLst>
-              <a:gd name="adj" fmla="val 6000"/>
-            </a:avLst>
-          </a:prstGeom>
-          <a:noFill/>
           <a:ln w="12700">
             <a:solidFill>
               <a:srgbClr val="CBD3DB"/>
@@ -14833,21 +15014,152 @@
       </p:sp>
       <p:sp>
         <p:nvSpPr>
-          <p:cNvPr id="9" name="Rounded Rectangle 8"/>
+          <p:cNvPr id="13" name="TextBox 12"/>
+          <p:cNvSpPr txBox="1"/>
+          <p:nvPr/>
+        </p:nvSpPr>
+        <p:spPr>
+          <a:xfrm>
+            <a:off x="3573703" y="2441448"/>
+            <a:ext cx="1600199" cy="274320"/>
+          </a:xfrm>
+          <a:prstGeom prst="rect">
+            <a:avLst/>
+          </a:prstGeom>
+          <a:noFill/>
+        </p:spPr>
+        <p:txBody>
+          <a:bodyPr wrap="square" lIns="0" rIns="0" tIns="0" bIns="0" anchor="t">
+            <a:spAutoFit/>
+          </a:bodyPr>
+          <a:lstStyle/>
+          <a:p>
+            <a:pPr algn="l"/>
+            <a:r>
+              <a:rPr sz="1400" b="1" i="0">
+                <a:solidFill>
+                  <a:srgbClr val="2E75B6"/>
+                </a:solidFill>
+                <a:latin typeface="Arial"/>
+              </a:rPr>
+              <a:t>2</a:t>
+            </a:r>
+          </a:p>
+        </p:txBody>
+      </p:sp>
+      <p:sp>
+        <p:nvSpPr>
+          <p:cNvPr id="14" name="TextBox 13"/>
+          <p:cNvSpPr txBox="1"/>
+          <p:nvPr/>
+        </p:nvSpPr>
+        <p:spPr>
+          <a:xfrm>
+            <a:off x="3573703" y="2715768"/>
+            <a:ext cx="1691639" cy="685800"/>
+          </a:xfrm>
+          <a:prstGeom prst="rect">
+            <a:avLst/>
+          </a:prstGeom>
+          <a:noFill/>
+        </p:spPr>
+        <p:txBody>
+          <a:bodyPr wrap="square" lIns="0" rIns="0" tIns="0" bIns="0" anchor="t">
+            <a:spAutoFit/>
+          </a:bodyPr>
+          <a:lstStyle/>
+          <a:p>
+            <a:pPr algn="l"/>
+            <a:r>
+              <a:rPr sz="1600" b="1" i="0">
+                <a:solidFill>
+                  <a:srgbClr val="1F3A5F"/>
+                </a:solidFill>
+                <a:latin typeface="Arial"/>
+              </a:rPr>
+              <a:t>Test de vivacité</a:t>
+            </a:r>
+          </a:p>
+        </p:txBody>
+      </p:sp>
+      <p:sp>
+        <p:nvSpPr>
+          <p:cNvPr id="15" name="TextBox 14"/>
+          <p:cNvSpPr txBox="1"/>
+          <p:nvPr/>
+        </p:nvSpPr>
+        <p:spPr>
+          <a:xfrm>
+            <a:off x="3573703" y="3383279"/>
+            <a:ext cx="1600199" cy="1188720"/>
+          </a:xfrm>
+          <a:prstGeom prst="rect">
+            <a:avLst/>
+          </a:prstGeom>
+          <a:noFill/>
+        </p:spPr>
+        <p:txBody>
+          <a:bodyPr wrap="square" lIns="0" rIns="0" tIns="0" bIns="0" anchor="t">
+            <a:spAutoFit/>
+          </a:bodyPr>
+          <a:lstStyle/>
+          <a:p>
+            <a:pPr algn="l">
+              <a:spcAft>
+                <a:spcPts val="200"/>
+              </a:spcAft>
+            </a:pPr>
+            <a:r>
+              <a:rPr sz="1500" b="0" i="0">
+                <a:solidFill>
+                  <a:srgbClr val="1B2530"/>
+                </a:solidFill>
+                <a:latin typeface="Arial"/>
+              </a:rPr>
+              <a:t>la personne est présente, en direct</a:t>
+            </a:r>
+          </a:p>
+        </p:txBody>
+      </p:sp>
+      <p:cxnSp>
+        <p:nvCxnSpPr>
+          <p:cNvPr id="16" name="Connector 15"/>
+          <p:cNvCxnSpPr/>
+          <p:nvPr/>
+        </p:nvCxnSpPr>
+        <p:spPr>
+          <a:xfrm>
+            <a:off x="5347639" y="3383279"/>
+            <a:ext cx="162992" cy="0"/>
+          </a:xfrm>
+          <a:prstGeom prst="line">
+            <a:avLst/>
+          </a:prstGeom>
+          <a:ln w="19050">
+            <a:solidFill>
+              <a:srgbClr val="1F3A5F"/>
+            </a:solidFill>
+            <a:tailEnd type="triangle" w="med" h="med"/>
+          </a:ln>
+        </p:spPr>
+      </p:cxnSp>
+      <p:sp>
+        <p:nvSpPr>
+          <p:cNvPr id="17" name="Rectangle 16"/>
           <p:cNvSpPr/>
           <p:nvPr/>
         </p:nvSpPr>
         <p:spPr>
           <a:xfrm>
-            <a:off x="1490472" y="2284171"/>
-            <a:ext cx="1783080" cy="1124840"/>
-          </a:xfrm>
-          <a:prstGeom prst="roundRect">
-            <a:avLst>
-              <a:gd name="adj" fmla="val 6000"/>
-            </a:avLst>
-          </a:prstGeom>
-          <a:noFill/>
+            <a:off x="5547207" y="2331720"/>
+            <a:ext cx="1874519" cy="2103120"/>
+          </a:xfrm>
+          <a:prstGeom prst="rect">
+            <a:avLst/>
+          </a:prstGeom>
+          <a:solidFill>
+            <a:srgbClr val="EEF2F6"/>
+          </a:solidFill>
           <a:ln w="12700">
             <a:solidFill>
               <a:srgbClr val="CBD3DB"/>
@@ -14862,90 +15174,145 @@
       </p:sp>
       <p:sp>
         <p:nvSpPr>
-          <p:cNvPr id="10" name="Rounded Rectangle 9"/>
-          <p:cNvSpPr/>
-          <p:nvPr/>
-        </p:nvSpPr>
-        <p:spPr>
-          <a:xfrm>
-            <a:off x="1417319" y="2240280"/>
-            <a:ext cx="1783080" cy="1124840"/>
-          </a:xfrm>
-          <a:prstGeom prst="roundRect">
-            <a:avLst>
-              <a:gd name="adj" fmla="val 6000"/>
-            </a:avLst>
-          </a:prstGeom>
-          <a:noFill/>
-          <a:ln w="12700">
+          <p:cNvPr id="18" name="TextBox 17"/>
+          <p:cNvSpPr txBox="1"/>
+          <p:nvPr/>
+        </p:nvSpPr>
+        <p:spPr>
+          <a:xfrm>
+            <a:off x="5684367" y="2441448"/>
+            <a:ext cx="1600199" cy="274320"/>
+          </a:xfrm>
+          <a:prstGeom prst="rect">
+            <a:avLst/>
+          </a:prstGeom>
+          <a:noFill/>
+        </p:spPr>
+        <p:txBody>
+          <a:bodyPr wrap="square" lIns="0" rIns="0" tIns="0" bIns="0" anchor="t">
+            <a:spAutoFit/>
+          </a:bodyPr>
+          <a:lstStyle/>
+          <a:p>
+            <a:pPr algn="l"/>
+            <a:r>
+              <a:rPr sz="1400" b="1" i="0">
+                <a:solidFill>
+                  <a:srgbClr val="2E75B6"/>
+                </a:solidFill>
+                <a:latin typeface="Arial"/>
+              </a:rPr>
+              <a:t>3</a:t>
+            </a:r>
+          </a:p>
+        </p:txBody>
+      </p:sp>
+      <p:sp>
+        <p:nvSpPr>
+          <p:cNvPr id="19" name="TextBox 18"/>
+          <p:cNvSpPr txBox="1"/>
+          <p:nvPr/>
+        </p:nvSpPr>
+        <p:spPr>
+          <a:xfrm>
+            <a:off x="5684367" y="2715768"/>
+            <a:ext cx="1691639" cy="685800"/>
+          </a:xfrm>
+          <a:prstGeom prst="rect">
+            <a:avLst/>
+          </a:prstGeom>
+          <a:noFill/>
+        </p:spPr>
+        <p:txBody>
+          <a:bodyPr wrap="square" lIns="0" rIns="0" tIns="0" bIns="0" anchor="t">
+            <a:spAutoFit/>
+          </a:bodyPr>
+          <a:lstStyle/>
+          <a:p>
+            <a:pPr algn="l"/>
+            <a:r>
+              <a:rPr sz="1600" b="1" i="0">
+                <a:solidFill>
+                  <a:srgbClr val="1F3A5F"/>
+                </a:solidFill>
+                <a:latin typeface="Arial"/>
+              </a:rPr>
+              <a:t>Comparaison des photos</a:t>
+            </a:r>
+          </a:p>
+        </p:txBody>
+      </p:sp>
+      <p:sp>
+        <p:nvSpPr>
+          <p:cNvPr id="20" name="TextBox 19"/>
+          <p:cNvSpPr txBox="1"/>
+          <p:nvPr/>
+        </p:nvSpPr>
+        <p:spPr>
+          <a:xfrm>
+            <a:off x="5684367" y="3383279"/>
+            <a:ext cx="1600199" cy="1188720"/>
+          </a:xfrm>
+          <a:prstGeom prst="rect">
+            <a:avLst/>
+          </a:prstGeom>
+          <a:noFill/>
+        </p:spPr>
+        <p:txBody>
+          <a:bodyPr wrap="square" lIns="0" rIns="0" tIns="0" bIns="0" anchor="t">
+            <a:spAutoFit/>
+          </a:bodyPr>
+          <a:lstStyle/>
+          <a:p>
+            <a:pPr algn="l">
+              <a:spcAft>
+                <a:spcPts val="200"/>
+              </a:spcAft>
+            </a:pPr>
+            <a:r>
+              <a:rPr sz="1500" b="0" i="0">
+                <a:solidFill>
+                  <a:srgbClr val="1B2530"/>
+                </a:solidFill>
+                <a:latin typeface="Arial"/>
+              </a:rPr>
+              <a:t>photo de la CIN ↔ visage du test de vivacité</a:t>
+            </a:r>
+          </a:p>
+        </p:txBody>
+      </p:sp>
+      <p:cxnSp>
+        <p:nvCxnSpPr>
+          <p:cNvPr id="21" name="Connector 20"/>
+          <p:cNvCxnSpPr/>
+          <p:nvPr/>
+        </p:nvCxnSpPr>
+        <p:spPr>
+          <a:xfrm>
+            <a:off x="7458303" y="3383279"/>
+            <a:ext cx="162992" cy="0"/>
+          </a:xfrm>
+          <a:prstGeom prst="line">
+            <a:avLst/>
+          </a:prstGeom>
+          <a:ln w="19050">
             <a:solidFill>
               <a:srgbClr val="1F3A5F"/>
             </a:solidFill>
+            <a:tailEnd type="triangle" w="med" h="med"/>
           </a:ln>
         </p:spPr>
-        <p:txBody>
-          <a:bodyPr rtlCol="0" anchor="ctr"/>
-          <a:lstStyle/>
-          <a:p/>
-        </p:txBody>
-      </p:sp>
-      <p:sp>
-        <p:nvSpPr>
-          <p:cNvPr id="11" name="TextBox 10"/>
-          <p:cNvSpPr txBox="1"/>
-          <p:nvPr/>
-        </p:nvSpPr>
-        <p:spPr>
-          <a:xfrm>
-            <a:off x="548640" y="4041648"/>
-            <a:ext cx="3520440" cy="594360"/>
-          </a:xfrm>
-          <a:prstGeom prst="rect">
-            <a:avLst/>
-          </a:prstGeom>
-          <a:noFill/>
-        </p:spPr>
-        <p:txBody>
-          <a:bodyPr wrap="square" lIns="0" rIns="0" tIns="0" bIns="0" anchor="t">
-            <a:spAutoFit/>
-          </a:bodyPr>
-          <a:lstStyle/>
-          <a:p>
-            <a:pPr algn="ctr"/>
-            <a:r>
-              <a:rPr sz="2000" b="1" i="0">
-                <a:solidFill>
-                  <a:srgbClr val="1F3A5F"/>
-                </a:solidFill>
-                <a:latin typeface="Arial"/>
-              </a:rPr>
-              <a:t>Floue</a:t>
-            </a:r>
-          </a:p>
-          <a:p>
-            <a:pPr algn="ctr"/>
-            <a:r>
-              <a:rPr sz="1600" b="0" i="0">
-                <a:solidFill>
-                  <a:srgbClr val="5B6B7A"/>
-                </a:solidFill>
-                <a:latin typeface="Arial"/>
-              </a:rPr>
-              <a:t>image inexploitable</a:t>
-            </a:r>
-          </a:p>
-        </p:txBody>
-      </p:sp>
-      <p:sp>
-        <p:nvSpPr>
-          <p:cNvPr id="12" name="Rectangle 11"/>
+      </p:cxnSp>
+      <p:sp>
+        <p:nvSpPr>
+          <p:cNvPr id="22" name="Rectangle 21"/>
           <p:cNvSpPr/>
           <p:nvPr/>
         </p:nvSpPr>
         <p:spPr>
           <a:xfrm>
-            <a:off x="4306824" y="1874519"/>
-            <a:ext cx="3520440" cy="2057400"/>
+            <a:off x="7657871" y="2331720"/>
+            <a:ext cx="1874519" cy="2103120"/>
           </a:xfrm>
           <a:prstGeom prst="rect">
             <a:avLst/>
@@ -14953,8 +15320,10 @@
           <a:solidFill>
             <a:srgbClr val="EEF2F6"/>
           </a:solidFill>
-          <a:ln>
-            <a:noFill/>
+          <a:ln w="12700">
+            <a:solidFill>
+              <a:srgbClr val="CBD3DB"/>
+            </a:solidFill>
           </a:ln>
         </p:spPr>
         <p:txBody>
@@ -14965,90 +15334,145 @@
       </p:sp>
       <p:sp>
         <p:nvSpPr>
-          <p:cNvPr id="13" name="Rounded Rectangle 12"/>
-          <p:cNvSpPr/>
-          <p:nvPr/>
-        </p:nvSpPr>
-        <p:spPr>
-          <a:xfrm rot="20760000">
-            <a:off x="5221224" y="2286000"/>
-            <a:ext cx="1783080" cy="1124712"/>
-          </a:xfrm>
-          <a:prstGeom prst="roundRect">
-            <a:avLst>
-              <a:gd name="adj" fmla="val 6000"/>
-            </a:avLst>
-          </a:prstGeom>
-          <a:noFill/>
-          <a:ln w="15875">
+          <p:cNvPr id="23" name="TextBox 22"/>
+          <p:cNvSpPr txBox="1"/>
+          <p:nvPr/>
+        </p:nvSpPr>
+        <p:spPr>
+          <a:xfrm>
+            <a:off x="7795031" y="2441448"/>
+            <a:ext cx="1600199" cy="274320"/>
+          </a:xfrm>
+          <a:prstGeom prst="rect">
+            <a:avLst/>
+          </a:prstGeom>
+          <a:noFill/>
+        </p:spPr>
+        <p:txBody>
+          <a:bodyPr wrap="square" lIns="0" rIns="0" tIns="0" bIns="0" anchor="t">
+            <a:spAutoFit/>
+          </a:bodyPr>
+          <a:lstStyle/>
+          <a:p>
+            <a:pPr algn="l"/>
+            <a:r>
+              <a:rPr sz="1400" b="1" i="0">
+                <a:solidFill>
+                  <a:srgbClr val="2E75B6"/>
+                </a:solidFill>
+                <a:latin typeface="Arial"/>
+              </a:rPr>
+              <a:t>4</a:t>
+            </a:r>
+          </a:p>
+        </p:txBody>
+      </p:sp>
+      <p:sp>
+        <p:nvSpPr>
+          <p:cNvPr id="24" name="TextBox 23"/>
+          <p:cNvSpPr txBox="1"/>
+          <p:nvPr/>
+        </p:nvSpPr>
+        <p:spPr>
+          <a:xfrm>
+            <a:off x="7795031" y="2715768"/>
+            <a:ext cx="1691639" cy="685800"/>
+          </a:xfrm>
+          <a:prstGeom prst="rect">
+            <a:avLst/>
+          </a:prstGeom>
+          <a:noFill/>
+        </p:spPr>
+        <p:txBody>
+          <a:bodyPr wrap="square" lIns="0" rIns="0" tIns="0" bIns="0" anchor="t">
+            <a:spAutoFit/>
+          </a:bodyPr>
+          <a:lstStyle/>
+          <a:p>
+            <a:pPr algn="l"/>
+            <a:r>
+              <a:rPr sz="1600" b="1" i="0">
+                <a:solidFill>
+                  <a:srgbClr val="1F3A5F"/>
+                </a:solidFill>
+                <a:latin typeface="Arial"/>
+              </a:rPr>
+              <a:t>OCR</a:t>
+            </a:r>
+          </a:p>
+        </p:txBody>
+      </p:sp>
+      <p:sp>
+        <p:nvSpPr>
+          <p:cNvPr id="25" name="TextBox 24"/>
+          <p:cNvSpPr txBox="1"/>
+          <p:nvPr/>
+        </p:nvSpPr>
+        <p:spPr>
+          <a:xfrm>
+            <a:off x="7795031" y="3383279"/>
+            <a:ext cx="1600199" cy="1188720"/>
+          </a:xfrm>
+          <a:prstGeom prst="rect">
+            <a:avLst/>
+          </a:prstGeom>
+          <a:noFill/>
+        </p:spPr>
+        <p:txBody>
+          <a:bodyPr wrap="square" lIns="0" rIns="0" tIns="0" bIns="0" anchor="t">
+            <a:spAutoFit/>
+          </a:bodyPr>
+          <a:lstStyle/>
+          <a:p>
+            <a:pPr algn="l">
+              <a:spcAft>
+                <a:spcPts val="200"/>
+              </a:spcAft>
+            </a:pPr>
+            <a:r>
+              <a:rPr sz="1500" b="0" i="0">
+                <a:solidFill>
+                  <a:srgbClr val="1B2530"/>
+                </a:solidFill>
+                <a:latin typeface="Arial"/>
+              </a:rPr>
+              <a:t>lecture des champs de la carte</a:t>
+            </a:r>
+          </a:p>
+        </p:txBody>
+      </p:sp>
+      <p:cxnSp>
+        <p:nvCxnSpPr>
+          <p:cNvPr id="26" name="Connector 25"/>
+          <p:cNvCxnSpPr/>
+          <p:nvPr/>
+        </p:nvCxnSpPr>
+        <p:spPr>
+          <a:xfrm>
+            <a:off x="9568967" y="3383279"/>
+            <a:ext cx="162992" cy="0"/>
+          </a:xfrm>
+          <a:prstGeom prst="line">
+            <a:avLst/>
+          </a:prstGeom>
+          <a:ln w="19050">
             <a:solidFill>
               <a:srgbClr val="1F3A5F"/>
             </a:solidFill>
+            <a:tailEnd type="triangle" w="med" h="med"/>
           </a:ln>
         </p:spPr>
-        <p:txBody>
-          <a:bodyPr rtlCol="0" anchor="ctr"/>
-          <a:lstStyle/>
-          <a:p/>
-        </p:txBody>
-      </p:sp>
-      <p:sp>
-        <p:nvSpPr>
-          <p:cNvPr id="14" name="TextBox 13"/>
-          <p:cNvSpPr txBox="1"/>
-          <p:nvPr/>
-        </p:nvSpPr>
-        <p:spPr>
-          <a:xfrm>
-            <a:off x="4306824" y="4041648"/>
-            <a:ext cx="3520440" cy="594360"/>
-          </a:xfrm>
-          <a:prstGeom prst="rect">
-            <a:avLst/>
-          </a:prstGeom>
-          <a:noFill/>
-        </p:spPr>
-        <p:txBody>
-          <a:bodyPr wrap="square" lIns="0" rIns="0" tIns="0" bIns="0" anchor="t">
-            <a:spAutoFit/>
-          </a:bodyPr>
-          <a:lstStyle/>
-          <a:p>
-            <a:pPr algn="ctr"/>
-            <a:r>
-              <a:rPr sz="2000" b="1" i="0">
-                <a:solidFill>
-                  <a:srgbClr val="1F3A5F"/>
-                </a:solidFill>
-                <a:latin typeface="Arial"/>
-              </a:rPr>
-              <a:t>De travers</a:t>
-            </a:r>
-          </a:p>
-          <a:p>
-            <a:pPr algn="ctr"/>
-            <a:r>
-              <a:rPr sz="1600" b="0" i="0">
-                <a:solidFill>
-                  <a:srgbClr val="5B6B7A"/>
-                </a:solidFill>
-                <a:latin typeface="Arial"/>
-              </a:rPr>
-              <a:t>carte mal cadrée</a:t>
-            </a:r>
-          </a:p>
-        </p:txBody>
-      </p:sp>
-      <p:sp>
-        <p:nvSpPr>
-          <p:cNvPr id="15" name="Rectangle 14"/>
+      </p:cxnSp>
+      <p:sp>
+        <p:nvSpPr>
+          <p:cNvPr id="27" name="Rectangle 26"/>
           <p:cNvSpPr/>
           <p:nvPr/>
         </p:nvSpPr>
         <p:spPr>
           <a:xfrm>
-            <a:off x="8065008" y="1874519"/>
-            <a:ext cx="3520440" cy="2057400"/>
+            <a:off x="9768535" y="2331720"/>
+            <a:ext cx="1874519" cy="2103120"/>
           </a:xfrm>
           <a:prstGeom prst="rect">
             <a:avLst/>
@@ -15056,38 +15480,9 @@
           <a:solidFill>
             <a:srgbClr val="EEF2F6"/>
           </a:solidFill>
-          <a:ln>
-            <a:noFill/>
-          </a:ln>
-        </p:spPr>
-        <p:txBody>
-          <a:bodyPr rtlCol="0" anchor="ctr"/>
-          <a:lstStyle/>
-          <a:p/>
-        </p:txBody>
-      </p:sp>
-      <p:sp>
-        <p:nvSpPr>
-          <p:cNvPr id="16" name="Rounded Rectangle 15"/>
-          <p:cNvSpPr/>
-          <p:nvPr/>
-        </p:nvSpPr>
-        <p:spPr>
-          <a:xfrm>
-            <a:off x="8750808" y="2212848"/>
-            <a:ext cx="1691640" cy="1069848"/>
-          </a:xfrm>
-          <a:prstGeom prst="roundRect">
-            <a:avLst>
-              <a:gd name="adj" fmla="val 6000"/>
-            </a:avLst>
-          </a:prstGeom>
-          <a:solidFill>
-            <a:srgbClr val="FFFFFF"/>
-          </a:solidFill>
-          <a:ln w="15875">
+          <a:ln w="12700">
             <a:solidFill>
-              <a:srgbClr val="1F3A5F"/>
+              <a:srgbClr val="CBD3DB"/>
             </a:solidFill>
           </a:ln>
         </p:spPr>
@@ -15099,14 +15494,14 @@
       </p:sp>
       <p:sp>
         <p:nvSpPr>
-          <p:cNvPr id="17" name="TextBox 16"/>
-          <p:cNvSpPr txBox="1"/>
-          <p:nvPr/>
-        </p:nvSpPr>
-        <p:spPr>
-          <a:xfrm>
-            <a:off x="8750808" y="2532888"/>
-            <a:ext cx="1691640" cy="365760"/>
+          <p:cNvPr id="28" name="TextBox 27"/>
+          <p:cNvSpPr txBox="1"/>
+          <p:nvPr/>
+        </p:nvSpPr>
+        <p:spPr>
+          <a:xfrm>
+            <a:off x="9905695" y="2441448"/>
+            <a:ext cx="1600199" cy="274320"/>
           </a:xfrm>
           <a:prstGeom prst="rect">
             <a:avLst/>
@@ -15119,60 +15514,124 @@
           </a:bodyPr>
           <a:lstStyle/>
           <a:p>
-            <a:pPr algn="ctr"/>
-            <a:r>
-              <a:rPr sz="1600" b="0" i="0">
+            <a:pPr algn="l"/>
+            <a:r>
+              <a:rPr sz="1400" b="1" i="0">
+                <a:solidFill>
+                  <a:srgbClr val="2E75B6"/>
+                </a:solidFill>
+                <a:latin typeface="Arial"/>
+              </a:rPr>
+              <a:t>5</a:t>
+            </a:r>
+          </a:p>
+        </p:txBody>
+      </p:sp>
+      <p:sp>
+        <p:nvSpPr>
+          <p:cNvPr id="29" name="TextBox 28"/>
+          <p:cNvSpPr txBox="1"/>
+          <p:nvPr/>
+        </p:nvSpPr>
+        <p:spPr>
+          <a:xfrm>
+            <a:off x="9905695" y="2715768"/>
+            <a:ext cx="1691639" cy="685800"/>
+          </a:xfrm>
+          <a:prstGeom prst="rect">
+            <a:avLst/>
+          </a:prstGeom>
+          <a:noFill/>
+        </p:spPr>
+        <p:txBody>
+          <a:bodyPr wrap="square" lIns="0" rIns="0" tIns="0" bIns="0" anchor="t">
+            <a:spAutoFit/>
+          </a:bodyPr>
+          <a:lstStyle/>
+          <a:p>
+            <a:pPr algn="l"/>
+            <a:r>
+              <a:rPr sz="1600" b="1" i="0">
                 <a:solidFill>
                   <a:srgbClr val="1F3A5F"/>
                 </a:solidFill>
                 <a:latin typeface="Arial"/>
               </a:rPr>
-              <a:t>recto</a:t>
-            </a:r>
-          </a:p>
-        </p:txBody>
-      </p:sp>
-      <p:sp>
-        <p:nvSpPr>
-          <p:cNvPr id="18" name="Rounded Rectangle 17"/>
-          <p:cNvSpPr/>
-          <p:nvPr/>
-        </p:nvSpPr>
-        <p:spPr>
-          <a:xfrm>
-            <a:off x="9134856" y="2404872"/>
-            <a:ext cx="1691640" cy="1069848"/>
-          </a:xfrm>
-          <a:prstGeom prst="roundRect">
-            <a:avLst>
-              <a:gd name="adj" fmla="val 6000"/>
-            </a:avLst>
-          </a:prstGeom>
-          <a:solidFill>
-            <a:srgbClr val="FFFFFF"/>
-          </a:solidFill>
-          <a:ln w="15875">
+              <a:t>Enregistrement</a:t>
+            </a:r>
+          </a:p>
+        </p:txBody>
+      </p:sp>
+      <p:sp>
+        <p:nvSpPr>
+          <p:cNvPr id="30" name="TextBox 29"/>
+          <p:cNvSpPr txBox="1"/>
+          <p:nvPr/>
+        </p:nvSpPr>
+        <p:spPr>
+          <a:xfrm>
+            <a:off x="9905695" y="3383279"/>
+            <a:ext cx="1600199" cy="1188720"/>
+          </a:xfrm>
+          <a:prstGeom prst="rect">
+            <a:avLst/>
+          </a:prstGeom>
+          <a:noFill/>
+        </p:spPr>
+        <p:txBody>
+          <a:bodyPr wrap="square" lIns="0" rIns="0" tIns="0" bIns="0" anchor="t">
+            <a:spAutoFit/>
+          </a:bodyPr>
+          <a:lstStyle/>
+          <a:p>
+            <a:pPr algn="l">
+              <a:spcAft>
+                <a:spcPts val="200"/>
+              </a:spcAft>
+            </a:pPr>
+            <a:r>
+              <a:rPr sz="1500" b="0" i="0">
+                <a:solidFill>
+                  <a:srgbClr val="1B2530"/>
+                </a:solidFill>
+                <a:latin typeface="Arial"/>
+              </a:rPr>
+              <a:t>sauvegarde du résultat</a:t>
+            </a:r>
+          </a:p>
+        </p:txBody>
+      </p:sp>
+      <p:cxnSp>
+        <p:nvCxnSpPr>
+          <p:cNvPr id="31" name="Connector 30"/>
+          <p:cNvCxnSpPr/>
+          <p:nvPr/>
+        </p:nvCxnSpPr>
+        <p:spPr>
+          <a:xfrm>
+            <a:off x="548640" y="2148840"/>
+            <a:ext cx="2651760" cy="0"/>
+          </a:xfrm>
+          <a:prstGeom prst="line">
+            <a:avLst/>
+          </a:prstGeom>
+          <a:ln w="38100">
             <a:solidFill>
-              <a:srgbClr val="1F3A5F"/>
+              <a:srgbClr val="2E75B6"/>
             </a:solidFill>
           </a:ln>
         </p:spPr>
-        <p:txBody>
-          <a:bodyPr rtlCol="0" anchor="ctr"/>
-          <a:lstStyle/>
-          <a:p/>
-        </p:txBody>
-      </p:sp>
-      <p:sp>
-        <p:nvSpPr>
-          <p:cNvPr id="19" name="TextBox 18"/>
-          <p:cNvSpPr txBox="1"/>
-          <p:nvPr/>
-        </p:nvSpPr>
-        <p:spPr>
-          <a:xfrm>
-            <a:off x="9134856" y="2724912"/>
-            <a:ext cx="1691640" cy="365760"/>
+      </p:cxnSp>
+      <p:sp>
+        <p:nvSpPr>
+          <p:cNvPr id="32" name="TextBox 31"/>
+          <p:cNvSpPr txBox="1"/>
+          <p:nvPr/>
+        </p:nvSpPr>
+        <p:spPr>
+          <a:xfrm>
+            <a:off x="548640" y="1828800"/>
+            <a:ext cx="2651760" cy="274320"/>
           </a:xfrm>
           <a:prstGeom prst="rect">
             <a:avLst/>
@@ -15185,29 +15644,129 @@
           </a:bodyPr>
           <a:lstStyle/>
           <a:p>
-            <a:pPr algn="ctr"/>
-            <a:r>
-              <a:rPr sz="1600" b="0" i="0">
+            <a:pPr algn="l"/>
+            <a:r>
+              <a:rPr sz="1300" b="1" i="0">
+                <a:solidFill>
+                  <a:srgbClr val="2E75B6"/>
+                </a:solidFill>
+                <a:latin typeface="Arial"/>
+              </a:rPr>
+              <a:t>CE STAGE</a:t>
+            </a:r>
+          </a:p>
+        </p:txBody>
+      </p:sp>
+      <p:cxnSp>
+        <p:nvCxnSpPr>
+          <p:cNvPr id="33" name="Connector 32"/>
+          <p:cNvCxnSpPr/>
+          <p:nvPr/>
+        </p:nvCxnSpPr>
+        <p:spPr>
+          <a:xfrm>
+            <a:off x="3436543" y="2148840"/>
+            <a:ext cx="8206512" cy="0"/>
+          </a:xfrm>
+          <a:prstGeom prst="line">
+            <a:avLst/>
+          </a:prstGeom>
+          <a:ln w="19050">
+            <a:solidFill>
+              <a:srgbClr val="5B6B7A"/>
+            </a:solidFill>
+          </a:ln>
+        </p:spPr>
+      </p:cxnSp>
+      <p:sp>
+        <p:nvSpPr>
+          <p:cNvPr id="34" name="TextBox 33"/>
+          <p:cNvSpPr txBox="1"/>
+          <p:nvPr/>
+        </p:nvSpPr>
+        <p:spPr>
+          <a:xfrm>
+            <a:off x="3436543" y="1828800"/>
+            <a:ext cx="5486400" cy="274320"/>
+          </a:xfrm>
+          <a:prstGeom prst="rect">
+            <a:avLst/>
+          </a:prstGeom>
+          <a:noFill/>
+        </p:spPr>
+        <p:txBody>
+          <a:bodyPr wrap="square" lIns="0" rIns="0" tIns="0" bIns="0" anchor="t">
+            <a:spAutoFit/>
+          </a:bodyPr>
+          <a:lstStyle/>
+          <a:p>
+            <a:pPr algn="l"/>
+            <a:r>
+              <a:rPr sz="1300" b="1" i="0">
+                <a:solidFill>
+                  <a:srgbClr val="5B6B7A"/>
+                </a:solidFill>
+                <a:latin typeface="Arial"/>
+              </a:rPr>
+              <a:t>SUITE DU PARCOURS AVATAR-ID</a:t>
+            </a:r>
+          </a:p>
+        </p:txBody>
+      </p:sp>
+      <p:sp>
+        <p:nvSpPr>
+          <p:cNvPr id="35" name="TextBox 34"/>
+          <p:cNvSpPr txBox="1"/>
+          <p:nvPr/>
+        </p:nvSpPr>
+        <p:spPr>
+          <a:xfrm>
+            <a:off x="548640" y="4754880"/>
+            <a:ext cx="5272887" cy="1280160"/>
+          </a:xfrm>
+          <a:prstGeom prst="rect">
+            <a:avLst/>
+          </a:prstGeom>
+          <a:noFill/>
+        </p:spPr>
+        <p:txBody>
+          <a:bodyPr wrap="square" lIns="0" rIns="0" tIns="0" bIns="0" anchor="t">
+            <a:spAutoFit/>
+          </a:bodyPr>
+          <a:lstStyle/>
+          <a:p>
+            <a:pPr algn="l"/>
+            <a:r>
+              <a:rPr sz="1800" b="1" i="0">
                 <a:solidFill>
                   <a:srgbClr val="1F3A5F"/>
                 </a:solidFill>
                 <a:latin typeface="Arial"/>
               </a:rPr>
-              <a:t>recto</a:t>
-            </a:r>
-          </a:p>
-        </p:txBody>
-      </p:sp>
-      <p:sp>
-        <p:nvSpPr>
-          <p:cNvPr id="20" name="TextBox 19"/>
-          <p:cNvSpPr txBox="1"/>
-          <p:nvPr/>
-        </p:nvSpPr>
-        <p:spPr>
-          <a:xfrm>
-            <a:off x="8065008" y="4041648"/>
-            <a:ext cx="3520440" cy="594360"/>
+              <a:t>Ce que le module transmet : </a:t>
+            </a:r>
+            <a:r>
+              <a:rPr sz="1800" b="0" i="0">
+                <a:solidFill>
+                  <a:srgbClr val="1B2530"/>
+                </a:solidFill>
+                <a:latin typeface="Arial"/>
+              </a:rPr>
+              <a:t>le recto et le verso redressés et orientés, ainsi que la page A4 composée.</a:t>
+            </a:r>
+          </a:p>
+        </p:txBody>
+      </p:sp>
+      <p:sp>
+        <p:nvSpPr>
+          <p:cNvPr id="36" name="TextBox 35"/>
+          <p:cNvSpPr txBox="1"/>
+          <p:nvPr/>
+        </p:nvSpPr>
+        <p:spPr>
+          <a:xfrm>
+            <a:off x="6370167" y="4754880"/>
+            <a:ext cx="5272887" cy="1280160"/>
           </a:xfrm>
           <a:prstGeom prst="rect">
             <a:avLst/>
@@ -15220,135 +15779,24 @@
           </a:bodyPr>
           <a:lstStyle/>
           <a:p>
-            <a:pPr algn="ctr"/>
-            <a:r>
-              <a:rPr sz="2000" b="1" i="0">
+            <a:pPr algn="l"/>
+            <a:r>
+              <a:rPr sz="1800" b="1" i="0">
                 <a:solidFill>
                   <a:srgbClr val="1F3A5F"/>
                 </a:solidFill>
                 <a:latin typeface="Arial"/>
               </a:rPr>
-              <a:t>Deux fois le recto</a:t>
-            </a:r>
-          </a:p>
-          <a:p>
-            <a:pPr algn="ctr"/>
-            <a:r>
-              <a:rPr sz="1600" b="0" i="0">
-                <a:solidFill>
-                  <a:srgbClr val="5B6B7A"/>
-                </a:solidFill>
-                <a:latin typeface="Arial"/>
-              </a:rPr>
-              <a:t>verso jamais fourni</a:t>
-            </a:r>
-          </a:p>
-        </p:txBody>
-      </p:sp>
-      <p:sp>
-        <p:nvSpPr>
-          <p:cNvPr id="21" name="TextBox 20"/>
-          <p:cNvSpPr txBox="1"/>
-          <p:nvPr/>
-        </p:nvSpPr>
-        <p:spPr>
-          <a:xfrm>
-            <a:off x="548640" y="4846320"/>
-            <a:ext cx="7589520" cy="1097280"/>
-          </a:xfrm>
-          <a:prstGeom prst="rect">
-            <a:avLst/>
-          </a:prstGeom>
-          <a:noFill/>
-        </p:spPr>
-        <p:txBody>
-          <a:bodyPr wrap="square" lIns="0" rIns="0" tIns="0" bIns="0" anchor="t">
-            <a:spAutoFit/>
-          </a:bodyPr>
-          <a:lstStyle/>
-          <a:p>
-            <a:pPr algn="l"/>
-            <a:r>
-              <a:rPr sz="2000" b="1" i="0">
-                <a:solidFill>
-                  <a:srgbClr val="1F3A5F"/>
-                </a:solidFill>
-                <a:latin typeface="Arial"/>
-              </a:rPr>
-              <a:t>Problématique — </a:t>
-            </a:r>
-            <a:r>
-              <a:rPr sz="2000" b="0" i="0">
+              <a:t>Pourquoi la qualité compte : </a:t>
+            </a:r>
+            <a:r>
+              <a:rPr sz="1800" b="0" i="0">
                 <a:solidFill>
                   <a:srgbClr val="1B2530"/>
                 </a:solidFill>
                 <a:latin typeface="Arial"/>
               </a:rPr>
-              <a:t>comment détecter de façon fiable et en temps réel les contours d'une CIN dans un flux caméra mobile, quels que soient l'éclairage et l'arrière-plan ?</a:t>
-            </a:r>
-          </a:p>
-        </p:txBody>
-      </p:sp>
-      <p:sp>
-        <p:nvSpPr>
-          <p:cNvPr id="22" name="TextBox 21"/>
-          <p:cNvSpPr txBox="1"/>
-          <p:nvPr/>
-        </p:nvSpPr>
-        <p:spPr>
-          <a:xfrm>
-            <a:off x="8503920" y="4846320"/>
-            <a:ext cx="3139135" cy="1188720"/>
-          </a:xfrm>
-          <a:prstGeom prst="rect">
-            <a:avLst/>
-          </a:prstGeom>
-          <a:noFill/>
-        </p:spPr>
-        <p:txBody>
-          <a:bodyPr wrap="square" lIns="0" rIns="0" tIns="0" bIns="0" anchor="t">
-            <a:spAutoFit/>
-          </a:bodyPr>
-          <a:lstStyle/>
-          <a:p>
-            <a:pPr algn="l">
-              <a:spcAft>
-                <a:spcPts val="600"/>
-              </a:spcAft>
-            </a:pPr>
-            <a:r>
-              <a:rPr sz="1600" b="1" i="0">
-                <a:solidFill>
-                  <a:srgbClr val="1F3A5F"/>
-                </a:solidFill>
-                <a:latin typeface="Arial"/>
-              </a:rPr>
-              <a:t>Avatar-ID</a:t>
-            </a:r>
-            <a:r>
-              <a:rPr sz="1600" b="0" i="0">
-                <a:solidFill>
-                  <a:srgbClr val="5B6B7A"/>
-                </a:solidFill>
-                <a:latin typeface="Arial"/>
-              </a:rPr>
-              <a:t> : vérification d'identité à distance, type KYC.</a:t>
-            </a:r>
-          </a:p>
-          <a:p>
-            <a:pPr algn="l">
-              <a:spcAft>
-                <a:spcPts val="600"/>
-              </a:spcAft>
-            </a:pPr>
-            <a:r>
-              <a:rPr sz="1600" b="0" i="0">
-                <a:solidFill>
-                  <a:srgbClr val="5B6B7A"/>
-                </a:solidFill>
-                <a:latin typeface="Arial"/>
-              </a:rPr>
-              <a:t>Sans guidage : contrôle humain coûteux ou nouvelle saisie.</a:t>
+              <a:t>une carte nette, bien cadrée et à l'endroit alimente directement la comparaison des photos et l'OCR.</a:t>
             </a:r>
           </a:p>
         </p:txBody>
@@ -16414,7 +16862,7 @@
                 </a:solidFill>
                 <a:latin typeface="Arial"/>
               </a:rPr>
-              <a:t>Mon module est la première étape du parcours Avatar-ID : sa qualité conditionne la suite</a:t>
+              <a:t>Une photo libre de CIN peut être floue, de travers ou envoyée deux fois</a:t>
             </a:r>
           </a:p>
         </p:txBody>
@@ -16427,216 +16875,8 @@
         </p:nvSpPr>
         <p:spPr>
           <a:xfrm>
-            <a:off x="548640" y="2331720"/>
-            <a:ext cx="2651760" cy="2103120"/>
-          </a:xfrm>
-          <a:prstGeom prst="rect">
-            <a:avLst/>
-          </a:prstGeom>
-          <a:solidFill>
-            <a:srgbClr val="FFFFFF"/>
-          </a:solidFill>
-          <a:ln w="28575">
-            <a:solidFill>
-              <a:srgbClr val="2E75B6"/>
-            </a:solidFill>
-          </a:ln>
-        </p:spPr>
-        <p:txBody>
-          <a:bodyPr rtlCol="0" anchor="ctr"/>
-          <a:lstStyle/>
-          <a:p/>
-        </p:txBody>
-      </p:sp>
-      <p:sp>
-        <p:nvSpPr>
-          <p:cNvPr id="8" name="TextBox 7"/>
-          <p:cNvSpPr txBox="1"/>
-          <p:nvPr/>
-        </p:nvSpPr>
-        <p:spPr>
-          <a:xfrm>
-            <a:off x="685800" y="2441448"/>
-            <a:ext cx="2377440" cy="274320"/>
-          </a:xfrm>
-          <a:prstGeom prst="rect">
-            <a:avLst/>
-          </a:prstGeom>
-          <a:noFill/>
-        </p:spPr>
-        <p:txBody>
-          <a:bodyPr wrap="square" lIns="0" rIns="0" tIns="0" bIns="0" anchor="t">
-            <a:spAutoFit/>
-          </a:bodyPr>
-          <a:lstStyle/>
-          <a:p>
-            <a:pPr algn="l"/>
-            <a:r>
-              <a:rPr sz="1400" b="1" i="0">
-                <a:solidFill>
-                  <a:srgbClr val="2E75B6"/>
-                </a:solidFill>
-                <a:latin typeface="Arial"/>
-              </a:rPr>
-              <a:t>1</a:t>
-            </a:r>
-          </a:p>
-        </p:txBody>
-      </p:sp>
-      <p:sp>
-        <p:nvSpPr>
-          <p:cNvPr id="9" name="TextBox 8"/>
-          <p:cNvSpPr txBox="1"/>
-          <p:nvPr/>
-        </p:nvSpPr>
-        <p:spPr>
-          <a:xfrm>
-            <a:off x="685800" y="2715768"/>
-            <a:ext cx="2468879" cy="685800"/>
-          </a:xfrm>
-          <a:prstGeom prst="rect">
-            <a:avLst/>
-          </a:prstGeom>
-          <a:noFill/>
-        </p:spPr>
-        <p:txBody>
-          <a:bodyPr wrap="square" lIns="0" rIns="0" tIns="0" bIns="0" anchor="t">
-            <a:spAutoFit/>
-          </a:bodyPr>
-          <a:lstStyle/>
-          <a:p>
-            <a:pPr algn="l"/>
-            <a:r>
-              <a:rPr sz="1700" b="1" i="0">
-                <a:solidFill>
-                  <a:srgbClr val="1F3A5F"/>
-                </a:solidFill>
-                <a:latin typeface="Arial"/>
-              </a:rPr>
-              <a:t>Capture de la CIN</a:t>
-            </a:r>
-          </a:p>
-        </p:txBody>
-      </p:sp>
-      <p:sp>
-        <p:nvSpPr>
-          <p:cNvPr id="10" name="TextBox 9"/>
-          <p:cNvSpPr txBox="1"/>
-          <p:nvPr/>
-        </p:nvSpPr>
-        <p:spPr>
-          <a:xfrm>
-            <a:off x="685800" y="3108960"/>
-            <a:ext cx="2377440" cy="1188720"/>
-          </a:xfrm>
-          <a:prstGeom prst="rect">
-            <a:avLst/>
-          </a:prstGeom>
-          <a:noFill/>
-        </p:spPr>
-        <p:txBody>
-          <a:bodyPr wrap="square" lIns="0" rIns="0" tIns="0" bIns="0" anchor="t">
-            <a:spAutoFit/>
-          </a:bodyPr>
-          <a:lstStyle/>
-          <a:p>
-            <a:pPr algn="l">
-              <a:spcAft>
-                <a:spcPts val="200"/>
-              </a:spcAft>
-            </a:pPr>
-            <a:r>
-              <a:rPr sz="1600" b="0" i="0">
-                <a:solidFill>
-                  <a:srgbClr val="1B2530"/>
-                </a:solidFill>
-                <a:latin typeface="Arial"/>
-              </a:rPr>
-              <a:t>détection</a:t>
-            </a:r>
-          </a:p>
-          <a:p>
-            <a:pPr algn="l">
-              <a:spcAft>
-                <a:spcPts val="200"/>
-              </a:spcAft>
-            </a:pPr>
-            <a:r>
-              <a:rPr sz="1600" b="0" i="0">
-                <a:solidFill>
-                  <a:srgbClr val="1B2530"/>
-                </a:solidFill>
-                <a:latin typeface="Arial"/>
-              </a:rPr>
-              <a:t>qualité d'image</a:t>
-            </a:r>
-          </a:p>
-          <a:p>
-            <a:pPr algn="l">
-              <a:spcAft>
-                <a:spcPts val="200"/>
-              </a:spcAft>
-            </a:pPr>
-            <a:r>
-              <a:rPr sz="1600" b="0" i="0">
-                <a:solidFill>
-                  <a:srgbClr val="1B2530"/>
-                </a:solidFill>
-                <a:latin typeface="Arial"/>
-              </a:rPr>
-              <a:t>recto puis verso</a:t>
-            </a:r>
-          </a:p>
-          <a:p>
-            <a:pPr algn="l">
-              <a:spcAft>
-                <a:spcPts val="200"/>
-              </a:spcAft>
-            </a:pPr>
-            <a:r>
-              <a:rPr sz="1600" b="0" i="0">
-                <a:solidFill>
-                  <a:srgbClr val="1B2530"/>
-                </a:solidFill>
-                <a:latin typeface="Arial"/>
-              </a:rPr>
-              <a:t>recadrage, amélioration</a:t>
-            </a:r>
-          </a:p>
-        </p:txBody>
-      </p:sp>
-      <p:cxnSp>
-        <p:nvCxnSpPr>
-          <p:cNvPr id="11" name="Connector 10"/>
-          <p:cNvCxnSpPr/>
-          <p:nvPr/>
-        </p:nvCxnSpPr>
-        <p:spPr>
-          <a:xfrm>
-            <a:off x="3236976" y="3383279"/>
-            <a:ext cx="162991" cy="0"/>
-          </a:xfrm>
-          <a:prstGeom prst="line">
-            <a:avLst/>
-          </a:prstGeom>
-          <a:ln w="19050">
-            <a:solidFill>
-              <a:srgbClr val="1F3A5F"/>
-            </a:solidFill>
-            <a:tailEnd type="triangle" w="med" h="med"/>
-          </a:ln>
-        </p:spPr>
-      </p:cxnSp>
-      <p:sp>
-        <p:nvSpPr>
-          <p:cNvPr id="12" name="Rectangle 11"/>
-          <p:cNvSpPr/>
-          <p:nvPr/>
-        </p:nvSpPr>
-        <p:spPr>
-          <a:xfrm>
-            <a:off x="3436543" y="2331720"/>
-            <a:ext cx="1874519" cy="2103120"/>
+            <a:off x="548640" y="1874519"/>
+            <a:ext cx="3520440" cy="2057400"/>
           </a:xfrm>
           <a:prstGeom prst="rect">
             <a:avLst/>
@@ -16644,6 +16884,33 @@
           <a:solidFill>
             <a:srgbClr val="EEF2F6"/>
           </a:solidFill>
+          <a:ln>
+            <a:noFill/>
+          </a:ln>
+        </p:spPr>
+        <p:txBody>
+          <a:bodyPr rtlCol="0" anchor="ctr"/>
+          <a:lstStyle/>
+          <a:p/>
+        </p:txBody>
+      </p:sp>
+      <p:sp>
+        <p:nvSpPr>
+          <p:cNvPr id="8" name="Rounded Rectangle 7"/>
+          <p:cNvSpPr/>
+          <p:nvPr/>
+        </p:nvSpPr>
+        <p:spPr>
+          <a:xfrm>
+            <a:off x="1563623" y="2328062"/>
+            <a:ext cx="1783080" cy="1124840"/>
+          </a:xfrm>
+          <a:prstGeom prst="roundRect">
+            <a:avLst>
+              <a:gd name="adj" fmla="val 6000"/>
+            </a:avLst>
+          </a:prstGeom>
+          <a:noFill/>
           <a:ln w="12700">
             <a:solidFill>
               <a:srgbClr val="CBD3DB"/>
@@ -16658,152 +16925,21 @@
       </p:sp>
       <p:sp>
         <p:nvSpPr>
-          <p:cNvPr id="13" name="TextBox 12"/>
-          <p:cNvSpPr txBox="1"/>
-          <p:nvPr/>
-        </p:nvSpPr>
-        <p:spPr>
-          <a:xfrm>
-            <a:off x="3573703" y="2441448"/>
-            <a:ext cx="1600199" cy="274320"/>
-          </a:xfrm>
-          <a:prstGeom prst="rect">
-            <a:avLst/>
-          </a:prstGeom>
-          <a:noFill/>
-        </p:spPr>
-        <p:txBody>
-          <a:bodyPr wrap="square" lIns="0" rIns="0" tIns="0" bIns="0" anchor="t">
-            <a:spAutoFit/>
-          </a:bodyPr>
-          <a:lstStyle/>
-          <a:p>
-            <a:pPr algn="l"/>
-            <a:r>
-              <a:rPr sz="1400" b="1" i="0">
-                <a:solidFill>
-                  <a:srgbClr val="2E75B6"/>
-                </a:solidFill>
-                <a:latin typeface="Arial"/>
-              </a:rPr>
-              <a:t>2</a:t>
-            </a:r>
-          </a:p>
-        </p:txBody>
-      </p:sp>
-      <p:sp>
-        <p:nvSpPr>
-          <p:cNvPr id="14" name="TextBox 13"/>
-          <p:cNvSpPr txBox="1"/>
-          <p:nvPr/>
-        </p:nvSpPr>
-        <p:spPr>
-          <a:xfrm>
-            <a:off x="3573703" y="2715768"/>
-            <a:ext cx="1691639" cy="685800"/>
-          </a:xfrm>
-          <a:prstGeom prst="rect">
-            <a:avLst/>
-          </a:prstGeom>
-          <a:noFill/>
-        </p:spPr>
-        <p:txBody>
-          <a:bodyPr wrap="square" lIns="0" rIns="0" tIns="0" bIns="0" anchor="t">
-            <a:spAutoFit/>
-          </a:bodyPr>
-          <a:lstStyle/>
-          <a:p>
-            <a:pPr algn="l"/>
-            <a:r>
-              <a:rPr sz="1600" b="1" i="0">
-                <a:solidFill>
-                  <a:srgbClr val="1F3A5F"/>
-                </a:solidFill>
-                <a:latin typeface="Arial"/>
-              </a:rPr>
-              <a:t>Test de vivacité</a:t>
-            </a:r>
-          </a:p>
-        </p:txBody>
-      </p:sp>
-      <p:sp>
-        <p:nvSpPr>
-          <p:cNvPr id="15" name="TextBox 14"/>
-          <p:cNvSpPr txBox="1"/>
-          <p:nvPr/>
-        </p:nvSpPr>
-        <p:spPr>
-          <a:xfrm>
-            <a:off x="3573703" y="3383279"/>
-            <a:ext cx="1600199" cy="1188720"/>
-          </a:xfrm>
-          <a:prstGeom prst="rect">
-            <a:avLst/>
-          </a:prstGeom>
-          <a:noFill/>
-        </p:spPr>
-        <p:txBody>
-          <a:bodyPr wrap="square" lIns="0" rIns="0" tIns="0" bIns="0" anchor="t">
-            <a:spAutoFit/>
-          </a:bodyPr>
-          <a:lstStyle/>
-          <a:p>
-            <a:pPr algn="l">
-              <a:spcAft>
-                <a:spcPts val="200"/>
-              </a:spcAft>
-            </a:pPr>
-            <a:r>
-              <a:rPr sz="1500" b="0" i="0">
-                <a:solidFill>
-                  <a:srgbClr val="1B2530"/>
-                </a:solidFill>
-                <a:latin typeface="Arial"/>
-              </a:rPr>
-              <a:t>la personne est présente, en direct</a:t>
-            </a:r>
-          </a:p>
-        </p:txBody>
-      </p:sp>
-      <p:cxnSp>
-        <p:nvCxnSpPr>
-          <p:cNvPr id="16" name="Connector 15"/>
-          <p:cNvCxnSpPr/>
-          <p:nvPr/>
-        </p:nvCxnSpPr>
-        <p:spPr>
-          <a:xfrm>
-            <a:off x="5347639" y="3383279"/>
-            <a:ext cx="162992" cy="0"/>
-          </a:xfrm>
-          <a:prstGeom prst="line">
-            <a:avLst/>
-          </a:prstGeom>
-          <a:ln w="19050">
-            <a:solidFill>
-              <a:srgbClr val="1F3A5F"/>
-            </a:solidFill>
-            <a:tailEnd type="triangle" w="med" h="med"/>
-          </a:ln>
-        </p:spPr>
-      </p:cxnSp>
-      <p:sp>
-        <p:nvSpPr>
-          <p:cNvPr id="17" name="Rectangle 16"/>
+          <p:cNvPr id="9" name="Rounded Rectangle 8"/>
           <p:cNvSpPr/>
           <p:nvPr/>
         </p:nvSpPr>
         <p:spPr>
           <a:xfrm>
-            <a:off x="5547207" y="2331720"/>
-            <a:ext cx="1874519" cy="2103120"/>
-          </a:xfrm>
-          <a:prstGeom prst="rect">
-            <a:avLst/>
-          </a:prstGeom>
-          <a:solidFill>
-            <a:srgbClr val="EEF2F6"/>
-          </a:solidFill>
+            <a:off x="1490472" y="2284171"/>
+            <a:ext cx="1783080" cy="1124840"/>
+          </a:xfrm>
+          <a:prstGeom prst="roundRect">
+            <a:avLst>
+              <a:gd name="adj" fmla="val 6000"/>
+            </a:avLst>
+          </a:prstGeom>
+          <a:noFill/>
           <a:ln w="12700">
             <a:solidFill>
               <a:srgbClr val="CBD3DB"/>
@@ -16818,145 +16954,90 @@
       </p:sp>
       <p:sp>
         <p:nvSpPr>
-          <p:cNvPr id="18" name="TextBox 17"/>
-          <p:cNvSpPr txBox="1"/>
-          <p:nvPr/>
-        </p:nvSpPr>
-        <p:spPr>
-          <a:xfrm>
-            <a:off x="5684367" y="2441448"/>
-            <a:ext cx="1600199" cy="274320"/>
-          </a:xfrm>
-          <a:prstGeom prst="rect">
-            <a:avLst/>
-          </a:prstGeom>
-          <a:noFill/>
-        </p:spPr>
-        <p:txBody>
-          <a:bodyPr wrap="square" lIns="0" rIns="0" tIns="0" bIns="0" anchor="t">
-            <a:spAutoFit/>
-          </a:bodyPr>
-          <a:lstStyle/>
-          <a:p>
-            <a:pPr algn="l"/>
-            <a:r>
-              <a:rPr sz="1400" b="1" i="0">
-                <a:solidFill>
-                  <a:srgbClr val="2E75B6"/>
-                </a:solidFill>
-                <a:latin typeface="Arial"/>
-              </a:rPr>
-              <a:t>3</a:t>
-            </a:r>
-          </a:p>
-        </p:txBody>
-      </p:sp>
-      <p:sp>
-        <p:nvSpPr>
-          <p:cNvPr id="19" name="TextBox 18"/>
-          <p:cNvSpPr txBox="1"/>
-          <p:nvPr/>
-        </p:nvSpPr>
-        <p:spPr>
-          <a:xfrm>
-            <a:off x="5684367" y="2715768"/>
-            <a:ext cx="1691639" cy="685800"/>
-          </a:xfrm>
-          <a:prstGeom prst="rect">
-            <a:avLst/>
-          </a:prstGeom>
-          <a:noFill/>
-        </p:spPr>
-        <p:txBody>
-          <a:bodyPr wrap="square" lIns="0" rIns="0" tIns="0" bIns="0" anchor="t">
-            <a:spAutoFit/>
-          </a:bodyPr>
-          <a:lstStyle/>
-          <a:p>
-            <a:pPr algn="l"/>
-            <a:r>
-              <a:rPr sz="1600" b="1" i="0">
-                <a:solidFill>
-                  <a:srgbClr val="1F3A5F"/>
-                </a:solidFill>
-                <a:latin typeface="Arial"/>
-              </a:rPr>
-              <a:t>Comparaison des photos</a:t>
-            </a:r>
-          </a:p>
-        </p:txBody>
-      </p:sp>
-      <p:sp>
-        <p:nvSpPr>
-          <p:cNvPr id="20" name="TextBox 19"/>
-          <p:cNvSpPr txBox="1"/>
-          <p:nvPr/>
-        </p:nvSpPr>
-        <p:spPr>
-          <a:xfrm>
-            <a:off x="5684367" y="3383279"/>
-            <a:ext cx="1600199" cy="1188720"/>
-          </a:xfrm>
-          <a:prstGeom prst="rect">
-            <a:avLst/>
-          </a:prstGeom>
-          <a:noFill/>
-        </p:spPr>
-        <p:txBody>
-          <a:bodyPr wrap="square" lIns="0" rIns="0" tIns="0" bIns="0" anchor="t">
-            <a:spAutoFit/>
-          </a:bodyPr>
-          <a:lstStyle/>
-          <a:p>
-            <a:pPr algn="l">
-              <a:spcAft>
-                <a:spcPts val="200"/>
-              </a:spcAft>
-            </a:pPr>
-            <a:r>
-              <a:rPr sz="1500" b="0" i="0">
-                <a:solidFill>
-                  <a:srgbClr val="1B2530"/>
-                </a:solidFill>
-                <a:latin typeface="Arial"/>
-              </a:rPr>
-              <a:t>photo de la CIN ↔ visage du test de vivacité</a:t>
-            </a:r>
-          </a:p>
-        </p:txBody>
-      </p:sp>
-      <p:cxnSp>
-        <p:nvCxnSpPr>
-          <p:cNvPr id="21" name="Connector 20"/>
-          <p:cNvCxnSpPr/>
-          <p:nvPr/>
-        </p:nvCxnSpPr>
-        <p:spPr>
-          <a:xfrm>
-            <a:off x="7458303" y="3383279"/>
-            <a:ext cx="162992" cy="0"/>
-          </a:xfrm>
-          <a:prstGeom prst="line">
-            <a:avLst/>
-          </a:prstGeom>
-          <a:ln w="19050">
+          <p:cNvPr id="10" name="Rounded Rectangle 9"/>
+          <p:cNvSpPr/>
+          <p:nvPr/>
+        </p:nvSpPr>
+        <p:spPr>
+          <a:xfrm>
+            <a:off x="1417319" y="2240280"/>
+            <a:ext cx="1783080" cy="1124840"/>
+          </a:xfrm>
+          <a:prstGeom prst="roundRect">
+            <a:avLst>
+              <a:gd name="adj" fmla="val 6000"/>
+            </a:avLst>
+          </a:prstGeom>
+          <a:noFill/>
+          <a:ln w="12700">
             <a:solidFill>
               <a:srgbClr val="1F3A5F"/>
             </a:solidFill>
-            <a:tailEnd type="triangle" w="med" h="med"/>
           </a:ln>
         </p:spPr>
-      </p:cxnSp>
-      <p:sp>
-        <p:nvSpPr>
-          <p:cNvPr id="22" name="Rectangle 21"/>
+        <p:txBody>
+          <a:bodyPr rtlCol="0" anchor="ctr"/>
+          <a:lstStyle/>
+          <a:p/>
+        </p:txBody>
+      </p:sp>
+      <p:sp>
+        <p:nvSpPr>
+          <p:cNvPr id="11" name="TextBox 10"/>
+          <p:cNvSpPr txBox="1"/>
+          <p:nvPr/>
+        </p:nvSpPr>
+        <p:spPr>
+          <a:xfrm>
+            <a:off x="548640" y="4041648"/>
+            <a:ext cx="3520440" cy="594360"/>
+          </a:xfrm>
+          <a:prstGeom prst="rect">
+            <a:avLst/>
+          </a:prstGeom>
+          <a:noFill/>
+        </p:spPr>
+        <p:txBody>
+          <a:bodyPr wrap="square" lIns="0" rIns="0" tIns="0" bIns="0" anchor="t">
+            <a:spAutoFit/>
+          </a:bodyPr>
+          <a:lstStyle/>
+          <a:p>
+            <a:pPr algn="ctr"/>
+            <a:r>
+              <a:rPr sz="2000" b="1" i="0">
+                <a:solidFill>
+                  <a:srgbClr val="1F3A5F"/>
+                </a:solidFill>
+                <a:latin typeface="Arial"/>
+              </a:rPr>
+              <a:t>Floue</a:t>
+            </a:r>
+          </a:p>
+          <a:p>
+            <a:pPr algn="ctr"/>
+            <a:r>
+              <a:rPr sz="1600" b="0" i="0">
+                <a:solidFill>
+                  <a:srgbClr val="5B6B7A"/>
+                </a:solidFill>
+                <a:latin typeface="Arial"/>
+              </a:rPr>
+              <a:t>image inexploitable</a:t>
+            </a:r>
+          </a:p>
+        </p:txBody>
+      </p:sp>
+      <p:sp>
+        <p:nvSpPr>
+          <p:cNvPr id="12" name="Rectangle 11"/>
           <p:cNvSpPr/>
           <p:nvPr/>
         </p:nvSpPr>
         <p:spPr>
           <a:xfrm>
-            <a:off x="7657871" y="2331720"/>
-            <a:ext cx="1874519" cy="2103120"/>
+            <a:off x="4306824" y="1874519"/>
+            <a:ext cx="3520440" cy="2057400"/>
           </a:xfrm>
           <a:prstGeom prst="rect">
             <a:avLst/>
@@ -16964,10 +17045,8 @@
           <a:solidFill>
             <a:srgbClr val="EEF2F6"/>
           </a:solidFill>
-          <a:ln w="12700">
-            <a:solidFill>
-              <a:srgbClr val="CBD3DB"/>
-            </a:solidFill>
+          <a:ln>
+            <a:noFill/>
           </a:ln>
         </p:spPr>
         <p:txBody>
@@ -16978,145 +17057,90 @@
       </p:sp>
       <p:sp>
         <p:nvSpPr>
-          <p:cNvPr id="23" name="TextBox 22"/>
-          <p:cNvSpPr txBox="1"/>
-          <p:nvPr/>
-        </p:nvSpPr>
-        <p:spPr>
-          <a:xfrm>
-            <a:off x="7795031" y="2441448"/>
-            <a:ext cx="1600199" cy="274320"/>
-          </a:xfrm>
-          <a:prstGeom prst="rect">
-            <a:avLst/>
-          </a:prstGeom>
-          <a:noFill/>
-        </p:spPr>
-        <p:txBody>
-          <a:bodyPr wrap="square" lIns="0" rIns="0" tIns="0" bIns="0" anchor="t">
-            <a:spAutoFit/>
-          </a:bodyPr>
-          <a:lstStyle/>
-          <a:p>
-            <a:pPr algn="l"/>
-            <a:r>
-              <a:rPr sz="1400" b="1" i="0">
-                <a:solidFill>
-                  <a:srgbClr val="2E75B6"/>
-                </a:solidFill>
-                <a:latin typeface="Arial"/>
-              </a:rPr>
-              <a:t>4</a:t>
-            </a:r>
-          </a:p>
-        </p:txBody>
-      </p:sp>
-      <p:sp>
-        <p:nvSpPr>
-          <p:cNvPr id="24" name="TextBox 23"/>
-          <p:cNvSpPr txBox="1"/>
-          <p:nvPr/>
-        </p:nvSpPr>
-        <p:spPr>
-          <a:xfrm>
-            <a:off x="7795031" y="2715768"/>
-            <a:ext cx="1691639" cy="685800"/>
-          </a:xfrm>
-          <a:prstGeom prst="rect">
-            <a:avLst/>
-          </a:prstGeom>
-          <a:noFill/>
-        </p:spPr>
-        <p:txBody>
-          <a:bodyPr wrap="square" lIns="0" rIns="0" tIns="0" bIns="0" anchor="t">
-            <a:spAutoFit/>
-          </a:bodyPr>
-          <a:lstStyle/>
-          <a:p>
-            <a:pPr algn="l"/>
-            <a:r>
-              <a:rPr sz="1600" b="1" i="0">
-                <a:solidFill>
-                  <a:srgbClr val="1F3A5F"/>
-                </a:solidFill>
-                <a:latin typeface="Arial"/>
-              </a:rPr>
-              <a:t>OCR</a:t>
-            </a:r>
-          </a:p>
-        </p:txBody>
-      </p:sp>
-      <p:sp>
-        <p:nvSpPr>
-          <p:cNvPr id="25" name="TextBox 24"/>
-          <p:cNvSpPr txBox="1"/>
-          <p:nvPr/>
-        </p:nvSpPr>
-        <p:spPr>
-          <a:xfrm>
-            <a:off x="7795031" y="3383279"/>
-            <a:ext cx="1600199" cy="1188720"/>
-          </a:xfrm>
-          <a:prstGeom prst="rect">
-            <a:avLst/>
-          </a:prstGeom>
-          <a:noFill/>
-        </p:spPr>
-        <p:txBody>
-          <a:bodyPr wrap="square" lIns="0" rIns="0" tIns="0" bIns="0" anchor="t">
-            <a:spAutoFit/>
-          </a:bodyPr>
-          <a:lstStyle/>
-          <a:p>
-            <a:pPr algn="l">
-              <a:spcAft>
-                <a:spcPts val="200"/>
-              </a:spcAft>
-            </a:pPr>
-            <a:r>
-              <a:rPr sz="1500" b="0" i="0">
-                <a:solidFill>
-                  <a:srgbClr val="1B2530"/>
-                </a:solidFill>
-                <a:latin typeface="Arial"/>
-              </a:rPr>
-              <a:t>lecture des champs de la carte</a:t>
-            </a:r>
-          </a:p>
-        </p:txBody>
-      </p:sp>
-      <p:cxnSp>
-        <p:nvCxnSpPr>
-          <p:cNvPr id="26" name="Connector 25"/>
-          <p:cNvCxnSpPr/>
-          <p:nvPr/>
-        </p:nvCxnSpPr>
-        <p:spPr>
-          <a:xfrm>
-            <a:off x="9568967" y="3383279"/>
-            <a:ext cx="162992" cy="0"/>
-          </a:xfrm>
-          <a:prstGeom prst="line">
-            <a:avLst/>
-          </a:prstGeom>
-          <a:ln w="19050">
+          <p:cNvPr id="13" name="Rounded Rectangle 12"/>
+          <p:cNvSpPr/>
+          <p:nvPr/>
+        </p:nvSpPr>
+        <p:spPr>
+          <a:xfrm rot="20760000">
+            <a:off x="5221224" y="2286000"/>
+            <a:ext cx="1783080" cy="1124712"/>
+          </a:xfrm>
+          <a:prstGeom prst="roundRect">
+            <a:avLst>
+              <a:gd name="adj" fmla="val 6000"/>
+            </a:avLst>
+          </a:prstGeom>
+          <a:noFill/>
+          <a:ln w="15875">
             <a:solidFill>
               <a:srgbClr val="1F3A5F"/>
             </a:solidFill>
-            <a:tailEnd type="triangle" w="med" h="med"/>
           </a:ln>
         </p:spPr>
-      </p:cxnSp>
-      <p:sp>
-        <p:nvSpPr>
-          <p:cNvPr id="27" name="Rectangle 26"/>
+        <p:txBody>
+          <a:bodyPr rtlCol="0" anchor="ctr"/>
+          <a:lstStyle/>
+          <a:p/>
+        </p:txBody>
+      </p:sp>
+      <p:sp>
+        <p:nvSpPr>
+          <p:cNvPr id="14" name="TextBox 13"/>
+          <p:cNvSpPr txBox="1"/>
+          <p:nvPr/>
+        </p:nvSpPr>
+        <p:spPr>
+          <a:xfrm>
+            <a:off x="4306824" y="4041648"/>
+            <a:ext cx="3520440" cy="594360"/>
+          </a:xfrm>
+          <a:prstGeom prst="rect">
+            <a:avLst/>
+          </a:prstGeom>
+          <a:noFill/>
+        </p:spPr>
+        <p:txBody>
+          <a:bodyPr wrap="square" lIns="0" rIns="0" tIns="0" bIns="0" anchor="t">
+            <a:spAutoFit/>
+          </a:bodyPr>
+          <a:lstStyle/>
+          <a:p>
+            <a:pPr algn="ctr"/>
+            <a:r>
+              <a:rPr sz="2000" b="1" i="0">
+                <a:solidFill>
+                  <a:srgbClr val="1F3A5F"/>
+                </a:solidFill>
+                <a:latin typeface="Arial"/>
+              </a:rPr>
+              <a:t>De travers</a:t>
+            </a:r>
+          </a:p>
+          <a:p>
+            <a:pPr algn="ctr"/>
+            <a:r>
+              <a:rPr sz="1600" b="0" i="0">
+                <a:solidFill>
+                  <a:srgbClr val="5B6B7A"/>
+                </a:solidFill>
+                <a:latin typeface="Arial"/>
+              </a:rPr>
+              <a:t>carte mal cadrée</a:t>
+            </a:r>
+          </a:p>
+        </p:txBody>
+      </p:sp>
+      <p:sp>
+        <p:nvSpPr>
+          <p:cNvPr id="15" name="Rectangle 14"/>
           <p:cNvSpPr/>
           <p:nvPr/>
         </p:nvSpPr>
         <p:spPr>
           <a:xfrm>
-            <a:off x="9768535" y="2331720"/>
-            <a:ext cx="1874519" cy="2103120"/>
+            <a:off x="8065008" y="1874519"/>
+            <a:ext cx="3520440" cy="2057400"/>
           </a:xfrm>
           <a:prstGeom prst="rect">
             <a:avLst/>
@@ -17124,9 +17148,38 @@
           <a:solidFill>
             <a:srgbClr val="EEF2F6"/>
           </a:solidFill>
-          <a:ln w="12700">
+          <a:ln>
+            <a:noFill/>
+          </a:ln>
+        </p:spPr>
+        <p:txBody>
+          <a:bodyPr rtlCol="0" anchor="ctr"/>
+          <a:lstStyle/>
+          <a:p/>
+        </p:txBody>
+      </p:sp>
+      <p:sp>
+        <p:nvSpPr>
+          <p:cNvPr id="16" name="Rounded Rectangle 15"/>
+          <p:cNvSpPr/>
+          <p:nvPr/>
+        </p:nvSpPr>
+        <p:spPr>
+          <a:xfrm>
+            <a:off x="8750808" y="2212848"/>
+            <a:ext cx="1691640" cy="1069848"/>
+          </a:xfrm>
+          <a:prstGeom prst="roundRect">
+            <a:avLst>
+              <a:gd name="adj" fmla="val 6000"/>
+            </a:avLst>
+          </a:prstGeom>
+          <a:solidFill>
+            <a:srgbClr val="FFFFFF"/>
+          </a:solidFill>
+          <a:ln w="15875">
             <a:solidFill>
-              <a:srgbClr val="CBD3DB"/>
+              <a:srgbClr val="1F3A5F"/>
             </a:solidFill>
           </a:ln>
         </p:spPr>
@@ -17138,14 +17191,14 @@
       </p:sp>
       <p:sp>
         <p:nvSpPr>
-          <p:cNvPr id="28" name="TextBox 27"/>
-          <p:cNvSpPr txBox="1"/>
-          <p:nvPr/>
-        </p:nvSpPr>
-        <p:spPr>
-          <a:xfrm>
-            <a:off x="9905695" y="2441448"/>
-            <a:ext cx="1600199" cy="274320"/>
+          <p:cNvPr id="17" name="TextBox 16"/>
+          <p:cNvSpPr txBox="1"/>
+          <p:nvPr/>
+        </p:nvSpPr>
+        <p:spPr>
+          <a:xfrm>
+            <a:off x="8750808" y="2532888"/>
+            <a:ext cx="1691640" cy="365760"/>
           </a:xfrm>
           <a:prstGeom prst="rect">
             <a:avLst/>
@@ -17158,64 +17211,186 @@
           </a:bodyPr>
           <a:lstStyle/>
           <a:p>
+            <a:pPr algn="ctr"/>
+            <a:r>
+              <a:rPr sz="1600" b="0" i="0">
+                <a:solidFill>
+                  <a:srgbClr val="1F3A5F"/>
+                </a:solidFill>
+                <a:latin typeface="Arial"/>
+              </a:rPr>
+              <a:t>recto</a:t>
+            </a:r>
+          </a:p>
+        </p:txBody>
+      </p:sp>
+      <p:sp>
+        <p:nvSpPr>
+          <p:cNvPr id="18" name="Rounded Rectangle 17"/>
+          <p:cNvSpPr/>
+          <p:nvPr/>
+        </p:nvSpPr>
+        <p:spPr>
+          <a:xfrm>
+            <a:off x="9134856" y="2404872"/>
+            <a:ext cx="1691640" cy="1069848"/>
+          </a:xfrm>
+          <a:prstGeom prst="roundRect">
+            <a:avLst>
+              <a:gd name="adj" fmla="val 6000"/>
+            </a:avLst>
+          </a:prstGeom>
+          <a:solidFill>
+            <a:srgbClr val="FFFFFF"/>
+          </a:solidFill>
+          <a:ln w="15875">
+            <a:solidFill>
+              <a:srgbClr val="1F3A5F"/>
+            </a:solidFill>
+          </a:ln>
+        </p:spPr>
+        <p:txBody>
+          <a:bodyPr rtlCol="0" anchor="ctr"/>
+          <a:lstStyle/>
+          <a:p/>
+        </p:txBody>
+      </p:sp>
+      <p:sp>
+        <p:nvSpPr>
+          <p:cNvPr id="19" name="TextBox 18"/>
+          <p:cNvSpPr txBox="1"/>
+          <p:nvPr/>
+        </p:nvSpPr>
+        <p:spPr>
+          <a:xfrm>
+            <a:off x="9134856" y="2724912"/>
+            <a:ext cx="1691640" cy="365760"/>
+          </a:xfrm>
+          <a:prstGeom prst="rect">
+            <a:avLst/>
+          </a:prstGeom>
+          <a:noFill/>
+        </p:spPr>
+        <p:txBody>
+          <a:bodyPr wrap="square" lIns="0" rIns="0" tIns="0" bIns="0" anchor="t">
+            <a:spAutoFit/>
+          </a:bodyPr>
+          <a:lstStyle/>
+          <a:p>
+            <a:pPr algn="ctr"/>
+            <a:r>
+              <a:rPr sz="1600" b="0" i="0">
+                <a:solidFill>
+                  <a:srgbClr val="1F3A5F"/>
+                </a:solidFill>
+                <a:latin typeface="Arial"/>
+              </a:rPr>
+              <a:t>recto</a:t>
+            </a:r>
+          </a:p>
+        </p:txBody>
+      </p:sp>
+      <p:sp>
+        <p:nvSpPr>
+          <p:cNvPr id="20" name="TextBox 19"/>
+          <p:cNvSpPr txBox="1"/>
+          <p:nvPr/>
+        </p:nvSpPr>
+        <p:spPr>
+          <a:xfrm>
+            <a:off x="8065008" y="4041648"/>
+            <a:ext cx="3520440" cy="594360"/>
+          </a:xfrm>
+          <a:prstGeom prst="rect">
+            <a:avLst/>
+          </a:prstGeom>
+          <a:noFill/>
+        </p:spPr>
+        <p:txBody>
+          <a:bodyPr wrap="square" lIns="0" rIns="0" tIns="0" bIns="0" anchor="t">
+            <a:spAutoFit/>
+          </a:bodyPr>
+          <a:lstStyle/>
+          <a:p>
+            <a:pPr algn="ctr"/>
+            <a:r>
+              <a:rPr sz="2000" b="1" i="0">
+                <a:solidFill>
+                  <a:srgbClr val="1F3A5F"/>
+                </a:solidFill>
+                <a:latin typeface="Arial"/>
+              </a:rPr>
+              <a:t>Deux fois le recto</a:t>
+            </a:r>
+          </a:p>
+          <a:p>
+            <a:pPr algn="ctr"/>
+            <a:r>
+              <a:rPr sz="1600" b="0" i="0">
+                <a:solidFill>
+                  <a:srgbClr val="5B6B7A"/>
+                </a:solidFill>
+                <a:latin typeface="Arial"/>
+              </a:rPr>
+              <a:t>verso jamais fourni</a:t>
+            </a:r>
+          </a:p>
+        </p:txBody>
+      </p:sp>
+      <p:sp>
+        <p:nvSpPr>
+          <p:cNvPr id="21" name="TextBox 20"/>
+          <p:cNvSpPr txBox="1"/>
+          <p:nvPr/>
+        </p:nvSpPr>
+        <p:spPr>
+          <a:xfrm>
+            <a:off x="548640" y="4846320"/>
+            <a:ext cx="7589520" cy="1097280"/>
+          </a:xfrm>
+          <a:prstGeom prst="rect">
+            <a:avLst/>
+          </a:prstGeom>
+          <a:noFill/>
+        </p:spPr>
+        <p:txBody>
+          <a:bodyPr wrap="square" lIns="0" rIns="0" tIns="0" bIns="0" anchor="t">
+            <a:spAutoFit/>
+          </a:bodyPr>
+          <a:lstStyle/>
+          <a:p>
             <a:pPr algn="l"/>
             <a:r>
-              <a:rPr sz="1400" b="1" i="0">
-                <a:solidFill>
-                  <a:srgbClr val="2E75B6"/>
-                </a:solidFill>
-                <a:latin typeface="Arial"/>
-              </a:rPr>
-              <a:t>5</a:t>
-            </a:r>
-          </a:p>
-        </p:txBody>
-      </p:sp>
-      <p:sp>
-        <p:nvSpPr>
-          <p:cNvPr id="29" name="TextBox 28"/>
-          <p:cNvSpPr txBox="1"/>
-          <p:nvPr/>
-        </p:nvSpPr>
-        <p:spPr>
-          <a:xfrm>
-            <a:off x="9905695" y="2715768"/>
-            <a:ext cx="1691639" cy="685800"/>
-          </a:xfrm>
-          <a:prstGeom prst="rect">
-            <a:avLst/>
-          </a:prstGeom>
-          <a:noFill/>
-        </p:spPr>
-        <p:txBody>
-          <a:bodyPr wrap="square" lIns="0" rIns="0" tIns="0" bIns="0" anchor="t">
-            <a:spAutoFit/>
-          </a:bodyPr>
-          <a:lstStyle/>
-          <a:p>
-            <a:pPr algn="l"/>
-            <a:r>
-              <a:rPr sz="1600" b="1" i="0">
+              <a:rPr sz="2000" b="1" i="0">
                 <a:solidFill>
                   <a:srgbClr val="1F3A5F"/>
                 </a:solidFill>
                 <a:latin typeface="Arial"/>
               </a:rPr>
-              <a:t>Enregistrement</a:t>
-            </a:r>
-          </a:p>
-        </p:txBody>
-      </p:sp>
-      <p:sp>
-        <p:nvSpPr>
-          <p:cNvPr id="30" name="TextBox 29"/>
-          <p:cNvSpPr txBox="1"/>
-          <p:nvPr/>
-        </p:nvSpPr>
-        <p:spPr>
-          <a:xfrm>
-            <a:off x="9905695" y="3383279"/>
-            <a:ext cx="1600199" cy="1188720"/>
+              <a:t>Problématique — </a:t>
+            </a:r>
+            <a:r>
+              <a:rPr sz="2000" b="0" i="0">
+                <a:solidFill>
+                  <a:srgbClr val="1B2530"/>
+                </a:solidFill>
+                <a:latin typeface="Arial"/>
+              </a:rPr>
+              <a:t>comment détecter de façon fiable et en temps réel les contours d'une CIN dans un flux caméra mobile, quels que soient l'éclairage et l'arrière-plan ?</a:t>
+            </a:r>
+          </a:p>
+        </p:txBody>
+      </p:sp>
+      <p:sp>
+        <p:nvSpPr>
+          <p:cNvPr id="22" name="TextBox 21"/>
+          <p:cNvSpPr txBox="1"/>
+          <p:nvPr/>
+        </p:nvSpPr>
+        <p:spPr>
+          <a:xfrm>
+            <a:off x="8503920" y="4846320"/>
+            <a:ext cx="3139135" cy="1188720"/>
           </a:xfrm>
           <a:prstGeom prst="rect">
             <a:avLst/>
@@ -17230,217 +17405,26 @@
           <a:p>
             <a:pPr algn="l">
               <a:spcAft>
-                <a:spcPts val="200"/>
+                <a:spcPts val="600"/>
               </a:spcAft>
             </a:pPr>
             <a:r>
-              <a:rPr sz="1500" b="0" i="0">
-                <a:solidFill>
-                  <a:srgbClr val="1B2530"/>
-                </a:solidFill>
-                <a:latin typeface="Arial"/>
-              </a:rPr>
-              <a:t>sauvegarde du résultat</a:t>
-            </a:r>
-          </a:p>
-        </p:txBody>
-      </p:sp>
-      <p:cxnSp>
-        <p:nvCxnSpPr>
-          <p:cNvPr id="31" name="Connector 30"/>
-          <p:cNvCxnSpPr/>
-          <p:nvPr/>
-        </p:nvCxnSpPr>
-        <p:spPr>
-          <a:xfrm>
-            <a:off x="548640" y="2148840"/>
-            <a:ext cx="2651760" cy="0"/>
-          </a:xfrm>
-          <a:prstGeom prst="line">
-            <a:avLst/>
-          </a:prstGeom>
-          <a:ln w="38100">
-            <a:solidFill>
-              <a:srgbClr val="2E75B6"/>
-            </a:solidFill>
-          </a:ln>
-        </p:spPr>
-      </p:cxnSp>
-      <p:sp>
-        <p:nvSpPr>
-          <p:cNvPr id="32" name="TextBox 31"/>
-          <p:cNvSpPr txBox="1"/>
-          <p:nvPr/>
-        </p:nvSpPr>
-        <p:spPr>
-          <a:xfrm>
-            <a:off x="548640" y="1828800"/>
-            <a:ext cx="2651760" cy="274320"/>
-          </a:xfrm>
-          <a:prstGeom prst="rect">
-            <a:avLst/>
-          </a:prstGeom>
-          <a:noFill/>
-        </p:spPr>
-        <p:txBody>
-          <a:bodyPr wrap="square" lIns="0" rIns="0" tIns="0" bIns="0" anchor="t">
-            <a:spAutoFit/>
-          </a:bodyPr>
-          <a:lstStyle/>
-          <a:p>
-            <a:pPr algn="l"/>
-            <a:r>
-              <a:rPr sz="1300" b="1" i="0">
-                <a:solidFill>
-                  <a:srgbClr val="2E75B6"/>
-                </a:solidFill>
-                <a:latin typeface="Arial"/>
-              </a:rPr>
-              <a:t>CE STAGE</a:t>
-            </a:r>
-          </a:p>
-        </p:txBody>
-      </p:sp>
-      <p:cxnSp>
-        <p:nvCxnSpPr>
-          <p:cNvPr id="33" name="Connector 32"/>
-          <p:cNvCxnSpPr/>
-          <p:nvPr/>
-        </p:nvCxnSpPr>
-        <p:spPr>
-          <a:xfrm>
-            <a:off x="3436543" y="2148840"/>
-            <a:ext cx="8206512" cy="0"/>
-          </a:xfrm>
-          <a:prstGeom prst="line">
-            <a:avLst/>
-          </a:prstGeom>
-          <a:ln w="19050">
-            <a:solidFill>
-              <a:srgbClr val="5B6B7A"/>
-            </a:solidFill>
-          </a:ln>
-        </p:spPr>
-      </p:cxnSp>
-      <p:sp>
-        <p:nvSpPr>
-          <p:cNvPr id="34" name="TextBox 33"/>
-          <p:cNvSpPr txBox="1"/>
-          <p:nvPr/>
-        </p:nvSpPr>
-        <p:spPr>
-          <a:xfrm>
-            <a:off x="3436543" y="1828800"/>
-            <a:ext cx="5486400" cy="274320"/>
-          </a:xfrm>
-          <a:prstGeom prst="rect">
-            <a:avLst/>
-          </a:prstGeom>
-          <a:noFill/>
-        </p:spPr>
-        <p:txBody>
-          <a:bodyPr wrap="square" lIns="0" rIns="0" tIns="0" bIns="0" anchor="t">
-            <a:spAutoFit/>
-          </a:bodyPr>
-          <a:lstStyle/>
-          <a:p>
-            <a:pPr algn="l"/>
-            <a:r>
-              <a:rPr sz="1300" b="1" i="0">
+              <a:rPr sz="1600" b="1" i="0">
+                <a:solidFill>
+                  <a:srgbClr val="1F3A5F"/>
+                </a:solidFill>
+                <a:latin typeface="Arial"/>
+              </a:rPr>
+              <a:t>Sans guidage : </a:t>
+            </a:r>
+            <a:r>
+              <a:rPr sz="1600" b="0" i="0">
                 <a:solidFill>
                   <a:srgbClr val="5B6B7A"/>
                 </a:solidFill>
                 <a:latin typeface="Arial"/>
               </a:rPr>
-              <a:t>SUITE DU PARCOURS AVATAR-ID</a:t>
-            </a:r>
-          </a:p>
-        </p:txBody>
-      </p:sp>
-      <p:sp>
-        <p:nvSpPr>
-          <p:cNvPr id="35" name="TextBox 34"/>
-          <p:cNvSpPr txBox="1"/>
-          <p:nvPr/>
-        </p:nvSpPr>
-        <p:spPr>
-          <a:xfrm>
-            <a:off x="548640" y="4754880"/>
-            <a:ext cx="5272887" cy="1280160"/>
-          </a:xfrm>
-          <a:prstGeom prst="rect">
-            <a:avLst/>
-          </a:prstGeom>
-          <a:noFill/>
-        </p:spPr>
-        <p:txBody>
-          <a:bodyPr wrap="square" lIns="0" rIns="0" tIns="0" bIns="0" anchor="t">
-            <a:spAutoFit/>
-          </a:bodyPr>
-          <a:lstStyle/>
-          <a:p>
-            <a:pPr algn="l"/>
-            <a:r>
-              <a:rPr sz="1800" b="1" i="0">
-                <a:solidFill>
-                  <a:srgbClr val="1F3A5F"/>
-                </a:solidFill>
-                <a:latin typeface="Arial"/>
-              </a:rPr>
-              <a:t>Ce que le module transmet : </a:t>
-            </a:r>
-            <a:r>
-              <a:rPr sz="1800" b="0" i="0">
-                <a:solidFill>
-                  <a:srgbClr val="1B2530"/>
-                </a:solidFill>
-                <a:latin typeface="Arial"/>
-              </a:rPr>
-              <a:t>le recto et le verso redressés et orientés, ainsi que la page A4 composée.</a:t>
-            </a:r>
-          </a:p>
-        </p:txBody>
-      </p:sp>
-      <p:sp>
-        <p:nvSpPr>
-          <p:cNvPr id="36" name="TextBox 35"/>
-          <p:cNvSpPr txBox="1"/>
-          <p:nvPr/>
-        </p:nvSpPr>
-        <p:spPr>
-          <a:xfrm>
-            <a:off x="6370167" y="4754880"/>
-            <a:ext cx="5272887" cy="1280160"/>
-          </a:xfrm>
-          <a:prstGeom prst="rect">
-            <a:avLst/>
-          </a:prstGeom>
-          <a:noFill/>
-        </p:spPr>
-        <p:txBody>
-          <a:bodyPr wrap="square" lIns="0" rIns="0" tIns="0" bIns="0" anchor="t">
-            <a:spAutoFit/>
-          </a:bodyPr>
-          <a:lstStyle/>
-          <a:p>
-            <a:pPr algn="l"/>
-            <a:r>
-              <a:rPr sz="1800" b="1" i="0">
-                <a:solidFill>
-                  <a:srgbClr val="1F3A5F"/>
-                </a:solidFill>
-                <a:latin typeface="Arial"/>
-              </a:rPr>
-              <a:t>Pourquoi la qualité compte : </a:t>
-            </a:r>
-            <a:r>
-              <a:rPr sz="1800" b="0" i="0">
-                <a:solidFill>
-                  <a:srgbClr val="1B2530"/>
-                </a:solidFill>
-                <a:latin typeface="Arial"/>
-              </a:rPr>
-              <a:t>une carte nette, bien cadrée et à l'endroit alimente directement la comparaison des photos et l'OCR.</a:t>
+              <a:t>contrôle humain coûteux, nouvelle saisie, et étapes suivantes (photos, OCR) dégradées.</a:t>
             </a:r>
           </a:p>
         </p:txBody>
@@ -18705,8 +18689,8 @@
           <p:nvPr/>
         </p:nvGraphicFramePr>
         <p:xfrm>
-          <a:off x="548640" y="1874519"/>
-          <a:ext cx="11094415" cy="3273552"/>
+          <a:off x="548640" y="1828800"/>
+          <a:ext cx="11094415" cy="2907792"/>
         </p:xfrm>
         <a:graphic>
           <a:graphicData uri="http://schemas.openxmlformats.org/drawingml/2006/table">
@@ -18718,7 +18702,7 @@
                 <a:gridCol w="2743200"/>
                 <a:gridCol w="2864815"/>
               </a:tblGrid>
-              <a:tr h="786384">
+              <a:tr h="713232">
                 <a:tc>
                   <a:txBody>
                     <a:bodyPr/>
@@ -18841,7 +18825,7 @@
                   </a:tcPr>
                 </a:tc>
               </a:tr>
-              <a:tr h="621792">
+              <a:tr h="548640">
                 <a:tc>
                   <a:txBody>
                     <a:bodyPr/>
@@ -18931,7 +18915,7 @@
                   </a:tcPr>
                 </a:tc>
               </a:tr>
-              <a:tr h="621792">
+              <a:tr h="548640">
                 <a:tc>
                   <a:txBody>
                     <a:bodyPr/>
@@ -19032,7 +19016,7 @@
                   </a:tcPr>
                 </a:tc>
               </a:tr>
-              <a:tr h="621792">
+              <a:tr h="548640">
                 <a:tc>
                   <a:txBody>
                     <a:bodyPr/>
@@ -19122,7 +19106,7 @@
                   </a:tcPr>
                 </a:tc>
               </a:tr>
-              <a:tr h="621792">
+              <a:tr h="548640">
                 <a:tc>
                   <a:txBody>
                     <a:bodyPr/>
@@ -19224,8 +19208,220 @@
         </p:nvSpPr>
         <p:spPr>
           <a:xfrm>
-            <a:off x="548640" y="5349240"/>
-            <a:ext cx="11094415" cy="731520"/>
+            <a:off x="548640" y="5138928"/>
+            <a:ext cx="1828800" cy="457200"/>
+          </a:xfrm>
+          <a:prstGeom prst="rect">
+            <a:avLst/>
+          </a:prstGeom>
+          <a:noFill/>
+        </p:spPr>
+        <p:txBody>
+          <a:bodyPr wrap="square" lIns="0" rIns="0" tIns="0" bIns="0" anchor="ctr">
+            <a:spAutoFit/>
+          </a:bodyPr>
+          <a:lstStyle/>
+          <a:p>
+            <a:pPr algn="l"/>
+            <a:r>
+              <a:rPr sz="1300" b="1" i="0">
+                <a:solidFill>
+                  <a:srgbClr val="2E75B6"/>
+                </a:solidFill>
+                <a:latin typeface="Arial"/>
+              </a:rPr>
+              <a:t>PILE RETENUE</a:t>
+            </a:r>
+          </a:p>
+        </p:txBody>
+      </p:sp>
+      <p:pic>
+        <p:nvPicPr>
+          <p:cNvPr id="9" name="Picture 8" descr="Logo Flutter"/>
+          <p:cNvPicPr>
+            <a:picLocks noChangeAspect="1"/>
+          </p:cNvPicPr>
+          <p:nvPr/>
+        </p:nvPicPr>
+        <p:blipFill>
+          <a:blip r:embed="rId2"/>
+          <a:stretch>
+            <a:fillRect/>
+          </a:stretch>
+        </p:blipFill>
+        <p:spPr>
+          <a:xfrm>
+            <a:off x="2377440" y="5120640"/>
+            <a:ext cx="407365" cy="502920"/>
+          </a:xfrm>
+          <a:prstGeom prst="rect">
+            <a:avLst/>
+          </a:prstGeom>
+        </p:spPr>
+      </p:pic>
+      <p:sp>
+        <p:nvSpPr>
+          <p:cNvPr id="10" name="TextBox 9"/>
+          <p:cNvSpPr txBox="1"/>
+          <p:nvPr/>
+        </p:nvSpPr>
+        <p:spPr>
+          <a:xfrm>
+            <a:off x="2921965" y="5120640"/>
+            <a:ext cx="2926080" cy="502920"/>
+          </a:xfrm>
+          <a:prstGeom prst="rect">
+            <a:avLst/>
+          </a:prstGeom>
+          <a:noFill/>
+        </p:spPr>
+        <p:txBody>
+          <a:bodyPr wrap="square" lIns="0" rIns="0" tIns="0" bIns="0" anchor="ctr">
+            <a:spAutoFit/>
+          </a:bodyPr>
+          <a:lstStyle/>
+          <a:p>
+            <a:pPr algn="l"/>
+            <a:r>
+              <a:rPr sz="1800" b="1" i="0">
+                <a:solidFill>
+                  <a:srgbClr val="1F3A5F"/>
+                </a:solidFill>
+                <a:latin typeface="Arial"/>
+              </a:rPr>
+              <a:t>Flutter</a:t>
+            </a:r>
+          </a:p>
+        </p:txBody>
+      </p:sp>
+      <p:pic>
+        <p:nvPicPr>
+          <p:cNvPr id="11" name="Picture 10" descr="Logo Dart"/>
+          <p:cNvPicPr>
+            <a:picLocks noChangeAspect="1"/>
+          </p:cNvPicPr>
+          <p:nvPr/>
+        </p:nvPicPr>
+        <p:blipFill>
+          <a:blip r:embed="rId3"/>
+          <a:stretch>
+            <a:fillRect/>
+          </a:stretch>
+        </p:blipFill>
+        <p:spPr>
+          <a:xfrm>
+            <a:off x="4293565" y="5120640"/>
+            <a:ext cx="502920" cy="502920"/>
+          </a:xfrm>
+          <a:prstGeom prst="rect">
+            <a:avLst/>
+          </a:prstGeom>
+        </p:spPr>
+      </p:pic>
+      <p:sp>
+        <p:nvSpPr>
+          <p:cNvPr id="12" name="TextBox 11"/>
+          <p:cNvSpPr txBox="1"/>
+          <p:nvPr/>
+        </p:nvSpPr>
+        <p:spPr>
+          <a:xfrm>
+            <a:off x="4933645" y="5120640"/>
+            <a:ext cx="2926080" cy="502920"/>
+          </a:xfrm>
+          <a:prstGeom prst="rect">
+            <a:avLst/>
+          </a:prstGeom>
+          <a:noFill/>
+        </p:spPr>
+        <p:txBody>
+          <a:bodyPr wrap="square" lIns="0" rIns="0" tIns="0" bIns="0" anchor="ctr">
+            <a:spAutoFit/>
+          </a:bodyPr>
+          <a:lstStyle/>
+          <a:p>
+            <a:pPr algn="l"/>
+            <a:r>
+              <a:rPr sz="1800" b="1" i="0">
+                <a:solidFill>
+                  <a:srgbClr val="1F3A5F"/>
+                </a:solidFill>
+                <a:latin typeface="Arial"/>
+              </a:rPr>
+              <a:t>Dart</a:t>
+            </a:r>
+          </a:p>
+        </p:txBody>
+      </p:sp>
+      <p:pic>
+        <p:nvPicPr>
+          <p:cNvPr id="13" name="Picture 12" descr="Logo OpenCV"/>
+          <p:cNvPicPr>
+            <a:picLocks noChangeAspect="1"/>
+          </p:cNvPicPr>
+          <p:nvPr/>
+        </p:nvPicPr>
+        <p:blipFill>
+          <a:blip r:embed="rId4"/>
+          <a:stretch>
+            <a:fillRect/>
+          </a:stretch>
+        </p:blipFill>
+        <p:spPr>
+          <a:xfrm>
+            <a:off x="5939485" y="5120640"/>
+            <a:ext cx="540774" cy="502920"/>
+          </a:xfrm>
+          <a:prstGeom prst="rect">
+            <a:avLst/>
+          </a:prstGeom>
+        </p:spPr>
+      </p:pic>
+      <p:sp>
+        <p:nvSpPr>
+          <p:cNvPr id="14" name="TextBox 13"/>
+          <p:cNvSpPr txBox="1"/>
+          <p:nvPr/>
+        </p:nvSpPr>
+        <p:spPr>
+          <a:xfrm>
+            <a:off x="6617419" y="5120640"/>
+            <a:ext cx="2926080" cy="502920"/>
+          </a:xfrm>
+          <a:prstGeom prst="rect">
+            <a:avLst/>
+          </a:prstGeom>
+          <a:noFill/>
+        </p:spPr>
+        <p:txBody>
+          <a:bodyPr wrap="square" lIns="0" rIns="0" tIns="0" bIns="0" anchor="ctr">
+            <a:spAutoFit/>
+          </a:bodyPr>
+          <a:lstStyle/>
+          <a:p>
+            <a:pPr algn="l"/>
+            <a:r>
+              <a:rPr sz="1800" b="1" i="0">
+                <a:solidFill>
+                  <a:srgbClr val="1F3A5F"/>
+                </a:solidFill>
+                <a:latin typeface="Arial"/>
+              </a:rPr>
+              <a:t>OpenCV · opencv_dart</a:t>
+            </a:r>
+          </a:p>
+        </p:txBody>
+      </p:sp>
+      <p:sp>
+        <p:nvSpPr>
+          <p:cNvPr id="15" name="TextBox 14"/>
+          <p:cNvSpPr txBox="1"/>
+          <p:nvPr/>
+        </p:nvSpPr>
+        <p:spPr>
+          <a:xfrm>
+            <a:off x="548640" y="5833872"/>
+            <a:ext cx="11094415" cy="457200"/>
           </a:xfrm>
           <a:prstGeom prst="rect">
             <a:avLst/>
@@ -19255,7 +19451,7 @@
                 </a:solidFill>
                 <a:latin typeface="Arial"/>
               </a:rPr>
-              <a:t>Choix par élimination sur les contraintes du projet ; Vision/VisionKit (iOS) écarté pour la même raison : deux chaînes de détection à maintenir.</a:t>
+              <a:t>Vision/VisionKit (iOS) écarté aussi : deux chaînes de détection à maintenir.</a:t>
             </a:r>
           </a:p>
         </p:txBody>
@@ -22944,7 +23140,7 @@
         <p:spPr>
           <a:xfrm>
             <a:off x="548640" y="2286000"/>
-            <a:ext cx="3383280" cy="2743200"/>
+            <a:ext cx="3383280" cy="1554480"/>
           </a:xfrm>
           <a:prstGeom prst="rect">
             <a:avLst/>
@@ -22965,14 +23161,202 @@
                 </a:solidFill>
                 <a:latin typeface="Arial"/>
               </a:rPr>
-              <a:t>Carte claire sur table blanche ou feuille de papier : détection très souvent en échec, alors qu'elle marchait sur fond sombre.</a:t>
-            </a:r>
-          </a:p>
-        </p:txBody>
-      </p:sp>
-      <p:sp>
-        <p:nvSpPr>
-          <p:cNvPr id="13" name="TextBox 12"/>
+              <a:t>Carte claire sur table blanche : détection souvent en échec, alors qu'elle marchait sur fond sombre.</a:t>
+            </a:r>
+          </a:p>
+        </p:txBody>
+      </p:sp>
+      <p:sp>
+        <p:nvSpPr>
+          <p:cNvPr id="13" name="Rectangle 12"/>
+          <p:cNvSpPr/>
+          <p:nvPr/>
+        </p:nvSpPr>
+        <p:spPr>
+          <a:xfrm>
+            <a:off x="548640" y="3931920"/>
+            <a:ext cx="1600200" cy="960120"/>
+          </a:xfrm>
+          <a:prstGeom prst="rect">
+            <a:avLst/>
+          </a:prstGeom>
+          <a:solidFill>
+            <a:srgbClr val="2B313A"/>
+          </a:solidFill>
+          <a:ln>
+            <a:noFill/>
+          </a:ln>
+        </p:spPr>
+        <p:txBody>
+          <a:bodyPr rtlCol="0" anchor="ctr"/>
+          <a:lstStyle/>
+          <a:p/>
+        </p:txBody>
+      </p:sp>
+      <p:sp>
+        <p:nvSpPr>
+          <p:cNvPr id="14" name="Rounded Rectangle 13"/>
+          <p:cNvSpPr/>
+          <p:nvPr/>
+        </p:nvSpPr>
+        <p:spPr>
+          <a:xfrm>
+            <a:off x="841247" y="4078224"/>
+            <a:ext cx="1014984" cy="640080"/>
+          </a:xfrm>
+          <a:prstGeom prst="roundRect">
+            <a:avLst>
+              <a:gd name="adj" fmla="val 8000"/>
+            </a:avLst>
+          </a:prstGeom>
+          <a:solidFill>
+            <a:srgbClr val="FFFFFF"/>
+          </a:solidFill>
+          <a:ln w="12700">
+            <a:solidFill>
+              <a:srgbClr val="FFFFFF"/>
+            </a:solidFill>
+          </a:ln>
+        </p:spPr>
+        <p:txBody>
+          <a:bodyPr rtlCol="0" anchor="ctr"/>
+          <a:lstStyle/>
+          <a:p/>
+        </p:txBody>
+      </p:sp>
+      <p:sp>
+        <p:nvSpPr>
+          <p:cNvPr id="15" name="TextBox 14"/>
+          <p:cNvSpPr txBox="1"/>
+          <p:nvPr/>
+        </p:nvSpPr>
+        <p:spPr>
+          <a:xfrm>
+            <a:off x="548640" y="4937760"/>
+            <a:ext cx="1600200" cy="274320"/>
+          </a:xfrm>
+          <a:prstGeom prst="rect">
+            <a:avLst/>
+          </a:prstGeom>
+          <a:noFill/>
+        </p:spPr>
+        <p:txBody>
+          <a:bodyPr wrap="square" lIns="0" rIns="0" tIns="0" bIns="0" anchor="t">
+            <a:spAutoFit/>
+          </a:bodyPr>
+          <a:lstStyle/>
+          <a:p>
+            <a:pPr algn="ctr"/>
+            <a:r>
+              <a:rPr sz="1200" b="0" i="0">
+                <a:solidFill>
+                  <a:srgbClr val="5B6B7A"/>
+                </a:solidFill>
+                <a:latin typeface="Arial"/>
+              </a:rPr>
+              <a:t>fond sombre : bord net</a:t>
+            </a:r>
+          </a:p>
+        </p:txBody>
+      </p:sp>
+      <p:sp>
+        <p:nvSpPr>
+          <p:cNvPr id="16" name="Rectangle 15"/>
+          <p:cNvSpPr/>
+          <p:nvPr/>
+        </p:nvSpPr>
+        <p:spPr>
+          <a:xfrm>
+            <a:off x="2286000" y="3931920"/>
+            <a:ext cx="1600200" cy="960120"/>
+          </a:xfrm>
+          <a:prstGeom prst="rect">
+            <a:avLst/>
+          </a:prstGeom>
+          <a:solidFill>
+            <a:srgbClr val="F1F3F5"/>
+          </a:solidFill>
+          <a:ln w="9525">
+            <a:solidFill>
+              <a:srgbClr val="CBD3DB"/>
+            </a:solidFill>
+          </a:ln>
+        </p:spPr>
+        <p:txBody>
+          <a:bodyPr rtlCol="0" anchor="ctr"/>
+          <a:lstStyle/>
+          <a:p/>
+        </p:txBody>
+      </p:sp>
+      <p:sp>
+        <p:nvSpPr>
+          <p:cNvPr id="17" name="Rounded Rectangle 16"/>
+          <p:cNvSpPr/>
+          <p:nvPr/>
+        </p:nvSpPr>
+        <p:spPr>
+          <a:xfrm>
+            <a:off x="2578608" y="4078224"/>
+            <a:ext cx="1014984" cy="640080"/>
+          </a:xfrm>
+          <a:prstGeom prst="roundRect">
+            <a:avLst>
+              <a:gd name="adj" fmla="val 8000"/>
+            </a:avLst>
+          </a:prstGeom>
+          <a:solidFill>
+            <a:srgbClr val="FAFBFC"/>
+          </a:solidFill>
+          <a:ln w="12700">
+            <a:solidFill>
+              <a:srgbClr val="E4E8EC"/>
+            </a:solidFill>
+          </a:ln>
+        </p:spPr>
+        <p:txBody>
+          <a:bodyPr rtlCol="0" anchor="ctr"/>
+          <a:lstStyle/>
+          <a:p/>
+        </p:txBody>
+      </p:sp>
+      <p:sp>
+        <p:nvSpPr>
+          <p:cNvPr id="18" name="TextBox 17"/>
+          <p:cNvSpPr txBox="1"/>
+          <p:nvPr/>
+        </p:nvSpPr>
+        <p:spPr>
+          <a:xfrm>
+            <a:off x="2286000" y="4937760"/>
+            <a:ext cx="1600200" cy="274320"/>
+          </a:xfrm>
+          <a:prstGeom prst="rect">
+            <a:avLst/>
+          </a:prstGeom>
+          <a:noFill/>
+        </p:spPr>
+        <p:txBody>
+          <a:bodyPr wrap="square" lIns="0" rIns="0" tIns="0" bIns="0" anchor="t">
+            <a:spAutoFit/>
+          </a:bodyPr>
+          <a:lstStyle/>
+          <a:p>
+            <a:pPr algn="ctr"/>
+            <a:r>
+              <a:rPr sz="1200" b="0" i="0">
+                <a:solidFill>
+                  <a:srgbClr val="5B6B7A"/>
+                </a:solidFill>
+                <a:latin typeface="Arial"/>
+              </a:rPr>
+              <a:t>fond clair : bord faible</a:t>
+            </a:r>
+          </a:p>
+        </p:txBody>
+      </p:sp>
+      <p:sp>
+        <p:nvSpPr>
+          <p:cNvPr id="19" name="TextBox 18"/>
           <p:cNvSpPr txBox="1"/>
           <p:nvPr/>
         </p:nvSpPr>
@@ -23063,7 +23447,7 @@
       </p:sp>
       <p:sp>
         <p:nvSpPr>
-          <p:cNvPr id="14" name="TextBox 13"/>
+          <p:cNvPr id="20" name="TextBox 19"/>
           <p:cNvSpPr txBox="1"/>
           <p:nvPr/>
         </p:nvSpPr>
@@ -23161,7 +23545,7 @@
       </p:sp>
       <p:sp>
         <p:nvSpPr>
-          <p:cNvPr id="15" name="Rectangle 14"/>
+          <p:cNvPr id="21" name="Rectangle 20"/>
           <p:cNvSpPr/>
           <p:nvPr/>
         </p:nvSpPr>
@@ -23188,7 +23572,7 @@
       </p:sp>
       <p:sp>
         <p:nvSpPr>
-          <p:cNvPr id="16" name="TextBox 15"/>
+          <p:cNvPr id="22" name="TextBox 21"/>
           <p:cNvSpPr txBox="1"/>
           <p:nvPr/>
         </p:nvSpPr>

</xml_diff>

<commit_message>
Add subtle fade transitions and click-to-reveal builds on five slides
Co-Authored-By: Claude Opus 5.5 <noreply@anthropic.com>
Claude-Session: https://claude.ai/code/session_01AnZDiX8uz3hSw1L6vhKaQS
</commit_message>
<xml_diff>
--- a/Soutenance_Stage_ENSI_Final.pptx
+++ b/Soutenance_Stage_ENSI_Final.pptx
@@ -929,6 +929,12 @@
           <a:p/>
           <a:p>
             <a:r>
+              <a:t>ANIMATIONS — 3 clics : une mesure par clic (temps, reconnaissance, délai) ; Android et iOS arrive avec la troisième.</a:t>
+            </a:r>
+          </a:p>
+          <a:p/>
+          <a:p>
+            <a:r>
               <a:t>TEXTE ORAL</a:t>
             </a:r>
           </a:p>
@@ -1539,6 +1545,12 @@
           <a:p/>
           <a:p>
             <a:r>
+              <a:t>ANIMATIONS — 2 clics : 1) étapes 2 à 5 d'Avatar-ID, après « Mon module est la première » ; 2) les deux conclusions du bas.</a:t>
+            </a:r>
+          </a:p>
+          <a:p/>
+          <a:p>
+            <a:r>
               <a:t>TEXTE ORAL</a:t>
             </a:r>
           </a:p>
@@ -2114,6 +2126,12 @@
           <a:p/>
           <a:p>
             <a:r>
+              <a:t>ANIMATIONS — 1 clic : la bande « conçu et développé pendant le stage », au moment de « En bas, ce que j'ai conçu ».</a:t>
+            </a:r>
+          </a:p>
+          <a:p/>
+          <a:p>
+            <a:r>
               <a:t>TEXTE ORAL</a:t>
             </a:r>
           </a:p>
@@ -2222,6 +2240,12 @@
           <a:p/>
           <a:p>
             <a:r>
+              <a:t>ANIMATIONS — 3 clics : 1) les deux causes ; 2) les trois correctifs ; 3) le résultat observé.</a:t>
+            </a:r>
+          </a:p>
+          <a:p/>
+          <a:p>
+            <a:r>
               <a:t>TEXTE ORAL</a:t>
             </a:r>
           </a:p>
@@ -2315,6 +2339,12 @@
           <a:p>
             <a:r>
               <a:t>⏱ 1:15 (cumul 8:30)</a:t>
+            </a:r>
+          </a:p>
+          <a:p/>
+          <a:p>
+            <a:r>
+              <a:t>ANIMATIONS — 1 clic : les cinq contrôles, après avoir décrit la machine à états.</a:t>
             </a:r>
           </a:p>
           <a:p/>
@@ -5859,6 +5889,9 @@
   <p:clrMapOvr>
     <a:masterClrMapping/>
   </p:clrMapOvr>
+  <p:transition spd="med">
+    <p:fade/>
+  </p:transition>
 </p:sld>
 </file>
 
@@ -6615,6 +6648,9 @@
   <p:clrMapOvr>
     <a:masterClrMapping/>
   </p:clrMapOvr>
+  <p:transition spd="med">
+    <p:fade/>
+  </p:transition>
 </p:sld>
 </file>
 
@@ -7450,6 +7486,9 @@
   <p:clrMapOvr>
     <a:masterClrMapping/>
   </p:clrMapOvr>
+  <p:transition spd="med">
+    <p:fade/>
+  </p:transition>
 </p:sld>
 </file>
 
@@ -8280,6 +8319,9 @@
   <p:clrMapOvr>
     <a:masterClrMapping/>
   </p:clrMapOvr>
+  <p:transition spd="med">
+    <p:fade/>
+  </p:transition>
 </p:sld>
 </file>
 
@@ -9228,6 +9270,704 @@
   <p:clrMapOvr>
     <a:masterClrMapping/>
   </p:clrMapOvr>
+  <p:transition spd="med">
+    <p:fade/>
+  </p:transition>
+  <p:timing>
+    <p:tnLst>
+      <p:par>
+        <p:cTn id="1" dur="indefinite" restart="never" nodeType="tmRoot">
+          <p:childTnLst>
+            <p:seq concurrent="1" nextAc="seek">
+              <p:cTn id="2" dur="indefinite" nodeType="mainSeq">
+                <p:childTnLst>
+                  <p:par>
+                    <p:cTn id="18" fill="hold">
+                      <p:stCondLst>
+                        <p:cond delay="indefinite"/>
+                      </p:stCondLst>
+                      <p:childTnLst>
+                        <p:par>
+                          <p:cTn id="19" fill="hold">
+                            <p:stCondLst>
+                              <p:cond delay="0"/>
+                            </p:stCondLst>
+                            <p:childTnLst>
+                              <p:par>
+                                <p:cTn id="3" presetID="10" presetClass="entr" presetSubtype="0" fill="hold" nodeType="clickEffect">
+                                  <p:stCondLst>
+                                    <p:cond delay="0"/>
+                                  </p:stCondLst>
+                                  <p:childTnLst>
+                                    <p:set>
+                                      <p:cBhvr>
+                                        <p:cTn id="4" dur="1" fill="hold">
+                                          <p:stCondLst>
+                                            <p:cond delay="0"/>
+                                          </p:stCondLst>
+                                        </p:cTn>
+                                        <p:tgtEl>
+                                          <p:spTgt spid="11"/>
+                                        </p:tgtEl>
+                                        <p:attrNameLst>
+                                          <p:attrName>style.visibility</p:attrName>
+                                        </p:attrNameLst>
+                                      </p:cBhvr>
+                                      <p:to>
+                                        <p:strVal val="visible"/>
+                                      </p:to>
+                                    </p:set>
+                                    <p:animEffect transition="in" filter="fade">
+                                      <p:cBhvr>
+                                        <p:cTn id="5" dur="400"/>
+                                        <p:tgtEl>
+                                          <p:spTgt spid="11"/>
+                                        </p:tgtEl>
+                                      </p:cBhvr>
+                                    </p:animEffect>
+                                  </p:childTnLst>
+                                </p:cTn>
+                              </p:par>
+                              <p:par>
+                                <p:cTn id="6" presetID="10" presetClass="entr" presetSubtype="0" fill="hold" nodeType="withEffect">
+                                  <p:stCondLst>
+                                    <p:cond delay="0"/>
+                                  </p:stCondLst>
+                                  <p:childTnLst>
+                                    <p:set>
+                                      <p:cBhvr>
+                                        <p:cTn id="7" dur="1" fill="hold">
+                                          <p:stCondLst>
+                                            <p:cond delay="0"/>
+                                          </p:stCondLst>
+                                        </p:cTn>
+                                        <p:tgtEl>
+                                          <p:spTgt spid="12"/>
+                                        </p:tgtEl>
+                                        <p:attrNameLst>
+                                          <p:attrName>style.visibility</p:attrName>
+                                        </p:attrNameLst>
+                                      </p:cBhvr>
+                                      <p:to>
+                                        <p:strVal val="visible"/>
+                                      </p:to>
+                                    </p:set>
+                                    <p:animEffect transition="in" filter="fade">
+                                      <p:cBhvr>
+                                        <p:cTn id="8" dur="400"/>
+                                        <p:tgtEl>
+                                          <p:spTgt spid="12"/>
+                                        </p:tgtEl>
+                                      </p:cBhvr>
+                                    </p:animEffect>
+                                  </p:childTnLst>
+                                </p:cTn>
+                              </p:par>
+                              <p:par>
+                                <p:cTn id="9" presetID="10" presetClass="entr" presetSubtype="0" fill="hold" nodeType="withEffect">
+                                  <p:stCondLst>
+                                    <p:cond delay="0"/>
+                                  </p:stCondLst>
+                                  <p:childTnLst>
+                                    <p:set>
+                                      <p:cBhvr>
+                                        <p:cTn id="10" dur="1" fill="hold">
+                                          <p:stCondLst>
+                                            <p:cond delay="0"/>
+                                          </p:stCondLst>
+                                        </p:cTn>
+                                        <p:tgtEl>
+                                          <p:spTgt spid="13"/>
+                                        </p:tgtEl>
+                                        <p:attrNameLst>
+                                          <p:attrName>style.visibility</p:attrName>
+                                        </p:attrNameLst>
+                                      </p:cBhvr>
+                                      <p:to>
+                                        <p:strVal val="visible"/>
+                                      </p:to>
+                                    </p:set>
+                                    <p:animEffect transition="in" filter="fade">
+                                      <p:cBhvr>
+                                        <p:cTn id="11" dur="400"/>
+                                        <p:tgtEl>
+                                          <p:spTgt spid="13"/>
+                                        </p:tgtEl>
+                                      </p:cBhvr>
+                                    </p:animEffect>
+                                  </p:childTnLst>
+                                </p:cTn>
+                              </p:par>
+                              <p:par>
+                                <p:cTn id="12" presetID="10" presetClass="entr" presetSubtype="0" fill="hold" nodeType="withEffect">
+                                  <p:stCondLst>
+                                    <p:cond delay="0"/>
+                                  </p:stCondLst>
+                                  <p:childTnLst>
+                                    <p:set>
+                                      <p:cBhvr>
+                                        <p:cTn id="13" dur="1" fill="hold">
+                                          <p:stCondLst>
+                                            <p:cond delay="0"/>
+                                          </p:stCondLst>
+                                        </p:cTn>
+                                        <p:tgtEl>
+                                          <p:spTgt spid="14"/>
+                                        </p:tgtEl>
+                                        <p:attrNameLst>
+                                          <p:attrName>style.visibility</p:attrName>
+                                        </p:attrNameLst>
+                                      </p:cBhvr>
+                                      <p:to>
+                                        <p:strVal val="visible"/>
+                                      </p:to>
+                                    </p:set>
+                                    <p:animEffect transition="in" filter="fade">
+                                      <p:cBhvr>
+                                        <p:cTn id="14" dur="400"/>
+                                        <p:tgtEl>
+                                          <p:spTgt spid="14"/>
+                                        </p:tgtEl>
+                                      </p:cBhvr>
+                                    </p:animEffect>
+                                  </p:childTnLst>
+                                </p:cTn>
+                              </p:par>
+                              <p:par>
+                                <p:cTn id="15" presetID="10" presetClass="entr" presetSubtype="0" fill="hold" nodeType="withEffect">
+                                  <p:stCondLst>
+                                    <p:cond delay="0"/>
+                                  </p:stCondLst>
+                                  <p:childTnLst>
+                                    <p:set>
+                                      <p:cBhvr>
+                                        <p:cTn id="16" dur="1" fill="hold">
+                                          <p:stCondLst>
+                                            <p:cond delay="0"/>
+                                          </p:stCondLst>
+                                        </p:cTn>
+                                        <p:tgtEl>
+                                          <p:spTgt spid="15"/>
+                                        </p:tgtEl>
+                                        <p:attrNameLst>
+                                          <p:attrName>style.visibility</p:attrName>
+                                        </p:attrNameLst>
+                                      </p:cBhvr>
+                                      <p:to>
+                                        <p:strVal val="visible"/>
+                                      </p:to>
+                                    </p:set>
+                                    <p:animEffect transition="in" filter="fade">
+                                      <p:cBhvr>
+                                        <p:cTn id="17" dur="400"/>
+                                        <p:tgtEl>
+                                          <p:spTgt spid="15"/>
+                                        </p:tgtEl>
+                                      </p:cBhvr>
+                                    </p:animEffect>
+                                  </p:childTnLst>
+                                </p:cTn>
+                              </p:par>
+                            </p:childTnLst>
+                          </p:cTn>
+                        </p:par>
+                      </p:childTnLst>
+                    </p:cTn>
+                  </p:par>
+                  <p:par>
+                    <p:cTn id="35" fill="hold">
+                      <p:stCondLst>
+                        <p:cond delay="indefinite"/>
+                      </p:stCondLst>
+                      <p:childTnLst>
+                        <p:par>
+                          <p:cTn id="36" fill="hold">
+                            <p:stCondLst>
+                              <p:cond delay="0"/>
+                            </p:stCondLst>
+                            <p:childTnLst>
+                              <p:par>
+                                <p:cTn id="20" presetID="10" presetClass="entr" presetSubtype="0" fill="hold" nodeType="clickEffect">
+                                  <p:stCondLst>
+                                    <p:cond delay="0"/>
+                                  </p:stCondLst>
+                                  <p:childTnLst>
+                                    <p:set>
+                                      <p:cBhvr>
+                                        <p:cTn id="21" dur="1" fill="hold">
+                                          <p:stCondLst>
+                                            <p:cond delay="0"/>
+                                          </p:stCondLst>
+                                        </p:cTn>
+                                        <p:tgtEl>
+                                          <p:spTgt spid="16"/>
+                                        </p:tgtEl>
+                                        <p:attrNameLst>
+                                          <p:attrName>style.visibility</p:attrName>
+                                        </p:attrNameLst>
+                                      </p:cBhvr>
+                                      <p:to>
+                                        <p:strVal val="visible"/>
+                                      </p:to>
+                                    </p:set>
+                                    <p:animEffect transition="in" filter="fade">
+                                      <p:cBhvr>
+                                        <p:cTn id="22" dur="400"/>
+                                        <p:tgtEl>
+                                          <p:spTgt spid="16"/>
+                                        </p:tgtEl>
+                                      </p:cBhvr>
+                                    </p:animEffect>
+                                  </p:childTnLst>
+                                </p:cTn>
+                              </p:par>
+                              <p:par>
+                                <p:cTn id="23" presetID="10" presetClass="entr" presetSubtype="0" fill="hold" nodeType="withEffect">
+                                  <p:stCondLst>
+                                    <p:cond delay="0"/>
+                                  </p:stCondLst>
+                                  <p:childTnLst>
+                                    <p:set>
+                                      <p:cBhvr>
+                                        <p:cTn id="24" dur="1" fill="hold">
+                                          <p:stCondLst>
+                                            <p:cond delay="0"/>
+                                          </p:stCondLst>
+                                        </p:cTn>
+                                        <p:tgtEl>
+                                          <p:spTgt spid="17"/>
+                                        </p:tgtEl>
+                                        <p:attrNameLst>
+                                          <p:attrName>style.visibility</p:attrName>
+                                        </p:attrNameLst>
+                                      </p:cBhvr>
+                                      <p:to>
+                                        <p:strVal val="visible"/>
+                                      </p:to>
+                                    </p:set>
+                                    <p:animEffect transition="in" filter="fade">
+                                      <p:cBhvr>
+                                        <p:cTn id="25" dur="400"/>
+                                        <p:tgtEl>
+                                          <p:spTgt spid="17"/>
+                                        </p:tgtEl>
+                                      </p:cBhvr>
+                                    </p:animEffect>
+                                  </p:childTnLst>
+                                </p:cTn>
+                              </p:par>
+                              <p:par>
+                                <p:cTn id="26" presetID="10" presetClass="entr" presetSubtype="0" fill="hold" nodeType="withEffect">
+                                  <p:stCondLst>
+                                    <p:cond delay="0"/>
+                                  </p:stCondLst>
+                                  <p:childTnLst>
+                                    <p:set>
+                                      <p:cBhvr>
+                                        <p:cTn id="27" dur="1" fill="hold">
+                                          <p:stCondLst>
+                                            <p:cond delay="0"/>
+                                          </p:stCondLst>
+                                        </p:cTn>
+                                        <p:tgtEl>
+                                          <p:spTgt spid="18"/>
+                                        </p:tgtEl>
+                                        <p:attrNameLst>
+                                          <p:attrName>style.visibility</p:attrName>
+                                        </p:attrNameLst>
+                                      </p:cBhvr>
+                                      <p:to>
+                                        <p:strVal val="visible"/>
+                                      </p:to>
+                                    </p:set>
+                                    <p:animEffect transition="in" filter="fade">
+                                      <p:cBhvr>
+                                        <p:cTn id="28" dur="400"/>
+                                        <p:tgtEl>
+                                          <p:spTgt spid="18"/>
+                                        </p:tgtEl>
+                                      </p:cBhvr>
+                                    </p:animEffect>
+                                  </p:childTnLst>
+                                </p:cTn>
+                              </p:par>
+                              <p:par>
+                                <p:cTn id="29" presetID="10" presetClass="entr" presetSubtype="0" fill="hold" nodeType="withEffect">
+                                  <p:stCondLst>
+                                    <p:cond delay="0"/>
+                                  </p:stCondLst>
+                                  <p:childTnLst>
+                                    <p:set>
+                                      <p:cBhvr>
+                                        <p:cTn id="30" dur="1" fill="hold">
+                                          <p:stCondLst>
+                                            <p:cond delay="0"/>
+                                          </p:stCondLst>
+                                        </p:cTn>
+                                        <p:tgtEl>
+                                          <p:spTgt spid="19"/>
+                                        </p:tgtEl>
+                                        <p:attrNameLst>
+                                          <p:attrName>style.visibility</p:attrName>
+                                        </p:attrNameLst>
+                                      </p:cBhvr>
+                                      <p:to>
+                                        <p:strVal val="visible"/>
+                                      </p:to>
+                                    </p:set>
+                                    <p:animEffect transition="in" filter="fade">
+                                      <p:cBhvr>
+                                        <p:cTn id="31" dur="400"/>
+                                        <p:tgtEl>
+                                          <p:spTgt spid="19"/>
+                                        </p:tgtEl>
+                                      </p:cBhvr>
+                                    </p:animEffect>
+                                  </p:childTnLst>
+                                </p:cTn>
+                              </p:par>
+                              <p:par>
+                                <p:cTn id="32" presetID="10" presetClass="entr" presetSubtype="0" fill="hold" nodeType="withEffect">
+                                  <p:stCondLst>
+                                    <p:cond delay="0"/>
+                                  </p:stCondLst>
+                                  <p:childTnLst>
+                                    <p:set>
+                                      <p:cBhvr>
+                                        <p:cTn id="33" dur="1" fill="hold">
+                                          <p:stCondLst>
+                                            <p:cond delay="0"/>
+                                          </p:stCondLst>
+                                        </p:cTn>
+                                        <p:tgtEl>
+                                          <p:spTgt spid="20"/>
+                                        </p:tgtEl>
+                                        <p:attrNameLst>
+                                          <p:attrName>style.visibility</p:attrName>
+                                        </p:attrNameLst>
+                                      </p:cBhvr>
+                                      <p:to>
+                                        <p:strVal val="visible"/>
+                                      </p:to>
+                                    </p:set>
+                                    <p:animEffect transition="in" filter="fade">
+                                      <p:cBhvr>
+                                        <p:cTn id="34" dur="400"/>
+                                        <p:tgtEl>
+                                          <p:spTgt spid="20"/>
+                                        </p:tgtEl>
+                                      </p:cBhvr>
+                                    </p:animEffect>
+                                  </p:childTnLst>
+                                </p:cTn>
+                              </p:par>
+                            </p:childTnLst>
+                          </p:cTn>
+                        </p:par>
+                      </p:childTnLst>
+                    </p:cTn>
+                  </p:par>
+                  <p:par>
+                    <p:cTn id="58" fill="hold">
+                      <p:stCondLst>
+                        <p:cond delay="indefinite"/>
+                      </p:stCondLst>
+                      <p:childTnLst>
+                        <p:par>
+                          <p:cTn id="59" fill="hold">
+                            <p:stCondLst>
+                              <p:cond delay="0"/>
+                            </p:stCondLst>
+                            <p:childTnLst>
+                              <p:par>
+                                <p:cTn id="37" presetID="10" presetClass="entr" presetSubtype="0" fill="hold" nodeType="clickEffect">
+                                  <p:stCondLst>
+                                    <p:cond delay="0"/>
+                                  </p:stCondLst>
+                                  <p:childTnLst>
+                                    <p:set>
+                                      <p:cBhvr>
+                                        <p:cTn id="38" dur="1" fill="hold">
+                                          <p:stCondLst>
+                                            <p:cond delay="0"/>
+                                          </p:stCondLst>
+                                        </p:cTn>
+                                        <p:tgtEl>
+                                          <p:spTgt spid="21"/>
+                                        </p:tgtEl>
+                                        <p:attrNameLst>
+                                          <p:attrName>style.visibility</p:attrName>
+                                        </p:attrNameLst>
+                                      </p:cBhvr>
+                                      <p:to>
+                                        <p:strVal val="visible"/>
+                                      </p:to>
+                                    </p:set>
+                                    <p:animEffect transition="in" filter="fade">
+                                      <p:cBhvr>
+                                        <p:cTn id="39" dur="400"/>
+                                        <p:tgtEl>
+                                          <p:spTgt spid="21"/>
+                                        </p:tgtEl>
+                                      </p:cBhvr>
+                                    </p:animEffect>
+                                  </p:childTnLst>
+                                </p:cTn>
+                              </p:par>
+                              <p:par>
+                                <p:cTn id="40" presetID="10" presetClass="entr" presetSubtype="0" fill="hold" nodeType="withEffect">
+                                  <p:stCondLst>
+                                    <p:cond delay="0"/>
+                                  </p:stCondLst>
+                                  <p:childTnLst>
+                                    <p:set>
+                                      <p:cBhvr>
+                                        <p:cTn id="41" dur="1" fill="hold">
+                                          <p:stCondLst>
+                                            <p:cond delay="0"/>
+                                          </p:stCondLst>
+                                        </p:cTn>
+                                        <p:tgtEl>
+                                          <p:spTgt spid="22"/>
+                                        </p:tgtEl>
+                                        <p:attrNameLst>
+                                          <p:attrName>style.visibility</p:attrName>
+                                        </p:attrNameLst>
+                                      </p:cBhvr>
+                                      <p:to>
+                                        <p:strVal val="visible"/>
+                                      </p:to>
+                                    </p:set>
+                                    <p:animEffect transition="in" filter="fade">
+                                      <p:cBhvr>
+                                        <p:cTn id="42" dur="400"/>
+                                        <p:tgtEl>
+                                          <p:spTgt spid="22"/>
+                                        </p:tgtEl>
+                                      </p:cBhvr>
+                                    </p:animEffect>
+                                  </p:childTnLst>
+                                </p:cTn>
+                              </p:par>
+                              <p:par>
+                                <p:cTn id="43" presetID="10" presetClass="entr" presetSubtype="0" fill="hold" nodeType="withEffect">
+                                  <p:stCondLst>
+                                    <p:cond delay="0"/>
+                                  </p:stCondLst>
+                                  <p:childTnLst>
+                                    <p:set>
+                                      <p:cBhvr>
+                                        <p:cTn id="44" dur="1" fill="hold">
+                                          <p:stCondLst>
+                                            <p:cond delay="0"/>
+                                          </p:stCondLst>
+                                        </p:cTn>
+                                        <p:tgtEl>
+                                          <p:spTgt spid="23"/>
+                                        </p:tgtEl>
+                                        <p:attrNameLst>
+                                          <p:attrName>style.visibility</p:attrName>
+                                        </p:attrNameLst>
+                                      </p:cBhvr>
+                                      <p:to>
+                                        <p:strVal val="visible"/>
+                                      </p:to>
+                                    </p:set>
+                                    <p:animEffect transition="in" filter="fade">
+                                      <p:cBhvr>
+                                        <p:cTn id="45" dur="400"/>
+                                        <p:tgtEl>
+                                          <p:spTgt spid="23"/>
+                                        </p:tgtEl>
+                                      </p:cBhvr>
+                                    </p:animEffect>
+                                  </p:childTnLst>
+                                </p:cTn>
+                              </p:par>
+                              <p:par>
+                                <p:cTn id="46" presetID="10" presetClass="entr" presetSubtype="0" fill="hold" nodeType="withEffect">
+                                  <p:stCondLst>
+                                    <p:cond delay="0"/>
+                                  </p:stCondLst>
+                                  <p:childTnLst>
+                                    <p:set>
+                                      <p:cBhvr>
+                                        <p:cTn id="47" dur="1" fill="hold">
+                                          <p:stCondLst>
+                                            <p:cond delay="0"/>
+                                          </p:stCondLst>
+                                        </p:cTn>
+                                        <p:tgtEl>
+                                          <p:spTgt spid="24"/>
+                                        </p:tgtEl>
+                                        <p:attrNameLst>
+                                          <p:attrName>style.visibility</p:attrName>
+                                        </p:attrNameLst>
+                                      </p:cBhvr>
+                                      <p:to>
+                                        <p:strVal val="visible"/>
+                                      </p:to>
+                                    </p:set>
+                                    <p:animEffect transition="in" filter="fade">
+                                      <p:cBhvr>
+                                        <p:cTn id="48" dur="400"/>
+                                        <p:tgtEl>
+                                          <p:spTgt spid="24"/>
+                                        </p:tgtEl>
+                                      </p:cBhvr>
+                                    </p:animEffect>
+                                  </p:childTnLst>
+                                </p:cTn>
+                              </p:par>
+                              <p:par>
+                                <p:cTn id="49" presetID="10" presetClass="entr" presetSubtype="0" fill="hold" nodeType="withEffect">
+                                  <p:stCondLst>
+                                    <p:cond delay="0"/>
+                                  </p:stCondLst>
+                                  <p:childTnLst>
+                                    <p:set>
+                                      <p:cBhvr>
+                                        <p:cTn id="50" dur="1" fill="hold">
+                                          <p:stCondLst>
+                                            <p:cond delay="0"/>
+                                          </p:stCondLst>
+                                        </p:cTn>
+                                        <p:tgtEl>
+                                          <p:spTgt spid="25"/>
+                                        </p:tgtEl>
+                                        <p:attrNameLst>
+                                          <p:attrName>style.visibility</p:attrName>
+                                        </p:attrNameLst>
+                                      </p:cBhvr>
+                                      <p:to>
+                                        <p:strVal val="visible"/>
+                                      </p:to>
+                                    </p:set>
+                                    <p:animEffect transition="in" filter="fade">
+                                      <p:cBhvr>
+                                        <p:cTn id="51" dur="400"/>
+                                        <p:tgtEl>
+                                          <p:spTgt spid="25"/>
+                                        </p:tgtEl>
+                                      </p:cBhvr>
+                                    </p:animEffect>
+                                  </p:childTnLst>
+                                </p:cTn>
+                              </p:par>
+                              <p:par>
+                                <p:cTn id="52" presetID="10" presetClass="entr" presetSubtype="0" fill="hold" nodeType="withEffect">
+                                  <p:stCondLst>
+                                    <p:cond delay="0"/>
+                                  </p:stCondLst>
+                                  <p:childTnLst>
+                                    <p:set>
+                                      <p:cBhvr>
+                                        <p:cTn id="53" dur="1" fill="hold">
+                                          <p:stCondLst>
+                                            <p:cond delay="0"/>
+                                          </p:stCondLst>
+                                        </p:cTn>
+                                        <p:tgtEl>
+                                          <p:spTgt spid="27"/>
+                                        </p:tgtEl>
+                                        <p:attrNameLst>
+                                          <p:attrName>style.visibility</p:attrName>
+                                        </p:attrNameLst>
+                                      </p:cBhvr>
+                                      <p:to>
+                                        <p:strVal val="visible"/>
+                                      </p:to>
+                                    </p:set>
+                                    <p:animEffect transition="in" filter="fade">
+                                      <p:cBhvr>
+                                        <p:cTn id="54" dur="400"/>
+                                        <p:tgtEl>
+                                          <p:spTgt spid="27"/>
+                                        </p:tgtEl>
+                                      </p:cBhvr>
+                                    </p:animEffect>
+                                  </p:childTnLst>
+                                </p:cTn>
+                              </p:par>
+                              <p:par>
+                                <p:cTn id="55" presetID="10" presetClass="entr" presetSubtype="0" fill="hold" nodeType="withEffect">
+                                  <p:stCondLst>
+                                    <p:cond delay="0"/>
+                                  </p:stCondLst>
+                                  <p:childTnLst>
+                                    <p:set>
+                                      <p:cBhvr>
+                                        <p:cTn id="56" dur="1" fill="hold">
+                                          <p:stCondLst>
+                                            <p:cond delay="0"/>
+                                          </p:stCondLst>
+                                        </p:cTn>
+                                        <p:tgtEl>
+                                          <p:spTgt spid="28"/>
+                                        </p:tgtEl>
+                                        <p:attrNameLst>
+                                          <p:attrName>style.visibility</p:attrName>
+                                        </p:attrNameLst>
+                                      </p:cBhvr>
+                                      <p:to>
+                                        <p:strVal val="visible"/>
+                                      </p:to>
+                                    </p:set>
+                                    <p:animEffect transition="in" filter="fade">
+                                      <p:cBhvr>
+                                        <p:cTn id="57" dur="400"/>
+                                        <p:tgtEl>
+                                          <p:spTgt spid="28"/>
+                                        </p:tgtEl>
+                                      </p:cBhvr>
+                                    </p:animEffect>
+                                  </p:childTnLst>
+                                </p:cTn>
+                              </p:par>
+                            </p:childTnLst>
+                          </p:cTn>
+                        </p:par>
+                      </p:childTnLst>
+                    </p:cTn>
+                  </p:par>
+                </p:childTnLst>
+              </p:cTn>
+              <p:prevCondLst>
+                <p:cond evt="onPrev" delay="0">
+                  <p:tgtEl>
+                    <p:sldTgt/>
+                  </p:tgtEl>
+                </p:cond>
+              </p:prevCondLst>
+              <p:nextCondLst>
+                <p:cond evt="onNext" delay="0">
+                  <p:tgtEl>
+                    <p:sldTgt/>
+                  </p:tgtEl>
+                </p:cond>
+              </p:nextCondLst>
+            </p:seq>
+          </p:childTnLst>
+        </p:cTn>
+      </p:par>
+    </p:tnLst>
+    <p:bldLst>
+      <p:bldP spid="12" grpId="0"/>
+      <p:bldP spid="13" grpId="0"/>
+      <p:bldP spid="14" grpId="0"/>
+      <p:bldP spid="15" grpId="0"/>
+      <p:bldP spid="17" grpId="0"/>
+      <p:bldP spid="18" grpId="0"/>
+      <p:bldP spid="19" grpId="0"/>
+      <p:bldP spid="20" grpId="0"/>
+      <p:bldP spid="22" grpId="0"/>
+      <p:bldP spid="23" grpId="0"/>
+      <p:bldP spid="24" grpId="0"/>
+      <p:bldP spid="25" grpId="0"/>
+      <p:bldP spid="27" grpId="0"/>
+      <p:bldP spid="28" grpId="0"/>
+    </p:bldLst>
+  </p:timing>
 </p:sld>
 </file>
 
@@ -9912,6 +10652,9 @@
   <p:clrMapOvr>
     <a:masterClrMapping/>
   </p:clrMapOvr>
+  <p:transition spd="med">
+    <p:fade/>
+  </p:transition>
 </p:sld>
 </file>
 
@@ -10647,6 +11390,9 @@
   <p:clrMapOvr>
     <a:masterClrMapping/>
   </p:clrMapOvr>
+  <p:transition spd="med">
+    <p:fade/>
+  </p:transition>
 </p:sld>
 </file>
 
@@ -11150,6 +11896,9 @@
   <p:clrMapOvr>
     <a:masterClrMapping/>
   </p:clrMapOvr>
+  <p:transition spd="med">
+    <p:fade/>
+  </p:transition>
 </p:sld>
 </file>
 
@@ -13026,6 +13775,9 @@
   <p:clrMapOvr>
     <a:masterClrMapping/>
   </p:clrMapOvr>
+  <p:transition spd="med">
+    <p:fade/>
+  </p:transition>
 </p:sld>
 </file>
 
@@ -14005,6 +14757,9 @@
   <p:clrMapOvr>
     <a:masterClrMapping/>
   </p:clrMapOvr>
+  <p:transition spd="med">
+    <p:fade/>
+  </p:transition>
 </p:sld>
 </file>
 
@@ -14547,6 +15302,9 @@
   <p:clrMapOvr>
     <a:masterClrMapping/>
   </p:clrMapOvr>
+  <p:transition spd="med">
+    <p:fade/>
+  </p:transition>
 </p:sld>
 </file>
 
@@ -15806,6 +16564,936 @@
   <p:clrMapOvr>
     <a:masterClrMapping/>
   </p:clrMapOvr>
+  <p:transition spd="med">
+    <p:fade/>
+  </p:transition>
+  <p:timing>
+    <p:tnLst>
+      <p:par>
+        <p:cTn id="1" dur="indefinite" restart="never" nodeType="tmRoot">
+          <p:childTnLst>
+            <p:seq concurrent="1" nextAc="seek">
+              <p:cTn id="2" dur="indefinite" nodeType="mainSeq">
+                <p:childTnLst>
+                  <p:par>
+                    <p:cTn id="69" fill="hold">
+                      <p:stCondLst>
+                        <p:cond delay="indefinite"/>
+                      </p:stCondLst>
+                      <p:childTnLst>
+                        <p:par>
+                          <p:cTn id="70" fill="hold">
+                            <p:stCondLst>
+                              <p:cond delay="0"/>
+                            </p:stCondLst>
+                            <p:childTnLst>
+                              <p:par>
+                                <p:cTn id="3" presetID="10" presetClass="entr" presetSubtype="0" fill="hold" nodeType="clickEffect">
+                                  <p:stCondLst>
+                                    <p:cond delay="0"/>
+                                  </p:stCondLst>
+                                  <p:childTnLst>
+                                    <p:set>
+                                      <p:cBhvr>
+                                        <p:cTn id="4" dur="1" fill="hold">
+                                          <p:stCondLst>
+                                            <p:cond delay="0"/>
+                                          </p:stCondLst>
+                                        </p:cTn>
+                                        <p:tgtEl>
+                                          <p:spTgt spid="11"/>
+                                        </p:tgtEl>
+                                        <p:attrNameLst>
+                                          <p:attrName>style.visibility</p:attrName>
+                                        </p:attrNameLst>
+                                      </p:cBhvr>
+                                      <p:to>
+                                        <p:strVal val="visible"/>
+                                      </p:to>
+                                    </p:set>
+                                    <p:animEffect transition="in" filter="fade">
+                                      <p:cBhvr>
+                                        <p:cTn id="5" dur="400"/>
+                                        <p:tgtEl>
+                                          <p:spTgt spid="11"/>
+                                        </p:tgtEl>
+                                      </p:cBhvr>
+                                    </p:animEffect>
+                                  </p:childTnLst>
+                                </p:cTn>
+                              </p:par>
+                              <p:par>
+                                <p:cTn id="6" presetID="10" presetClass="entr" presetSubtype="0" fill="hold" nodeType="withEffect">
+                                  <p:stCondLst>
+                                    <p:cond delay="0"/>
+                                  </p:stCondLst>
+                                  <p:childTnLst>
+                                    <p:set>
+                                      <p:cBhvr>
+                                        <p:cTn id="7" dur="1" fill="hold">
+                                          <p:stCondLst>
+                                            <p:cond delay="0"/>
+                                          </p:stCondLst>
+                                        </p:cTn>
+                                        <p:tgtEl>
+                                          <p:spTgt spid="12"/>
+                                        </p:tgtEl>
+                                        <p:attrNameLst>
+                                          <p:attrName>style.visibility</p:attrName>
+                                        </p:attrNameLst>
+                                      </p:cBhvr>
+                                      <p:to>
+                                        <p:strVal val="visible"/>
+                                      </p:to>
+                                    </p:set>
+                                    <p:animEffect transition="in" filter="fade">
+                                      <p:cBhvr>
+                                        <p:cTn id="8" dur="400"/>
+                                        <p:tgtEl>
+                                          <p:spTgt spid="12"/>
+                                        </p:tgtEl>
+                                      </p:cBhvr>
+                                    </p:animEffect>
+                                  </p:childTnLst>
+                                </p:cTn>
+                              </p:par>
+                              <p:par>
+                                <p:cTn id="9" presetID="10" presetClass="entr" presetSubtype="0" fill="hold" nodeType="withEffect">
+                                  <p:stCondLst>
+                                    <p:cond delay="0"/>
+                                  </p:stCondLst>
+                                  <p:childTnLst>
+                                    <p:set>
+                                      <p:cBhvr>
+                                        <p:cTn id="10" dur="1" fill="hold">
+                                          <p:stCondLst>
+                                            <p:cond delay="0"/>
+                                          </p:stCondLst>
+                                        </p:cTn>
+                                        <p:tgtEl>
+                                          <p:spTgt spid="13"/>
+                                        </p:tgtEl>
+                                        <p:attrNameLst>
+                                          <p:attrName>style.visibility</p:attrName>
+                                        </p:attrNameLst>
+                                      </p:cBhvr>
+                                      <p:to>
+                                        <p:strVal val="visible"/>
+                                      </p:to>
+                                    </p:set>
+                                    <p:animEffect transition="in" filter="fade">
+                                      <p:cBhvr>
+                                        <p:cTn id="11" dur="400"/>
+                                        <p:tgtEl>
+                                          <p:spTgt spid="13"/>
+                                        </p:tgtEl>
+                                      </p:cBhvr>
+                                    </p:animEffect>
+                                  </p:childTnLst>
+                                </p:cTn>
+                              </p:par>
+                              <p:par>
+                                <p:cTn id="12" presetID="10" presetClass="entr" presetSubtype="0" fill="hold" nodeType="withEffect">
+                                  <p:stCondLst>
+                                    <p:cond delay="0"/>
+                                  </p:stCondLst>
+                                  <p:childTnLst>
+                                    <p:set>
+                                      <p:cBhvr>
+                                        <p:cTn id="13" dur="1" fill="hold">
+                                          <p:stCondLst>
+                                            <p:cond delay="0"/>
+                                          </p:stCondLst>
+                                        </p:cTn>
+                                        <p:tgtEl>
+                                          <p:spTgt spid="14"/>
+                                        </p:tgtEl>
+                                        <p:attrNameLst>
+                                          <p:attrName>style.visibility</p:attrName>
+                                        </p:attrNameLst>
+                                      </p:cBhvr>
+                                      <p:to>
+                                        <p:strVal val="visible"/>
+                                      </p:to>
+                                    </p:set>
+                                    <p:animEffect transition="in" filter="fade">
+                                      <p:cBhvr>
+                                        <p:cTn id="14" dur="400"/>
+                                        <p:tgtEl>
+                                          <p:spTgt spid="14"/>
+                                        </p:tgtEl>
+                                      </p:cBhvr>
+                                    </p:animEffect>
+                                  </p:childTnLst>
+                                </p:cTn>
+                              </p:par>
+                              <p:par>
+                                <p:cTn id="15" presetID="10" presetClass="entr" presetSubtype="0" fill="hold" nodeType="withEffect">
+                                  <p:stCondLst>
+                                    <p:cond delay="0"/>
+                                  </p:stCondLst>
+                                  <p:childTnLst>
+                                    <p:set>
+                                      <p:cBhvr>
+                                        <p:cTn id="16" dur="1" fill="hold">
+                                          <p:stCondLst>
+                                            <p:cond delay="0"/>
+                                          </p:stCondLst>
+                                        </p:cTn>
+                                        <p:tgtEl>
+                                          <p:spTgt spid="15"/>
+                                        </p:tgtEl>
+                                        <p:attrNameLst>
+                                          <p:attrName>style.visibility</p:attrName>
+                                        </p:attrNameLst>
+                                      </p:cBhvr>
+                                      <p:to>
+                                        <p:strVal val="visible"/>
+                                      </p:to>
+                                    </p:set>
+                                    <p:animEffect transition="in" filter="fade">
+                                      <p:cBhvr>
+                                        <p:cTn id="17" dur="400"/>
+                                        <p:tgtEl>
+                                          <p:spTgt spid="15"/>
+                                        </p:tgtEl>
+                                      </p:cBhvr>
+                                    </p:animEffect>
+                                  </p:childTnLst>
+                                </p:cTn>
+                              </p:par>
+                              <p:par>
+                                <p:cTn id="18" presetID="10" presetClass="entr" presetSubtype="0" fill="hold" nodeType="withEffect">
+                                  <p:stCondLst>
+                                    <p:cond delay="0"/>
+                                  </p:stCondLst>
+                                  <p:childTnLst>
+                                    <p:set>
+                                      <p:cBhvr>
+                                        <p:cTn id="19" dur="1" fill="hold">
+                                          <p:stCondLst>
+                                            <p:cond delay="0"/>
+                                          </p:stCondLst>
+                                        </p:cTn>
+                                        <p:tgtEl>
+                                          <p:spTgt spid="16"/>
+                                        </p:tgtEl>
+                                        <p:attrNameLst>
+                                          <p:attrName>style.visibility</p:attrName>
+                                        </p:attrNameLst>
+                                      </p:cBhvr>
+                                      <p:to>
+                                        <p:strVal val="visible"/>
+                                      </p:to>
+                                    </p:set>
+                                    <p:animEffect transition="in" filter="fade">
+                                      <p:cBhvr>
+                                        <p:cTn id="20" dur="400"/>
+                                        <p:tgtEl>
+                                          <p:spTgt spid="16"/>
+                                        </p:tgtEl>
+                                      </p:cBhvr>
+                                    </p:animEffect>
+                                  </p:childTnLst>
+                                </p:cTn>
+                              </p:par>
+                              <p:par>
+                                <p:cTn id="21" presetID="10" presetClass="entr" presetSubtype="0" fill="hold" nodeType="withEffect">
+                                  <p:stCondLst>
+                                    <p:cond delay="0"/>
+                                  </p:stCondLst>
+                                  <p:childTnLst>
+                                    <p:set>
+                                      <p:cBhvr>
+                                        <p:cTn id="22" dur="1" fill="hold">
+                                          <p:stCondLst>
+                                            <p:cond delay="0"/>
+                                          </p:stCondLst>
+                                        </p:cTn>
+                                        <p:tgtEl>
+                                          <p:spTgt spid="17"/>
+                                        </p:tgtEl>
+                                        <p:attrNameLst>
+                                          <p:attrName>style.visibility</p:attrName>
+                                        </p:attrNameLst>
+                                      </p:cBhvr>
+                                      <p:to>
+                                        <p:strVal val="visible"/>
+                                      </p:to>
+                                    </p:set>
+                                    <p:animEffect transition="in" filter="fade">
+                                      <p:cBhvr>
+                                        <p:cTn id="23" dur="400"/>
+                                        <p:tgtEl>
+                                          <p:spTgt spid="17"/>
+                                        </p:tgtEl>
+                                      </p:cBhvr>
+                                    </p:animEffect>
+                                  </p:childTnLst>
+                                </p:cTn>
+                              </p:par>
+                              <p:par>
+                                <p:cTn id="24" presetID="10" presetClass="entr" presetSubtype="0" fill="hold" nodeType="withEffect">
+                                  <p:stCondLst>
+                                    <p:cond delay="0"/>
+                                  </p:stCondLst>
+                                  <p:childTnLst>
+                                    <p:set>
+                                      <p:cBhvr>
+                                        <p:cTn id="25" dur="1" fill="hold">
+                                          <p:stCondLst>
+                                            <p:cond delay="0"/>
+                                          </p:stCondLst>
+                                        </p:cTn>
+                                        <p:tgtEl>
+                                          <p:spTgt spid="18"/>
+                                        </p:tgtEl>
+                                        <p:attrNameLst>
+                                          <p:attrName>style.visibility</p:attrName>
+                                        </p:attrNameLst>
+                                      </p:cBhvr>
+                                      <p:to>
+                                        <p:strVal val="visible"/>
+                                      </p:to>
+                                    </p:set>
+                                    <p:animEffect transition="in" filter="fade">
+                                      <p:cBhvr>
+                                        <p:cTn id="26" dur="400"/>
+                                        <p:tgtEl>
+                                          <p:spTgt spid="18"/>
+                                        </p:tgtEl>
+                                      </p:cBhvr>
+                                    </p:animEffect>
+                                  </p:childTnLst>
+                                </p:cTn>
+                              </p:par>
+                              <p:par>
+                                <p:cTn id="27" presetID="10" presetClass="entr" presetSubtype="0" fill="hold" nodeType="withEffect">
+                                  <p:stCondLst>
+                                    <p:cond delay="0"/>
+                                  </p:stCondLst>
+                                  <p:childTnLst>
+                                    <p:set>
+                                      <p:cBhvr>
+                                        <p:cTn id="28" dur="1" fill="hold">
+                                          <p:stCondLst>
+                                            <p:cond delay="0"/>
+                                          </p:stCondLst>
+                                        </p:cTn>
+                                        <p:tgtEl>
+                                          <p:spTgt spid="19"/>
+                                        </p:tgtEl>
+                                        <p:attrNameLst>
+                                          <p:attrName>style.visibility</p:attrName>
+                                        </p:attrNameLst>
+                                      </p:cBhvr>
+                                      <p:to>
+                                        <p:strVal val="visible"/>
+                                      </p:to>
+                                    </p:set>
+                                    <p:animEffect transition="in" filter="fade">
+                                      <p:cBhvr>
+                                        <p:cTn id="29" dur="400"/>
+                                        <p:tgtEl>
+                                          <p:spTgt spid="19"/>
+                                        </p:tgtEl>
+                                      </p:cBhvr>
+                                    </p:animEffect>
+                                  </p:childTnLst>
+                                </p:cTn>
+                              </p:par>
+                              <p:par>
+                                <p:cTn id="30" presetID="10" presetClass="entr" presetSubtype="0" fill="hold" nodeType="withEffect">
+                                  <p:stCondLst>
+                                    <p:cond delay="0"/>
+                                  </p:stCondLst>
+                                  <p:childTnLst>
+                                    <p:set>
+                                      <p:cBhvr>
+                                        <p:cTn id="31" dur="1" fill="hold">
+                                          <p:stCondLst>
+                                            <p:cond delay="0"/>
+                                          </p:stCondLst>
+                                        </p:cTn>
+                                        <p:tgtEl>
+                                          <p:spTgt spid="20"/>
+                                        </p:tgtEl>
+                                        <p:attrNameLst>
+                                          <p:attrName>style.visibility</p:attrName>
+                                        </p:attrNameLst>
+                                      </p:cBhvr>
+                                      <p:to>
+                                        <p:strVal val="visible"/>
+                                      </p:to>
+                                    </p:set>
+                                    <p:animEffect transition="in" filter="fade">
+                                      <p:cBhvr>
+                                        <p:cTn id="32" dur="400"/>
+                                        <p:tgtEl>
+                                          <p:spTgt spid="20"/>
+                                        </p:tgtEl>
+                                      </p:cBhvr>
+                                    </p:animEffect>
+                                  </p:childTnLst>
+                                </p:cTn>
+                              </p:par>
+                              <p:par>
+                                <p:cTn id="33" presetID="10" presetClass="entr" presetSubtype="0" fill="hold" nodeType="withEffect">
+                                  <p:stCondLst>
+                                    <p:cond delay="0"/>
+                                  </p:stCondLst>
+                                  <p:childTnLst>
+                                    <p:set>
+                                      <p:cBhvr>
+                                        <p:cTn id="34" dur="1" fill="hold">
+                                          <p:stCondLst>
+                                            <p:cond delay="0"/>
+                                          </p:stCondLst>
+                                        </p:cTn>
+                                        <p:tgtEl>
+                                          <p:spTgt spid="21"/>
+                                        </p:tgtEl>
+                                        <p:attrNameLst>
+                                          <p:attrName>style.visibility</p:attrName>
+                                        </p:attrNameLst>
+                                      </p:cBhvr>
+                                      <p:to>
+                                        <p:strVal val="visible"/>
+                                      </p:to>
+                                    </p:set>
+                                    <p:animEffect transition="in" filter="fade">
+                                      <p:cBhvr>
+                                        <p:cTn id="35" dur="400"/>
+                                        <p:tgtEl>
+                                          <p:spTgt spid="21"/>
+                                        </p:tgtEl>
+                                      </p:cBhvr>
+                                    </p:animEffect>
+                                  </p:childTnLst>
+                                </p:cTn>
+                              </p:par>
+                              <p:par>
+                                <p:cTn id="36" presetID="10" presetClass="entr" presetSubtype="0" fill="hold" nodeType="withEffect">
+                                  <p:stCondLst>
+                                    <p:cond delay="0"/>
+                                  </p:stCondLst>
+                                  <p:childTnLst>
+                                    <p:set>
+                                      <p:cBhvr>
+                                        <p:cTn id="37" dur="1" fill="hold">
+                                          <p:stCondLst>
+                                            <p:cond delay="0"/>
+                                          </p:stCondLst>
+                                        </p:cTn>
+                                        <p:tgtEl>
+                                          <p:spTgt spid="22"/>
+                                        </p:tgtEl>
+                                        <p:attrNameLst>
+                                          <p:attrName>style.visibility</p:attrName>
+                                        </p:attrNameLst>
+                                      </p:cBhvr>
+                                      <p:to>
+                                        <p:strVal val="visible"/>
+                                      </p:to>
+                                    </p:set>
+                                    <p:animEffect transition="in" filter="fade">
+                                      <p:cBhvr>
+                                        <p:cTn id="38" dur="400"/>
+                                        <p:tgtEl>
+                                          <p:spTgt spid="22"/>
+                                        </p:tgtEl>
+                                      </p:cBhvr>
+                                    </p:animEffect>
+                                  </p:childTnLst>
+                                </p:cTn>
+                              </p:par>
+                              <p:par>
+                                <p:cTn id="39" presetID="10" presetClass="entr" presetSubtype="0" fill="hold" nodeType="withEffect">
+                                  <p:stCondLst>
+                                    <p:cond delay="0"/>
+                                  </p:stCondLst>
+                                  <p:childTnLst>
+                                    <p:set>
+                                      <p:cBhvr>
+                                        <p:cTn id="40" dur="1" fill="hold">
+                                          <p:stCondLst>
+                                            <p:cond delay="0"/>
+                                          </p:stCondLst>
+                                        </p:cTn>
+                                        <p:tgtEl>
+                                          <p:spTgt spid="23"/>
+                                        </p:tgtEl>
+                                        <p:attrNameLst>
+                                          <p:attrName>style.visibility</p:attrName>
+                                        </p:attrNameLst>
+                                      </p:cBhvr>
+                                      <p:to>
+                                        <p:strVal val="visible"/>
+                                      </p:to>
+                                    </p:set>
+                                    <p:animEffect transition="in" filter="fade">
+                                      <p:cBhvr>
+                                        <p:cTn id="41" dur="400"/>
+                                        <p:tgtEl>
+                                          <p:spTgt spid="23"/>
+                                        </p:tgtEl>
+                                      </p:cBhvr>
+                                    </p:animEffect>
+                                  </p:childTnLst>
+                                </p:cTn>
+                              </p:par>
+                              <p:par>
+                                <p:cTn id="42" presetID="10" presetClass="entr" presetSubtype="0" fill="hold" nodeType="withEffect">
+                                  <p:stCondLst>
+                                    <p:cond delay="0"/>
+                                  </p:stCondLst>
+                                  <p:childTnLst>
+                                    <p:set>
+                                      <p:cBhvr>
+                                        <p:cTn id="43" dur="1" fill="hold">
+                                          <p:stCondLst>
+                                            <p:cond delay="0"/>
+                                          </p:stCondLst>
+                                        </p:cTn>
+                                        <p:tgtEl>
+                                          <p:spTgt spid="24"/>
+                                        </p:tgtEl>
+                                        <p:attrNameLst>
+                                          <p:attrName>style.visibility</p:attrName>
+                                        </p:attrNameLst>
+                                      </p:cBhvr>
+                                      <p:to>
+                                        <p:strVal val="visible"/>
+                                      </p:to>
+                                    </p:set>
+                                    <p:animEffect transition="in" filter="fade">
+                                      <p:cBhvr>
+                                        <p:cTn id="44" dur="400"/>
+                                        <p:tgtEl>
+                                          <p:spTgt spid="24"/>
+                                        </p:tgtEl>
+                                      </p:cBhvr>
+                                    </p:animEffect>
+                                  </p:childTnLst>
+                                </p:cTn>
+                              </p:par>
+                              <p:par>
+                                <p:cTn id="45" presetID="10" presetClass="entr" presetSubtype="0" fill="hold" nodeType="withEffect">
+                                  <p:stCondLst>
+                                    <p:cond delay="0"/>
+                                  </p:stCondLst>
+                                  <p:childTnLst>
+                                    <p:set>
+                                      <p:cBhvr>
+                                        <p:cTn id="46" dur="1" fill="hold">
+                                          <p:stCondLst>
+                                            <p:cond delay="0"/>
+                                          </p:stCondLst>
+                                        </p:cTn>
+                                        <p:tgtEl>
+                                          <p:spTgt spid="25"/>
+                                        </p:tgtEl>
+                                        <p:attrNameLst>
+                                          <p:attrName>style.visibility</p:attrName>
+                                        </p:attrNameLst>
+                                      </p:cBhvr>
+                                      <p:to>
+                                        <p:strVal val="visible"/>
+                                      </p:to>
+                                    </p:set>
+                                    <p:animEffect transition="in" filter="fade">
+                                      <p:cBhvr>
+                                        <p:cTn id="47" dur="400"/>
+                                        <p:tgtEl>
+                                          <p:spTgt spid="25"/>
+                                        </p:tgtEl>
+                                      </p:cBhvr>
+                                    </p:animEffect>
+                                  </p:childTnLst>
+                                </p:cTn>
+                              </p:par>
+                              <p:par>
+                                <p:cTn id="48" presetID="10" presetClass="entr" presetSubtype="0" fill="hold" nodeType="withEffect">
+                                  <p:stCondLst>
+                                    <p:cond delay="0"/>
+                                  </p:stCondLst>
+                                  <p:childTnLst>
+                                    <p:set>
+                                      <p:cBhvr>
+                                        <p:cTn id="49" dur="1" fill="hold">
+                                          <p:stCondLst>
+                                            <p:cond delay="0"/>
+                                          </p:stCondLst>
+                                        </p:cTn>
+                                        <p:tgtEl>
+                                          <p:spTgt spid="26"/>
+                                        </p:tgtEl>
+                                        <p:attrNameLst>
+                                          <p:attrName>style.visibility</p:attrName>
+                                        </p:attrNameLst>
+                                      </p:cBhvr>
+                                      <p:to>
+                                        <p:strVal val="visible"/>
+                                      </p:to>
+                                    </p:set>
+                                    <p:animEffect transition="in" filter="fade">
+                                      <p:cBhvr>
+                                        <p:cTn id="50" dur="400"/>
+                                        <p:tgtEl>
+                                          <p:spTgt spid="26"/>
+                                        </p:tgtEl>
+                                      </p:cBhvr>
+                                    </p:animEffect>
+                                  </p:childTnLst>
+                                </p:cTn>
+                              </p:par>
+                              <p:par>
+                                <p:cTn id="51" presetID="10" presetClass="entr" presetSubtype="0" fill="hold" nodeType="withEffect">
+                                  <p:stCondLst>
+                                    <p:cond delay="0"/>
+                                  </p:stCondLst>
+                                  <p:childTnLst>
+                                    <p:set>
+                                      <p:cBhvr>
+                                        <p:cTn id="52" dur="1" fill="hold">
+                                          <p:stCondLst>
+                                            <p:cond delay="0"/>
+                                          </p:stCondLst>
+                                        </p:cTn>
+                                        <p:tgtEl>
+                                          <p:spTgt spid="27"/>
+                                        </p:tgtEl>
+                                        <p:attrNameLst>
+                                          <p:attrName>style.visibility</p:attrName>
+                                        </p:attrNameLst>
+                                      </p:cBhvr>
+                                      <p:to>
+                                        <p:strVal val="visible"/>
+                                      </p:to>
+                                    </p:set>
+                                    <p:animEffect transition="in" filter="fade">
+                                      <p:cBhvr>
+                                        <p:cTn id="53" dur="400"/>
+                                        <p:tgtEl>
+                                          <p:spTgt spid="27"/>
+                                        </p:tgtEl>
+                                      </p:cBhvr>
+                                    </p:animEffect>
+                                  </p:childTnLst>
+                                </p:cTn>
+                              </p:par>
+                              <p:par>
+                                <p:cTn id="54" presetID="10" presetClass="entr" presetSubtype="0" fill="hold" nodeType="withEffect">
+                                  <p:stCondLst>
+                                    <p:cond delay="0"/>
+                                  </p:stCondLst>
+                                  <p:childTnLst>
+                                    <p:set>
+                                      <p:cBhvr>
+                                        <p:cTn id="55" dur="1" fill="hold">
+                                          <p:stCondLst>
+                                            <p:cond delay="0"/>
+                                          </p:stCondLst>
+                                        </p:cTn>
+                                        <p:tgtEl>
+                                          <p:spTgt spid="28"/>
+                                        </p:tgtEl>
+                                        <p:attrNameLst>
+                                          <p:attrName>style.visibility</p:attrName>
+                                        </p:attrNameLst>
+                                      </p:cBhvr>
+                                      <p:to>
+                                        <p:strVal val="visible"/>
+                                      </p:to>
+                                    </p:set>
+                                    <p:animEffect transition="in" filter="fade">
+                                      <p:cBhvr>
+                                        <p:cTn id="56" dur="400"/>
+                                        <p:tgtEl>
+                                          <p:spTgt spid="28"/>
+                                        </p:tgtEl>
+                                      </p:cBhvr>
+                                    </p:animEffect>
+                                  </p:childTnLst>
+                                </p:cTn>
+                              </p:par>
+                              <p:par>
+                                <p:cTn id="57" presetID="10" presetClass="entr" presetSubtype="0" fill="hold" nodeType="withEffect">
+                                  <p:stCondLst>
+                                    <p:cond delay="0"/>
+                                  </p:stCondLst>
+                                  <p:childTnLst>
+                                    <p:set>
+                                      <p:cBhvr>
+                                        <p:cTn id="58" dur="1" fill="hold">
+                                          <p:stCondLst>
+                                            <p:cond delay="0"/>
+                                          </p:stCondLst>
+                                        </p:cTn>
+                                        <p:tgtEl>
+                                          <p:spTgt spid="29"/>
+                                        </p:tgtEl>
+                                        <p:attrNameLst>
+                                          <p:attrName>style.visibility</p:attrName>
+                                        </p:attrNameLst>
+                                      </p:cBhvr>
+                                      <p:to>
+                                        <p:strVal val="visible"/>
+                                      </p:to>
+                                    </p:set>
+                                    <p:animEffect transition="in" filter="fade">
+                                      <p:cBhvr>
+                                        <p:cTn id="59" dur="400"/>
+                                        <p:tgtEl>
+                                          <p:spTgt spid="29"/>
+                                        </p:tgtEl>
+                                      </p:cBhvr>
+                                    </p:animEffect>
+                                  </p:childTnLst>
+                                </p:cTn>
+                              </p:par>
+                              <p:par>
+                                <p:cTn id="60" presetID="10" presetClass="entr" presetSubtype="0" fill="hold" nodeType="withEffect">
+                                  <p:stCondLst>
+                                    <p:cond delay="0"/>
+                                  </p:stCondLst>
+                                  <p:childTnLst>
+                                    <p:set>
+                                      <p:cBhvr>
+                                        <p:cTn id="61" dur="1" fill="hold">
+                                          <p:stCondLst>
+                                            <p:cond delay="0"/>
+                                          </p:stCondLst>
+                                        </p:cTn>
+                                        <p:tgtEl>
+                                          <p:spTgt spid="30"/>
+                                        </p:tgtEl>
+                                        <p:attrNameLst>
+                                          <p:attrName>style.visibility</p:attrName>
+                                        </p:attrNameLst>
+                                      </p:cBhvr>
+                                      <p:to>
+                                        <p:strVal val="visible"/>
+                                      </p:to>
+                                    </p:set>
+                                    <p:animEffect transition="in" filter="fade">
+                                      <p:cBhvr>
+                                        <p:cTn id="62" dur="400"/>
+                                        <p:tgtEl>
+                                          <p:spTgt spid="30"/>
+                                        </p:tgtEl>
+                                      </p:cBhvr>
+                                    </p:animEffect>
+                                  </p:childTnLst>
+                                </p:cTn>
+                              </p:par>
+                              <p:par>
+                                <p:cTn id="63" presetID="10" presetClass="entr" presetSubtype="0" fill="hold" nodeType="withEffect">
+                                  <p:stCondLst>
+                                    <p:cond delay="0"/>
+                                  </p:stCondLst>
+                                  <p:childTnLst>
+                                    <p:set>
+                                      <p:cBhvr>
+                                        <p:cTn id="64" dur="1" fill="hold">
+                                          <p:stCondLst>
+                                            <p:cond delay="0"/>
+                                          </p:stCondLst>
+                                        </p:cTn>
+                                        <p:tgtEl>
+                                          <p:spTgt spid="33"/>
+                                        </p:tgtEl>
+                                        <p:attrNameLst>
+                                          <p:attrName>style.visibility</p:attrName>
+                                        </p:attrNameLst>
+                                      </p:cBhvr>
+                                      <p:to>
+                                        <p:strVal val="visible"/>
+                                      </p:to>
+                                    </p:set>
+                                    <p:animEffect transition="in" filter="fade">
+                                      <p:cBhvr>
+                                        <p:cTn id="65" dur="400"/>
+                                        <p:tgtEl>
+                                          <p:spTgt spid="33"/>
+                                        </p:tgtEl>
+                                      </p:cBhvr>
+                                    </p:animEffect>
+                                  </p:childTnLst>
+                                </p:cTn>
+                              </p:par>
+                              <p:par>
+                                <p:cTn id="66" presetID="10" presetClass="entr" presetSubtype="0" fill="hold" nodeType="withEffect">
+                                  <p:stCondLst>
+                                    <p:cond delay="0"/>
+                                  </p:stCondLst>
+                                  <p:childTnLst>
+                                    <p:set>
+                                      <p:cBhvr>
+                                        <p:cTn id="67" dur="1" fill="hold">
+                                          <p:stCondLst>
+                                            <p:cond delay="0"/>
+                                          </p:stCondLst>
+                                        </p:cTn>
+                                        <p:tgtEl>
+                                          <p:spTgt spid="34"/>
+                                        </p:tgtEl>
+                                        <p:attrNameLst>
+                                          <p:attrName>style.visibility</p:attrName>
+                                        </p:attrNameLst>
+                                      </p:cBhvr>
+                                      <p:to>
+                                        <p:strVal val="visible"/>
+                                      </p:to>
+                                    </p:set>
+                                    <p:animEffect transition="in" filter="fade">
+                                      <p:cBhvr>
+                                        <p:cTn id="68" dur="400"/>
+                                        <p:tgtEl>
+                                          <p:spTgt spid="34"/>
+                                        </p:tgtEl>
+                                      </p:cBhvr>
+                                    </p:animEffect>
+                                  </p:childTnLst>
+                                </p:cTn>
+                              </p:par>
+                            </p:childTnLst>
+                          </p:cTn>
+                        </p:par>
+                      </p:childTnLst>
+                    </p:cTn>
+                  </p:par>
+                  <p:par>
+                    <p:cTn id="77" fill="hold">
+                      <p:stCondLst>
+                        <p:cond delay="indefinite"/>
+                      </p:stCondLst>
+                      <p:childTnLst>
+                        <p:par>
+                          <p:cTn id="78" fill="hold">
+                            <p:stCondLst>
+                              <p:cond delay="0"/>
+                            </p:stCondLst>
+                            <p:childTnLst>
+                              <p:par>
+                                <p:cTn id="71" presetID="10" presetClass="entr" presetSubtype="0" fill="hold" nodeType="clickEffect">
+                                  <p:stCondLst>
+                                    <p:cond delay="0"/>
+                                  </p:stCondLst>
+                                  <p:childTnLst>
+                                    <p:set>
+                                      <p:cBhvr>
+                                        <p:cTn id="72" dur="1" fill="hold">
+                                          <p:stCondLst>
+                                            <p:cond delay="0"/>
+                                          </p:stCondLst>
+                                        </p:cTn>
+                                        <p:tgtEl>
+                                          <p:spTgt spid="35"/>
+                                        </p:tgtEl>
+                                        <p:attrNameLst>
+                                          <p:attrName>style.visibility</p:attrName>
+                                        </p:attrNameLst>
+                                      </p:cBhvr>
+                                      <p:to>
+                                        <p:strVal val="visible"/>
+                                      </p:to>
+                                    </p:set>
+                                    <p:animEffect transition="in" filter="fade">
+                                      <p:cBhvr>
+                                        <p:cTn id="73" dur="400"/>
+                                        <p:tgtEl>
+                                          <p:spTgt spid="35"/>
+                                        </p:tgtEl>
+                                      </p:cBhvr>
+                                    </p:animEffect>
+                                  </p:childTnLst>
+                                </p:cTn>
+                              </p:par>
+                              <p:par>
+                                <p:cTn id="74" presetID="10" presetClass="entr" presetSubtype="0" fill="hold" nodeType="withEffect">
+                                  <p:stCondLst>
+                                    <p:cond delay="0"/>
+                                  </p:stCondLst>
+                                  <p:childTnLst>
+                                    <p:set>
+                                      <p:cBhvr>
+                                        <p:cTn id="75" dur="1" fill="hold">
+                                          <p:stCondLst>
+                                            <p:cond delay="0"/>
+                                          </p:stCondLst>
+                                        </p:cTn>
+                                        <p:tgtEl>
+                                          <p:spTgt spid="36"/>
+                                        </p:tgtEl>
+                                        <p:attrNameLst>
+                                          <p:attrName>style.visibility</p:attrName>
+                                        </p:attrNameLst>
+                                      </p:cBhvr>
+                                      <p:to>
+                                        <p:strVal val="visible"/>
+                                      </p:to>
+                                    </p:set>
+                                    <p:animEffect transition="in" filter="fade">
+                                      <p:cBhvr>
+                                        <p:cTn id="76" dur="400"/>
+                                        <p:tgtEl>
+                                          <p:spTgt spid="36"/>
+                                        </p:tgtEl>
+                                      </p:cBhvr>
+                                    </p:animEffect>
+                                  </p:childTnLst>
+                                </p:cTn>
+                              </p:par>
+                            </p:childTnLst>
+                          </p:cTn>
+                        </p:par>
+                      </p:childTnLst>
+                    </p:cTn>
+                  </p:par>
+                </p:childTnLst>
+              </p:cTn>
+              <p:prevCondLst>
+                <p:cond evt="onPrev" delay="0">
+                  <p:tgtEl>
+                    <p:sldTgt/>
+                  </p:tgtEl>
+                </p:cond>
+              </p:prevCondLst>
+              <p:nextCondLst>
+                <p:cond evt="onNext" delay="0">
+                  <p:tgtEl>
+                    <p:sldTgt/>
+                  </p:tgtEl>
+                </p:cond>
+              </p:nextCondLst>
+            </p:seq>
+          </p:childTnLst>
+        </p:cTn>
+      </p:par>
+    </p:tnLst>
+    <p:bldLst>
+      <p:bldP spid="12" grpId="0"/>
+      <p:bldP spid="13" grpId="0"/>
+      <p:bldP spid="14" grpId="0"/>
+      <p:bldP spid="15" grpId="0"/>
+      <p:bldP spid="17" grpId="0"/>
+      <p:bldP spid="18" grpId="0"/>
+      <p:bldP spid="19" grpId="0"/>
+      <p:bldP spid="20" grpId="0"/>
+      <p:bldP spid="22" grpId="0"/>
+      <p:bldP spid="23" grpId="0"/>
+      <p:bldP spid="24" grpId="0"/>
+      <p:bldP spid="25" grpId="0"/>
+      <p:bldP spid="27" grpId="0"/>
+      <p:bldP spid="28" grpId="0"/>
+      <p:bldP spid="29" grpId="0"/>
+      <p:bldP spid="30" grpId="0"/>
+      <p:bldP spid="34" grpId="0"/>
+      <p:bldP spid="35" grpId="0"/>
+      <p:bldP spid="36" grpId="0"/>
+    </p:bldLst>
+  </p:timing>
 </p:sld>
 </file>
 
@@ -16639,6 +18327,9 @@
   <p:clrMapOvr>
     <a:masterClrMapping/>
   </p:clrMapOvr>
+  <p:transition spd="med">
+    <p:fade/>
+  </p:transition>
 </p:sld>
 </file>
 
@@ -17434,6 +19125,9 @@
   <p:clrMapOvr>
     <a:masterClrMapping/>
   </p:clrMapOvr>
+  <p:transition spd="med">
+    <p:fade/>
+  </p:transition>
 </p:sld>
 </file>
 
@@ -18452,6 +20146,9 @@
   <p:clrMapOvr>
     <a:masterClrMapping/>
   </p:clrMapOvr>
+  <p:transition spd="med">
+    <p:fade/>
+  </p:transition>
 </p:sld>
 </file>
 
@@ -19461,6 +21158,9 @@
   <p:clrMapOvr>
     <a:masterClrMapping/>
   </p:clrMapOvr>
+  <p:transition spd="med">
+    <p:fade/>
+  </p:transition>
 </p:sld>
 </file>
 
@@ -21258,6 +22958,9 @@
   <p:clrMapOvr>
     <a:masterClrMapping/>
   </p:clrMapOvr>
+  <p:transition spd="med">
+    <p:fade/>
+  </p:transition>
 </p:sld>
 </file>
 
@@ -22756,6 +24459,379 @@
   <p:clrMapOvr>
     <a:masterClrMapping/>
   </p:clrMapOvr>
+  <p:transition spd="med">
+    <p:fade/>
+  </p:transition>
+  <p:timing>
+    <p:tnLst>
+      <p:par>
+        <p:cTn id="1" dur="indefinite" restart="never" nodeType="tmRoot">
+          <p:childTnLst>
+            <p:seq concurrent="1" nextAc="seek">
+              <p:cTn id="2" dur="indefinite" nodeType="mainSeq">
+                <p:childTnLst>
+                  <p:par>
+                    <p:cTn id="30" fill="hold">
+                      <p:stCondLst>
+                        <p:cond delay="indefinite"/>
+                      </p:stCondLst>
+                      <p:childTnLst>
+                        <p:par>
+                          <p:cTn id="31" fill="hold">
+                            <p:stCondLst>
+                              <p:cond delay="0"/>
+                            </p:stCondLst>
+                            <p:childTnLst>
+                              <p:par>
+                                <p:cTn id="3" presetID="10" presetClass="entr" presetSubtype="0" fill="hold" nodeType="clickEffect">
+                                  <p:stCondLst>
+                                    <p:cond delay="0"/>
+                                  </p:stCondLst>
+                                  <p:childTnLst>
+                                    <p:set>
+                                      <p:cBhvr>
+                                        <p:cTn id="4" dur="1" fill="hold">
+                                          <p:stCondLst>
+                                            <p:cond delay="0"/>
+                                          </p:stCondLst>
+                                        </p:cTn>
+                                        <p:tgtEl>
+                                          <p:spTgt spid="31"/>
+                                        </p:tgtEl>
+                                        <p:attrNameLst>
+                                          <p:attrName>style.visibility</p:attrName>
+                                        </p:attrNameLst>
+                                      </p:cBhvr>
+                                      <p:to>
+                                        <p:strVal val="visible"/>
+                                      </p:to>
+                                    </p:set>
+                                    <p:animEffect transition="in" filter="fade">
+                                      <p:cBhvr>
+                                        <p:cTn id="5" dur="400"/>
+                                        <p:tgtEl>
+                                          <p:spTgt spid="31"/>
+                                        </p:tgtEl>
+                                      </p:cBhvr>
+                                    </p:animEffect>
+                                  </p:childTnLst>
+                                </p:cTn>
+                              </p:par>
+                              <p:par>
+                                <p:cTn id="6" presetID="10" presetClass="entr" presetSubtype="0" fill="hold" nodeType="withEffect">
+                                  <p:stCondLst>
+                                    <p:cond delay="0"/>
+                                  </p:stCondLst>
+                                  <p:childTnLst>
+                                    <p:set>
+                                      <p:cBhvr>
+                                        <p:cTn id="7" dur="1" fill="hold">
+                                          <p:stCondLst>
+                                            <p:cond delay="0"/>
+                                          </p:stCondLst>
+                                        </p:cTn>
+                                        <p:tgtEl>
+                                          <p:spTgt spid="32"/>
+                                        </p:tgtEl>
+                                        <p:attrNameLst>
+                                          <p:attrName>style.visibility</p:attrName>
+                                        </p:attrNameLst>
+                                      </p:cBhvr>
+                                      <p:to>
+                                        <p:strVal val="visible"/>
+                                      </p:to>
+                                    </p:set>
+                                    <p:animEffect transition="in" filter="fade">
+                                      <p:cBhvr>
+                                        <p:cTn id="8" dur="400"/>
+                                        <p:tgtEl>
+                                          <p:spTgt spid="32"/>
+                                        </p:tgtEl>
+                                      </p:cBhvr>
+                                    </p:animEffect>
+                                  </p:childTnLst>
+                                </p:cTn>
+                              </p:par>
+                              <p:par>
+                                <p:cTn id="9" presetID="10" presetClass="entr" presetSubtype="0" fill="hold" nodeType="withEffect">
+                                  <p:stCondLst>
+                                    <p:cond delay="0"/>
+                                  </p:stCondLst>
+                                  <p:childTnLst>
+                                    <p:set>
+                                      <p:cBhvr>
+                                        <p:cTn id="10" dur="1" fill="hold">
+                                          <p:stCondLst>
+                                            <p:cond delay="0"/>
+                                          </p:stCondLst>
+                                        </p:cTn>
+                                        <p:tgtEl>
+                                          <p:spTgt spid="33"/>
+                                        </p:tgtEl>
+                                        <p:attrNameLst>
+                                          <p:attrName>style.visibility</p:attrName>
+                                        </p:attrNameLst>
+                                      </p:cBhvr>
+                                      <p:to>
+                                        <p:strVal val="visible"/>
+                                      </p:to>
+                                    </p:set>
+                                    <p:animEffect transition="in" filter="fade">
+                                      <p:cBhvr>
+                                        <p:cTn id="11" dur="400"/>
+                                        <p:tgtEl>
+                                          <p:spTgt spid="33"/>
+                                        </p:tgtEl>
+                                      </p:cBhvr>
+                                    </p:animEffect>
+                                  </p:childTnLst>
+                                </p:cTn>
+                              </p:par>
+                              <p:par>
+                                <p:cTn id="12" presetID="10" presetClass="entr" presetSubtype="0" fill="hold" nodeType="withEffect">
+                                  <p:stCondLst>
+                                    <p:cond delay="0"/>
+                                  </p:stCondLst>
+                                  <p:childTnLst>
+                                    <p:set>
+                                      <p:cBhvr>
+                                        <p:cTn id="13" dur="1" fill="hold">
+                                          <p:stCondLst>
+                                            <p:cond delay="0"/>
+                                          </p:stCondLst>
+                                        </p:cTn>
+                                        <p:tgtEl>
+                                          <p:spTgt spid="34"/>
+                                        </p:tgtEl>
+                                        <p:attrNameLst>
+                                          <p:attrName>style.visibility</p:attrName>
+                                        </p:attrNameLst>
+                                      </p:cBhvr>
+                                      <p:to>
+                                        <p:strVal val="visible"/>
+                                      </p:to>
+                                    </p:set>
+                                    <p:animEffect transition="in" filter="fade">
+                                      <p:cBhvr>
+                                        <p:cTn id="14" dur="400"/>
+                                        <p:tgtEl>
+                                          <p:spTgt spid="34"/>
+                                        </p:tgtEl>
+                                      </p:cBhvr>
+                                    </p:animEffect>
+                                  </p:childTnLst>
+                                </p:cTn>
+                              </p:par>
+                              <p:par>
+                                <p:cTn id="15" presetID="10" presetClass="entr" presetSubtype="0" fill="hold" nodeType="withEffect">
+                                  <p:stCondLst>
+                                    <p:cond delay="0"/>
+                                  </p:stCondLst>
+                                  <p:childTnLst>
+                                    <p:set>
+                                      <p:cBhvr>
+                                        <p:cTn id="16" dur="1" fill="hold">
+                                          <p:stCondLst>
+                                            <p:cond delay="0"/>
+                                          </p:stCondLst>
+                                        </p:cTn>
+                                        <p:tgtEl>
+                                          <p:spTgt spid="35"/>
+                                        </p:tgtEl>
+                                        <p:attrNameLst>
+                                          <p:attrName>style.visibility</p:attrName>
+                                        </p:attrNameLst>
+                                      </p:cBhvr>
+                                      <p:to>
+                                        <p:strVal val="visible"/>
+                                      </p:to>
+                                    </p:set>
+                                    <p:animEffect transition="in" filter="fade">
+                                      <p:cBhvr>
+                                        <p:cTn id="17" dur="400"/>
+                                        <p:tgtEl>
+                                          <p:spTgt spid="35"/>
+                                        </p:tgtEl>
+                                      </p:cBhvr>
+                                    </p:animEffect>
+                                  </p:childTnLst>
+                                </p:cTn>
+                              </p:par>
+                              <p:par>
+                                <p:cTn id="18" presetID="10" presetClass="entr" presetSubtype="0" fill="hold" nodeType="withEffect">
+                                  <p:stCondLst>
+                                    <p:cond delay="0"/>
+                                  </p:stCondLst>
+                                  <p:childTnLst>
+                                    <p:set>
+                                      <p:cBhvr>
+                                        <p:cTn id="19" dur="1" fill="hold">
+                                          <p:stCondLst>
+                                            <p:cond delay="0"/>
+                                          </p:stCondLst>
+                                        </p:cTn>
+                                        <p:tgtEl>
+                                          <p:spTgt spid="36"/>
+                                        </p:tgtEl>
+                                        <p:attrNameLst>
+                                          <p:attrName>style.visibility</p:attrName>
+                                        </p:attrNameLst>
+                                      </p:cBhvr>
+                                      <p:to>
+                                        <p:strVal val="visible"/>
+                                      </p:to>
+                                    </p:set>
+                                    <p:animEffect transition="in" filter="fade">
+                                      <p:cBhvr>
+                                        <p:cTn id="20" dur="400"/>
+                                        <p:tgtEl>
+                                          <p:spTgt spid="36"/>
+                                        </p:tgtEl>
+                                      </p:cBhvr>
+                                    </p:animEffect>
+                                  </p:childTnLst>
+                                </p:cTn>
+                              </p:par>
+                              <p:par>
+                                <p:cTn id="21" presetID="10" presetClass="entr" presetSubtype="0" fill="hold" nodeType="withEffect">
+                                  <p:stCondLst>
+                                    <p:cond delay="0"/>
+                                  </p:stCondLst>
+                                  <p:childTnLst>
+                                    <p:set>
+                                      <p:cBhvr>
+                                        <p:cTn id="22" dur="1" fill="hold">
+                                          <p:stCondLst>
+                                            <p:cond delay="0"/>
+                                          </p:stCondLst>
+                                        </p:cTn>
+                                        <p:tgtEl>
+                                          <p:spTgt spid="37"/>
+                                        </p:tgtEl>
+                                        <p:attrNameLst>
+                                          <p:attrName>style.visibility</p:attrName>
+                                        </p:attrNameLst>
+                                      </p:cBhvr>
+                                      <p:to>
+                                        <p:strVal val="visible"/>
+                                      </p:to>
+                                    </p:set>
+                                    <p:animEffect transition="in" filter="fade">
+                                      <p:cBhvr>
+                                        <p:cTn id="23" dur="400"/>
+                                        <p:tgtEl>
+                                          <p:spTgt spid="37"/>
+                                        </p:tgtEl>
+                                      </p:cBhvr>
+                                    </p:animEffect>
+                                  </p:childTnLst>
+                                </p:cTn>
+                              </p:par>
+                              <p:par>
+                                <p:cTn id="24" presetID="10" presetClass="entr" presetSubtype="0" fill="hold" nodeType="withEffect">
+                                  <p:stCondLst>
+                                    <p:cond delay="0"/>
+                                  </p:stCondLst>
+                                  <p:childTnLst>
+                                    <p:set>
+                                      <p:cBhvr>
+                                        <p:cTn id="25" dur="1" fill="hold">
+                                          <p:stCondLst>
+                                            <p:cond delay="0"/>
+                                          </p:stCondLst>
+                                        </p:cTn>
+                                        <p:tgtEl>
+                                          <p:spTgt spid="38"/>
+                                        </p:tgtEl>
+                                        <p:attrNameLst>
+                                          <p:attrName>style.visibility</p:attrName>
+                                        </p:attrNameLst>
+                                      </p:cBhvr>
+                                      <p:to>
+                                        <p:strVal val="visible"/>
+                                      </p:to>
+                                    </p:set>
+                                    <p:animEffect transition="in" filter="fade">
+                                      <p:cBhvr>
+                                        <p:cTn id="26" dur="400"/>
+                                        <p:tgtEl>
+                                          <p:spTgt spid="38"/>
+                                        </p:tgtEl>
+                                      </p:cBhvr>
+                                    </p:animEffect>
+                                  </p:childTnLst>
+                                </p:cTn>
+                              </p:par>
+                              <p:par>
+                                <p:cTn id="27" presetID="10" presetClass="entr" presetSubtype="0" fill="hold" nodeType="withEffect">
+                                  <p:stCondLst>
+                                    <p:cond delay="0"/>
+                                  </p:stCondLst>
+                                  <p:childTnLst>
+                                    <p:set>
+                                      <p:cBhvr>
+                                        <p:cTn id="28" dur="1" fill="hold">
+                                          <p:stCondLst>
+                                            <p:cond delay="0"/>
+                                          </p:stCondLst>
+                                        </p:cTn>
+                                        <p:tgtEl>
+                                          <p:spTgt spid="39"/>
+                                        </p:tgtEl>
+                                        <p:attrNameLst>
+                                          <p:attrName>style.visibility</p:attrName>
+                                        </p:attrNameLst>
+                                      </p:cBhvr>
+                                      <p:to>
+                                        <p:strVal val="visible"/>
+                                      </p:to>
+                                    </p:set>
+                                    <p:animEffect transition="in" filter="fade">
+                                      <p:cBhvr>
+                                        <p:cTn id="29" dur="400"/>
+                                        <p:tgtEl>
+                                          <p:spTgt spid="39"/>
+                                        </p:tgtEl>
+                                      </p:cBhvr>
+                                    </p:animEffect>
+                                  </p:childTnLst>
+                                </p:cTn>
+                              </p:par>
+                            </p:childTnLst>
+                          </p:cTn>
+                        </p:par>
+                      </p:childTnLst>
+                    </p:cTn>
+                  </p:par>
+                </p:childTnLst>
+              </p:cTn>
+              <p:prevCondLst>
+                <p:cond evt="onPrev" delay="0">
+                  <p:tgtEl>
+                    <p:sldTgt/>
+                  </p:tgtEl>
+                </p:cond>
+              </p:prevCondLst>
+              <p:nextCondLst>
+                <p:cond evt="onNext" delay="0">
+                  <p:tgtEl>
+                    <p:sldTgt/>
+                  </p:tgtEl>
+                </p:cond>
+              </p:nextCondLst>
+            </p:seq>
+          </p:childTnLst>
+        </p:cTn>
+      </p:par>
+    </p:tnLst>
+    <p:bldLst>
+      <p:bldP spid="31" grpId="0"/>
+      <p:bldP spid="33" grpId="0"/>
+      <p:bldP spid="35" grpId="0"/>
+      <p:bldP spid="37" grpId="0"/>
+      <p:bldP spid="39" grpId="0"/>
+    </p:bldLst>
+  </p:timing>
 </p:sld>
 </file>
 
@@ -23619,6 +25695,239 @@
   <p:clrMapOvr>
     <a:masterClrMapping/>
   </p:clrMapOvr>
+  <p:transition spd="med">
+    <p:fade/>
+  </p:transition>
+  <p:timing>
+    <p:tnLst>
+      <p:par>
+        <p:cTn id="1" dur="indefinite" restart="never" nodeType="tmRoot">
+          <p:childTnLst>
+            <p:seq concurrent="1" nextAc="seek">
+              <p:cTn id="2" dur="indefinite" nodeType="mainSeq">
+                <p:childTnLst>
+                  <p:par>
+                    <p:cTn id="6" fill="hold">
+                      <p:stCondLst>
+                        <p:cond delay="indefinite"/>
+                      </p:stCondLst>
+                      <p:childTnLst>
+                        <p:par>
+                          <p:cTn id="7" fill="hold">
+                            <p:stCondLst>
+                              <p:cond delay="0"/>
+                            </p:stCondLst>
+                            <p:childTnLst>
+                              <p:par>
+                                <p:cTn id="3" presetID="10" presetClass="entr" presetSubtype="0" fill="hold" nodeType="clickEffect">
+                                  <p:stCondLst>
+                                    <p:cond delay="0"/>
+                                  </p:stCondLst>
+                                  <p:childTnLst>
+                                    <p:set>
+                                      <p:cBhvr>
+                                        <p:cTn id="4" dur="1" fill="hold">
+                                          <p:stCondLst>
+                                            <p:cond delay="0"/>
+                                          </p:stCondLst>
+                                        </p:cTn>
+                                        <p:tgtEl>
+                                          <p:spTgt spid="19"/>
+                                        </p:tgtEl>
+                                        <p:attrNameLst>
+                                          <p:attrName>style.visibility</p:attrName>
+                                        </p:attrNameLst>
+                                      </p:cBhvr>
+                                      <p:to>
+                                        <p:strVal val="visible"/>
+                                      </p:to>
+                                    </p:set>
+                                    <p:animEffect transition="in" filter="fade">
+                                      <p:cBhvr>
+                                        <p:cTn id="5" dur="400"/>
+                                        <p:tgtEl>
+                                          <p:spTgt spid="19"/>
+                                        </p:tgtEl>
+                                      </p:cBhvr>
+                                    </p:animEffect>
+                                  </p:childTnLst>
+                                </p:cTn>
+                              </p:par>
+                            </p:childTnLst>
+                          </p:cTn>
+                        </p:par>
+                      </p:childTnLst>
+                    </p:cTn>
+                  </p:par>
+                  <p:par>
+                    <p:cTn id="11" fill="hold">
+                      <p:stCondLst>
+                        <p:cond delay="indefinite"/>
+                      </p:stCondLst>
+                      <p:childTnLst>
+                        <p:par>
+                          <p:cTn id="12" fill="hold">
+                            <p:stCondLst>
+                              <p:cond delay="0"/>
+                            </p:stCondLst>
+                            <p:childTnLst>
+                              <p:par>
+                                <p:cTn id="8" presetID="10" presetClass="entr" presetSubtype="0" fill="hold" nodeType="clickEffect">
+                                  <p:stCondLst>
+                                    <p:cond delay="0"/>
+                                  </p:stCondLst>
+                                  <p:childTnLst>
+                                    <p:set>
+                                      <p:cBhvr>
+                                        <p:cTn id="9" dur="1" fill="hold">
+                                          <p:stCondLst>
+                                            <p:cond delay="0"/>
+                                          </p:stCondLst>
+                                        </p:cTn>
+                                        <p:tgtEl>
+                                          <p:spTgt spid="20"/>
+                                        </p:tgtEl>
+                                        <p:attrNameLst>
+                                          <p:attrName>style.visibility</p:attrName>
+                                        </p:attrNameLst>
+                                      </p:cBhvr>
+                                      <p:to>
+                                        <p:strVal val="visible"/>
+                                      </p:to>
+                                    </p:set>
+                                    <p:animEffect transition="in" filter="fade">
+                                      <p:cBhvr>
+                                        <p:cTn id="10" dur="400"/>
+                                        <p:tgtEl>
+                                          <p:spTgt spid="20"/>
+                                        </p:tgtEl>
+                                      </p:cBhvr>
+                                    </p:animEffect>
+                                  </p:childTnLst>
+                                </p:cTn>
+                              </p:par>
+                            </p:childTnLst>
+                          </p:cTn>
+                        </p:par>
+                      </p:childTnLst>
+                    </p:cTn>
+                  </p:par>
+                  <p:par>
+                    <p:cTn id="19" fill="hold">
+                      <p:stCondLst>
+                        <p:cond delay="indefinite"/>
+                      </p:stCondLst>
+                      <p:childTnLst>
+                        <p:par>
+                          <p:cTn id="20" fill="hold">
+                            <p:stCondLst>
+                              <p:cond delay="0"/>
+                            </p:stCondLst>
+                            <p:childTnLst>
+                              <p:par>
+                                <p:cTn id="13" presetID="10" presetClass="entr" presetSubtype="0" fill="hold" nodeType="clickEffect">
+                                  <p:stCondLst>
+                                    <p:cond delay="0"/>
+                                  </p:stCondLst>
+                                  <p:childTnLst>
+                                    <p:set>
+                                      <p:cBhvr>
+                                        <p:cTn id="14" dur="1" fill="hold">
+                                          <p:stCondLst>
+                                            <p:cond delay="0"/>
+                                          </p:stCondLst>
+                                        </p:cTn>
+                                        <p:tgtEl>
+                                          <p:spTgt spid="21"/>
+                                        </p:tgtEl>
+                                        <p:attrNameLst>
+                                          <p:attrName>style.visibility</p:attrName>
+                                        </p:attrNameLst>
+                                      </p:cBhvr>
+                                      <p:to>
+                                        <p:strVal val="visible"/>
+                                      </p:to>
+                                    </p:set>
+                                    <p:animEffect transition="in" filter="fade">
+                                      <p:cBhvr>
+                                        <p:cTn id="15" dur="400"/>
+                                        <p:tgtEl>
+                                          <p:spTgt spid="21"/>
+                                        </p:tgtEl>
+                                      </p:cBhvr>
+                                    </p:animEffect>
+                                  </p:childTnLst>
+                                </p:cTn>
+                              </p:par>
+                              <p:par>
+                                <p:cTn id="16" presetID="10" presetClass="entr" presetSubtype="0" fill="hold" nodeType="withEffect">
+                                  <p:stCondLst>
+                                    <p:cond delay="0"/>
+                                  </p:stCondLst>
+                                  <p:childTnLst>
+                                    <p:set>
+                                      <p:cBhvr>
+                                        <p:cTn id="17" dur="1" fill="hold">
+                                          <p:stCondLst>
+                                            <p:cond delay="0"/>
+                                          </p:stCondLst>
+                                        </p:cTn>
+                                        <p:tgtEl>
+                                          <p:spTgt spid="22"/>
+                                        </p:tgtEl>
+                                        <p:attrNameLst>
+                                          <p:attrName>style.visibility</p:attrName>
+                                        </p:attrNameLst>
+                                      </p:cBhvr>
+                                      <p:to>
+                                        <p:strVal val="visible"/>
+                                      </p:to>
+                                    </p:set>
+                                    <p:animEffect transition="in" filter="fade">
+                                      <p:cBhvr>
+                                        <p:cTn id="18" dur="400"/>
+                                        <p:tgtEl>
+                                          <p:spTgt spid="22"/>
+                                        </p:tgtEl>
+                                      </p:cBhvr>
+                                    </p:animEffect>
+                                  </p:childTnLst>
+                                </p:cTn>
+                              </p:par>
+                            </p:childTnLst>
+                          </p:cTn>
+                        </p:par>
+                      </p:childTnLst>
+                    </p:cTn>
+                  </p:par>
+                </p:childTnLst>
+              </p:cTn>
+              <p:prevCondLst>
+                <p:cond evt="onPrev" delay="0">
+                  <p:tgtEl>
+                    <p:sldTgt/>
+                  </p:tgtEl>
+                </p:cond>
+              </p:prevCondLst>
+              <p:nextCondLst>
+                <p:cond evt="onNext" delay="0">
+                  <p:tgtEl>
+                    <p:sldTgt/>
+                  </p:tgtEl>
+                </p:cond>
+              </p:nextCondLst>
+            </p:seq>
+          </p:childTnLst>
+        </p:cTn>
+      </p:par>
+    </p:tnLst>
+    <p:bldLst>
+      <p:bldP spid="19" grpId="0"/>
+      <p:bldP spid="20" grpId="0"/>
+      <p:bldP spid="21" grpId="0"/>
+      <p:bldP spid="22" grpId="0"/>
+    </p:bldLst>
+  </p:timing>
 </p:sld>
 </file>
 
@@ -24977,6 +27286,419 @@
   <p:clrMapOvr>
     <a:masterClrMapping/>
   </p:clrMapOvr>
+  <p:transition spd="med">
+    <p:fade/>
+  </p:transition>
+  <p:timing>
+    <p:tnLst>
+      <p:par>
+        <p:cTn id="1" dur="indefinite" restart="never" nodeType="tmRoot">
+          <p:childTnLst>
+            <p:seq concurrent="1" nextAc="seek">
+              <p:cTn id="2" dur="indefinite" nodeType="mainSeq">
+                <p:childTnLst>
+                  <p:par>
+                    <p:cTn id="33" fill="hold">
+                      <p:stCondLst>
+                        <p:cond delay="indefinite"/>
+                      </p:stCondLst>
+                      <p:childTnLst>
+                        <p:par>
+                          <p:cTn id="34" fill="hold">
+                            <p:stCondLst>
+                              <p:cond delay="0"/>
+                            </p:stCondLst>
+                            <p:childTnLst>
+                              <p:par>
+                                <p:cTn id="3" presetID="10" presetClass="entr" presetSubtype="0" fill="hold" nodeType="clickEffect">
+                                  <p:stCondLst>
+                                    <p:cond delay="0"/>
+                                  </p:stCondLst>
+                                  <p:childTnLst>
+                                    <p:set>
+                                      <p:cBhvr>
+                                        <p:cTn id="4" dur="1" fill="hold">
+                                          <p:stCondLst>
+                                            <p:cond delay="0"/>
+                                          </p:stCondLst>
+                                        </p:cTn>
+                                        <p:tgtEl>
+                                          <p:spTgt spid="32"/>
+                                        </p:tgtEl>
+                                        <p:attrNameLst>
+                                          <p:attrName>style.visibility</p:attrName>
+                                        </p:attrNameLst>
+                                      </p:cBhvr>
+                                      <p:to>
+                                        <p:strVal val="visible"/>
+                                      </p:to>
+                                    </p:set>
+                                    <p:animEffect transition="in" filter="fade">
+                                      <p:cBhvr>
+                                        <p:cTn id="5" dur="400"/>
+                                        <p:tgtEl>
+                                          <p:spTgt spid="32"/>
+                                        </p:tgtEl>
+                                      </p:cBhvr>
+                                    </p:animEffect>
+                                  </p:childTnLst>
+                                </p:cTn>
+                              </p:par>
+                              <p:par>
+                                <p:cTn id="6" presetID="10" presetClass="entr" presetSubtype="0" fill="hold" nodeType="withEffect">
+                                  <p:stCondLst>
+                                    <p:cond delay="0"/>
+                                  </p:stCondLst>
+                                  <p:childTnLst>
+                                    <p:set>
+                                      <p:cBhvr>
+                                        <p:cTn id="7" dur="1" fill="hold">
+                                          <p:stCondLst>
+                                            <p:cond delay="0"/>
+                                          </p:stCondLst>
+                                        </p:cTn>
+                                        <p:tgtEl>
+                                          <p:spTgt spid="33"/>
+                                        </p:tgtEl>
+                                        <p:attrNameLst>
+                                          <p:attrName>style.visibility</p:attrName>
+                                        </p:attrNameLst>
+                                      </p:cBhvr>
+                                      <p:to>
+                                        <p:strVal val="visible"/>
+                                      </p:to>
+                                    </p:set>
+                                    <p:animEffect transition="in" filter="fade">
+                                      <p:cBhvr>
+                                        <p:cTn id="8" dur="400"/>
+                                        <p:tgtEl>
+                                          <p:spTgt spid="33"/>
+                                        </p:tgtEl>
+                                      </p:cBhvr>
+                                    </p:animEffect>
+                                  </p:childTnLst>
+                                </p:cTn>
+                              </p:par>
+                              <p:par>
+                                <p:cTn id="9" presetID="10" presetClass="entr" presetSubtype="0" fill="hold" nodeType="withEffect">
+                                  <p:stCondLst>
+                                    <p:cond delay="0"/>
+                                  </p:stCondLst>
+                                  <p:childTnLst>
+                                    <p:set>
+                                      <p:cBhvr>
+                                        <p:cTn id="10" dur="1" fill="hold">
+                                          <p:stCondLst>
+                                            <p:cond delay="0"/>
+                                          </p:stCondLst>
+                                        </p:cTn>
+                                        <p:tgtEl>
+                                          <p:spTgt spid="34"/>
+                                        </p:tgtEl>
+                                        <p:attrNameLst>
+                                          <p:attrName>style.visibility</p:attrName>
+                                        </p:attrNameLst>
+                                      </p:cBhvr>
+                                      <p:to>
+                                        <p:strVal val="visible"/>
+                                      </p:to>
+                                    </p:set>
+                                    <p:animEffect transition="in" filter="fade">
+                                      <p:cBhvr>
+                                        <p:cTn id="11" dur="400"/>
+                                        <p:tgtEl>
+                                          <p:spTgt spid="34"/>
+                                        </p:tgtEl>
+                                      </p:cBhvr>
+                                    </p:animEffect>
+                                  </p:childTnLst>
+                                </p:cTn>
+                              </p:par>
+                              <p:par>
+                                <p:cTn id="12" presetID="10" presetClass="entr" presetSubtype="0" fill="hold" nodeType="withEffect">
+                                  <p:stCondLst>
+                                    <p:cond delay="0"/>
+                                  </p:stCondLst>
+                                  <p:childTnLst>
+                                    <p:set>
+                                      <p:cBhvr>
+                                        <p:cTn id="13" dur="1" fill="hold">
+                                          <p:stCondLst>
+                                            <p:cond delay="0"/>
+                                          </p:stCondLst>
+                                        </p:cTn>
+                                        <p:tgtEl>
+                                          <p:spTgt spid="35"/>
+                                        </p:tgtEl>
+                                        <p:attrNameLst>
+                                          <p:attrName>style.visibility</p:attrName>
+                                        </p:attrNameLst>
+                                      </p:cBhvr>
+                                      <p:to>
+                                        <p:strVal val="visible"/>
+                                      </p:to>
+                                    </p:set>
+                                    <p:animEffect transition="in" filter="fade">
+                                      <p:cBhvr>
+                                        <p:cTn id="14" dur="400"/>
+                                        <p:tgtEl>
+                                          <p:spTgt spid="35"/>
+                                        </p:tgtEl>
+                                      </p:cBhvr>
+                                    </p:animEffect>
+                                  </p:childTnLst>
+                                </p:cTn>
+                              </p:par>
+                              <p:par>
+                                <p:cTn id="15" presetID="10" presetClass="entr" presetSubtype="0" fill="hold" nodeType="withEffect">
+                                  <p:stCondLst>
+                                    <p:cond delay="0"/>
+                                  </p:stCondLst>
+                                  <p:childTnLst>
+                                    <p:set>
+                                      <p:cBhvr>
+                                        <p:cTn id="16" dur="1" fill="hold">
+                                          <p:stCondLst>
+                                            <p:cond delay="0"/>
+                                          </p:stCondLst>
+                                        </p:cTn>
+                                        <p:tgtEl>
+                                          <p:spTgt spid="36"/>
+                                        </p:tgtEl>
+                                        <p:attrNameLst>
+                                          <p:attrName>style.visibility</p:attrName>
+                                        </p:attrNameLst>
+                                      </p:cBhvr>
+                                      <p:to>
+                                        <p:strVal val="visible"/>
+                                      </p:to>
+                                    </p:set>
+                                    <p:animEffect transition="in" filter="fade">
+                                      <p:cBhvr>
+                                        <p:cTn id="17" dur="400"/>
+                                        <p:tgtEl>
+                                          <p:spTgt spid="36"/>
+                                        </p:tgtEl>
+                                      </p:cBhvr>
+                                    </p:animEffect>
+                                  </p:childTnLst>
+                                </p:cTn>
+                              </p:par>
+                              <p:par>
+                                <p:cTn id="18" presetID="10" presetClass="entr" presetSubtype="0" fill="hold" nodeType="withEffect">
+                                  <p:stCondLst>
+                                    <p:cond delay="0"/>
+                                  </p:stCondLst>
+                                  <p:childTnLst>
+                                    <p:set>
+                                      <p:cBhvr>
+                                        <p:cTn id="19" dur="1" fill="hold">
+                                          <p:stCondLst>
+                                            <p:cond delay="0"/>
+                                          </p:stCondLst>
+                                        </p:cTn>
+                                        <p:tgtEl>
+                                          <p:spTgt spid="37"/>
+                                        </p:tgtEl>
+                                        <p:attrNameLst>
+                                          <p:attrName>style.visibility</p:attrName>
+                                        </p:attrNameLst>
+                                      </p:cBhvr>
+                                      <p:to>
+                                        <p:strVal val="visible"/>
+                                      </p:to>
+                                    </p:set>
+                                    <p:animEffect transition="in" filter="fade">
+                                      <p:cBhvr>
+                                        <p:cTn id="20" dur="400"/>
+                                        <p:tgtEl>
+                                          <p:spTgt spid="37"/>
+                                        </p:tgtEl>
+                                      </p:cBhvr>
+                                    </p:animEffect>
+                                  </p:childTnLst>
+                                </p:cTn>
+                              </p:par>
+                              <p:par>
+                                <p:cTn id="21" presetID="10" presetClass="entr" presetSubtype="0" fill="hold" nodeType="withEffect">
+                                  <p:stCondLst>
+                                    <p:cond delay="0"/>
+                                  </p:stCondLst>
+                                  <p:childTnLst>
+                                    <p:set>
+                                      <p:cBhvr>
+                                        <p:cTn id="22" dur="1" fill="hold">
+                                          <p:stCondLst>
+                                            <p:cond delay="0"/>
+                                          </p:stCondLst>
+                                        </p:cTn>
+                                        <p:tgtEl>
+                                          <p:spTgt spid="38"/>
+                                        </p:tgtEl>
+                                        <p:attrNameLst>
+                                          <p:attrName>style.visibility</p:attrName>
+                                        </p:attrNameLst>
+                                      </p:cBhvr>
+                                      <p:to>
+                                        <p:strVal val="visible"/>
+                                      </p:to>
+                                    </p:set>
+                                    <p:animEffect transition="in" filter="fade">
+                                      <p:cBhvr>
+                                        <p:cTn id="23" dur="400"/>
+                                        <p:tgtEl>
+                                          <p:spTgt spid="38"/>
+                                        </p:tgtEl>
+                                      </p:cBhvr>
+                                    </p:animEffect>
+                                  </p:childTnLst>
+                                </p:cTn>
+                              </p:par>
+                              <p:par>
+                                <p:cTn id="24" presetID="10" presetClass="entr" presetSubtype="0" fill="hold" nodeType="withEffect">
+                                  <p:stCondLst>
+                                    <p:cond delay="0"/>
+                                  </p:stCondLst>
+                                  <p:childTnLst>
+                                    <p:set>
+                                      <p:cBhvr>
+                                        <p:cTn id="25" dur="1" fill="hold">
+                                          <p:stCondLst>
+                                            <p:cond delay="0"/>
+                                          </p:stCondLst>
+                                        </p:cTn>
+                                        <p:tgtEl>
+                                          <p:spTgt spid="39"/>
+                                        </p:tgtEl>
+                                        <p:attrNameLst>
+                                          <p:attrName>style.visibility</p:attrName>
+                                        </p:attrNameLst>
+                                      </p:cBhvr>
+                                      <p:to>
+                                        <p:strVal val="visible"/>
+                                      </p:to>
+                                    </p:set>
+                                    <p:animEffect transition="in" filter="fade">
+                                      <p:cBhvr>
+                                        <p:cTn id="26" dur="400"/>
+                                        <p:tgtEl>
+                                          <p:spTgt spid="39"/>
+                                        </p:tgtEl>
+                                      </p:cBhvr>
+                                    </p:animEffect>
+                                  </p:childTnLst>
+                                </p:cTn>
+                              </p:par>
+                              <p:par>
+                                <p:cTn id="27" presetID="10" presetClass="entr" presetSubtype="0" fill="hold" nodeType="withEffect">
+                                  <p:stCondLst>
+                                    <p:cond delay="0"/>
+                                  </p:stCondLst>
+                                  <p:childTnLst>
+                                    <p:set>
+                                      <p:cBhvr>
+                                        <p:cTn id="28" dur="1" fill="hold">
+                                          <p:stCondLst>
+                                            <p:cond delay="0"/>
+                                          </p:stCondLst>
+                                        </p:cTn>
+                                        <p:tgtEl>
+                                          <p:spTgt spid="40"/>
+                                        </p:tgtEl>
+                                        <p:attrNameLst>
+                                          <p:attrName>style.visibility</p:attrName>
+                                        </p:attrNameLst>
+                                      </p:cBhvr>
+                                      <p:to>
+                                        <p:strVal val="visible"/>
+                                      </p:to>
+                                    </p:set>
+                                    <p:animEffect transition="in" filter="fade">
+                                      <p:cBhvr>
+                                        <p:cTn id="29" dur="400"/>
+                                        <p:tgtEl>
+                                          <p:spTgt spid="40"/>
+                                        </p:tgtEl>
+                                      </p:cBhvr>
+                                    </p:animEffect>
+                                  </p:childTnLst>
+                                </p:cTn>
+                              </p:par>
+                              <p:par>
+                                <p:cTn id="30" presetID="10" presetClass="entr" presetSubtype="0" fill="hold" nodeType="withEffect">
+                                  <p:stCondLst>
+                                    <p:cond delay="0"/>
+                                  </p:stCondLst>
+                                  <p:childTnLst>
+                                    <p:set>
+                                      <p:cBhvr>
+                                        <p:cTn id="31" dur="1" fill="hold">
+                                          <p:stCondLst>
+                                            <p:cond delay="0"/>
+                                          </p:stCondLst>
+                                        </p:cTn>
+                                        <p:tgtEl>
+                                          <p:spTgt spid="41"/>
+                                        </p:tgtEl>
+                                        <p:attrNameLst>
+                                          <p:attrName>style.visibility</p:attrName>
+                                        </p:attrNameLst>
+                                      </p:cBhvr>
+                                      <p:to>
+                                        <p:strVal val="visible"/>
+                                      </p:to>
+                                    </p:set>
+                                    <p:animEffect transition="in" filter="fade">
+                                      <p:cBhvr>
+                                        <p:cTn id="32" dur="400"/>
+                                        <p:tgtEl>
+                                          <p:spTgt spid="41"/>
+                                        </p:tgtEl>
+                                      </p:cBhvr>
+                                    </p:animEffect>
+                                  </p:childTnLst>
+                                </p:cTn>
+                              </p:par>
+                            </p:childTnLst>
+                          </p:cTn>
+                        </p:par>
+                      </p:childTnLst>
+                    </p:cTn>
+                  </p:par>
+                </p:childTnLst>
+              </p:cTn>
+              <p:prevCondLst>
+                <p:cond evt="onPrev" delay="0">
+                  <p:tgtEl>
+                    <p:sldTgt/>
+                  </p:tgtEl>
+                </p:cond>
+              </p:prevCondLst>
+              <p:nextCondLst>
+                <p:cond evt="onNext" delay="0">
+                  <p:tgtEl>
+                    <p:sldTgt/>
+                  </p:tgtEl>
+                </p:cond>
+              </p:nextCondLst>
+            </p:seq>
+          </p:childTnLst>
+        </p:cTn>
+      </p:par>
+    </p:tnLst>
+    <p:bldLst>
+      <p:bldP spid="32" grpId="0"/>
+      <p:bldP spid="33" grpId="0"/>
+      <p:bldP spid="34" grpId="0"/>
+      <p:bldP spid="35" grpId="0"/>
+      <p:bldP spid="36" grpId="0"/>
+      <p:bldP spid="37" grpId="0"/>
+      <p:bldP spid="38" grpId="0"/>
+      <p:bldP spid="39" grpId="0"/>
+      <p:bldP spid="40" grpId="0"/>
+      <p:bldP spid="41" grpId="0"/>
+    </p:bldLst>
+  </p:timing>
 </p:sld>
 </file>
 

</xml_diff>

<commit_message>
Compact speaker script to fit a 10-minute defense (slides unchanged)
Co-Authored-By: Claude Opus 5.5 <noreply@anthropic.com>
Claude-Session: https://claude.ai/code/session_01AnZDiX8uz3hSw1L6vhKaQS
</commit_message>
<xml_diff>
--- a/Soutenance_Stage_ENSI_Final.pptx
+++ b/Soutenance_Stage_ENSI_Final.pptx
@@ -521,7 +521,7 @@
           <a:lstStyle/>
           <a:p>
             <a:r>
-              <a:t>⏱ 0:30 (cumul 0:30)</a:t>
+              <a:t>⏱ 0:20 (cumul 0:20)</a:t>
             </a:r>
           </a:p>
           <a:p/>
@@ -532,13 +532,13 @@
           </a:p>
           <a:p>
             <a:r>
-              <a:t>Madame, Monsieur les membres du jury, bonjour. Je vais vous présenter le travail de mon stage d'été de six semaines chez Codingaholic, à La Marsa, encadré par M. Jendoubi : un module mobile qui détecte et capture automatiquement le recto puis le verso de la carte d'identité nationale tunisienne, pour l'application Avatar-ID. Je vais suivre le fil contexte, conception, résultats, puis bilan, en une quinzaine de minutes.</a:t>
+              <a:t>Bonjour. Je présente mon stage d'été de six semaines chez Codingaholic, encadré par M. Jendoubi : un module mobile qui détecte et capture automatiquement le recto puis le verso de la carte d'identité tunisienne, pour l'application Avatar-ID.</a:t>
             </a:r>
           </a:p>
           <a:p/>
           <a:p>
             <a:r>
-              <a:t>TRANSITION — « Commençons par situer le module dans Avatar-ID. »</a:t>
+              <a:t>TRANSITION — « D'abord, le contexte. »</a:t>
             </a:r>
           </a:p>
           <a:p/>
@@ -619,7 +619,7 @@
           <a:lstStyle/>
           <a:p>
             <a:r>
-              <a:t>⏱ 1:10 (cumul 9:40)</a:t>
+              <a:t>⏱ 0:35 (cumul 5:30)</a:t>
             </a:r>
           </a:p>
           <a:p/>
@@ -636,13 +636,13 @@
           </a:p>
           <a:p>
             <a:r>
-              <a:t>Pour savoir quelle face est présentée, j'exploite la mise en page de la CIN. Au recto, la photo est toujours dans le quart supérieur gauche. J'y cherche un visage avec la cascade de Haar standard d'OpenCV — pré-entraînée, je ne l'ai pas entraînée sur la CIN — en testant les quatre rotations : celle qui trouve le visage me donne en plus l'orientation de la carte. Je confirme ensuite avec le logo et le drapeau par template matching, avec une corrélation d'au moins 0,6 ; ce sont les gabarits que vous voyez, embarqués dans l'application. Le verso n'a pas de visage : trois indices votent sur les quatre rotations — la localisation du code-barres, la texture de l'empreinte mesurée par la variance du Laplacien, et la ligne de séparation trouvée par une transformée de Hough. Conséquence : après le recto, présenter à nouveau le recto ne déclenche rien. Les images montrent les silhouettes de guidage de l'application, pas des détections.</a:t>
+              <a:t>[clic] Le recto se reconnaît au visage, détecté par une cascade de Haar d'OpenCV sur quatre rotations, ce qui donne aussi l'orientation, puis au logo et au drapeau. [clic] Le verso n'a pas de visage : le code-barres, l'empreinte et la ligne de séparation votent sur quatre rotations. [clic] Ainsi, présenter deux fois le recto ne déclenche rien.</a:t>
             </a:r>
           </a:p>
           <a:p/>
           <a:p>
             <a:r>
-              <a:t>TRANSITION — « Voyons maintenant ce que l'utilisateur obtient. »</a:t>
+              <a:t>TRANSITION — « Côté utilisateur. »</a:t>
             </a:r>
           </a:p>
           <a:p/>
@@ -723,7 +723,7 @@
           <a:lstStyle/>
           <a:p>
             <a:r>
-              <a:t>⏱ 1:15 (cumul 10:55) — si la démonstration en direct est prévue, la lancer ici (≈ 45 s) et raccourcir le commentaire.</a:t>
+              <a:t>⏱ 0:35 (cumul 6:05)</a:t>
             </a:r>
           </a:p>
           <a:p/>
@@ -735,18 +735,18 @@
           <a:p/>
           <a:p>
             <a:r>
-              <a:t>TEXTE ORAL</a:t>
-            </a:r>
-          </a:p>
-          <a:p>
-            <a:r>
-              <a:t>Voici le parcours tel qu'il apparaît à l'écran, sur des captures de ma session de test où les données de la carte sont masquées. L'utilisateur présente le recto puis le verso : les deux captures partent seules. Il arrive ensuite sur l'écran de vérification : il peut régler le contraste, activer la netteté ou un mode scan noir et blanc. Il peut ajuster chaque face séparément, en glissant les coins du cadre ou en la faisant pivoter, sans perdre l'autre face. Enfin, il exporte vers la galerie le recto, le verso et une page A4 à 300 dpi qui compose les deux faces comme un scanner ; il retrouve ses captures dans l'historique. Pour Avatar-ID, le module restitue les deux images finales et, si besoin, la page A4.</a:t>
+              <a:t>TEXTE ORAL (si démonstration en direct : la lancer ici, ≈ 45 s, et sauter ce texte)</a:t>
+            </a:r>
+          </a:p>
+          <a:p>
+            <a:r>
+              <a:t>Une fois les deux faces capturées, l'utilisateur [clic] vérifie et règle contraste et netteté, [clic] ajuste le recadrage si besoin, [clic] puis exporte le recto, le verso et une page A4. Tout est traité sur l'appareil.</a:t>
             </a:r>
           </a:p>
           <a:p/>
           <a:p>
             <a:r>
-              <a:t>TRANSITION — « Comment ai-je vérifié que tout cela fonctionne ? »</a:t>
+              <a:t>TRANSITION — « Comment l'ai-je validé ? »</a:t>
             </a:r>
           </a:p>
           <a:p/>
@@ -832,7 +832,7 @@
           <a:lstStyle/>
           <a:p>
             <a:r>
-              <a:t>⏱ 0:50 (cumul 11:45)</a:t>
+              <a:t>⏱ 0:25 (cumul 6:30)</a:t>
             </a:r>
           </a:p>
           <a:p/>
@@ -849,13 +849,13 @@
           </a:p>
           <a:p>
             <a:r>
-              <a:t>Pour les tests automatisés, j'ai organisé la suite en quatre paliers, selon ce dont chaque test a besoin pour tourner. Palier A : la logique Dart pure, comme la machine à états, la décision de capture ou la stabilité. Palier B : les plugins simulés avec mocktail, pour la caméra, les permissions et le stockage. Palier C : le vrai binaire OpenCV, sur des images synthétiques générées dans le test. Palier D : les vraies cartes, sur téléphone, avec un protocole de test manuel. Lors de la dernière campagne, 177 cas de test sont passés, sans aucun échec, en seize secondes. C'est la séparation en couches qui rend ces tests rapides.</a:t>
+              <a:t>177 tests automatisés passent sans échec, répartis en quatre paliers : [clic] la logique pure, [clic] la plateforme simulée, [clic] OpenCV sur images synthétiques, [clic] et les vraies cartes sur téléphone.</a:t>
             </a:r>
           </a:p>
           <a:p/>
           <a:p>
             <a:r>
-              <a:t>TRANSITION — « Le palier D a produit trois mesures sur appareil réel. »</a:t>
+              <a:t>TRANSITION — « Et sur appareil réel ? »</a:t>
             </a:r>
           </a:p>
           <a:p/>
@@ -941,7 +941,7 @@
           <a:lstStyle/>
           <a:p>
             <a:r>
-              <a:t>⏱ 1:00 (cumul 12:45)</a:t>
+              <a:t>⏱ 0:30 (cumul 7:00)</a:t>
             </a:r>
           </a:p>
           <a:p/>
@@ -958,13 +958,13 @@
           </a:p>
           <a:p>
             <a:r>
-              <a:t>Sur appareil réel, j'ai relevé trois mesures face aux trois cibles. Le traitement d'une image dans l'isolate prend entre 92 et 100 millisecondes, pour une cible de moins de 100. Le recto et le verso sont bien reconnus dans 92 % des cas, pour une cible de 90 % en conditions normales, c'est-à-dire en intérieur éclairé, carte à plat, sans reflet. Et la capture part environ deux secondes après la stabilisation du cadre, ce qui correspond à la cible. Enfin, l'application a été testée sur Android et sur iOS : le même pipeline donne le même comportement sur les deux plateformes, ce qui valide le choix d'OpenCV.</a:t>
+              <a:t>Les trois cibles sont atteintes : [clic] 92 à 100 millisecondes par image, [clic] 92 % de recto/verso reconnus, [clic] et environ deux secondes jusqu'à la capture, avec le même comportement sur Android et iOS.</a:t>
             </a:r>
           </a:p>
           <a:p/>
           <a:p>
             <a:r>
-              <a:t>TRANSITION — « Ces résultats ouvrent plusieurs pistes d'amélioration. »</a:t>
+              <a:t>TRANSITION — « Pour la suite. »</a:t>
             </a:r>
           </a:p>
           <a:p/>
@@ -1055,7 +1055,7 @@
           <a:lstStyle/>
           <a:p>
             <a:r>
-              <a:t>⏱ 0:45 (cumul 13:30)</a:t>
+              <a:t>⏱ 0:20 (cumul 7:20)</a:t>
             </a:r>
           </a:p>
           <a:p/>
@@ -1072,7 +1072,7 @@
           </a:p>
           <a:p>
             <a:r>
-              <a:t>Pour aller vers la production, je vois quatre pistes. D'abord, constituer un jeu d'images de CIN plus large, dans le respect de la confidentialité : il permettrait d'affiner les seuils et, à terme, d'ajouter un modèle appris en complément d'OpenCV. Ensuite, automatiser les tests sur cartes réelles avec des images de référence. Troisièmement, ajouter un message qui prévient l'utilisateur quand aucune carte n'est détectée après un délai. Enfin, la vivacité de la personne est déjà vérifiée en aval par Avatar-ID ; côté carte, une analyse de texture permettrait de repérer une carte affichée sur un écran.</a:t>
+              <a:t>Quatre pistes vers la production : [clic] un jeu d'images plus large, [clic] des tests réels automatisés, [clic] un message de timeout, [clic] et une analyse anti-fraude de la carte.</a:t>
             </a:r>
           </a:p>
           <a:p/>
@@ -1159,7 +1159,7 @@
           <a:lstStyle/>
           <a:p>
             <a:r>
-              <a:t>⏱ 0:50 (cumul 14:20)</a:t>
+              <a:t>⏱ 0:35 (cumul 7:55)</a:t>
             </a:r>
           </a:p>
           <a:p/>
@@ -1176,7 +1176,7 @@
           </a:p>
           <a:p>
             <a:r>
-              <a:t>En six semaines, j'ai livré un module qui capture seul le recto puis le verso d'une CIN, sur Android comme sur iOS : détection par quatre passes et un score, autocapture sur quatre contrôles, reconnaissance recto/verso avec anti-doublon, puis vérification, page A4, export et historique. Les trois cibles sont atteintes et 177 tests passent sans échec. Mon apport, c'est tout ce qui entoure les primitives d'OpenCV : leur enchaînement, le score, l'isolate, la machine à états, le vote recto/verso et le post-traitement. J'en retiens qu'un choix technique se défend par les contraintes réelles d'un projet.</a:t>
+              <a:t>En résumé, [clic] j'ai livré un module complet en six semaines, [clic] qui atteint ses trois cibles sur Android et iOS, [clic] avec des pistes claires pour la suite. [clic] Mon apport, c'est tout ce qui entoure les primitives d'OpenCV, de la détection à la capture. J'en retiens qu'un choix technique se justifie par les contraintes réelles du projet.</a:t>
             </a:r>
           </a:p>
           <a:p/>
@@ -1252,7 +1252,7 @@
           <a:lstStyle/>
           <a:p>
             <a:r>
-              <a:t>⏱ 0:10 (cumul 14:30)</a:t>
+              <a:t>⏱ 0:05 (cumul 8:00)</a:t>
             </a:r>
           </a:p>
           <a:p/>
@@ -1569,7 +1569,7 @@
           <a:lstStyle/>
           <a:p>
             <a:r>
-              <a:t>⏱ 0:40 (cumul 1:55)</a:t>
+              <a:t>⏱ 0:30 (cumul 0:50)</a:t>
             </a:r>
           </a:p>
           <a:p/>
@@ -1586,13 +1586,13 @@
           </a:p>
           <a:p>
             <a:r>
-              <a:t>Avatar-ID est une application de vérification d'identité à distance, dans l'esprit du KYC des banques. Elle enchaîne plusieurs étapes. Mon module est la première : il capture le recto puis le verso de la carte. Ensuite, Avatar-ID réalise un test de vivacité, compare la photo de la carte avec le visage de l'utilisateur, lit les champs de la carte par OCR, puis enregistre le résultat. Mon module transmet donc le recto et le verso redressés et orientés. C'est pour cela que la qualité de capture est si importante : une image floue ou de travers dégrade directement la comparaison des visages et la lecture OCR.</a:t>
+              <a:t>Avatar-ID vérifie l'identité à distance, comme un KYC bancaire. Mon module en est la première étape : la capture de la carte. [clic] Ensuite, Avatar-ID réalise le test de vivacité, compare les photos, lit la carte par OCR et enregistre le résultat. [clic] La qualité de ma capture conditionne donc toute la suite.</a:t>
             </a:r>
           </a:p>
           <a:p/>
           <a:p>
             <a:r>
-              <a:t>TRANSITION — « Or, sans guidage, cette première étape échoue souvent. »</a:t>
+              <a:t>TRANSITION — « Or cette capture échoue souvent. »</a:t>
             </a:r>
           </a:p>
           <a:p/>
@@ -1753,7 +1753,7 @@
           <a:lstStyle/>
           <a:p>
             <a:r>
-              <a:t>⏱ 0:45 (cumul 1:15)</a:t>
+              <a:t>⏱ 0:30 (cumul 1:20)</a:t>
             </a:r>
           </a:p>
           <a:p/>
@@ -1770,13 +1770,13 @@
           </a:p>
           <a:p>
             <a:r>
-              <a:t>À la première étape, l'utilisateur doit fournir sa carte d'identité. Si on lui demande simplement une photo, on obtient trop souvent une image floue, une carte de travers, ou deux fois le recto à la place du verso. Chaque défaut coûte un contrôle humain, une nouvelle saisie, et dégrade la comparaison des photos et l'OCR qui suivent. La question que j'ai traitée est donc : comment détecter de manière fiable et en temps réel les contours de la carte dans le flux caméra, quel que soit l'éclairage ou l'arrière-plan, pour ne capturer que des images exploitables, une seule fois par face.</a:t>
+              <a:t>Une simple photo de la carte est souvent [clic] floue, [clic] de travers, [clic] ou c'est deux fois le recto au lieu du verso. [clic] D'où ma problématique : détecter en temps réel et de façon fiable les contours de la CIN, quels que soient l'éclairage et l'arrière-plan.</a:t>
             </a:r>
           </a:p>
           <a:p/>
           <a:p>
             <a:r>
-              <a:t>TRANSITION — « Concrètement, voici ce que le module devait faire. »</a:t>
+              <a:t>TRANSITION — « Voici ce que le module devait faire. »</a:t>
             </a:r>
           </a:p>
           <a:p/>
@@ -1857,7 +1857,7 @@
           <a:lstStyle/>
           <a:p>
             <a:r>
-              <a:t>⏱ 1:00 (cumul 2:55)</a:t>
+              <a:t>⏱ 0:35 (cumul 1:55)</a:t>
             </a:r>
           </a:p>
           <a:p/>
@@ -1874,13 +1874,13 @@
           </a:p>
           <a:p>
             <a:r>
-              <a:t>Le besoin se résume à cinq fonctions : détecter la carte et ses contours, vérifier que l'image est nette, bien exposée et stable, reconnaître le recto puis le verso, déclencher la capture sans bouton, et enfin recadrer et améliorer l'image. Le cahier des charges fixait aussi trois cibles : moins de 100 millisecondes de traitement par image, idéalement ; au moins 90 % de recto/verso bien reconnus en conditions normales, c'est-à-dire en intérieur éclairé, carte à plat, sans reflet ; et environ deux secondes entre le moment où la carte est bien placée et la capture. Le tout sur Android et sur iOS, avec un seul code, en six semaines. Je montrerai plus loin que ces trois cibles sont atteintes.</a:t>
+              <a:t>[clic] Cinq fonctions : détecter la carte, contrôler la qualité de l'image, distinguer le recto du verso, capturer sans bouton, puis recadrer et améliorer. [clic] Trois cibles : moins de 100 millisecondes par image, au moins 90 % de recto/verso reconnus, et environ deux secondes jusqu'à la capture. [clic] Le tout sur Android et iOS, en six semaines.</a:t>
             </a:r>
           </a:p>
           <a:p/>
           <a:p>
             <a:r>
-              <a:t>TRANSITION — « La contrainte Android + iOS a directement décidé de la technologie. »</a:t>
+              <a:t>TRANSITION — « Cette double plateforme a dicté la technologie. »</a:t>
             </a:r>
           </a:p>
           <a:p/>
@@ -1961,7 +1961,7 @@
           <a:lstStyle/>
           <a:p>
             <a:r>
-              <a:t>⏱ 0:55 (cumul 3:50)</a:t>
+              <a:t>⏱ 0:35 (cumul 2:30)</a:t>
             </a:r>
           </a:p>
           <a:p/>
@@ -1978,13 +1978,13 @@
           </a:p>
           <a:p>
             <a:r>
-              <a:t>Trois briques ont été évaluées. Le Document Scanner de Google ML Kit est simple à intégrer, mais il n'existe que sur Android : il aurait fallu une deuxième chaîne de détection pour iOS. Un modèle entraîné sur mesure aurait été le plus robuste, mais il demande plusieurs centaines d'images de CIN annotées ; pour une pièce d'identité, je ne pouvais ni les collecter ni les annoter en six semaines. Il restait OpenCV, multiplateforme, sans entraînement. Le prix à payer, je l'assume : tous les seuils sont réglés de façon empirique. Résultat : un seul pipeline, testé sur Android et sur iOS avec le même comportement.</a:t>
+              <a:t>ML Kit n'existe pas sur iOS. Un modèle entraîné sur mesure exigeait des centaines d'images annotées, impossible en six semaines. J'ai donc retenu OpenCV : multiplateforme et sans entraînement, au prix d'un réglage empirique des seuils. [clic] La pile : Flutter, Dart et OpenCV via opencv_dart. [clic] En orange, le critère qui élimine chaque option.</a:t>
             </a:r>
           </a:p>
           <a:p/>
           <a:p>
             <a:r>
-              <a:t>TRANSITION — « Voyons comment j'ai organisé le code autour de cette brique. »</a:t>
+              <a:t>TRANSITION — « Voyons l'organisation du code. »</a:t>
             </a:r>
           </a:p>
           <a:p/>
@@ -2070,7 +2070,7 @@
           <a:lstStyle/>
           <a:p>
             <a:r>
-              <a:t>⏱ 0:55 (cumul 4:45)</a:t>
+              <a:t>⏱ 0:30 (cumul 3:00)</a:t>
             </a:r>
           </a:p>
           <a:p/>
@@ -2087,13 +2087,13 @@
           </a:p>
           <a:p>
             <a:r>
-              <a:t>L'application suit la Clean Architecture, découpée par fonctionnalité : sept modules, plus deux modules transverses. À gauche, le motif d'un module : la présentation dépend du domaine, et la couche données implémente les interfaces du domaine. Le point clé est la couche domaine, en bleu : elle ne dépend ni de Flutter ni d'OpenCV. La machine à états, la décision de capture ou la géométrie du quadrilatère se testent donc sans caméra et sans émulateur. À droite, je montre honnêtement que chaque module ne prend que les couches dont il a besoin : seuls document_detection et image_postprocessing ont les trois.</a:t>
+              <a:t>Le code suit la Clean Architecture, découpée par fonctionnalité. La clé est la couche domaine : elle ne dépend ni de Flutter ni d'OpenCV, donc la logique se teste sans caméra ni émulateur. [clic] Chaque module ne prend que les couches dont il a besoin.</a:t>
             </a:r>
           </a:p>
           <a:p/>
           <a:p>
             <a:r>
-              <a:t>TRANSITION — « Entrons dans le cœur technique : la détection de la carte. »</a:t>
+              <a:t>TRANSITION — « Passons au cœur : la détection. »</a:t>
             </a:r>
           </a:p>
           <a:p/>
@@ -2174,13 +2174,13 @@
           <a:lstStyle/>
           <a:p>
             <a:r>
-              <a:t>⏱ 1:25 (cumul 6:10)</a:t>
+              <a:t>⏱ 0:45 (cumul 3:45)</a:t>
             </a:r>
           </a:p>
           <a:p/>
           <a:p>
             <a:r>
-              <a:t>ANIMATIONS — 1 clic : la bande « conçu et développé pendant le stage », au moment de « En bas, ce que j'ai conçu ».</a:t>
+              <a:t>ANIMATIONS — 1 clic : la bande « conçu et développé pendant le stage », au moment de « Autour d'OpenCV, j'ai conçu ».</a:t>
             </a:r>
           </a:p>
           <a:p/>
@@ -2191,18 +2191,13 @@
           </a:p>
           <a:p>
             <a:r>
-              <a:t>Voici le pipeline, appliqué à chaque image. Un : la frame caméra, en YUV420 sur Android ou BGRA sur iOS, est convertie en matrice OpenCV. Deux : un CLAHE renforce le contraste local. Trois : quatre passes indépendantes produisent chacune un masque de contours : Canny, avec des seuils calculés à partir de la médiane d'intensité ; un seuillage adaptatif gaussien ; une segmentation sur la saturation HSV avec Otsu ; et, en dernier recours, un gradient morphologique. Chaque contour est simplifié en polygone ; s'il a quatre sommets convexes, c'est un candidat. Quatre : un score que j'ai défini, 80 % sur la proportion par rapport au format ID-1 et 20 % sur la taille, retient le meilleur au-dessus de 0,30. Cinq : une homographie redresse la carte en 856 par 540 pixels.</a:t>
-            </a:r>
-          </a:p>
-          <a:p>
-            <a:r>
-              <a:t>En bas, ce que j'ai conçu autour des primitives d'OpenCV : la sortie anticipée qui évite les passes coûteuses, le suivi qui ne cherche qu'autour de la position précédente, les garde-fous contre un faux quadrilatère qui « verrouillerait » le fond, et l'isolate Dart qui garde l'aperçu fluide : s'il est occupé, la frame suivante est simplement ignorée, sans file d'attente.</a:t>
+              <a:t>Chaque image devient une matrice OpenCV, puis un CLAHE renforce le contraste local. Quatre passes produisent des masques de contours : Canny sur la médiane, seuillage adaptatif, saturation et gradient morphologique. Un score, 80 % proportion et 20 % taille, retient le meilleur quadrilatère, redressé ensuite en 856 par 540 pixels. [clic] Autour d'OpenCV, j'ai conçu la sortie anticipée, le suivi d'une image à l'autre, les garde-fous et l'isolate qui garde l'aperçu fluide.</a:t>
             </a:r>
           </a:p>
           <a:p/>
           <a:p>
             <a:r>
-              <a:t>TRANSITION — « Cette chaîne n'a pas marché du premier coup. »</a:t>
+              <a:t>TRANSITION — « Cela n'a pas marché du premier coup. »</a:t>
             </a:r>
           </a:p>
           <a:p/>
@@ -2288,7 +2283,7 @@
           <a:lstStyle/>
           <a:p>
             <a:r>
-              <a:t>⏱ 1:05 (cumul 7:15)</a:t>
+              <a:t>⏱ 0:35 (cumul 4:20)</a:t>
             </a:r>
           </a:p>
           <a:p/>
@@ -2305,13 +2300,13 @@
           </a:p>
           <a:p>
             <a:r>
-              <a:t>La vraie difficulté du projet est apparue pendant les essais : la détection fonctionnait sur fond sombre, mais échouait très souvent avec une carte claire posée sur une table blanche, un cas pourtant courant. J'ai trouvé deux causes. D'abord un bug : les seuils de Canny étaient calculés à partir de la moyenne d'intensité de l'image, et pas de sa médiane ; sur une scène claire, la moyenne monte et les seuils deviennent trop stricts pour un bord faible. Ensuite, un contraste local insuffisant. J'ai appliqué trois correctifs ensemble : la vraie médiane, une passe CLAHE avant la détection, et un nouveau réglage des seuils de score et d'aire. Après ces correctifs, j'ai observé un taux de détection comparable sur les deux fonds.</a:t>
+              <a:t>Sur fond clair, la détection échouait souvent. [clic] Deux causes : des seuils de Canny calculés sur la moyenne au lieu de la médiane, et un contraste local trop faible. [clic] Trois correctifs : la vraie médiane, un CLAHE avant la détection, et le réglage des seuils. [clic] Résultat : une détection comparable sur fond clair et sur fond sombre.</a:t>
             </a:r>
           </a:p>
           <a:p/>
           <a:p>
             <a:r>
-              <a:t>TRANSITION — « Une fois la carte trouvée, il faut décider quand capturer. »</a:t>
+              <a:t>TRANSITION — « Ensuite, quand capturer ? »</a:t>
             </a:r>
           </a:p>
           <a:p/>
@@ -2392,7 +2387,7 @@
           <a:lstStyle/>
           <a:p>
             <a:r>
-              <a:t>⏱ 1:15 (cumul 8:30)</a:t>
+              <a:t>⏱ 0:35 (cumul 4:55)</a:t>
             </a:r>
           </a:p>
           <a:p/>
@@ -2409,13 +2404,13 @@
           </a:p>
           <a:p>
             <a:r>
-              <a:t>L'autocapture est une machine à états. On part de searching. Dès que la carte est trouvée, on passe en poorQuality tant qu'un contrôle échoue. Les contrôles sont au nombre de quatre : la netteté, mesurée par la variance du Laplacien après CLAHE, au moins 120 sur l'image redressée ; la luminosité, avec une moyenne entre 60 et 225 et au plus 12 % de pixels saturés, pour détecter un reflet ; la stabilité, avec une dérive des coins inférieure à 2,5 % de la diagonale sur trois frames ; et enfin le contenu, c'est-à-dire la bonne face. Quand tout est bon, on entre en holding ; il faut tenir deux frames bonnes consécutives : c'est un compteur, pas une minuterie. Alors seulement la capture part. Si la carte est perdue, on revient à searching ; si la capture échoue, on réinitialise. À droite, l'écran réel : l'application dit à l'utilisateur ce qui bloque, ici « Ne bougez plus ».</a:t>
+              <a:t>L'autocapture est une machine à états : on cherche la carte, on attend une bonne qualité, on maintient, puis on capture ; si un contrôle échoue, on revient en arrière. [clic] Cinq contrôles : la netteté, la luminosité sans reflet, la stabilité des coins, la bonne face, et deux images bonnes consécutives.</a:t>
             </a:r>
           </a:p>
           <a:p/>
           <a:p>
             <a:r>
-              <a:t>TRANSITION — « Le contrôle de contenu repose sur la reconnaissance du recto et du verso. »</a:t>
+              <a:t>TRANSITION — « La bonne face, justement. »</a:t>
             </a:r>
           </a:p>
           <a:p/>

</xml_diff>

<commit_message>
Add demo slide, 9-minute technical script, and study documents (script, technical guide, Q&A, demo video guide)
Co-Authored-By: Claude Opus 5.5 <noreply@anthropic.com>
Claude-Session: https://claude.ai/code/session_01AnZDiX8uz3hSw1L6vhKaQS
</commit_message>
<xml_diff>
--- a/Soutenance_Stage_ENSI_Final.pptx
+++ b/Soutenance_Stage_ENSI_Final.pptx
@@ -25,6 +25,7 @@
     <p:sldId id="273" r:id="rId25"/>
     <p:sldId id="274" r:id="rId26"/>
     <p:sldId id="275" r:id="rId27"/>
+    <p:sldId id="276" r:id="rId28"/>
   </p:sldIdLst>
   <p:sldSz cx="12191695" cy="6858000" type="screen4x3"/>
   <p:notesSz cx="6858000" cy="9144000"/>
@@ -619,7 +620,7 @@
           <a:lstStyle/>
           <a:p>
             <a:r>
-              <a:t>⏱ 0:35 (cumul 5:30)</a:t>
+              <a:t>⏱ 0:40 (cumul 6:05)</a:t>
             </a:r>
           </a:p>
           <a:p/>
@@ -636,13 +637,13 @@
           </a:p>
           <a:p>
             <a:r>
-              <a:t>[clic] Le recto se reconnaît au visage, détecté par une cascade de Haar d'OpenCV sur quatre rotations, ce qui donne aussi l'orientation, puis au logo et au drapeau. [clic] Le verso n'a pas de visage : le code-barres, l'empreinte et la ligne de séparation votent sur quatre rotations. [clic] Ainsi, présenter deux fois le recto ne déclenche rien.</a:t>
+              <a:t>[clic] Au recto, la photo est toujours en haut à gauche : j'y cherche un visage avec la cascade de Haar d'OpenCV, pré-entraînée, sur quatre rotations, ce qui donne aussi l'orientation. Le logo et le drapeau sont confirmés par template matching, avec une corrélation d'au moins 0,6. [clic] Le verso n'a pas de visage : le code-barres, la texture de l'empreinte et la ligne de séparation, trouvée par une transformée de Hough, votent sur quatre rotations. [clic] Ainsi, présenter deux fois le recto ne déclenche rien.</a:t>
             </a:r>
           </a:p>
           <a:p/>
           <a:p>
             <a:r>
-              <a:t>TRANSITION — « Côté utilisateur. »</a:t>
+              <a:t>TRANSITION — « Voyons-le en vrai. »</a:t>
             </a:r>
           </a:p>
           <a:p/>
@@ -723,46 +724,30 @@
           <a:lstStyle/>
           <a:p>
             <a:r>
-              <a:t>⏱ 0:35 (cumul 6:05)</a:t>
+              <a:t>⏱ 0:45 (cumul 6:50)</a:t>
             </a:r>
           </a:p>
           <a:p/>
           <a:p>
             <a:r>
-              <a:t>ANIMATIONS — 3 clics : une capture d'écran par clic (vérification, recadrage, page A4).</a:t>
+              <a:t>VIDÉO — 40 s environ. Lancer la vidéo dès l'arrivée sur la diapositive (clic sur la vidéo). Pour l'intégrer : déposer le fichier dans build/assets/demo.mp4 puis relancer le script, ou dans PowerPoint : Insertion → Vidéo → Cet appareil, à la place du cadre, puis Lecture → Démarrer « Automatiquement ».</a:t>
             </a:r>
           </a:p>
           <a:p/>
           <a:p>
             <a:r>
-              <a:t>TEXTE ORAL (si démonstration en direct : la lancer ici, ≈ 45 s, et sauter ce texte)</a:t>
-            </a:r>
-          </a:p>
-          <a:p>
-            <a:r>
-              <a:t>Une fois les deux faces capturées, l'utilisateur [clic] vérifie et règle contraste et netteté, [clic] ajuste le recadrage si besoin, [clic] puis exporte le recto, le verso et une page A4. Tout est traité sur l'appareil.</a:t>
+              <a:t>TEXTE ORAL</a:t>
+            </a:r>
+          </a:p>
+          <a:p>
+            <a:r>
+              <a:t>Voici le module en action. [lancer la vidéo] Le cadre est rouge tant que la carte n'est pas détectée, puis passe au vert. L'application guide l'utilisateur avec ses messages, et capture le recto toute seule dès que la netteté, la luminosité et la stabilité sont bonnes. Elle passe ensuite au verso, le reconnaît à ses trois indices, et le capture à son tour, sans aucun bouton.</a:t>
             </a:r>
           </a:p>
           <a:p/>
           <a:p>
             <a:r>
-              <a:t>TRANSITION — « Comment l'ai-je validé ? »</a:t>
-            </a:r>
-          </a:p>
-          <a:p/>
-          <a:p>
-            <a:r>
-              <a:t>QUESTIONS PROBABLES</a:t>
-            </a:r>
-          </a:p>
-          <a:p>
-            <a:r>
-              <a:t>– « Où vont les images exportées ? » → dans la galerie de l'appareil ; à partir de là, elles suivent la vie normale des photos (sauvegarde cloud, partage) : l'utilisateur doit en être informé (rapport §7.2.4).</a:t>
-            </a:r>
-          </a:p>
-          <a:p>
-            <a:r>
-              <a:t>– « Qu'est-ce qu'Avatar-ID reçoit ? » → deux images (Uint8List) et, le cas échéant, la page d'impression : le module est une brique autonome (rapport §8.2.5).</a:t>
+              <a:t>TRANSITION — « Après la capture, l'utilisateur garde la main. »</a:t>
             </a:r>
           </a:p>
         </p:txBody>
@@ -832,13 +817,13 @@
           <a:lstStyle/>
           <a:p>
             <a:r>
-              <a:t>⏱ 0:25 (cumul 6:30)</a:t>
+              <a:t>⏱ 0:25 (cumul 7:15)</a:t>
             </a:r>
           </a:p>
           <a:p/>
           <a:p>
             <a:r>
-              <a:t>ANIMATIONS — 4 clics : un palier de test par clic (A, B, C, D).</a:t>
+              <a:t>ANIMATIONS — 3 clics : une capture d'écran par clic (vérification, recadrage, page A4).</a:t>
             </a:r>
           </a:p>
           <a:p/>
@@ -849,29 +834,29 @@
           </a:p>
           <a:p>
             <a:r>
-              <a:t>177 tests automatisés passent sans échec, répartis en quatre paliers : [clic] la logique pure, [clic] la plateforme simulée, [clic] OpenCV sur images synthétiques, [clic] et les vraies cartes sur téléphone.</a:t>
+              <a:t>Une fois les deux faces capturées, l'utilisateur [clic] vérifie et règle contraste et netteté, [clic] ajuste le recadrage si besoin, [clic] puis exporte le recto, le verso et une page A4 à 300 dpi. Tout est traité sur l'appareil.</a:t>
             </a:r>
           </a:p>
           <a:p/>
           <a:p>
             <a:r>
-              <a:t>TRANSITION — « Et sur appareil réel ? »</a:t>
+              <a:t>TRANSITION — « Comment l'ai-je validé ? »</a:t>
             </a:r>
           </a:p>
           <a:p/>
           <a:p>
             <a:r>
-              <a:t>QUESTIONS PROBABLES (préparation, ne pas lire)</a:t>
-            </a:r>
-          </a:p>
-          <a:p>
-            <a:r>
-              <a:t>– « Combien de fichiers de test ? » → 28 fichiers (15 A, 6 B, 7 C) ; la dernière campagne en a exécuté 21, pour 177 cas réussis. Les autres sont à relancer avec flutter test --reporter expanded.</a:t>
-            </a:r>
-          </a:p>
-          <a:p>
-            <a:r>
-              <a:t>– « Quelle couverture ? » → elle n'a pas été mesurée ; flutter test --coverage le permet directement.</a:t>
+              <a:t>QUESTIONS PROBABLES</a:t>
+            </a:r>
+          </a:p>
+          <a:p>
+            <a:r>
+              <a:t>– « Où vont les images exportées ? » → dans la galerie de l'appareil ; à partir de là, elles suivent la vie normale des photos (sauvegarde cloud, partage) : l'utilisateur doit en être informé (rapport §7.2.4).</a:t>
+            </a:r>
+          </a:p>
+          <a:p>
+            <a:r>
+              <a:t>– « Qu'est-ce qu'Avatar-ID reçoit ? » → deux images (Uint8List) et, le cas échéant, la page d'impression : le module est une brique autonome (rapport §8.2.5).</a:t>
             </a:r>
           </a:p>
         </p:txBody>
@@ -941,13 +926,13 @@
           <a:lstStyle/>
           <a:p>
             <a:r>
-              <a:t>⏱ 0:30 (cumul 7:00)</a:t>
+              <a:t>⏱ 0:25 (cumul 7:40)</a:t>
             </a:r>
           </a:p>
           <a:p/>
           <a:p>
             <a:r>
-              <a:t>ANIMATIONS — 3 clics : une mesure par clic (temps, reconnaissance, délai) ; Android et iOS arrive avec la troisième.</a:t>
+              <a:t>ANIMATIONS — 4 clics : un palier de test par clic (A, B, C, D).</a:t>
             </a:r>
           </a:p>
           <a:p/>
@@ -958,13 +943,13 @@
           </a:p>
           <a:p>
             <a:r>
-              <a:t>Les trois cibles sont atteintes : [clic] 92 à 100 millisecondes par image, [clic] 92 % de recto/verso reconnus, [clic] et environ deux secondes jusqu'à la capture, avec le même comportement sur Android et iOS.</a:t>
+              <a:t>177 tests automatisés passent sans échec, répartis en quatre paliers : [clic] la logique pure Dart, [clic] la plateforme simulée avec mocktail, [clic] OpenCV réel sur images synthétiques, [clic] et les vraies cartes sur téléphone, avec un protocole manuel.</a:t>
             </a:r>
           </a:p>
           <a:p/>
           <a:p>
             <a:r>
-              <a:t>TRANSITION — « Pour la suite. »</a:t>
+              <a:t>TRANSITION — « Et sur appareil réel ? »</a:t>
             </a:r>
           </a:p>
           <a:p/>
@@ -975,17 +960,12 @@
           </a:p>
           <a:p>
             <a:r>
-              <a:t>– « Sur quel téléphone, combien d'essais ? » → donner vos notes d'essais (modèles Android et iOS, nombre de cartes).</a:t>
-            </a:r>
-          </a:p>
-          <a:p>
-            <a:r>
-              <a:t>– « 92–100 ms, c'est la latence de bout en bout ? » → non : c'est le traitement dans l'isolate ; l'aperçu reste fluide car les frames reçues pendant un traitement sont ignorées.</a:t>
-            </a:r>
-          </a:p>
-          <a:p>
-            <a:r>
-              <a:t>– « Pourquoi ≈ 2 s si deux frames suffisent ? » → à environ dix analyses par seconde, les compteurs (3 frames de stabilité, 2 de maintien) ne font qu'une fraction de seconde ; le reste vient de la confirmation des signaux de contenu et du geste de l'utilisateur.</a:t>
+              <a:t>– « Combien de fichiers de test ? » → 28 fichiers (15 A, 6 B, 7 C) ; la dernière campagne en a exécuté 21, pour 177 cas réussis. Les autres sont à relancer avec flutter test --reporter expanded.</a:t>
+            </a:r>
+          </a:p>
+          <a:p>
+            <a:r>
+              <a:t>– « Quelle couverture ? » → elle n'a pas été mesurée ; flutter test --coverage le permet directement.</a:t>
             </a:r>
           </a:p>
         </p:txBody>
@@ -1055,13 +1035,13 @@
           <a:lstStyle/>
           <a:p>
             <a:r>
-              <a:t>⏱ 0:20 (cumul 7:20)</a:t>
+              <a:t>⏱ 0:30 (cumul 8:10)</a:t>
             </a:r>
           </a:p>
           <a:p/>
           <a:p>
             <a:r>
-              <a:t>ANIMATIONS — 4 clics : une piste par clic.</a:t>
+              <a:t>ANIMATIONS — 3 clics : une mesure par clic (temps, reconnaissance, délai) ; Android et iOS arrive avec la troisième.</a:t>
             </a:r>
           </a:p>
           <a:p/>
@@ -1072,13 +1052,13 @@
           </a:p>
           <a:p>
             <a:r>
-              <a:t>Quatre pistes vers la production : [clic] un jeu d'images plus large, [clic] des tests réels automatisés, [clic] un message de timeout, [clic] et une analyse anti-fraude de la carte.</a:t>
+              <a:t>Les trois cibles sont atteintes : [clic] 92 à 100 millisecondes de traitement par image dans l'isolate, [clic] 92 % de recto/verso reconnus sur cartes réelles, [clic] et environ deux secondes entre le cadre stabilisé et la capture, avec le même comportement sur Android et iOS.</a:t>
             </a:r>
           </a:p>
           <a:p/>
           <a:p>
             <a:r>
-              <a:t>TRANSITION — « Pour conclure. »</a:t>
+              <a:t>TRANSITION — « Pour la suite. »</a:t>
             </a:r>
           </a:p>
           <a:p/>
@@ -1089,7 +1069,17 @@
           </a:p>
           <a:p>
             <a:r>
-              <a:t>– « Une photo d'écran passe-t-elle ? » → les contrôles (capture en direct, deux faces, qualité) réduisent fortement ce risque ; la vivacité de la personne est ensuite vérifiée par Avatar-ID ; une analyse de texture de la carte renforcerait encore la chaîne.</a:t>
+              <a:t>– « Sur quel téléphone, combien d'essais ? » → donner vos notes d'essais (modèles Android et iOS, nombre de cartes).</a:t>
+            </a:r>
+          </a:p>
+          <a:p>
+            <a:r>
+              <a:t>– « 92–100 ms, c'est la latence de bout en bout ? » → non : c'est le traitement dans l'isolate ; l'aperçu reste fluide car les frames reçues pendant un traitement sont ignorées.</a:t>
+            </a:r>
+          </a:p>
+          <a:p>
+            <a:r>
+              <a:t>– « Pourquoi ≈ 2 s si deux frames suffisent ? » → à environ dix analyses par seconde, les compteurs (3 frames de stabilité, 2 de maintien) ne font qu'une fraction de seconde ; le reste vient de la confirmation des signaux de contenu et du geste de l'utilisateur.</a:t>
             </a:r>
           </a:p>
         </p:txBody>
@@ -1159,13 +1149,13 @@
           <a:lstStyle/>
           <a:p>
             <a:r>
-              <a:t>⏱ 0:35 (cumul 7:55)</a:t>
+              <a:t>⏱ 0:20 (cumul 8:30)</a:t>
             </a:r>
           </a:p>
           <a:p/>
           <a:p>
             <a:r>
-              <a:t>ANIMATIONS — 4 clics : 1) livré ; 2) mesuré ; 3) perspectives ; 4) mon apport.</a:t>
+              <a:t>ANIMATIONS — 4 clics : une piste par clic.</a:t>
             </a:r>
           </a:p>
           <a:p/>
@@ -1176,13 +1166,24 @@
           </a:p>
           <a:p>
             <a:r>
-              <a:t>En résumé, [clic] j'ai livré un module complet en six semaines, [clic] qui atteint ses trois cibles sur Android et iOS, [clic] avec des pistes claires pour la suite. [clic] Mon apport, c'est tout ce qui entoure les primitives d'OpenCV, de la détection à la capture. J'en retiens qu'un choix technique se justifie par les contraintes réelles du projet.</a:t>
+              <a:t>Quatre pistes vers la production : [clic] un jeu d'images plus large, [clic] des tests réels automatisés, [clic] un message de timeout, [clic] et une analyse de texture contre les cartes affichées sur un écran.</a:t>
             </a:r>
           </a:p>
           <a:p/>
           <a:p>
             <a:r>
-              <a:t>TRANSITION — « Merci de votre attention. »</a:t>
+              <a:t>TRANSITION — « Pour conclure. »</a:t>
+            </a:r>
+          </a:p>
+          <a:p/>
+          <a:p>
+            <a:r>
+              <a:t>QUESTIONS PROBABLES (préparation, ne pas lire)</a:t>
+            </a:r>
+          </a:p>
+          <a:p>
+            <a:r>
+              <a:t>– « Une photo d'écran passe-t-elle ? » → les contrôles (capture en direct, deux faces, qualité) réduisent fortement ce risque ; la vivacité de la personne est ensuite vérifiée par Avatar-ID ; une analyse de texture de la carte renforcerait encore la chaîne.</a:t>
             </a:r>
           </a:p>
         </p:txBody>
@@ -1252,24 +1253,30 @@
           <a:lstStyle/>
           <a:p>
             <a:r>
-              <a:t>⏱ 0:05 (cumul 8:00)</a:t>
+              <a:t>⏱ 0:35 (cumul 9:05)</a:t>
             </a:r>
           </a:p>
           <a:p/>
           <a:p>
             <a:r>
+              <a:t>ANIMATIONS — 4 clics : 1) livré ; 2) mesuré ; 3) perspectives ; 4) mon apport.</a:t>
+            </a:r>
+          </a:p>
+          <a:p/>
+          <a:p>
+            <a:r>
               <a:t>TEXTE ORAL</a:t>
             </a:r>
           </a:p>
           <a:p>
             <a:r>
-              <a:t>Merci de votre attention ; je suis à votre disposition pour vos questions.</a:t>
+              <a:t>En résumé, [clic] j'ai livré un module complet en six semaines, [clic] qui atteint ses trois cibles sur Android et iOS, [clic] avec des pistes claires pour la suite. [clic] Mon apport, c'est tout ce qui entoure les primitives d'OpenCV : l'enchaînement des passes, le score, l'isolate, la machine à états et le vote recto/verso. J'en retiens qu'un choix technique se justifie par les contraintes réelles du projet.</a:t>
             </a:r>
           </a:p>
           <a:p/>
           <a:p>
             <a:r>
-              <a:t>PENDANT LES QUESTIONS — revenir si besoin à la diapositive 15 (bilan) ; secours A à D après cette diapositive : A seuils, B méthodes de test, C sécurité et confidentialité, D apport personnel et références.</a:t>
+              <a:t>TRANSITION — « Merci de votre attention. »</a:t>
             </a:r>
           </a:p>
         </p:txBody>
@@ -1339,12 +1346,24 @@
           <a:lstStyle/>
           <a:p>
             <a:r>
-              <a:t>SECOURS A — à ouvrir seulement si le jury interroge les seuils.</a:t>
-            </a:r>
-          </a:p>
-          <a:p>
-            <a:r>
-              <a:t>Tous ont été fixés par réglage empirique sur les échantillons de CIN disponibles (rapport §5.5). Le seuil de netteté 120 est calibré sur l'image redressée de 856 × 540 px : à une autre résolution, la variance du Laplacien change et le seuil n'est plus valable. Aucune analyse de sensibilité n'a été faite : c'est une perspective naturelle une fois un jeu d'images constitué.</a:t>
+              <a:t>⏱ 0:05 (cumul 9:10)</a:t>
+            </a:r>
+          </a:p>
+          <a:p/>
+          <a:p>
+            <a:r>
+              <a:t>TEXTE ORAL</a:t>
+            </a:r>
+          </a:p>
+          <a:p>
+            <a:r>
+              <a:t>Merci de votre attention ; je suis à votre disposition pour vos questions.</a:t>
+            </a:r>
+          </a:p>
+          <a:p/>
+          <a:p>
+            <a:r>
+              <a:t>PENDANT LES QUESTIONS — revenir si besoin à la diapositive 16 (bilan) ; secours A à D après cette diapositive : A seuils, B méthodes de test, C sécurité et confidentialité, D apport personnel et références.</a:t>
             </a:r>
           </a:p>
         </p:txBody>
@@ -1414,17 +1433,12 @@
           <a:lstStyle/>
           <a:p>
             <a:r>
-              <a:t>SECOURS B — méthodes de test (rapport, tableau 9.3).</a:t>
-            </a:r>
-          </a:p>
-          <a:p>
-            <a:r>
-              <a:t>Paliers : A logique pure Dart, B plateforme simulée (mocktail), C OpenCV réel sur images synthétiques, D cartes réelles sur appareil (manuel).</a:t>
-            </a:r>
-          </a:p>
-          <a:p>
-            <a:r>
-              <a:t>Si l'on vous demande le détail : 28 fichiers de test (15 A, 6 B, 7 C) ; la dernière campagne a exécuté 177 cas, tous réussis.</a:t>
+              <a:t>SECOURS A — à ouvrir seulement si le jury interroge les seuils.</a:t>
+            </a:r>
+          </a:p>
+          <a:p>
+            <a:r>
+              <a:t>Tous ont été fixés par réglage empirique sur les échantillons de CIN disponibles (rapport §5.5). Le seuil de netteté 120 est calibré sur l'image redressée de 856 × 540 px : à une autre résolution, la variance du Laplacien change et le seuil n'est plus valable. Aucune analyse de sensibilité n'a été faite : c'est une perspective naturelle une fois un jeu d'images constitué.</a:t>
             </a:r>
           </a:p>
         </p:txBody>
@@ -1494,12 +1508,17 @@
           <a:lstStyle/>
           <a:p>
             <a:r>
-              <a:t>SECOURS C — sécurité et confidentialité.</a:t>
-            </a:r>
-          </a:p>
-          <a:p>
-            <a:r>
-              <a:t>Les contrôles (capture en direct, deux faces, qualité) réduisent fortement le risque de photo d'écran ou d'image préparée ; la vivacité de la personne et la comparaison des photos sont réalisées ensuite par Avatar-ID ; une analyse de texture de la carte reste une piste (rapport §7.2.4). Les images exportées en galerie suivent ensuite la vie normale des photos (sauvegarde cloud, partage). Chiffrement : non traité pendant le stage.</a:t>
+              <a:t>SECOURS B — méthodes de test (rapport, tableau 9.3).</a:t>
+            </a:r>
+          </a:p>
+          <a:p>
+            <a:r>
+              <a:t>Paliers : A logique pure Dart, B plateforme simulée (mocktail), C OpenCV réel sur images synthétiques, D cartes réelles sur appareil (manuel).</a:t>
+            </a:r>
+          </a:p>
+          <a:p>
+            <a:r>
+              <a:t>Si l'on vous demande le détail : 28 fichiers de test (15 A, 6 B, 7 C) ; la dernière campagne a exécuté 177 cas, tous réussis.</a:t>
             </a:r>
           </a:p>
         </p:txBody>
@@ -1586,7 +1605,7 @@
           </a:p>
           <a:p>
             <a:r>
-              <a:t>Avatar-ID vérifie l'identité à distance, comme un KYC bancaire. Mon module en est la première étape : la capture de la carte. [clic] Ensuite, Avatar-ID réalise le test de vivacité, compare les photos, lit la carte par OCR et enregistre le résultat. [clic] La qualité de ma capture conditionne donc toute la suite.</a:t>
+              <a:t>Avatar-ID vérifie l'identité à distance, comme un KYC bancaire. Mon module en est la première étape : la capture de la carte. [clic] Ensuite, Avatar-ID réalise le test de vivacité, compare la photo de la carte au visage, lit la carte par OCR et enregistre le résultat. [clic] La qualité de ma capture conditionne donc toute la suite.</a:t>
             </a:r>
           </a:p>
           <a:p/>
@@ -1678,6 +1697,81 @@
           <a:lstStyle/>
           <a:p>
             <a:r>
+              <a:t>SECOURS C — sécurité et confidentialité.</a:t>
+            </a:r>
+          </a:p>
+          <a:p>
+            <a:r>
+              <a:t>Les contrôles (capture en direct, deux faces, qualité) réduisent fortement le risque de photo d'écran ou d'image préparée ; la vivacité de la personne et la comparaison des photos sont réalisées ensuite par Avatar-ID ; une analyse de texture de la carte reste une piste (rapport §7.2.4). Les images exportées en galerie suivent ensuite la vie normale des photos (sauvegarde cloud, partage). Chiffrement : non traité pendant le stage.</a:t>
+            </a:r>
+          </a:p>
+        </p:txBody>
+      </p:sp>
+      <p:sp>
+        <p:nvSpPr>
+          <p:cNvPr id="4" name="Slide Number Placeholder 3"/>
+          <p:cNvSpPr>
+            <a:spLocks noGrp="1"/>
+          </p:cNvSpPr>
+          <p:nvPr>
+            <p:ph type="sldNum" idx="5" sz="quarter"/>
+          </p:nvPr>
+        </p:nvSpPr>
+        <p:spPr/>
+      </p:sp>
+    </p:spTree>
+  </p:cSld>
+  <p:clrMapOvr>
+    <a:masterClrMapping/>
+  </p:clrMapOvr>
+</p:notes>
+</file>
+
+<file path=ppt/notesSlides/notesSlide21.xml><?xml version="1.0" encoding="utf-8"?>
+<p:notes xmlns:a="http://schemas.openxmlformats.org/drawingml/2006/main" xmlns:p="http://schemas.openxmlformats.org/presentationml/2006/main" xmlns:r="http://schemas.openxmlformats.org/officeDocument/2006/relationships">
+  <p:cSld>
+    <p:spTree>
+      <p:nvGrpSpPr>
+        <p:cNvPr id="1" name=""/>
+        <p:cNvGrpSpPr/>
+        <p:nvPr/>
+      </p:nvGrpSpPr>
+      <p:grpSpPr>
+        <a:xfrm>
+          <a:off x="0" y="0"/>
+          <a:ext cx="0" cy="0"/>
+          <a:chOff x="0" y="0"/>
+          <a:chExt cx="0" cy="0"/>
+        </a:xfrm>
+      </p:grpSpPr>
+      <p:sp>
+        <p:nvSpPr>
+          <p:cNvPr id="2" name="Slide Image Placeholder 1"/>
+          <p:cNvSpPr>
+            <a:spLocks noGrp="1"/>
+          </p:cNvSpPr>
+          <p:nvPr>
+            <p:ph type="sldImg" idx="2"/>
+          </p:nvPr>
+        </p:nvSpPr>
+        <p:spPr/>
+      </p:sp>
+      <p:sp>
+        <p:nvSpPr>
+          <p:cNvPr id="3" name="Notes Placeholder 2"/>
+          <p:cNvSpPr>
+            <a:spLocks noGrp="1"/>
+          </p:cNvSpPr>
+          <p:nvPr>
+            <p:ph type="body" idx="3" sz="quarter"/>
+          </p:nvPr>
+        </p:nvSpPr>
+        <p:spPr/>
+        <p:txBody>
+          <a:bodyPr/>
+          <a:lstStyle/>
+          <a:p>
+            <a:r>
               <a:t>SECOURS D — « Qu'avez-vous développé vous-même ? » et références.</a:t>
             </a:r>
           </a:p>
@@ -1874,7 +1968,7 @@
           </a:p>
           <a:p>
             <a:r>
-              <a:t>[clic] Cinq fonctions : détecter la carte, contrôler la qualité de l'image, distinguer le recto du verso, capturer sans bouton, puis recadrer et améliorer. [clic] Trois cibles : moins de 100 millisecondes par image, au moins 90 % de recto/verso reconnus, et environ deux secondes jusqu'à la capture. [clic] Le tout sur Android et iOS, en six semaines.</a:t>
+              <a:t>[clic] Cinq fonctions : détecter la carte, contrôler la netteté, la luminosité et la stabilité, distinguer le recto du verso, capturer sans bouton, puis recadrer et améliorer. [clic] Trois cibles : moins de 100 millisecondes par image, au moins 90 % de recto/verso reconnus en conditions normales, et environ deux secondes jusqu'à la capture. [clic] Le tout sur Android et iOS, avec un seul code, en six semaines.</a:t>
             </a:r>
           </a:p>
           <a:p/>
@@ -1978,7 +2072,7 @@
           </a:p>
           <a:p>
             <a:r>
-              <a:t>ML Kit n'existe pas sur iOS. Un modèle entraîné sur mesure exigeait des centaines d'images annotées, impossible en six semaines. J'ai donc retenu OpenCV : multiplateforme et sans entraînement, au prix d'un réglage empirique des seuils. [clic] La pile : Flutter, Dart et OpenCV via opencv_dart. [clic] En orange, le critère qui élimine chaque option.</a:t>
+              <a:t>Le Document Scanner de ML Kit n'existe que sur Android. Un modèle entraîné sur mesure exigeait plusieurs centaines d'images de CIN annotées, impossible à constituer en six semaines. J'ai donc retenu OpenCV : multiplateforme et sans entraînement, au prix d'un réglage empirique des seuils. [clic] La pile : Flutter et Dart pour l'application, OpenCV via le binding opencv_dart. [clic] En orange, le critère qui élimine chaque option.</a:t>
             </a:r>
           </a:p>
           <a:p/>
@@ -2087,7 +2181,7 @@
           </a:p>
           <a:p>
             <a:r>
-              <a:t>Le code suit la Clean Architecture, découpée par fonctionnalité. La clé est la couche domaine : elle ne dépend ni de Flutter ni d'OpenCV, donc la logique se teste sans caméra ni émulateur. [clic] Chaque module ne prend que les couches dont il a besoin.</a:t>
+              <a:t>Le code suit la Clean Architecture, découpée par fonctionnalité. La couche présentation dépend du domaine, et la couche données l'implémente. La clé est le domaine : il ne dépend ni de Flutter ni d'OpenCV, donc la machine à états ou la géométrie se testent sans caméra ni émulateur. [clic] Chaque module ne prend que les couches dont il a besoin.</a:t>
             </a:r>
           </a:p>
           <a:p/>
@@ -2174,7 +2268,7 @@
           <a:lstStyle/>
           <a:p>
             <a:r>
-              <a:t>⏱ 0:45 (cumul 3:45)</a:t>
+              <a:t>⏱ 1:00 (cumul 4:00)</a:t>
             </a:r>
           </a:p>
           <a:p/>
@@ -2191,7 +2285,7 @@
           </a:p>
           <a:p>
             <a:r>
-              <a:t>Chaque image devient une matrice OpenCV, puis un CLAHE renforce le contraste local. Quatre passes produisent des masques de contours : Canny sur la médiane, seuillage adaptatif, saturation et gradient morphologique. Un score, 80 % proportion et 20 % taille, retient le meilleur quadrilatère, redressé ensuite en 856 par 540 pixels. [clic] Autour d'OpenCV, j'ai conçu la sortie anticipée, le suivi d'une image à l'autre, les garde-fous et l'isolate qui garde l'aperçu fluide.</a:t>
+              <a:t>Chaque image caméra, en YUV420 ou BGRA, devient une matrice OpenCV. Un CLAHE, une égalisation d'histogramme locale, renforce le contraste. Quatre passes produisent ensuite des masques de contours : Canny, avec des seuils à 0,66 et 1,33 fois la médiane ; un seuillage adaptatif ; la saturation HSV avec Otsu ; et, en dernier recours, un gradient morphologique. Chaque contour est simplifié en polygone ; un score de 80 % sur la proportion du format ID-1 et 20 % sur la taille retient le meilleur quadrilatère au-dessus de 0,30. Une homographie le redresse en 856 par 540 pixels. [clic] Autour de ces primitives, j'ai conçu la sortie anticipée à 0,65, le suivi à plus ou moins 20 % autour de la position précédente, les garde-fous contre un faux quadrilatère, et un isolate Dart qui garde l'aperçu fluide.</a:t>
             </a:r>
           </a:p>
           <a:p/>
@@ -2283,7 +2377,7 @@
           <a:lstStyle/>
           <a:p>
             <a:r>
-              <a:t>⏱ 0:35 (cumul 4:20)</a:t>
+              <a:t>⏱ 0:40 (cumul 4:40)</a:t>
             </a:r>
           </a:p>
           <a:p/>
@@ -2300,13 +2394,13 @@
           </a:p>
           <a:p>
             <a:r>
-              <a:t>Sur fond clair, la détection échouait souvent. [clic] Deux causes : des seuils de Canny calculés sur la moyenne au lieu de la médiane, et un contraste local trop faible. [clic] Trois correctifs : la vraie médiane, un CLAHE avant la détection, et le réglage des seuils. [clic] Résultat : une détection comparable sur fond clair et sur fond sombre.</a:t>
+              <a:t>Sur fond clair, une table blanche par exemple, la détection échouait souvent. [clic] Deux causes : un bug, les seuils de Canny calculés sur la moyenne au lieu de la médiane, donc trop hauts sur une scène claire ; et un contraste local trop faible. [clic] Trois correctifs : la vraie médiane, un CLAHE avant la détection, et le réglage des seuils de score et d'aire. [clic] Résultat : une détection comparable sur fond clair et sur fond sombre.</a:t>
             </a:r>
           </a:p>
           <a:p/>
           <a:p>
             <a:r>
-              <a:t>TRANSITION — « Ensuite, quand capturer ? »</a:t>
+              <a:t>TRANSITION — « Une fois la carte trouvée, quand capturer ? »</a:t>
             </a:r>
           </a:p>
           <a:p/>
@@ -2387,7 +2481,7 @@
           <a:lstStyle/>
           <a:p>
             <a:r>
-              <a:t>⏱ 0:35 (cumul 4:55)</a:t>
+              <a:t>⏱ 0:45 (cumul 5:25)</a:t>
             </a:r>
           </a:p>
           <a:p/>
@@ -2404,7 +2498,7 @@
           </a:p>
           <a:p>
             <a:r>
-              <a:t>L'autocapture est une machine à états : on cherche la carte, on attend une bonne qualité, on maintient, puis on capture ; si un contrôle échoue, on revient en arrière. [clic] Cinq contrôles : la netteté, la luminosité sans reflet, la stabilité des coins, la bonne face, et deux images bonnes consécutives.</a:t>
+              <a:t>L'autocapture est une machine à états : searching tant qu'aucune carte n'est trouvée, poorQuality tant qu'un contrôle échoue, holding pendant le maintien, puis triggerCapture et captured. Si un contrôle échoue, on revient en arrière. [clic] Cinq contrôles : la netteté, mesurée par la variance du Laplacien, au moins 120 ; la luminosité, avec au plus 12 % de pixels saturés pour écarter les reflets ; la stabilité, une dérive des coins sous 2,5 % de la diagonale ; la bonne face ; et un maintien de deux images consécutives. C'est un compteur d'images, pas une minuterie.</a:t>
             </a:r>
           </a:p>
           <a:p/>
@@ -6129,7 +6223,7 @@
                 </a:solidFill>
                 <a:latin typeface="Arial"/>
               </a:rPr>
-              <a:t>10 / 16</a:t>
+              <a:t>10 / 17</a:t>
             </a:r>
           </a:p>
         </p:txBody>
@@ -7366,7 +7460,666 @@
                 </a:solidFill>
                 <a:latin typeface="Arial"/>
               </a:rPr>
-              <a:t>11 / 16</a:t>
+              <a:t>11 / 17</a:t>
+            </a:r>
+          </a:p>
+        </p:txBody>
+      </p:sp>
+      <p:sp>
+        <p:nvSpPr>
+          <p:cNvPr id="6" name="Titre"/>
+          <p:cNvSpPr txBox="1"/>
+          <p:nvPr/>
+        </p:nvSpPr>
+        <p:spPr>
+          <a:xfrm>
+            <a:off x="548640" y="777240"/>
+            <a:ext cx="11094415" cy="1005840"/>
+          </a:xfrm>
+          <a:prstGeom prst="rect">
+            <a:avLst/>
+          </a:prstGeom>
+          <a:noFill/>
+        </p:spPr>
+        <p:txBody>
+          <a:bodyPr wrap="square" lIns="0" rIns="0" tIns="0" bIns="0" anchor="t">
+            <a:spAutoFit/>
+          </a:bodyPr>
+          <a:lstStyle/>
+          <a:p>
+            <a:pPr algn="l"/>
+            <a:r>
+              <a:rPr sz="2800" b="1" i="0">
+                <a:solidFill>
+                  <a:srgbClr val="1F3A5F"/>
+                </a:solidFill>
+                <a:latin typeface="Arial"/>
+              </a:rPr>
+              <a:t>Démonstration : la carte est détectée, contrôlée et capturée sans bouton</a:t>
+            </a:r>
+          </a:p>
+        </p:txBody>
+      </p:sp>
+      <p:sp>
+        <p:nvSpPr>
+          <p:cNvPr id="7" name="Rounded Rectangle 6"/>
+          <p:cNvSpPr/>
+          <p:nvPr/>
+        </p:nvSpPr>
+        <p:spPr>
+          <a:xfrm>
+            <a:off x="822959" y="1783080"/>
+            <a:ext cx="2420909" cy="4160520"/>
+          </a:xfrm>
+          <a:prstGeom prst="roundRect">
+            <a:avLst>
+              <a:gd name="adj" fmla="val 8000"/>
+            </a:avLst>
+          </a:prstGeom>
+          <a:solidFill>
+            <a:srgbClr val="EEF2F6"/>
+          </a:solidFill>
+          <a:ln w="25400">
+            <a:solidFill>
+              <a:srgbClr val="1F3A5F"/>
+            </a:solidFill>
+          </a:ln>
+        </p:spPr>
+        <p:txBody>
+          <a:bodyPr rtlCol="0" anchor="ctr"/>
+          <a:lstStyle/>
+          <a:p/>
+        </p:txBody>
+      </p:sp>
+      <p:pic>
+        <p:nvPicPr>
+          <p:cNvPr id="8" name="Picture 7" descr="Aperçu : écran recto (à remplacer par la vidéo de démonstration)"/>
+          <p:cNvPicPr>
+            <a:picLocks noChangeAspect="1"/>
+          </p:cNvPicPr>
+          <p:nvPr/>
+        </p:nvPicPr>
+        <p:blipFill>
+          <a:blip r:embed="rId2"/>
+          <a:stretch>
+            <a:fillRect/>
+          </a:stretch>
+        </p:blipFill>
+        <p:spPr>
+          <a:xfrm>
+            <a:off x="932688" y="1892807"/>
+            <a:ext cx="2201453" cy="3941063"/>
+          </a:xfrm>
+          <a:prstGeom prst="rect">
+            <a:avLst/>
+          </a:prstGeom>
+          <a:ln w="9525">
+            <a:solidFill>
+              <a:srgbClr val="CBD3DB"/>
+            </a:solidFill>
+          </a:ln>
+        </p:spPr>
+      </p:pic>
+      <p:sp>
+        <p:nvSpPr>
+          <p:cNvPr id="9" name="TextBox 8"/>
+          <p:cNvSpPr txBox="1"/>
+          <p:nvPr/>
+        </p:nvSpPr>
+        <p:spPr>
+          <a:xfrm>
+            <a:off x="822959" y="6016752"/>
+            <a:ext cx="3792509" cy="274320"/>
+          </a:xfrm>
+          <a:prstGeom prst="rect">
+            <a:avLst/>
+          </a:prstGeom>
+          <a:noFill/>
+        </p:spPr>
+        <p:txBody>
+          <a:bodyPr wrap="square" lIns="0" rIns="0" tIns="0" bIns="0" anchor="t">
+            <a:spAutoFit/>
+          </a:bodyPr>
+          <a:lstStyle/>
+          <a:p>
+            <a:pPr algn="l"/>
+            <a:r>
+              <a:rPr sz="1200" b="1" i="0">
+                <a:solidFill>
+                  <a:srgbClr val="B84A12"/>
+                </a:solidFill>
+                <a:latin typeface="Arial"/>
+              </a:rPr>
+              <a:t>Vidéo à insérer ici (Insertion → Vidéo)</a:t>
+            </a:r>
+          </a:p>
+        </p:txBody>
+      </p:sp>
+      <p:sp>
+        <p:nvSpPr>
+          <p:cNvPr id="10" name="TextBox 9"/>
+          <p:cNvSpPr txBox="1"/>
+          <p:nvPr/>
+        </p:nvSpPr>
+        <p:spPr>
+          <a:xfrm>
+            <a:off x="4480560" y="1965960"/>
+            <a:ext cx="457200" cy="548640"/>
+          </a:xfrm>
+          <a:prstGeom prst="rect">
+            <a:avLst/>
+          </a:prstGeom>
+          <a:noFill/>
+        </p:spPr>
+        <p:txBody>
+          <a:bodyPr wrap="square" lIns="0" rIns="0" tIns="0" bIns="0" anchor="t">
+            <a:spAutoFit/>
+          </a:bodyPr>
+          <a:lstStyle/>
+          <a:p>
+            <a:pPr algn="l"/>
+            <a:r>
+              <a:rPr sz="2600" b="1" i="0">
+                <a:solidFill>
+                  <a:srgbClr val="2E75B6"/>
+                </a:solidFill>
+                <a:latin typeface="Arial"/>
+              </a:rPr>
+              <a:t>1</a:t>
+            </a:r>
+          </a:p>
+        </p:txBody>
+      </p:sp>
+      <p:sp>
+        <p:nvSpPr>
+          <p:cNvPr id="11" name="TextBox 10"/>
+          <p:cNvSpPr txBox="1"/>
+          <p:nvPr/>
+        </p:nvSpPr>
+        <p:spPr>
+          <a:xfrm>
+            <a:off x="4983480" y="1984248"/>
+            <a:ext cx="6583680" cy="822960"/>
+          </a:xfrm>
+          <a:prstGeom prst="rect">
+            <a:avLst/>
+          </a:prstGeom>
+          <a:noFill/>
+        </p:spPr>
+        <p:txBody>
+          <a:bodyPr wrap="square" lIns="0" rIns="0" tIns="0" bIns="0" anchor="t">
+            <a:spAutoFit/>
+          </a:bodyPr>
+          <a:lstStyle/>
+          <a:p>
+            <a:pPr algn="l"/>
+            <a:r>
+              <a:rPr sz="1800" b="1" i="0">
+                <a:solidFill>
+                  <a:srgbClr val="1F3A5F"/>
+                </a:solidFill>
+                <a:latin typeface="Arial"/>
+              </a:rPr>
+              <a:t>Cadre rouge, puis vert</a:t>
+            </a:r>
+          </a:p>
+          <a:p>
+            <a:pPr algn="l"/>
+            <a:r>
+              <a:rPr sz="1800" b="0" i="0">
+                <a:solidFill>
+                  <a:srgbClr val="1B2530"/>
+                </a:solidFill>
+                <a:latin typeface="Arial"/>
+              </a:rPr>
+              <a:t>la carte est détectée et suivie</a:t>
+            </a:r>
+          </a:p>
+        </p:txBody>
+      </p:sp>
+      <p:sp>
+        <p:nvSpPr>
+          <p:cNvPr id="12" name="TextBox 11"/>
+          <p:cNvSpPr txBox="1"/>
+          <p:nvPr/>
+        </p:nvSpPr>
+        <p:spPr>
+          <a:xfrm>
+            <a:off x="4480560" y="2953512"/>
+            <a:ext cx="457200" cy="548640"/>
+          </a:xfrm>
+          <a:prstGeom prst="rect">
+            <a:avLst/>
+          </a:prstGeom>
+          <a:noFill/>
+        </p:spPr>
+        <p:txBody>
+          <a:bodyPr wrap="square" lIns="0" rIns="0" tIns="0" bIns="0" anchor="t">
+            <a:spAutoFit/>
+          </a:bodyPr>
+          <a:lstStyle/>
+          <a:p>
+            <a:pPr algn="l"/>
+            <a:r>
+              <a:rPr sz="2600" b="1" i="0">
+                <a:solidFill>
+                  <a:srgbClr val="2E75B6"/>
+                </a:solidFill>
+                <a:latin typeface="Arial"/>
+              </a:rPr>
+              <a:t>2</a:t>
+            </a:r>
+          </a:p>
+        </p:txBody>
+      </p:sp>
+      <p:sp>
+        <p:nvSpPr>
+          <p:cNvPr id="13" name="TextBox 12"/>
+          <p:cNvSpPr txBox="1"/>
+          <p:nvPr/>
+        </p:nvSpPr>
+        <p:spPr>
+          <a:xfrm>
+            <a:off x="4983480" y="2971800"/>
+            <a:ext cx="6583680" cy="822960"/>
+          </a:xfrm>
+          <a:prstGeom prst="rect">
+            <a:avLst/>
+          </a:prstGeom>
+          <a:noFill/>
+        </p:spPr>
+        <p:txBody>
+          <a:bodyPr wrap="square" lIns="0" rIns="0" tIns="0" bIns="0" anchor="t">
+            <a:spAutoFit/>
+          </a:bodyPr>
+          <a:lstStyle/>
+          <a:p>
+            <a:pPr algn="l"/>
+            <a:r>
+              <a:rPr sz="1800" b="1" i="0">
+                <a:solidFill>
+                  <a:srgbClr val="1F3A5F"/>
+                </a:solidFill>
+                <a:latin typeface="Arial"/>
+              </a:rPr>
+              <a:t>Messages de qualité</a:t>
+            </a:r>
+          </a:p>
+          <a:p>
+            <a:pPr algn="l"/>
+            <a:r>
+              <a:rPr sz="1800" b="0" i="0">
+                <a:solidFill>
+                  <a:srgbClr val="1B2530"/>
+                </a:solidFill>
+                <a:latin typeface="Arial"/>
+              </a:rPr>
+              <a:t>« Ne bougez plus… » jusqu'à ce que tout soit bon</a:t>
+            </a:r>
+          </a:p>
+        </p:txBody>
+      </p:sp>
+      <p:sp>
+        <p:nvSpPr>
+          <p:cNvPr id="14" name="TextBox 13"/>
+          <p:cNvSpPr txBox="1"/>
+          <p:nvPr/>
+        </p:nvSpPr>
+        <p:spPr>
+          <a:xfrm>
+            <a:off x="4480560" y="3941064"/>
+            <a:ext cx="457200" cy="548640"/>
+          </a:xfrm>
+          <a:prstGeom prst="rect">
+            <a:avLst/>
+          </a:prstGeom>
+          <a:noFill/>
+        </p:spPr>
+        <p:txBody>
+          <a:bodyPr wrap="square" lIns="0" rIns="0" tIns="0" bIns="0" anchor="t">
+            <a:spAutoFit/>
+          </a:bodyPr>
+          <a:lstStyle/>
+          <a:p>
+            <a:pPr algn="l"/>
+            <a:r>
+              <a:rPr sz="2600" b="1" i="0">
+                <a:solidFill>
+                  <a:srgbClr val="2E75B6"/>
+                </a:solidFill>
+                <a:latin typeface="Arial"/>
+              </a:rPr>
+              <a:t>3</a:t>
+            </a:r>
+          </a:p>
+        </p:txBody>
+      </p:sp>
+      <p:sp>
+        <p:nvSpPr>
+          <p:cNvPr id="15" name="TextBox 14"/>
+          <p:cNvSpPr txBox="1"/>
+          <p:nvPr/>
+        </p:nvSpPr>
+        <p:spPr>
+          <a:xfrm>
+            <a:off x="4983480" y="3959352"/>
+            <a:ext cx="6583680" cy="822960"/>
+          </a:xfrm>
+          <a:prstGeom prst="rect">
+            <a:avLst/>
+          </a:prstGeom>
+          <a:noFill/>
+        </p:spPr>
+        <p:txBody>
+          <a:bodyPr wrap="square" lIns="0" rIns="0" tIns="0" bIns="0" anchor="t">
+            <a:spAutoFit/>
+          </a:bodyPr>
+          <a:lstStyle/>
+          <a:p>
+            <a:pPr algn="l"/>
+            <a:r>
+              <a:rPr sz="1800" b="1" i="0">
+                <a:solidFill>
+                  <a:srgbClr val="1F3A5F"/>
+                </a:solidFill>
+                <a:latin typeface="Arial"/>
+              </a:rPr>
+              <a:t>Capture du recto, seule</a:t>
+            </a:r>
+          </a:p>
+          <a:p>
+            <a:pPr algn="l"/>
+            <a:r>
+              <a:rPr sz="1800" b="0" i="0">
+                <a:solidFill>
+                  <a:srgbClr val="1B2530"/>
+                </a:solidFill>
+                <a:latin typeface="Arial"/>
+              </a:rPr>
+              <a:t>puis passage automatique au verso</a:t>
+            </a:r>
+          </a:p>
+        </p:txBody>
+      </p:sp>
+      <p:sp>
+        <p:nvSpPr>
+          <p:cNvPr id="16" name="TextBox 15"/>
+          <p:cNvSpPr txBox="1"/>
+          <p:nvPr/>
+        </p:nvSpPr>
+        <p:spPr>
+          <a:xfrm>
+            <a:off x="4480560" y="4928616"/>
+            <a:ext cx="457200" cy="548640"/>
+          </a:xfrm>
+          <a:prstGeom prst="rect">
+            <a:avLst/>
+          </a:prstGeom>
+          <a:noFill/>
+        </p:spPr>
+        <p:txBody>
+          <a:bodyPr wrap="square" lIns="0" rIns="0" tIns="0" bIns="0" anchor="t">
+            <a:spAutoFit/>
+          </a:bodyPr>
+          <a:lstStyle/>
+          <a:p>
+            <a:pPr algn="l"/>
+            <a:r>
+              <a:rPr sz="2600" b="1" i="0">
+                <a:solidFill>
+                  <a:srgbClr val="2E75B6"/>
+                </a:solidFill>
+                <a:latin typeface="Arial"/>
+              </a:rPr>
+              <a:t>4</a:t>
+            </a:r>
+          </a:p>
+        </p:txBody>
+      </p:sp>
+      <p:sp>
+        <p:nvSpPr>
+          <p:cNvPr id="17" name="TextBox 16"/>
+          <p:cNvSpPr txBox="1"/>
+          <p:nvPr/>
+        </p:nvSpPr>
+        <p:spPr>
+          <a:xfrm>
+            <a:off x="4983480" y="4946904"/>
+            <a:ext cx="6583680" cy="822960"/>
+          </a:xfrm>
+          <a:prstGeom prst="rect">
+            <a:avLst/>
+          </a:prstGeom>
+          <a:noFill/>
+        </p:spPr>
+        <p:txBody>
+          <a:bodyPr wrap="square" lIns="0" rIns="0" tIns="0" bIns="0" anchor="t">
+            <a:spAutoFit/>
+          </a:bodyPr>
+          <a:lstStyle/>
+          <a:p>
+            <a:pPr algn="l"/>
+            <a:r>
+              <a:rPr sz="1800" b="1" i="0">
+                <a:solidFill>
+                  <a:srgbClr val="1F3A5F"/>
+                </a:solidFill>
+                <a:latin typeface="Arial"/>
+              </a:rPr>
+              <a:t>Capture du verso</a:t>
+            </a:r>
+          </a:p>
+          <a:p>
+            <a:pPr algn="l"/>
+            <a:r>
+              <a:rPr sz="1800" b="0" i="0">
+                <a:solidFill>
+                  <a:srgbClr val="1B2530"/>
+                </a:solidFill>
+                <a:latin typeface="Arial"/>
+              </a:rPr>
+              <a:t>puis écran de vérification</a:t>
+            </a:r>
+          </a:p>
+        </p:txBody>
+      </p:sp>
+    </p:spTree>
+  </p:cSld>
+  <p:clrMapOvr>
+    <a:masterClrMapping/>
+  </p:clrMapOvr>
+  <p:transition spd="med">
+    <p:fade/>
+  </p:transition>
+</p:sld>
+</file>
+
+<file path=ppt/slides/slide12.xml><?xml version="1.0" encoding="utf-8"?>
+<p:sld xmlns:a="http://schemas.openxmlformats.org/drawingml/2006/main" xmlns:p="http://schemas.openxmlformats.org/presentationml/2006/main" xmlns:r="http://schemas.openxmlformats.org/officeDocument/2006/relationships">
+  <p:cSld>
+    <p:spTree>
+      <p:nvGrpSpPr>
+        <p:cNvPr id="1" name=""/>
+        <p:cNvGrpSpPr/>
+        <p:nvPr/>
+      </p:nvGrpSpPr>
+      <p:grpSpPr/>
+      <p:sp>
+        <p:nvSpPr>
+          <p:cNvPr id="2" name="TextBox 1"/>
+          <p:cNvSpPr txBox="1"/>
+          <p:nvPr/>
+        </p:nvSpPr>
+        <p:spPr>
+          <a:xfrm>
+            <a:off x="5973775" y="429768"/>
+            <a:ext cx="5669280" cy="274320"/>
+          </a:xfrm>
+          <a:prstGeom prst="rect">
+            <a:avLst/>
+          </a:prstGeom>
+          <a:noFill/>
+        </p:spPr>
+        <p:txBody>
+          <a:bodyPr wrap="square" lIns="0" rIns="0" tIns="0" bIns="0" anchor="t">
+            <a:spAutoFit/>
+          </a:bodyPr>
+          <a:lstStyle/>
+          <a:p>
+            <a:pPr algn="r"/>
+            <a:r>
+              <a:rPr sz="1100" b="0" i="0">
+                <a:solidFill>
+                  <a:srgbClr val="5B6B7A"/>
+                </a:solidFill>
+                <a:latin typeface="Arial"/>
+              </a:rPr>
+              <a:t>CONTEXTE</a:t>
+            </a:r>
+            <a:r>
+              <a:rPr sz="1100" b="0" i="0">
+                <a:solidFill>
+                  <a:srgbClr val="CBD3DB"/>
+                </a:solidFill>
+                <a:latin typeface="Arial"/>
+              </a:rPr>
+              <a:t>   ·   </a:t>
+            </a:r>
+            <a:r>
+              <a:rPr sz="1100" b="0" i="0">
+                <a:solidFill>
+                  <a:srgbClr val="5B6B7A"/>
+                </a:solidFill>
+                <a:latin typeface="Arial"/>
+              </a:rPr>
+              <a:t>CONCEPTION</a:t>
+            </a:r>
+            <a:r>
+              <a:rPr sz="1100" b="0" i="0">
+                <a:solidFill>
+                  <a:srgbClr val="CBD3DB"/>
+                </a:solidFill>
+                <a:latin typeface="Arial"/>
+              </a:rPr>
+              <a:t>   ·   </a:t>
+            </a:r>
+            <a:r>
+              <a:rPr sz="1100" b="1" i="0">
+                <a:solidFill>
+                  <a:srgbClr val="2E75B6"/>
+                </a:solidFill>
+                <a:latin typeface="Arial"/>
+              </a:rPr>
+              <a:t>RÉSULTATS</a:t>
+            </a:r>
+            <a:r>
+              <a:rPr sz="1100" b="0" i="0">
+                <a:solidFill>
+                  <a:srgbClr val="CBD3DB"/>
+                </a:solidFill>
+                <a:latin typeface="Arial"/>
+              </a:rPr>
+              <a:t>   ·   </a:t>
+            </a:r>
+            <a:r>
+              <a:rPr sz="1100" b="0" i="0">
+                <a:solidFill>
+                  <a:srgbClr val="5B6B7A"/>
+                </a:solidFill>
+                <a:latin typeface="Arial"/>
+              </a:rPr>
+              <a:t>BILAN</a:t>
+            </a:r>
+          </a:p>
+        </p:txBody>
+      </p:sp>
+      <p:cxnSp>
+        <p:nvCxnSpPr>
+          <p:cNvPr id="3" name="Connector 2"/>
+          <p:cNvCxnSpPr/>
+          <p:nvPr/>
+        </p:nvCxnSpPr>
+        <p:spPr>
+          <a:xfrm>
+            <a:off x="548640" y="6382512"/>
+            <a:ext cx="11094415" cy="0"/>
+          </a:xfrm>
+          <a:prstGeom prst="line">
+            <a:avLst/>
+          </a:prstGeom>
+          <a:ln w="9525">
+            <a:solidFill>
+              <a:srgbClr val="CBD3DB"/>
+            </a:solidFill>
+          </a:ln>
+        </p:spPr>
+      </p:cxnSp>
+      <p:sp>
+        <p:nvSpPr>
+          <p:cNvPr id="4" name="TextBox 3"/>
+          <p:cNvSpPr txBox="1"/>
+          <p:nvPr/>
+        </p:nvSpPr>
+        <p:spPr>
+          <a:xfrm>
+            <a:off x="548640" y="6455664"/>
+            <a:ext cx="7315200" cy="228600"/>
+          </a:xfrm>
+          <a:prstGeom prst="rect">
+            <a:avLst/>
+          </a:prstGeom>
+          <a:noFill/>
+        </p:spPr>
+        <p:txBody>
+          <a:bodyPr wrap="square" lIns="0" rIns="0" tIns="0" bIns="0" anchor="t">
+            <a:spAutoFit/>
+          </a:bodyPr>
+          <a:lstStyle/>
+          <a:p>
+            <a:pPr algn="l"/>
+            <a:r>
+              <a:rPr sz="1100" b="0" i="0">
+                <a:solidFill>
+                  <a:srgbClr val="5B6B7A"/>
+                </a:solidFill>
+                <a:latin typeface="Arial"/>
+              </a:rPr>
+              <a:t>Avatar-ID · autocapture de la CIN · Mohammed Amine Chaieb · ENSI 2025/2026</a:t>
+            </a:r>
+          </a:p>
+        </p:txBody>
+      </p:sp>
+      <p:sp>
+        <p:nvSpPr>
+          <p:cNvPr id="5" name="TextBox 4"/>
+          <p:cNvSpPr txBox="1"/>
+          <p:nvPr/>
+        </p:nvSpPr>
+        <p:spPr>
+          <a:xfrm>
+            <a:off x="9814255" y="6455664"/>
+            <a:ext cx="1828800" cy="228600"/>
+          </a:xfrm>
+          <a:prstGeom prst="rect">
+            <a:avLst/>
+          </a:prstGeom>
+          <a:noFill/>
+        </p:spPr>
+        <p:txBody>
+          <a:bodyPr wrap="square" lIns="0" rIns="0" tIns="0" bIns="0" anchor="t">
+            <a:spAutoFit/>
+          </a:bodyPr>
+          <a:lstStyle/>
+          <a:p>
+            <a:pPr algn="r"/>
+            <a:r>
+              <a:rPr sz="1100" b="0" i="0">
+                <a:solidFill>
+                  <a:srgbClr val="5B6B7A"/>
+                </a:solidFill>
+                <a:latin typeface="Arial"/>
+              </a:rPr>
+              <a:t>12 / 17</a:t>
             </a:r>
           </a:p>
         </p:txBody>
@@ -8318,7 +9071,7 @@
 </p:sld>
 </file>
 
-<file path=ppt/slides/slide12.xml><?xml version="1.0" encoding="utf-8"?>
+<file path=ppt/slides/slide13.xml><?xml version="1.0" encoding="utf-8"?>
 <p:sld xmlns:a="http://schemas.openxmlformats.org/drawingml/2006/main" xmlns:p="http://schemas.openxmlformats.org/presentationml/2006/main" xmlns:r="http://schemas.openxmlformats.org/officeDocument/2006/relationships">
   <p:cSld>
     <p:spTree>
@@ -8503,7 +9256,7 @@
                 </a:solidFill>
                 <a:latin typeface="Arial"/>
               </a:rPr>
-              <a:t>12 / 16</a:t>
+              <a:t>13 / 17</a:t>
             </a:r>
           </a:p>
         </p:txBody>
@@ -9687,7 +10440,7 @@
 </p:sld>
 </file>
 
-<file path=ppt/slides/slide13.xml><?xml version="1.0" encoding="utf-8"?>
+<file path=ppt/slides/slide14.xml><?xml version="1.0" encoding="utf-8"?>
 <p:sld xmlns:a="http://schemas.openxmlformats.org/drawingml/2006/main" xmlns:p="http://schemas.openxmlformats.org/presentationml/2006/main" xmlns:r="http://schemas.openxmlformats.org/officeDocument/2006/relationships">
   <p:cSld>
     <p:spTree>
@@ -9872,7 +10625,7 @@
                 </a:solidFill>
                 <a:latin typeface="Arial"/>
               </a:rPr>
-              <a:t>13 / 16</a:t>
+              <a:t>14 / 17</a:t>
             </a:r>
           </a:p>
         </p:txBody>
@@ -11333,7 +12086,7 @@
 </p:sld>
 </file>
 
-<file path=ppt/slides/slide14.xml><?xml version="1.0" encoding="utf-8"?>
+<file path=ppt/slides/slide15.xml><?xml version="1.0" encoding="utf-8"?>
 <p:sld xmlns:a="http://schemas.openxmlformats.org/drawingml/2006/main" xmlns:p="http://schemas.openxmlformats.org/presentationml/2006/main" xmlns:r="http://schemas.openxmlformats.org/officeDocument/2006/relationships">
   <p:cSld>
     <p:spTree>
@@ -11518,7 +12271,7 @@
                 </a:solidFill>
                 <a:latin typeface="Arial"/>
               </a:rPr>
-              <a:t>14 / 16</a:t>
+              <a:t>15 / 17</a:t>
             </a:r>
           </a:p>
         </p:txBody>
@@ -12661,7 +13414,7 @@
 </p:sld>
 </file>
 
-<file path=ppt/slides/slide15.xml><?xml version="1.0" encoding="utf-8"?>
+<file path=ppt/slides/slide16.xml><?xml version="1.0" encoding="utf-8"?>
 <p:sld xmlns:a="http://schemas.openxmlformats.org/drawingml/2006/main" xmlns:p="http://schemas.openxmlformats.org/presentationml/2006/main" xmlns:r="http://schemas.openxmlformats.org/officeDocument/2006/relationships">
   <p:cSld>
     <p:spTree>
@@ -12846,7 +13599,7 @@
                 </a:solidFill>
                 <a:latin typeface="Arial"/>
               </a:rPr>
-              <a:t>15 / 16</a:t>
+              <a:t>16 / 17</a:t>
             </a:r>
           </a:p>
         </p:txBody>
@@ -13860,7 +14613,7 @@
 </p:sld>
 </file>
 
-<file path=ppt/slides/slide16.xml><?xml version="1.0" encoding="utf-8"?>
+<file path=ppt/slides/slide17.xml><?xml version="1.0" encoding="utf-8"?>
 <p:sld xmlns:a="http://schemas.openxmlformats.org/drawingml/2006/main" xmlns:p="http://schemas.openxmlformats.org/presentationml/2006/main" xmlns:r="http://schemas.openxmlformats.org/officeDocument/2006/relationships">
   <p:cSld>
     <p:spTree>
@@ -13956,7 +14709,7 @@
                 </a:solidFill>
                 <a:latin typeface="Arial"/>
               </a:rPr>
-              <a:t>16 / 16</a:t>
+              <a:t>17 / 17</a:t>
             </a:r>
           </a:p>
         </p:txBody>
@@ -14366,7 +15119,7 @@
 </p:sld>
 </file>
 
-<file path=ppt/slides/slide17.xml><?xml version="1.0" encoding="utf-8"?>
+<file path=ppt/slides/slide18.xml><?xml version="1.0" encoding="utf-8"?>
 <p:sld xmlns:a="http://schemas.openxmlformats.org/drawingml/2006/main" xmlns:p="http://schemas.openxmlformats.org/presentationml/2006/main" xmlns:r="http://schemas.openxmlformats.org/officeDocument/2006/relationships">
   <p:cSld>
     <p:spTree>
@@ -16245,7 +16998,7 @@
 </p:sld>
 </file>
 
-<file path=ppt/slides/slide18.xml><?xml version="1.0" encoding="utf-8"?>
+<file path=ppt/slides/slide19.xml><?xml version="1.0" encoding="utf-8"?>
 <p:sld xmlns:a="http://schemas.openxmlformats.org/drawingml/2006/main" xmlns:p="http://schemas.openxmlformats.org/presentationml/2006/main" xmlns:r="http://schemas.openxmlformats.org/officeDocument/2006/relationships">
   <p:cSld>
     <p:spTree>
@@ -17227,551 +17980,6 @@
 </p:sld>
 </file>
 
-<file path=ppt/slides/slide19.xml><?xml version="1.0" encoding="utf-8"?>
-<p:sld xmlns:a="http://schemas.openxmlformats.org/drawingml/2006/main" xmlns:p="http://schemas.openxmlformats.org/presentationml/2006/main" xmlns:r="http://schemas.openxmlformats.org/officeDocument/2006/relationships">
-  <p:cSld>
-    <p:spTree>
-      <p:nvGrpSpPr>
-        <p:cNvPr id="1" name=""/>
-        <p:cNvGrpSpPr/>
-        <p:nvPr/>
-      </p:nvGrpSpPr>
-      <p:grpSpPr/>
-      <p:sp>
-        <p:nvSpPr>
-          <p:cNvPr id="2" name="Rectangle 1"/>
-          <p:cNvSpPr/>
-          <p:nvPr/>
-        </p:nvSpPr>
-        <p:spPr>
-          <a:xfrm>
-            <a:off x="10317175" y="384048"/>
-            <a:ext cx="1325880" cy="310896"/>
-          </a:xfrm>
-          <a:prstGeom prst="rect">
-            <a:avLst/>
-          </a:prstGeom>
-          <a:solidFill>
-            <a:srgbClr val="EEF2F6"/>
-          </a:solidFill>
-          <a:ln>
-            <a:noFill/>
-          </a:ln>
-        </p:spPr>
-        <p:txBody>
-          <a:bodyPr rtlCol="0" anchor="ctr"/>
-          <a:lstStyle/>
-          <a:p/>
-        </p:txBody>
-      </p:sp>
-      <p:sp>
-        <p:nvSpPr>
-          <p:cNvPr id="3" name="TextBox 2"/>
-          <p:cNvSpPr txBox="1"/>
-          <p:nvPr/>
-        </p:nvSpPr>
-        <p:spPr>
-          <a:xfrm>
-            <a:off x="10317175" y="384048"/>
-            <a:ext cx="1325880" cy="310896"/>
-          </a:xfrm>
-          <a:prstGeom prst="rect">
-            <a:avLst/>
-          </a:prstGeom>
-          <a:noFill/>
-        </p:spPr>
-        <p:txBody>
-          <a:bodyPr wrap="square" lIns="0" rIns="0" tIns="0" bIns="0" anchor="ctr">
-            <a:spAutoFit/>
-          </a:bodyPr>
-          <a:lstStyle/>
-          <a:p>
-            <a:pPr algn="ctr"/>
-            <a:r>
-              <a:rPr sz="1200" b="1" i="0">
-                <a:solidFill>
-                  <a:srgbClr val="5B6B7A"/>
-                </a:solidFill>
-                <a:latin typeface="Arial"/>
-              </a:rPr>
-              <a:t>Secours C</a:t>
-            </a:r>
-          </a:p>
-        </p:txBody>
-      </p:sp>
-      <p:cxnSp>
-        <p:nvCxnSpPr>
-          <p:cNvPr id="4" name="Connector 3"/>
-          <p:cNvCxnSpPr/>
-          <p:nvPr/>
-        </p:nvCxnSpPr>
-        <p:spPr>
-          <a:xfrm>
-            <a:off x="548640" y="6382512"/>
-            <a:ext cx="11094415" cy="0"/>
-          </a:xfrm>
-          <a:prstGeom prst="line">
-            <a:avLst/>
-          </a:prstGeom>
-          <a:ln w="9525">
-            <a:solidFill>
-              <a:srgbClr val="CBD3DB"/>
-            </a:solidFill>
-          </a:ln>
-        </p:spPr>
-      </p:cxnSp>
-      <p:sp>
-        <p:nvSpPr>
-          <p:cNvPr id="5" name="TextBox 4"/>
-          <p:cNvSpPr txBox="1"/>
-          <p:nvPr/>
-        </p:nvSpPr>
-        <p:spPr>
-          <a:xfrm>
-            <a:off x="548640" y="6455664"/>
-            <a:ext cx="7315200" cy="228600"/>
-          </a:xfrm>
-          <a:prstGeom prst="rect">
-            <a:avLst/>
-          </a:prstGeom>
-          <a:noFill/>
-        </p:spPr>
-        <p:txBody>
-          <a:bodyPr wrap="square" lIns="0" rIns="0" tIns="0" bIns="0" anchor="t">
-            <a:spAutoFit/>
-          </a:bodyPr>
-          <a:lstStyle/>
-          <a:p>
-            <a:pPr algn="l"/>
-            <a:r>
-              <a:rPr sz="1100" b="0" i="0">
-                <a:solidFill>
-                  <a:srgbClr val="5B6B7A"/>
-                </a:solidFill>
-                <a:latin typeface="Arial"/>
-              </a:rPr>
-              <a:t>Avatar-ID · autocapture de la CIN · Mohammed Amine Chaieb · ENSI 2025/2026</a:t>
-            </a:r>
-          </a:p>
-        </p:txBody>
-      </p:sp>
-      <p:sp>
-        <p:nvSpPr>
-          <p:cNvPr id="6" name="TextBox 5"/>
-          <p:cNvSpPr txBox="1"/>
-          <p:nvPr/>
-        </p:nvSpPr>
-        <p:spPr>
-          <a:xfrm>
-            <a:off x="9814255" y="6455664"/>
-            <a:ext cx="1828800" cy="228600"/>
-          </a:xfrm>
-          <a:prstGeom prst="rect">
-            <a:avLst/>
-          </a:prstGeom>
-          <a:noFill/>
-        </p:spPr>
-        <p:txBody>
-          <a:bodyPr wrap="square" lIns="0" rIns="0" tIns="0" bIns="0" anchor="t">
-            <a:spAutoFit/>
-          </a:bodyPr>
-          <a:lstStyle/>
-          <a:p>
-            <a:pPr algn="r"/>
-            <a:r>
-              <a:rPr sz="1100" b="0" i="0">
-                <a:solidFill>
-                  <a:srgbClr val="5B6B7A"/>
-                </a:solidFill>
-                <a:latin typeface="Arial"/>
-              </a:rPr>
-              <a:t>Secours C</a:t>
-            </a:r>
-          </a:p>
-        </p:txBody>
-      </p:sp>
-      <p:sp>
-        <p:nvSpPr>
-          <p:cNvPr id="7" name="Titre"/>
-          <p:cNvSpPr txBox="1"/>
-          <p:nvPr/>
-        </p:nvSpPr>
-        <p:spPr>
-          <a:xfrm>
-            <a:off x="548640" y="777240"/>
-            <a:ext cx="11094415" cy="1005840"/>
-          </a:xfrm>
-          <a:prstGeom prst="rect">
-            <a:avLst/>
-          </a:prstGeom>
-          <a:noFill/>
-        </p:spPr>
-        <p:txBody>
-          <a:bodyPr wrap="square" lIns="0" rIns="0" tIns="0" bIns="0" anchor="t">
-            <a:spAutoFit/>
-          </a:bodyPr>
-          <a:lstStyle/>
-          <a:p>
-            <a:pPr algn="l"/>
-            <a:r>
-              <a:rPr sz="2800" b="1" i="0">
-                <a:solidFill>
-                  <a:srgbClr val="1F3A5F"/>
-                </a:solidFill>
-                <a:latin typeface="Arial"/>
-              </a:rPr>
-              <a:t>La capture est sûre par construction ; la vivacité est vérifiée ensuite par Avatar-ID</a:t>
-            </a:r>
-          </a:p>
-        </p:txBody>
-      </p:sp>
-      <p:sp>
-        <p:nvSpPr>
-          <p:cNvPr id="8" name="TextBox 7"/>
-          <p:cNvSpPr txBox="1"/>
-          <p:nvPr/>
-        </p:nvSpPr>
-        <p:spPr>
-          <a:xfrm>
-            <a:off x="548640" y="1828800"/>
-            <a:ext cx="5272887" cy="320040"/>
-          </a:xfrm>
-          <a:prstGeom prst="rect">
-            <a:avLst/>
-          </a:prstGeom>
-          <a:noFill/>
-        </p:spPr>
-        <p:txBody>
-          <a:bodyPr wrap="square" lIns="0" rIns="0" tIns="0" bIns="0" anchor="t">
-            <a:spAutoFit/>
-          </a:bodyPr>
-          <a:lstStyle/>
-          <a:p>
-            <a:pPr algn="l"/>
-            <a:r>
-              <a:rPr sz="1300" b="1" i="0">
-                <a:solidFill>
-                  <a:srgbClr val="2E75B6"/>
-                </a:solidFill>
-                <a:latin typeface="Arial"/>
-              </a:rPr>
-              <a:t>GARANTI PAR CONSTRUCTION</a:t>
-            </a:r>
-          </a:p>
-        </p:txBody>
-      </p:sp>
-      <p:sp>
-        <p:nvSpPr>
-          <p:cNvPr id="9" name="TextBox 8"/>
-          <p:cNvSpPr txBox="1"/>
-          <p:nvPr/>
-        </p:nvSpPr>
-        <p:spPr>
-          <a:xfrm>
-            <a:off x="548640" y="2286000"/>
-            <a:ext cx="5272887" cy="3108960"/>
-          </a:xfrm>
-          <a:prstGeom prst="rect">
-            <a:avLst/>
-          </a:prstGeom>
-          <a:noFill/>
-        </p:spPr>
-        <p:txBody>
-          <a:bodyPr wrap="square" lIns="0" rIns="0" tIns="0" bIns="0" anchor="t">
-            <a:spAutoFit/>
-          </a:bodyPr>
-          <a:lstStyle/>
-          <a:p>
-            <a:pPr algn="l">
-              <a:spcAft>
-                <a:spcPts val="1200"/>
-              </a:spcAft>
-            </a:pPr>
-            <a:r>
-              <a:rPr sz="1800" b="0" i="0">
-                <a:solidFill>
-                  <a:srgbClr val="1B2530"/>
-                </a:solidFill>
-                <a:latin typeface="Arial"/>
-              </a:rPr>
-              <a:t>Capture en direct, depuis le flux caméra</a:t>
-            </a:r>
-          </a:p>
-          <a:p>
-            <a:pPr algn="l">
-              <a:spcAft>
-                <a:spcPts val="1200"/>
-              </a:spcAft>
-            </a:pPr>
-            <a:r>
-              <a:rPr sz="1800" b="0" i="0">
-                <a:solidFill>
-                  <a:srgbClr val="1B2530"/>
-                </a:solidFill>
-                <a:latin typeface="Arial"/>
-              </a:rPr>
-              <a:t>Deux faces distinctes, dans l'ordre recto → verso</a:t>
-            </a:r>
-          </a:p>
-          <a:p>
-            <a:pPr algn="l">
-              <a:spcAft>
-                <a:spcPts val="1200"/>
-              </a:spcAft>
-            </a:pPr>
-            <a:r>
-              <a:rPr sz="1800" b="0" i="0">
-                <a:solidFill>
-                  <a:srgbClr val="1B2530"/>
-                </a:solidFill>
-                <a:latin typeface="Arial"/>
-              </a:rPr>
-              <a:t>Qualité contrôlée : netteté, luminosité, stabilité</a:t>
-            </a:r>
-          </a:p>
-          <a:p>
-            <a:pPr algn="l">
-              <a:spcAft>
-                <a:spcPts val="1200"/>
-              </a:spcAft>
-            </a:pPr>
-            <a:r>
-              <a:rPr sz="1800" b="0" i="0">
-                <a:solidFill>
-                  <a:srgbClr val="1B2530"/>
-                </a:solidFill>
-                <a:latin typeface="Arial"/>
-              </a:rPr>
-              <a:t>Traitement sur l'appareil, sans service tiers</a:t>
-            </a:r>
-          </a:p>
-        </p:txBody>
-      </p:sp>
-      <p:cxnSp>
-        <p:nvCxnSpPr>
-          <p:cNvPr id="10" name="Connector 9"/>
-          <p:cNvCxnSpPr/>
-          <p:nvPr/>
-        </p:nvCxnSpPr>
-        <p:spPr>
-          <a:xfrm>
-            <a:off x="6095847" y="1828800"/>
-            <a:ext cx="0" cy="3291840"/>
-          </a:xfrm>
-          <a:prstGeom prst="line">
-            <a:avLst/>
-          </a:prstGeom>
-          <a:ln w="9525">
-            <a:solidFill>
-              <a:srgbClr val="CBD3DB"/>
-            </a:solidFill>
-          </a:ln>
-        </p:spPr>
-      </p:cxnSp>
-      <p:sp>
-        <p:nvSpPr>
-          <p:cNvPr id="11" name="TextBox 10"/>
-          <p:cNvSpPr txBox="1"/>
-          <p:nvPr/>
-        </p:nvSpPr>
-        <p:spPr>
-          <a:xfrm>
-            <a:off x="6370167" y="1828800"/>
-            <a:ext cx="5272887" cy="320040"/>
-          </a:xfrm>
-          <a:prstGeom prst="rect">
-            <a:avLst/>
-          </a:prstGeom>
-          <a:noFill/>
-        </p:spPr>
-        <p:txBody>
-          <a:bodyPr wrap="square" lIns="0" rIns="0" tIns="0" bIns="0" anchor="t">
-            <a:spAutoFit/>
-          </a:bodyPr>
-          <a:lstStyle/>
-          <a:p>
-            <a:pPr algn="l"/>
-            <a:r>
-              <a:rPr sz="1300" b="1" i="0">
-                <a:solidFill>
-                  <a:srgbClr val="1F3A5F"/>
-                </a:solidFill>
-                <a:latin typeface="Arial"/>
-              </a:rPr>
-              <a:t>EN AVAL ET PROCHAINES ÉTAPES</a:t>
-            </a:r>
-          </a:p>
-        </p:txBody>
-      </p:sp>
-      <p:sp>
-        <p:nvSpPr>
-          <p:cNvPr id="12" name="TextBox 11"/>
-          <p:cNvSpPr txBox="1"/>
-          <p:nvPr/>
-        </p:nvSpPr>
-        <p:spPr>
-          <a:xfrm>
-            <a:off x="6370167" y="2286000"/>
-            <a:ext cx="5272887" cy="3108960"/>
-          </a:xfrm>
-          <a:prstGeom prst="rect">
-            <a:avLst/>
-          </a:prstGeom>
-          <a:noFill/>
-        </p:spPr>
-        <p:txBody>
-          <a:bodyPr wrap="square" lIns="0" rIns="0" tIns="0" bIns="0" anchor="t">
-            <a:spAutoFit/>
-          </a:bodyPr>
-          <a:lstStyle/>
-          <a:p>
-            <a:pPr algn="l">
-              <a:spcAft>
-                <a:spcPts val="1200"/>
-              </a:spcAft>
-            </a:pPr>
-            <a:r>
-              <a:rPr sz="1800" b="0" i="0">
-                <a:solidFill>
-                  <a:srgbClr val="1B2530"/>
-                </a:solidFill>
-                <a:latin typeface="Arial"/>
-              </a:rPr>
-              <a:t>Vivacité et comparaison des photos : Avatar-ID</a:t>
-            </a:r>
-          </a:p>
-          <a:p>
-            <a:pPr algn="l">
-              <a:spcAft>
-                <a:spcPts val="1200"/>
-              </a:spcAft>
-            </a:pPr>
-            <a:r>
-              <a:rPr sz="1800" b="0" i="0">
-                <a:solidFill>
-                  <a:srgbClr val="1B2530"/>
-                </a:solidFill>
-                <a:latin typeface="Arial"/>
-              </a:rPr>
-              <a:t>Analyse de texture contre les cartes sur écran</a:t>
-            </a:r>
-          </a:p>
-          <a:p>
-            <a:pPr algn="l">
-              <a:spcAft>
-                <a:spcPts val="1200"/>
-              </a:spcAft>
-            </a:pPr>
-            <a:r>
-              <a:rPr sz="1800" b="0" i="0">
-                <a:solidFill>
-                  <a:srgbClr val="1B2530"/>
-                </a:solidFill>
-                <a:latin typeface="Arial"/>
-              </a:rPr>
-              <a:t>Informer l'utilisateur lors de l'export en galerie</a:t>
-            </a:r>
-          </a:p>
-          <a:p>
-            <a:pPr algn="l">
-              <a:spcAft>
-                <a:spcPts val="1200"/>
-              </a:spcAft>
-            </a:pPr>
-            <a:r>
-              <a:rPr sz="1800" b="0" i="0">
-                <a:solidFill>
-                  <a:srgbClr val="1B2530"/>
-                </a:solidFill>
-                <a:latin typeface="Arial"/>
-              </a:rPr>
-              <a:t>Chiffrement des captures stockées</a:t>
-            </a:r>
-          </a:p>
-        </p:txBody>
-      </p:sp>
-      <p:sp>
-        <p:nvSpPr>
-          <p:cNvPr id="13" name="Rectangle 12"/>
-          <p:cNvSpPr/>
-          <p:nvPr/>
-        </p:nvSpPr>
-        <p:spPr>
-          <a:xfrm>
-            <a:off x="548640" y="5349240"/>
-            <a:ext cx="11094415" cy="566928"/>
-          </a:xfrm>
-          <a:prstGeom prst="rect">
-            <a:avLst/>
-          </a:prstGeom>
-          <a:solidFill>
-            <a:srgbClr val="EEF2F6"/>
-          </a:solidFill>
-          <a:ln>
-            <a:noFill/>
-          </a:ln>
-        </p:spPr>
-        <p:txBody>
-          <a:bodyPr rtlCol="0" anchor="ctr"/>
-          <a:lstStyle/>
-          <a:p/>
-        </p:txBody>
-      </p:sp>
-      <p:sp>
-        <p:nvSpPr>
-          <p:cNvPr id="14" name="TextBox 13"/>
-          <p:cNvSpPr txBox="1"/>
-          <p:nvPr/>
-        </p:nvSpPr>
-        <p:spPr>
-          <a:xfrm>
-            <a:off x="777240" y="5349240"/>
-            <a:ext cx="10637215" cy="566928"/>
-          </a:xfrm>
-          <a:prstGeom prst="rect">
-            <a:avLst/>
-          </a:prstGeom>
-          <a:noFill/>
-        </p:spPr>
-        <p:txBody>
-          <a:bodyPr wrap="square" lIns="0" rIns="0" tIns="0" bIns="0" anchor="ctr">
-            <a:spAutoFit/>
-          </a:bodyPr>
-          <a:lstStyle/>
-          <a:p>
-            <a:pPr algn="l"/>
-            <a:r>
-              <a:rPr sz="1600" b="1" i="0">
-                <a:solidFill>
-                  <a:srgbClr val="1F3A5F"/>
-                </a:solidFill>
-                <a:latin typeface="Arial"/>
-              </a:rPr>
-              <a:t>Données de test : </a:t>
-            </a:r>
-            <a:r>
-              <a:rPr sz="1600" b="0" i="0">
-                <a:solidFill>
-                  <a:srgbClr val="1B2530"/>
-                </a:solidFill>
-                <a:latin typeface="Arial"/>
-              </a:rPr>
-              <a:t>les captures montrées dans cette soutenance sont masquées dans les pixels (photo, nom, numéros, code-barres).</a:t>
-            </a:r>
-          </a:p>
-        </p:txBody>
-      </p:sp>
-    </p:spTree>
-  </p:cSld>
-  <p:clrMapOvr>
-    <a:masterClrMapping/>
-  </p:clrMapOvr>
-  <p:transition spd="med">
-    <p:fade/>
-  </p:transition>
-</p:sld>
-</file>
-
 <file path=ppt/slides/slide2.xml><?xml version="1.0" encoding="utf-8"?>
 <p:sld xmlns:a="http://schemas.openxmlformats.org/drawingml/2006/main" xmlns:p="http://schemas.openxmlformats.org/presentationml/2006/main" xmlns:r="http://schemas.openxmlformats.org/officeDocument/2006/relationships">
   <p:cSld>
@@ -17957,7 +18165,7 @@
                 </a:solidFill>
                 <a:latin typeface="Arial"/>
               </a:rPr>
-              <a:t>2 / 16</a:t>
+              <a:t>2 / 17</a:t>
             </a:r>
           </a:p>
         </p:txBody>
@@ -20028,6 +20236,551 @@
                 </a:solidFill>
                 <a:latin typeface="Arial"/>
               </a:rPr>
+              <a:t>Secours C</a:t>
+            </a:r>
+          </a:p>
+        </p:txBody>
+      </p:sp>
+      <p:cxnSp>
+        <p:nvCxnSpPr>
+          <p:cNvPr id="4" name="Connector 3"/>
+          <p:cNvCxnSpPr/>
+          <p:nvPr/>
+        </p:nvCxnSpPr>
+        <p:spPr>
+          <a:xfrm>
+            <a:off x="548640" y="6382512"/>
+            <a:ext cx="11094415" cy="0"/>
+          </a:xfrm>
+          <a:prstGeom prst="line">
+            <a:avLst/>
+          </a:prstGeom>
+          <a:ln w="9525">
+            <a:solidFill>
+              <a:srgbClr val="CBD3DB"/>
+            </a:solidFill>
+          </a:ln>
+        </p:spPr>
+      </p:cxnSp>
+      <p:sp>
+        <p:nvSpPr>
+          <p:cNvPr id="5" name="TextBox 4"/>
+          <p:cNvSpPr txBox="1"/>
+          <p:nvPr/>
+        </p:nvSpPr>
+        <p:spPr>
+          <a:xfrm>
+            <a:off x="548640" y="6455664"/>
+            <a:ext cx="7315200" cy="228600"/>
+          </a:xfrm>
+          <a:prstGeom prst="rect">
+            <a:avLst/>
+          </a:prstGeom>
+          <a:noFill/>
+        </p:spPr>
+        <p:txBody>
+          <a:bodyPr wrap="square" lIns="0" rIns="0" tIns="0" bIns="0" anchor="t">
+            <a:spAutoFit/>
+          </a:bodyPr>
+          <a:lstStyle/>
+          <a:p>
+            <a:pPr algn="l"/>
+            <a:r>
+              <a:rPr sz="1100" b="0" i="0">
+                <a:solidFill>
+                  <a:srgbClr val="5B6B7A"/>
+                </a:solidFill>
+                <a:latin typeface="Arial"/>
+              </a:rPr>
+              <a:t>Avatar-ID · autocapture de la CIN · Mohammed Amine Chaieb · ENSI 2025/2026</a:t>
+            </a:r>
+          </a:p>
+        </p:txBody>
+      </p:sp>
+      <p:sp>
+        <p:nvSpPr>
+          <p:cNvPr id="6" name="TextBox 5"/>
+          <p:cNvSpPr txBox="1"/>
+          <p:nvPr/>
+        </p:nvSpPr>
+        <p:spPr>
+          <a:xfrm>
+            <a:off x="9814255" y="6455664"/>
+            <a:ext cx="1828800" cy="228600"/>
+          </a:xfrm>
+          <a:prstGeom prst="rect">
+            <a:avLst/>
+          </a:prstGeom>
+          <a:noFill/>
+        </p:spPr>
+        <p:txBody>
+          <a:bodyPr wrap="square" lIns="0" rIns="0" tIns="0" bIns="0" anchor="t">
+            <a:spAutoFit/>
+          </a:bodyPr>
+          <a:lstStyle/>
+          <a:p>
+            <a:pPr algn="r"/>
+            <a:r>
+              <a:rPr sz="1100" b="0" i="0">
+                <a:solidFill>
+                  <a:srgbClr val="5B6B7A"/>
+                </a:solidFill>
+                <a:latin typeface="Arial"/>
+              </a:rPr>
+              <a:t>Secours C</a:t>
+            </a:r>
+          </a:p>
+        </p:txBody>
+      </p:sp>
+      <p:sp>
+        <p:nvSpPr>
+          <p:cNvPr id="7" name="Titre"/>
+          <p:cNvSpPr txBox="1"/>
+          <p:nvPr/>
+        </p:nvSpPr>
+        <p:spPr>
+          <a:xfrm>
+            <a:off x="548640" y="777240"/>
+            <a:ext cx="11094415" cy="1005840"/>
+          </a:xfrm>
+          <a:prstGeom prst="rect">
+            <a:avLst/>
+          </a:prstGeom>
+          <a:noFill/>
+        </p:spPr>
+        <p:txBody>
+          <a:bodyPr wrap="square" lIns="0" rIns="0" tIns="0" bIns="0" anchor="t">
+            <a:spAutoFit/>
+          </a:bodyPr>
+          <a:lstStyle/>
+          <a:p>
+            <a:pPr algn="l"/>
+            <a:r>
+              <a:rPr sz="2800" b="1" i="0">
+                <a:solidFill>
+                  <a:srgbClr val="1F3A5F"/>
+                </a:solidFill>
+                <a:latin typeface="Arial"/>
+              </a:rPr>
+              <a:t>La capture est sûre par construction ; la vivacité est vérifiée ensuite par Avatar-ID</a:t>
+            </a:r>
+          </a:p>
+        </p:txBody>
+      </p:sp>
+      <p:sp>
+        <p:nvSpPr>
+          <p:cNvPr id="8" name="TextBox 7"/>
+          <p:cNvSpPr txBox="1"/>
+          <p:nvPr/>
+        </p:nvSpPr>
+        <p:spPr>
+          <a:xfrm>
+            <a:off x="548640" y="1828800"/>
+            <a:ext cx="5272887" cy="320040"/>
+          </a:xfrm>
+          <a:prstGeom prst="rect">
+            <a:avLst/>
+          </a:prstGeom>
+          <a:noFill/>
+        </p:spPr>
+        <p:txBody>
+          <a:bodyPr wrap="square" lIns="0" rIns="0" tIns="0" bIns="0" anchor="t">
+            <a:spAutoFit/>
+          </a:bodyPr>
+          <a:lstStyle/>
+          <a:p>
+            <a:pPr algn="l"/>
+            <a:r>
+              <a:rPr sz="1300" b="1" i="0">
+                <a:solidFill>
+                  <a:srgbClr val="2E75B6"/>
+                </a:solidFill>
+                <a:latin typeface="Arial"/>
+              </a:rPr>
+              <a:t>GARANTI PAR CONSTRUCTION</a:t>
+            </a:r>
+          </a:p>
+        </p:txBody>
+      </p:sp>
+      <p:sp>
+        <p:nvSpPr>
+          <p:cNvPr id="9" name="TextBox 8"/>
+          <p:cNvSpPr txBox="1"/>
+          <p:nvPr/>
+        </p:nvSpPr>
+        <p:spPr>
+          <a:xfrm>
+            <a:off x="548640" y="2286000"/>
+            <a:ext cx="5272887" cy="3108960"/>
+          </a:xfrm>
+          <a:prstGeom prst="rect">
+            <a:avLst/>
+          </a:prstGeom>
+          <a:noFill/>
+        </p:spPr>
+        <p:txBody>
+          <a:bodyPr wrap="square" lIns="0" rIns="0" tIns="0" bIns="0" anchor="t">
+            <a:spAutoFit/>
+          </a:bodyPr>
+          <a:lstStyle/>
+          <a:p>
+            <a:pPr algn="l">
+              <a:spcAft>
+                <a:spcPts val="1200"/>
+              </a:spcAft>
+            </a:pPr>
+            <a:r>
+              <a:rPr sz="1800" b="0" i="0">
+                <a:solidFill>
+                  <a:srgbClr val="1B2530"/>
+                </a:solidFill>
+                <a:latin typeface="Arial"/>
+              </a:rPr>
+              <a:t>Capture en direct, depuis le flux caméra</a:t>
+            </a:r>
+          </a:p>
+          <a:p>
+            <a:pPr algn="l">
+              <a:spcAft>
+                <a:spcPts val="1200"/>
+              </a:spcAft>
+            </a:pPr>
+            <a:r>
+              <a:rPr sz="1800" b="0" i="0">
+                <a:solidFill>
+                  <a:srgbClr val="1B2530"/>
+                </a:solidFill>
+                <a:latin typeface="Arial"/>
+              </a:rPr>
+              <a:t>Deux faces distinctes, dans l'ordre recto → verso</a:t>
+            </a:r>
+          </a:p>
+          <a:p>
+            <a:pPr algn="l">
+              <a:spcAft>
+                <a:spcPts val="1200"/>
+              </a:spcAft>
+            </a:pPr>
+            <a:r>
+              <a:rPr sz="1800" b="0" i="0">
+                <a:solidFill>
+                  <a:srgbClr val="1B2530"/>
+                </a:solidFill>
+                <a:latin typeface="Arial"/>
+              </a:rPr>
+              <a:t>Qualité contrôlée : netteté, luminosité, stabilité</a:t>
+            </a:r>
+          </a:p>
+          <a:p>
+            <a:pPr algn="l">
+              <a:spcAft>
+                <a:spcPts val="1200"/>
+              </a:spcAft>
+            </a:pPr>
+            <a:r>
+              <a:rPr sz="1800" b="0" i="0">
+                <a:solidFill>
+                  <a:srgbClr val="1B2530"/>
+                </a:solidFill>
+                <a:latin typeface="Arial"/>
+              </a:rPr>
+              <a:t>Traitement sur l'appareil, sans service tiers</a:t>
+            </a:r>
+          </a:p>
+        </p:txBody>
+      </p:sp>
+      <p:cxnSp>
+        <p:nvCxnSpPr>
+          <p:cNvPr id="10" name="Connector 9"/>
+          <p:cNvCxnSpPr/>
+          <p:nvPr/>
+        </p:nvCxnSpPr>
+        <p:spPr>
+          <a:xfrm>
+            <a:off x="6095847" y="1828800"/>
+            <a:ext cx="0" cy="3291840"/>
+          </a:xfrm>
+          <a:prstGeom prst="line">
+            <a:avLst/>
+          </a:prstGeom>
+          <a:ln w="9525">
+            <a:solidFill>
+              <a:srgbClr val="CBD3DB"/>
+            </a:solidFill>
+          </a:ln>
+        </p:spPr>
+      </p:cxnSp>
+      <p:sp>
+        <p:nvSpPr>
+          <p:cNvPr id="11" name="TextBox 10"/>
+          <p:cNvSpPr txBox="1"/>
+          <p:nvPr/>
+        </p:nvSpPr>
+        <p:spPr>
+          <a:xfrm>
+            <a:off x="6370167" y="1828800"/>
+            <a:ext cx="5272887" cy="320040"/>
+          </a:xfrm>
+          <a:prstGeom prst="rect">
+            <a:avLst/>
+          </a:prstGeom>
+          <a:noFill/>
+        </p:spPr>
+        <p:txBody>
+          <a:bodyPr wrap="square" lIns="0" rIns="0" tIns="0" bIns="0" anchor="t">
+            <a:spAutoFit/>
+          </a:bodyPr>
+          <a:lstStyle/>
+          <a:p>
+            <a:pPr algn="l"/>
+            <a:r>
+              <a:rPr sz="1300" b="1" i="0">
+                <a:solidFill>
+                  <a:srgbClr val="1F3A5F"/>
+                </a:solidFill>
+                <a:latin typeface="Arial"/>
+              </a:rPr>
+              <a:t>EN AVAL ET PROCHAINES ÉTAPES</a:t>
+            </a:r>
+          </a:p>
+        </p:txBody>
+      </p:sp>
+      <p:sp>
+        <p:nvSpPr>
+          <p:cNvPr id="12" name="TextBox 11"/>
+          <p:cNvSpPr txBox="1"/>
+          <p:nvPr/>
+        </p:nvSpPr>
+        <p:spPr>
+          <a:xfrm>
+            <a:off x="6370167" y="2286000"/>
+            <a:ext cx="5272887" cy="3108960"/>
+          </a:xfrm>
+          <a:prstGeom prst="rect">
+            <a:avLst/>
+          </a:prstGeom>
+          <a:noFill/>
+        </p:spPr>
+        <p:txBody>
+          <a:bodyPr wrap="square" lIns="0" rIns="0" tIns="0" bIns="0" anchor="t">
+            <a:spAutoFit/>
+          </a:bodyPr>
+          <a:lstStyle/>
+          <a:p>
+            <a:pPr algn="l">
+              <a:spcAft>
+                <a:spcPts val="1200"/>
+              </a:spcAft>
+            </a:pPr>
+            <a:r>
+              <a:rPr sz="1800" b="0" i="0">
+                <a:solidFill>
+                  <a:srgbClr val="1B2530"/>
+                </a:solidFill>
+                <a:latin typeface="Arial"/>
+              </a:rPr>
+              <a:t>Vivacité et comparaison des photos : Avatar-ID</a:t>
+            </a:r>
+          </a:p>
+          <a:p>
+            <a:pPr algn="l">
+              <a:spcAft>
+                <a:spcPts val="1200"/>
+              </a:spcAft>
+            </a:pPr>
+            <a:r>
+              <a:rPr sz="1800" b="0" i="0">
+                <a:solidFill>
+                  <a:srgbClr val="1B2530"/>
+                </a:solidFill>
+                <a:latin typeface="Arial"/>
+              </a:rPr>
+              <a:t>Analyse de texture contre les cartes sur écran</a:t>
+            </a:r>
+          </a:p>
+          <a:p>
+            <a:pPr algn="l">
+              <a:spcAft>
+                <a:spcPts val="1200"/>
+              </a:spcAft>
+            </a:pPr>
+            <a:r>
+              <a:rPr sz="1800" b="0" i="0">
+                <a:solidFill>
+                  <a:srgbClr val="1B2530"/>
+                </a:solidFill>
+                <a:latin typeface="Arial"/>
+              </a:rPr>
+              <a:t>Informer l'utilisateur lors de l'export en galerie</a:t>
+            </a:r>
+          </a:p>
+          <a:p>
+            <a:pPr algn="l">
+              <a:spcAft>
+                <a:spcPts val="1200"/>
+              </a:spcAft>
+            </a:pPr>
+            <a:r>
+              <a:rPr sz="1800" b="0" i="0">
+                <a:solidFill>
+                  <a:srgbClr val="1B2530"/>
+                </a:solidFill>
+                <a:latin typeface="Arial"/>
+              </a:rPr>
+              <a:t>Chiffrement des captures stockées</a:t>
+            </a:r>
+          </a:p>
+        </p:txBody>
+      </p:sp>
+      <p:sp>
+        <p:nvSpPr>
+          <p:cNvPr id="13" name="Rectangle 12"/>
+          <p:cNvSpPr/>
+          <p:nvPr/>
+        </p:nvSpPr>
+        <p:spPr>
+          <a:xfrm>
+            <a:off x="548640" y="5349240"/>
+            <a:ext cx="11094415" cy="566928"/>
+          </a:xfrm>
+          <a:prstGeom prst="rect">
+            <a:avLst/>
+          </a:prstGeom>
+          <a:solidFill>
+            <a:srgbClr val="EEF2F6"/>
+          </a:solidFill>
+          <a:ln>
+            <a:noFill/>
+          </a:ln>
+        </p:spPr>
+        <p:txBody>
+          <a:bodyPr rtlCol="0" anchor="ctr"/>
+          <a:lstStyle/>
+          <a:p/>
+        </p:txBody>
+      </p:sp>
+      <p:sp>
+        <p:nvSpPr>
+          <p:cNvPr id="14" name="TextBox 13"/>
+          <p:cNvSpPr txBox="1"/>
+          <p:nvPr/>
+        </p:nvSpPr>
+        <p:spPr>
+          <a:xfrm>
+            <a:off x="777240" y="5349240"/>
+            <a:ext cx="10637215" cy="566928"/>
+          </a:xfrm>
+          <a:prstGeom prst="rect">
+            <a:avLst/>
+          </a:prstGeom>
+          <a:noFill/>
+        </p:spPr>
+        <p:txBody>
+          <a:bodyPr wrap="square" lIns="0" rIns="0" tIns="0" bIns="0" anchor="ctr">
+            <a:spAutoFit/>
+          </a:bodyPr>
+          <a:lstStyle/>
+          <a:p>
+            <a:pPr algn="l"/>
+            <a:r>
+              <a:rPr sz="1600" b="1" i="0">
+                <a:solidFill>
+                  <a:srgbClr val="1F3A5F"/>
+                </a:solidFill>
+                <a:latin typeface="Arial"/>
+              </a:rPr>
+              <a:t>Données de test : </a:t>
+            </a:r>
+            <a:r>
+              <a:rPr sz="1600" b="0" i="0">
+                <a:solidFill>
+                  <a:srgbClr val="1B2530"/>
+                </a:solidFill>
+                <a:latin typeface="Arial"/>
+              </a:rPr>
+              <a:t>les captures montrées dans cette soutenance sont masquées dans les pixels (photo, nom, numéros, code-barres).</a:t>
+            </a:r>
+          </a:p>
+        </p:txBody>
+      </p:sp>
+    </p:spTree>
+  </p:cSld>
+  <p:clrMapOvr>
+    <a:masterClrMapping/>
+  </p:clrMapOvr>
+  <p:transition spd="med">
+    <p:fade/>
+  </p:transition>
+</p:sld>
+</file>
+
+<file path=ppt/slides/slide21.xml><?xml version="1.0" encoding="utf-8"?>
+<p:sld xmlns:a="http://schemas.openxmlformats.org/drawingml/2006/main" xmlns:p="http://schemas.openxmlformats.org/presentationml/2006/main" xmlns:r="http://schemas.openxmlformats.org/officeDocument/2006/relationships">
+  <p:cSld>
+    <p:spTree>
+      <p:nvGrpSpPr>
+        <p:cNvPr id="1" name=""/>
+        <p:cNvGrpSpPr/>
+        <p:nvPr/>
+      </p:nvGrpSpPr>
+      <p:grpSpPr/>
+      <p:sp>
+        <p:nvSpPr>
+          <p:cNvPr id="2" name="Rectangle 1"/>
+          <p:cNvSpPr/>
+          <p:nvPr/>
+        </p:nvSpPr>
+        <p:spPr>
+          <a:xfrm>
+            <a:off x="10317175" y="384048"/>
+            <a:ext cx="1325880" cy="310896"/>
+          </a:xfrm>
+          <a:prstGeom prst="rect">
+            <a:avLst/>
+          </a:prstGeom>
+          <a:solidFill>
+            <a:srgbClr val="EEF2F6"/>
+          </a:solidFill>
+          <a:ln>
+            <a:noFill/>
+          </a:ln>
+        </p:spPr>
+        <p:txBody>
+          <a:bodyPr rtlCol="0" anchor="ctr"/>
+          <a:lstStyle/>
+          <a:p/>
+        </p:txBody>
+      </p:sp>
+      <p:sp>
+        <p:nvSpPr>
+          <p:cNvPr id="3" name="TextBox 2"/>
+          <p:cNvSpPr txBox="1"/>
+          <p:nvPr/>
+        </p:nvSpPr>
+        <p:spPr>
+          <a:xfrm>
+            <a:off x="10317175" y="384048"/>
+            <a:ext cx="1325880" cy="310896"/>
+          </a:xfrm>
+          <a:prstGeom prst="rect">
+            <a:avLst/>
+          </a:prstGeom>
+          <a:noFill/>
+        </p:spPr>
+        <p:txBody>
+          <a:bodyPr wrap="square" lIns="0" rIns="0" tIns="0" bIns="0" anchor="ctr">
+            <a:spAutoFit/>
+          </a:bodyPr>
+          <a:lstStyle/>
+          <a:p>
+            <a:pPr algn="ctr"/>
+            <a:r>
+              <a:rPr sz="1200" b="1" i="0">
+                <a:solidFill>
+                  <a:srgbClr val="5B6B7A"/>
+                </a:solidFill>
+                <a:latin typeface="Arial"/>
+              </a:rPr>
               <a:t>Secours D</a:t>
             </a:r>
           </a:p>
@@ -20982,7 +21735,7 @@
                 </a:solidFill>
                 <a:latin typeface="Arial"/>
               </a:rPr>
-              <a:t>3 / 16</a:t>
+              <a:t>3 / 17</a:t>
             </a:r>
           </a:p>
         </p:txBody>
@@ -22460,7 +23213,7 @@
                 </a:solidFill>
                 <a:latin typeface="Arial"/>
               </a:rPr>
-              <a:t>4 / 16</a:t>
+              <a:t>4 / 17</a:t>
             </a:r>
           </a:p>
         </p:txBody>
@@ -24355,7 +25108,7 @@
                 </a:solidFill>
                 <a:latin typeface="Arial"/>
               </a:rPr>
-              <a:t>5 / 16</a:t>
+              <a:t>5 / 17</a:t>
             </a:r>
           </a:p>
         </p:txBody>
@@ -25720,7 +26473,7 @@
                 </a:solidFill>
                 <a:latin typeface="Arial"/>
               </a:rPr>
-              <a:t>6 / 16</a:t>
+              <a:t>6 / 17</a:t>
             </a:r>
           </a:p>
         </p:txBody>
@@ -28995,7 +29748,7 @@
                 </a:solidFill>
                 <a:latin typeface="Arial"/>
               </a:rPr>
-              <a:t>7 / 16</a:t>
+              <a:t>7 / 17</a:t>
             </a:r>
           </a:p>
         </p:txBody>
@@ -30866,7 +31619,7 @@
                 </a:solidFill>
                 <a:latin typeface="Arial"/>
               </a:rPr>
-              <a:t>8 / 16</a:t>
+              <a:t>8 / 17</a:t>
             </a:r>
           </a:p>
         </p:txBody>
@@ -31962,7 +32715,7 @@
                 </a:solidFill>
                 <a:latin typeface="Arial"/>
               </a:rPr>
-              <a:t>9 / 16</a:t>
+              <a:t>9 / 17</a:t>
             </a:r>
           </a:p>
         </p:txBody>

</xml_diff>

<commit_message>
Move demo slide after post-processing; update script and video guide
Co-Authored-By: Claude Opus 5.5 <noreply@anthropic.com>
Claude-Session: https://claude.ai/code/session_01AnZDiX8uz3hSw1L6vhKaQS
</commit_message>
<xml_diff>
--- a/Soutenance_Stage_ENSI_Final.pptx
+++ b/Soutenance_Stage_ENSI_Final.pptx
@@ -643,7 +643,7 @@
           <a:p/>
           <a:p>
             <a:r>
-              <a:t>TRANSITION — « Voyons-le en vrai. »</a:t>
+              <a:t>TRANSITION — « Après la capture, l'utilisateur garde la main. »</a:t>
             </a:r>
           </a:p>
           <a:p/>
@@ -724,13 +724,13 @@
           <a:lstStyle/>
           <a:p>
             <a:r>
-              <a:t>⏱ 0:45 (cumul 6:50)</a:t>
+              <a:t>⏱ 0:25 (cumul 6:30)</a:t>
             </a:r>
           </a:p>
           <a:p/>
           <a:p>
             <a:r>
-              <a:t>VIDÉO — 40 s environ. Lancer la vidéo dès l'arrivée sur la diapositive (clic sur la vidéo). Pour l'intégrer : déposer le fichier dans build/assets/demo.mp4 puis relancer le script, ou dans PowerPoint : Insertion → Vidéo → Cet appareil, à la place du cadre, puis Lecture → Démarrer « Automatiquement ».</a:t>
+              <a:t>ANIMATIONS — 3 clics : une capture d'écran par clic (vérification, recadrage, page A4).</a:t>
             </a:r>
           </a:p>
           <a:p/>
@@ -741,13 +741,29 @@
           </a:p>
           <a:p>
             <a:r>
-              <a:t>Voici le module en action. [lancer la vidéo] Le cadre est rouge tant que la carte n'est pas détectée, puis passe au vert. L'application guide l'utilisateur avec ses messages, et capture le recto toute seule dès que la netteté, la luminosité et la stabilité sont bonnes. Elle passe ensuite au verso, le reconnaît à ses trois indices, et le capture à son tour, sans aucun bouton.</a:t>
+              <a:t>Une fois les deux faces capturées, l'utilisateur [clic] vérifie et règle contraste et netteté, [clic] ajuste le recadrage si besoin, [clic] puis exporte le recto, le verso et une page A4 à 300 dpi. Tout est traité sur l'appareil.</a:t>
             </a:r>
           </a:p>
           <a:p/>
           <a:p>
             <a:r>
-              <a:t>TRANSITION — « Après la capture, l'utilisateur garde la main. »</a:t>
+              <a:t>TRANSITION — « Voyons tout le parcours en vidéo. »</a:t>
+            </a:r>
+          </a:p>
+          <a:p/>
+          <a:p>
+            <a:r>
+              <a:t>QUESTIONS PROBABLES</a:t>
+            </a:r>
+          </a:p>
+          <a:p>
+            <a:r>
+              <a:t>– « Où vont les images exportées ? » → dans la galerie de l'appareil ; à partir de là, elles suivent la vie normale des photos (sauvegarde cloud, partage) : l'utilisateur doit en être informé (rapport §7.2.4).</a:t>
+            </a:r>
+          </a:p>
+          <a:p>
+            <a:r>
+              <a:t>– « Qu'est-ce qu'Avatar-ID reçoit ? » → deux images (Uint8List) et, le cas échéant, la page d'impression : le module est une brique autonome (rapport §8.2.5).</a:t>
             </a:r>
           </a:p>
         </p:txBody>
@@ -817,13 +833,13 @@
           <a:lstStyle/>
           <a:p>
             <a:r>
-              <a:t>⏱ 0:25 (cumul 7:15)</a:t>
+              <a:t>⏱ 0:45 (cumul 7:15)</a:t>
             </a:r>
           </a:p>
           <a:p/>
           <a:p>
             <a:r>
-              <a:t>ANIMATIONS — 3 clics : une capture d'écran par clic (vérification, recadrage, page A4).</a:t>
+              <a:t>VIDÉO — 40 s environ. Lancer la vidéo dès l'arrivée sur la diapositive (clic sur la vidéo). Pour l'intégrer : déposer le fichier dans build/assets/demo.mp4 puis relancer le script, ou dans PowerPoint : Insertion → Vidéo → Cet appareil, à la place du cadre, puis Lecture → Démarrer « Automatiquement ».</a:t>
             </a:r>
           </a:p>
           <a:p/>
@@ -834,29 +850,13 @@
           </a:p>
           <a:p>
             <a:r>
-              <a:t>Une fois les deux faces capturées, l'utilisateur [clic] vérifie et règle contraste et netteté, [clic] ajuste le recadrage si besoin, [clic] puis exporte le recto, le verso et une page A4 à 300 dpi. Tout est traité sur l'appareil.</a:t>
+              <a:t>Voici le module en action. [lancer la vidéo] Le cadre est rouge tant que la carte n'est pas détectée, puis passe au vert ; les messages guident l'utilisateur. Le recto est capturé tout seul dès que la netteté, la luminosité et la stabilité sont bonnes, puis l'application passe au verso et le capture à son tour. On arrive ensuite sur la vérification, l'ajustement et l'export de la page A4.</a:t>
             </a:r>
           </a:p>
           <a:p/>
           <a:p>
             <a:r>
               <a:t>TRANSITION — « Comment l'ai-je validé ? »</a:t>
-            </a:r>
-          </a:p>
-          <a:p/>
-          <a:p>
-            <a:r>
-              <a:t>QUESTIONS PROBABLES</a:t>
-            </a:r>
-          </a:p>
-          <a:p>
-            <a:r>
-              <a:t>– « Où vont les images exportées ? » → dans la galerie de l'appareil ; à partir de là, elles suivent la vie normale des photos (sauvegarde cloud, partage) : l'utilisateur doit en être informé (rapport §7.2.4).</a:t>
-            </a:r>
-          </a:p>
-          <a:p>
-            <a:r>
-              <a:t>– « Qu'est-ce qu'Avatar-ID reçoit ? » → deux images (Uint8List) et, le cas échéant, la page d'impression : le module est une brique autonome (rapport §8.2.5).</a:t>
             </a:r>
           </a:p>
         </p:txBody>
@@ -7495,665 +7495,6 @@
                 </a:solidFill>
                 <a:latin typeface="Arial"/>
               </a:rPr>
-              <a:t>Démonstration : la carte est détectée, contrôlée et capturée sans bouton</a:t>
-            </a:r>
-          </a:p>
-        </p:txBody>
-      </p:sp>
-      <p:sp>
-        <p:nvSpPr>
-          <p:cNvPr id="7" name="Rounded Rectangle 6"/>
-          <p:cNvSpPr/>
-          <p:nvPr/>
-        </p:nvSpPr>
-        <p:spPr>
-          <a:xfrm>
-            <a:off x="822959" y="1783080"/>
-            <a:ext cx="2420909" cy="4160520"/>
-          </a:xfrm>
-          <a:prstGeom prst="roundRect">
-            <a:avLst>
-              <a:gd name="adj" fmla="val 8000"/>
-            </a:avLst>
-          </a:prstGeom>
-          <a:solidFill>
-            <a:srgbClr val="EEF2F6"/>
-          </a:solidFill>
-          <a:ln w="25400">
-            <a:solidFill>
-              <a:srgbClr val="1F3A5F"/>
-            </a:solidFill>
-          </a:ln>
-        </p:spPr>
-        <p:txBody>
-          <a:bodyPr rtlCol="0" anchor="ctr"/>
-          <a:lstStyle/>
-          <a:p/>
-        </p:txBody>
-      </p:sp>
-      <p:pic>
-        <p:nvPicPr>
-          <p:cNvPr id="8" name="Picture 7" descr="Aperçu : écran recto (à remplacer par la vidéo de démonstration)"/>
-          <p:cNvPicPr>
-            <a:picLocks noChangeAspect="1"/>
-          </p:cNvPicPr>
-          <p:nvPr/>
-        </p:nvPicPr>
-        <p:blipFill>
-          <a:blip r:embed="rId2"/>
-          <a:stretch>
-            <a:fillRect/>
-          </a:stretch>
-        </p:blipFill>
-        <p:spPr>
-          <a:xfrm>
-            <a:off x="932688" y="1892807"/>
-            <a:ext cx="2201453" cy="3941063"/>
-          </a:xfrm>
-          <a:prstGeom prst="rect">
-            <a:avLst/>
-          </a:prstGeom>
-          <a:ln w="9525">
-            <a:solidFill>
-              <a:srgbClr val="CBD3DB"/>
-            </a:solidFill>
-          </a:ln>
-        </p:spPr>
-      </p:pic>
-      <p:sp>
-        <p:nvSpPr>
-          <p:cNvPr id="9" name="TextBox 8"/>
-          <p:cNvSpPr txBox="1"/>
-          <p:nvPr/>
-        </p:nvSpPr>
-        <p:spPr>
-          <a:xfrm>
-            <a:off x="822959" y="6016752"/>
-            <a:ext cx="3792509" cy="274320"/>
-          </a:xfrm>
-          <a:prstGeom prst="rect">
-            <a:avLst/>
-          </a:prstGeom>
-          <a:noFill/>
-        </p:spPr>
-        <p:txBody>
-          <a:bodyPr wrap="square" lIns="0" rIns="0" tIns="0" bIns="0" anchor="t">
-            <a:spAutoFit/>
-          </a:bodyPr>
-          <a:lstStyle/>
-          <a:p>
-            <a:pPr algn="l"/>
-            <a:r>
-              <a:rPr sz="1200" b="1" i="0">
-                <a:solidFill>
-                  <a:srgbClr val="B84A12"/>
-                </a:solidFill>
-                <a:latin typeface="Arial"/>
-              </a:rPr>
-              <a:t>Vidéo à insérer ici (Insertion → Vidéo)</a:t>
-            </a:r>
-          </a:p>
-        </p:txBody>
-      </p:sp>
-      <p:sp>
-        <p:nvSpPr>
-          <p:cNvPr id="10" name="TextBox 9"/>
-          <p:cNvSpPr txBox="1"/>
-          <p:nvPr/>
-        </p:nvSpPr>
-        <p:spPr>
-          <a:xfrm>
-            <a:off x="4480560" y="1965960"/>
-            <a:ext cx="457200" cy="548640"/>
-          </a:xfrm>
-          <a:prstGeom prst="rect">
-            <a:avLst/>
-          </a:prstGeom>
-          <a:noFill/>
-        </p:spPr>
-        <p:txBody>
-          <a:bodyPr wrap="square" lIns="0" rIns="0" tIns="0" bIns="0" anchor="t">
-            <a:spAutoFit/>
-          </a:bodyPr>
-          <a:lstStyle/>
-          <a:p>
-            <a:pPr algn="l"/>
-            <a:r>
-              <a:rPr sz="2600" b="1" i="0">
-                <a:solidFill>
-                  <a:srgbClr val="2E75B6"/>
-                </a:solidFill>
-                <a:latin typeface="Arial"/>
-              </a:rPr>
-              <a:t>1</a:t>
-            </a:r>
-          </a:p>
-        </p:txBody>
-      </p:sp>
-      <p:sp>
-        <p:nvSpPr>
-          <p:cNvPr id="11" name="TextBox 10"/>
-          <p:cNvSpPr txBox="1"/>
-          <p:nvPr/>
-        </p:nvSpPr>
-        <p:spPr>
-          <a:xfrm>
-            <a:off x="4983480" y="1984248"/>
-            <a:ext cx="6583680" cy="822960"/>
-          </a:xfrm>
-          <a:prstGeom prst="rect">
-            <a:avLst/>
-          </a:prstGeom>
-          <a:noFill/>
-        </p:spPr>
-        <p:txBody>
-          <a:bodyPr wrap="square" lIns="0" rIns="0" tIns="0" bIns="0" anchor="t">
-            <a:spAutoFit/>
-          </a:bodyPr>
-          <a:lstStyle/>
-          <a:p>
-            <a:pPr algn="l"/>
-            <a:r>
-              <a:rPr sz="1800" b="1" i="0">
-                <a:solidFill>
-                  <a:srgbClr val="1F3A5F"/>
-                </a:solidFill>
-                <a:latin typeface="Arial"/>
-              </a:rPr>
-              <a:t>Cadre rouge, puis vert</a:t>
-            </a:r>
-          </a:p>
-          <a:p>
-            <a:pPr algn="l"/>
-            <a:r>
-              <a:rPr sz="1800" b="0" i="0">
-                <a:solidFill>
-                  <a:srgbClr val="1B2530"/>
-                </a:solidFill>
-                <a:latin typeface="Arial"/>
-              </a:rPr>
-              <a:t>la carte est détectée et suivie</a:t>
-            </a:r>
-          </a:p>
-        </p:txBody>
-      </p:sp>
-      <p:sp>
-        <p:nvSpPr>
-          <p:cNvPr id="12" name="TextBox 11"/>
-          <p:cNvSpPr txBox="1"/>
-          <p:nvPr/>
-        </p:nvSpPr>
-        <p:spPr>
-          <a:xfrm>
-            <a:off x="4480560" y="2953512"/>
-            <a:ext cx="457200" cy="548640"/>
-          </a:xfrm>
-          <a:prstGeom prst="rect">
-            <a:avLst/>
-          </a:prstGeom>
-          <a:noFill/>
-        </p:spPr>
-        <p:txBody>
-          <a:bodyPr wrap="square" lIns="0" rIns="0" tIns="0" bIns="0" anchor="t">
-            <a:spAutoFit/>
-          </a:bodyPr>
-          <a:lstStyle/>
-          <a:p>
-            <a:pPr algn="l"/>
-            <a:r>
-              <a:rPr sz="2600" b="1" i="0">
-                <a:solidFill>
-                  <a:srgbClr val="2E75B6"/>
-                </a:solidFill>
-                <a:latin typeface="Arial"/>
-              </a:rPr>
-              <a:t>2</a:t>
-            </a:r>
-          </a:p>
-        </p:txBody>
-      </p:sp>
-      <p:sp>
-        <p:nvSpPr>
-          <p:cNvPr id="13" name="TextBox 12"/>
-          <p:cNvSpPr txBox="1"/>
-          <p:nvPr/>
-        </p:nvSpPr>
-        <p:spPr>
-          <a:xfrm>
-            <a:off x="4983480" y="2971800"/>
-            <a:ext cx="6583680" cy="822960"/>
-          </a:xfrm>
-          <a:prstGeom prst="rect">
-            <a:avLst/>
-          </a:prstGeom>
-          <a:noFill/>
-        </p:spPr>
-        <p:txBody>
-          <a:bodyPr wrap="square" lIns="0" rIns="0" tIns="0" bIns="0" anchor="t">
-            <a:spAutoFit/>
-          </a:bodyPr>
-          <a:lstStyle/>
-          <a:p>
-            <a:pPr algn="l"/>
-            <a:r>
-              <a:rPr sz="1800" b="1" i="0">
-                <a:solidFill>
-                  <a:srgbClr val="1F3A5F"/>
-                </a:solidFill>
-                <a:latin typeface="Arial"/>
-              </a:rPr>
-              <a:t>Messages de qualité</a:t>
-            </a:r>
-          </a:p>
-          <a:p>
-            <a:pPr algn="l"/>
-            <a:r>
-              <a:rPr sz="1800" b="0" i="0">
-                <a:solidFill>
-                  <a:srgbClr val="1B2530"/>
-                </a:solidFill>
-                <a:latin typeface="Arial"/>
-              </a:rPr>
-              <a:t>« Ne bougez plus… » jusqu'à ce que tout soit bon</a:t>
-            </a:r>
-          </a:p>
-        </p:txBody>
-      </p:sp>
-      <p:sp>
-        <p:nvSpPr>
-          <p:cNvPr id="14" name="TextBox 13"/>
-          <p:cNvSpPr txBox="1"/>
-          <p:nvPr/>
-        </p:nvSpPr>
-        <p:spPr>
-          <a:xfrm>
-            <a:off x="4480560" y="3941064"/>
-            <a:ext cx="457200" cy="548640"/>
-          </a:xfrm>
-          <a:prstGeom prst="rect">
-            <a:avLst/>
-          </a:prstGeom>
-          <a:noFill/>
-        </p:spPr>
-        <p:txBody>
-          <a:bodyPr wrap="square" lIns="0" rIns="0" tIns="0" bIns="0" anchor="t">
-            <a:spAutoFit/>
-          </a:bodyPr>
-          <a:lstStyle/>
-          <a:p>
-            <a:pPr algn="l"/>
-            <a:r>
-              <a:rPr sz="2600" b="1" i="0">
-                <a:solidFill>
-                  <a:srgbClr val="2E75B6"/>
-                </a:solidFill>
-                <a:latin typeface="Arial"/>
-              </a:rPr>
-              <a:t>3</a:t>
-            </a:r>
-          </a:p>
-        </p:txBody>
-      </p:sp>
-      <p:sp>
-        <p:nvSpPr>
-          <p:cNvPr id="15" name="TextBox 14"/>
-          <p:cNvSpPr txBox="1"/>
-          <p:nvPr/>
-        </p:nvSpPr>
-        <p:spPr>
-          <a:xfrm>
-            <a:off x="4983480" y="3959352"/>
-            <a:ext cx="6583680" cy="822960"/>
-          </a:xfrm>
-          <a:prstGeom prst="rect">
-            <a:avLst/>
-          </a:prstGeom>
-          <a:noFill/>
-        </p:spPr>
-        <p:txBody>
-          <a:bodyPr wrap="square" lIns="0" rIns="0" tIns="0" bIns="0" anchor="t">
-            <a:spAutoFit/>
-          </a:bodyPr>
-          <a:lstStyle/>
-          <a:p>
-            <a:pPr algn="l"/>
-            <a:r>
-              <a:rPr sz="1800" b="1" i="0">
-                <a:solidFill>
-                  <a:srgbClr val="1F3A5F"/>
-                </a:solidFill>
-                <a:latin typeface="Arial"/>
-              </a:rPr>
-              <a:t>Capture du recto, seule</a:t>
-            </a:r>
-          </a:p>
-          <a:p>
-            <a:pPr algn="l"/>
-            <a:r>
-              <a:rPr sz="1800" b="0" i="0">
-                <a:solidFill>
-                  <a:srgbClr val="1B2530"/>
-                </a:solidFill>
-                <a:latin typeface="Arial"/>
-              </a:rPr>
-              <a:t>puis passage automatique au verso</a:t>
-            </a:r>
-          </a:p>
-        </p:txBody>
-      </p:sp>
-      <p:sp>
-        <p:nvSpPr>
-          <p:cNvPr id="16" name="TextBox 15"/>
-          <p:cNvSpPr txBox="1"/>
-          <p:nvPr/>
-        </p:nvSpPr>
-        <p:spPr>
-          <a:xfrm>
-            <a:off x="4480560" y="4928616"/>
-            <a:ext cx="457200" cy="548640"/>
-          </a:xfrm>
-          <a:prstGeom prst="rect">
-            <a:avLst/>
-          </a:prstGeom>
-          <a:noFill/>
-        </p:spPr>
-        <p:txBody>
-          <a:bodyPr wrap="square" lIns="0" rIns="0" tIns="0" bIns="0" anchor="t">
-            <a:spAutoFit/>
-          </a:bodyPr>
-          <a:lstStyle/>
-          <a:p>
-            <a:pPr algn="l"/>
-            <a:r>
-              <a:rPr sz="2600" b="1" i="0">
-                <a:solidFill>
-                  <a:srgbClr val="2E75B6"/>
-                </a:solidFill>
-                <a:latin typeface="Arial"/>
-              </a:rPr>
-              <a:t>4</a:t>
-            </a:r>
-          </a:p>
-        </p:txBody>
-      </p:sp>
-      <p:sp>
-        <p:nvSpPr>
-          <p:cNvPr id="17" name="TextBox 16"/>
-          <p:cNvSpPr txBox="1"/>
-          <p:nvPr/>
-        </p:nvSpPr>
-        <p:spPr>
-          <a:xfrm>
-            <a:off x="4983480" y="4946904"/>
-            <a:ext cx="6583680" cy="822960"/>
-          </a:xfrm>
-          <a:prstGeom prst="rect">
-            <a:avLst/>
-          </a:prstGeom>
-          <a:noFill/>
-        </p:spPr>
-        <p:txBody>
-          <a:bodyPr wrap="square" lIns="0" rIns="0" tIns="0" bIns="0" anchor="t">
-            <a:spAutoFit/>
-          </a:bodyPr>
-          <a:lstStyle/>
-          <a:p>
-            <a:pPr algn="l"/>
-            <a:r>
-              <a:rPr sz="1800" b="1" i="0">
-                <a:solidFill>
-                  <a:srgbClr val="1F3A5F"/>
-                </a:solidFill>
-                <a:latin typeface="Arial"/>
-              </a:rPr>
-              <a:t>Capture du verso</a:t>
-            </a:r>
-          </a:p>
-          <a:p>
-            <a:pPr algn="l"/>
-            <a:r>
-              <a:rPr sz="1800" b="0" i="0">
-                <a:solidFill>
-                  <a:srgbClr val="1B2530"/>
-                </a:solidFill>
-                <a:latin typeface="Arial"/>
-              </a:rPr>
-              <a:t>puis écran de vérification</a:t>
-            </a:r>
-          </a:p>
-        </p:txBody>
-      </p:sp>
-    </p:spTree>
-  </p:cSld>
-  <p:clrMapOvr>
-    <a:masterClrMapping/>
-  </p:clrMapOvr>
-  <p:transition spd="med">
-    <p:fade/>
-  </p:transition>
-</p:sld>
-</file>
-
-<file path=ppt/slides/slide12.xml><?xml version="1.0" encoding="utf-8"?>
-<p:sld xmlns:a="http://schemas.openxmlformats.org/drawingml/2006/main" xmlns:p="http://schemas.openxmlformats.org/presentationml/2006/main" xmlns:r="http://schemas.openxmlformats.org/officeDocument/2006/relationships">
-  <p:cSld>
-    <p:spTree>
-      <p:nvGrpSpPr>
-        <p:cNvPr id="1" name=""/>
-        <p:cNvGrpSpPr/>
-        <p:nvPr/>
-      </p:nvGrpSpPr>
-      <p:grpSpPr/>
-      <p:sp>
-        <p:nvSpPr>
-          <p:cNvPr id="2" name="TextBox 1"/>
-          <p:cNvSpPr txBox="1"/>
-          <p:nvPr/>
-        </p:nvSpPr>
-        <p:spPr>
-          <a:xfrm>
-            <a:off x="5973775" y="429768"/>
-            <a:ext cx="5669280" cy="274320"/>
-          </a:xfrm>
-          <a:prstGeom prst="rect">
-            <a:avLst/>
-          </a:prstGeom>
-          <a:noFill/>
-        </p:spPr>
-        <p:txBody>
-          <a:bodyPr wrap="square" lIns="0" rIns="0" tIns="0" bIns="0" anchor="t">
-            <a:spAutoFit/>
-          </a:bodyPr>
-          <a:lstStyle/>
-          <a:p>
-            <a:pPr algn="r"/>
-            <a:r>
-              <a:rPr sz="1100" b="0" i="0">
-                <a:solidFill>
-                  <a:srgbClr val="5B6B7A"/>
-                </a:solidFill>
-                <a:latin typeface="Arial"/>
-              </a:rPr>
-              <a:t>CONTEXTE</a:t>
-            </a:r>
-            <a:r>
-              <a:rPr sz="1100" b="0" i="0">
-                <a:solidFill>
-                  <a:srgbClr val="CBD3DB"/>
-                </a:solidFill>
-                <a:latin typeface="Arial"/>
-              </a:rPr>
-              <a:t>   ·   </a:t>
-            </a:r>
-            <a:r>
-              <a:rPr sz="1100" b="0" i="0">
-                <a:solidFill>
-                  <a:srgbClr val="5B6B7A"/>
-                </a:solidFill>
-                <a:latin typeface="Arial"/>
-              </a:rPr>
-              <a:t>CONCEPTION</a:t>
-            </a:r>
-            <a:r>
-              <a:rPr sz="1100" b="0" i="0">
-                <a:solidFill>
-                  <a:srgbClr val="CBD3DB"/>
-                </a:solidFill>
-                <a:latin typeface="Arial"/>
-              </a:rPr>
-              <a:t>   ·   </a:t>
-            </a:r>
-            <a:r>
-              <a:rPr sz="1100" b="1" i="0">
-                <a:solidFill>
-                  <a:srgbClr val="2E75B6"/>
-                </a:solidFill>
-                <a:latin typeface="Arial"/>
-              </a:rPr>
-              <a:t>RÉSULTATS</a:t>
-            </a:r>
-            <a:r>
-              <a:rPr sz="1100" b="0" i="0">
-                <a:solidFill>
-                  <a:srgbClr val="CBD3DB"/>
-                </a:solidFill>
-                <a:latin typeface="Arial"/>
-              </a:rPr>
-              <a:t>   ·   </a:t>
-            </a:r>
-            <a:r>
-              <a:rPr sz="1100" b="0" i="0">
-                <a:solidFill>
-                  <a:srgbClr val="5B6B7A"/>
-                </a:solidFill>
-                <a:latin typeface="Arial"/>
-              </a:rPr>
-              <a:t>BILAN</a:t>
-            </a:r>
-          </a:p>
-        </p:txBody>
-      </p:sp>
-      <p:cxnSp>
-        <p:nvCxnSpPr>
-          <p:cNvPr id="3" name="Connector 2"/>
-          <p:cNvCxnSpPr/>
-          <p:nvPr/>
-        </p:nvCxnSpPr>
-        <p:spPr>
-          <a:xfrm>
-            <a:off x="548640" y="6382512"/>
-            <a:ext cx="11094415" cy="0"/>
-          </a:xfrm>
-          <a:prstGeom prst="line">
-            <a:avLst/>
-          </a:prstGeom>
-          <a:ln w="9525">
-            <a:solidFill>
-              <a:srgbClr val="CBD3DB"/>
-            </a:solidFill>
-          </a:ln>
-        </p:spPr>
-      </p:cxnSp>
-      <p:sp>
-        <p:nvSpPr>
-          <p:cNvPr id="4" name="TextBox 3"/>
-          <p:cNvSpPr txBox="1"/>
-          <p:nvPr/>
-        </p:nvSpPr>
-        <p:spPr>
-          <a:xfrm>
-            <a:off x="548640" y="6455664"/>
-            <a:ext cx="7315200" cy="228600"/>
-          </a:xfrm>
-          <a:prstGeom prst="rect">
-            <a:avLst/>
-          </a:prstGeom>
-          <a:noFill/>
-        </p:spPr>
-        <p:txBody>
-          <a:bodyPr wrap="square" lIns="0" rIns="0" tIns="0" bIns="0" anchor="t">
-            <a:spAutoFit/>
-          </a:bodyPr>
-          <a:lstStyle/>
-          <a:p>
-            <a:pPr algn="l"/>
-            <a:r>
-              <a:rPr sz="1100" b="0" i="0">
-                <a:solidFill>
-                  <a:srgbClr val="5B6B7A"/>
-                </a:solidFill>
-                <a:latin typeface="Arial"/>
-              </a:rPr>
-              <a:t>Avatar-ID · autocapture de la CIN · Mohammed Amine Chaieb · ENSI 2025/2026</a:t>
-            </a:r>
-          </a:p>
-        </p:txBody>
-      </p:sp>
-      <p:sp>
-        <p:nvSpPr>
-          <p:cNvPr id="5" name="TextBox 4"/>
-          <p:cNvSpPr txBox="1"/>
-          <p:nvPr/>
-        </p:nvSpPr>
-        <p:spPr>
-          <a:xfrm>
-            <a:off x="9814255" y="6455664"/>
-            <a:ext cx="1828800" cy="228600"/>
-          </a:xfrm>
-          <a:prstGeom prst="rect">
-            <a:avLst/>
-          </a:prstGeom>
-          <a:noFill/>
-        </p:spPr>
-        <p:txBody>
-          <a:bodyPr wrap="square" lIns="0" rIns="0" tIns="0" bIns="0" anchor="t">
-            <a:spAutoFit/>
-          </a:bodyPr>
-          <a:lstStyle/>
-          <a:p>
-            <a:pPr algn="r"/>
-            <a:r>
-              <a:rPr sz="1100" b="0" i="0">
-                <a:solidFill>
-                  <a:srgbClr val="5B6B7A"/>
-                </a:solidFill>
-                <a:latin typeface="Arial"/>
-              </a:rPr>
-              <a:t>12 / 17</a:t>
-            </a:r>
-          </a:p>
-        </p:txBody>
-      </p:sp>
-      <p:sp>
-        <p:nvSpPr>
-          <p:cNvPr id="6" name="Titre"/>
-          <p:cNvSpPr txBox="1"/>
-          <p:nvPr/>
-        </p:nvSpPr>
-        <p:spPr>
-          <a:xfrm>
-            <a:off x="548640" y="777240"/>
-            <a:ext cx="11094415" cy="1005840"/>
-          </a:xfrm>
-          <a:prstGeom prst="rect">
-            <a:avLst/>
-          </a:prstGeom>
-          <a:noFill/>
-        </p:spPr>
-        <p:txBody>
-          <a:bodyPr wrap="square" lIns="0" rIns="0" tIns="0" bIns="0" anchor="t">
-            <a:spAutoFit/>
-          </a:bodyPr>
-          <a:lstStyle/>
-          <a:p>
-            <a:pPr algn="l"/>
-            <a:r>
-              <a:rPr sz="2800" b="1" i="0">
-                <a:solidFill>
-                  <a:srgbClr val="1F3A5F"/>
-                </a:solidFill>
-                <a:latin typeface="Arial"/>
-              </a:rPr>
               <a:t>Après les deux captures, l'utilisateur vérifie, ajuste et exporte chaque face</a:t>
             </a:r>
           </a:p>
@@ -9068,6 +8409,665 @@
       <p:bldP spid="22" grpId="0"/>
     </p:bldLst>
   </p:timing>
+</p:sld>
+</file>
+
+<file path=ppt/slides/slide12.xml><?xml version="1.0" encoding="utf-8"?>
+<p:sld xmlns:a="http://schemas.openxmlformats.org/drawingml/2006/main" xmlns:p="http://schemas.openxmlformats.org/presentationml/2006/main" xmlns:r="http://schemas.openxmlformats.org/officeDocument/2006/relationships">
+  <p:cSld>
+    <p:spTree>
+      <p:nvGrpSpPr>
+        <p:cNvPr id="1" name=""/>
+        <p:cNvGrpSpPr/>
+        <p:nvPr/>
+      </p:nvGrpSpPr>
+      <p:grpSpPr/>
+      <p:sp>
+        <p:nvSpPr>
+          <p:cNvPr id="2" name="TextBox 1"/>
+          <p:cNvSpPr txBox="1"/>
+          <p:nvPr/>
+        </p:nvSpPr>
+        <p:spPr>
+          <a:xfrm>
+            <a:off x="5973775" y="429768"/>
+            <a:ext cx="5669280" cy="274320"/>
+          </a:xfrm>
+          <a:prstGeom prst="rect">
+            <a:avLst/>
+          </a:prstGeom>
+          <a:noFill/>
+        </p:spPr>
+        <p:txBody>
+          <a:bodyPr wrap="square" lIns="0" rIns="0" tIns="0" bIns="0" anchor="t">
+            <a:spAutoFit/>
+          </a:bodyPr>
+          <a:lstStyle/>
+          <a:p>
+            <a:pPr algn="r"/>
+            <a:r>
+              <a:rPr sz="1100" b="0" i="0">
+                <a:solidFill>
+                  <a:srgbClr val="5B6B7A"/>
+                </a:solidFill>
+                <a:latin typeface="Arial"/>
+              </a:rPr>
+              <a:t>CONTEXTE</a:t>
+            </a:r>
+            <a:r>
+              <a:rPr sz="1100" b="0" i="0">
+                <a:solidFill>
+                  <a:srgbClr val="CBD3DB"/>
+                </a:solidFill>
+                <a:latin typeface="Arial"/>
+              </a:rPr>
+              <a:t>   ·   </a:t>
+            </a:r>
+            <a:r>
+              <a:rPr sz="1100" b="0" i="0">
+                <a:solidFill>
+                  <a:srgbClr val="5B6B7A"/>
+                </a:solidFill>
+                <a:latin typeface="Arial"/>
+              </a:rPr>
+              <a:t>CONCEPTION</a:t>
+            </a:r>
+            <a:r>
+              <a:rPr sz="1100" b="0" i="0">
+                <a:solidFill>
+                  <a:srgbClr val="CBD3DB"/>
+                </a:solidFill>
+                <a:latin typeface="Arial"/>
+              </a:rPr>
+              <a:t>   ·   </a:t>
+            </a:r>
+            <a:r>
+              <a:rPr sz="1100" b="1" i="0">
+                <a:solidFill>
+                  <a:srgbClr val="2E75B6"/>
+                </a:solidFill>
+                <a:latin typeface="Arial"/>
+              </a:rPr>
+              <a:t>RÉSULTATS</a:t>
+            </a:r>
+            <a:r>
+              <a:rPr sz="1100" b="0" i="0">
+                <a:solidFill>
+                  <a:srgbClr val="CBD3DB"/>
+                </a:solidFill>
+                <a:latin typeface="Arial"/>
+              </a:rPr>
+              <a:t>   ·   </a:t>
+            </a:r>
+            <a:r>
+              <a:rPr sz="1100" b="0" i="0">
+                <a:solidFill>
+                  <a:srgbClr val="5B6B7A"/>
+                </a:solidFill>
+                <a:latin typeface="Arial"/>
+              </a:rPr>
+              <a:t>BILAN</a:t>
+            </a:r>
+          </a:p>
+        </p:txBody>
+      </p:sp>
+      <p:cxnSp>
+        <p:nvCxnSpPr>
+          <p:cNvPr id="3" name="Connector 2"/>
+          <p:cNvCxnSpPr/>
+          <p:nvPr/>
+        </p:nvCxnSpPr>
+        <p:spPr>
+          <a:xfrm>
+            <a:off x="548640" y="6382512"/>
+            <a:ext cx="11094415" cy="0"/>
+          </a:xfrm>
+          <a:prstGeom prst="line">
+            <a:avLst/>
+          </a:prstGeom>
+          <a:ln w="9525">
+            <a:solidFill>
+              <a:srgbClr val="CBD3DB"/>
+            </a:solidFill>
+          </a:ln>
+        </p:spPr>
+      </p:cxnSp>
+      <p:sp>
+        <p:nvSpPr>
+          <p:cNvPr id="4" name="TextBox 3"/>
+          <p:cNvSpPr txBox="1"/>
+          <p:nvPr/>
+        </p:nvSpPr>
+        <p:spPr>
+          <a:xfrm>
+            <a:off x="548640" y="6455664"/>
+            <a:ext cx="7315200" cy="228600"/>
+          </a:xfrm>
+          <a:prstGeom prst="rect">
+            <a:avLst/>
+          </a:prstGeom>
+          <a:noFill/>
+        </p:spPr>
+        <p:txBody>
+          <a:bodyPr wrap="square" lIns="0" rIns="0" tIns="0" bIns="0" anchor="t">
+            <a:spAutoFit/>
+          </a:bodyPr>
+          <a:lstStyle/>
+          <a:p>
+            <a:pPr algn="l"/>
+            <a:r>
+              <a:rPr sz="1100" b="0" i="0">
+                <a:solidFill>
+                  <a:srgbClr val="5B6B7A"/>
+                </a:solidFill>
+                <a:latin typeface="Arial"/>
+              </a:rPr>
+              <a:t>Avatar-ID · autocapture de la CIN · Mohammed Amine Chaieb · ENSI 2025/2026</a:t>
+            </a:r>
+          </a:p>
+        </p:txBody>
+      </p:sp>
+      <p:sp>
+        <p:nvSpPr>
+          <p:cNvPr id="5" name="TextBox 4"/>
+          <p:cNvSpPr txBox="1"/>
+          <p:nvPr/>
+        </p:nvSpPr>
+        <p:spPr>
+          <a:xfrm>
+            <a:off x="9814255" y="6455664"/>
+            <a:ext cx="1828800" cy="228600"/>
+          </a:xfrm>
+          <a:prstGeom prst="rect">
+            <a:avLst/>
+          </a:prstGeom>
+          <a:noFill/>
+        </p:spPr>
+        <p:txBody>
+          <a:bodyPr wrap="square" lIns="0" rIns="0" tIns="0" bIns="0" anchor="t">
+            <a:spAutoFit/>
+          </a:bodyPr>
+          <a:lstStyle/>
+          <a:p>
+            <a:pPr algn="r"/>
+            <a:r>
+              <a:rPr sz="1100" b="0" i="0">
+                <a:solidFill>
+                  <a:srgbClr val="5B6B7A"/>
+                </a:solidFill>
+                <a:latin typeface="Arial"/>
+              </a:rPr>
+              <a:t>12 / 17</a:t>
+            </a:r>
+          </a:p>
+        </p:txBody>
+      </p:sp>
+      <p:sp>
+        <p:nvSpPr>
+          <p:cNvPr id="6" name="Titre"/>
+          <p:cNvSpPr txBox="1"/>
+          <p:nvPr/>
+        </p:nvSpPr>
+        <p:spPr>
+          <a:xfrm>
+            <a:off x="548640" y="777240"/>
+            <a:ext cx="11094415" cy="1005840"/>
+          </a:xfrm>
+          <a:prstGeom prst="rect">
+            <a:avLst/>
+          </a:prstGeom>
+          <a:noFill/>
+        </p:spPr>
+        <p:txBody>
+          <a:bodyPr wrap="square" lIns="0" rIns="0" tIns="0" bIns="0" anchor="t">
+            <a:spAutoFit/>
+          </a:bodyPr>
+          <a:lstStyle/>
+          <a:p>
+            <a:pPr algn="l"/>
+            <a:r>
+              <a:rPr sz="2800" b="1" i="0">
+                <a:solidFill>
+                  <a:srgbClr val="1F3A5F"/>
+                </a:solidFill>
+                <a:latin typeface="Arial"/>
+              </a:rPr>
+              <a:t>Démonstration : de la carte posée devant la caméra à la page A4</a:t>
+            </a:r>
+          </a:p>
+        </p:txBody>
+      </p:sp>
+      <p:sp>
+        <p:nvSpPr>
+          <p:cNvPr id="7" name="Rounded Rectangle 6"/>
+          <p:cNvSpPr/>
+          <p:nvPr/>
+        </p:nvSpPr>
+        <p:spPr>
+          <a:xfrm>
+            <a:off x="822959" y="1783080"/>
+            <a:ext cx="2420909" cy="4160520"/>
+          </a:xfrm>
+          <a:prstGeom prst="roundRect">
+            <a:avLst>
+              <a:gd name="adj" fmla="val 8000"/>
+            </a:avLst>
+          </a:prstGeom>
+          <a:solidFill>
+            <a:srgbClr val="EEF2F6"/>
+          </a:solidFill>
+          <a:ln w="25400">
+            <a:solidFill>
+              <a:srgbClr val="1F3A5F"/>
+            </a:solidFill>
+          </a:ln>
+        </p:spPr>
+        <p:txBody>
+          <a:bodyPr rtlCol="0" anchor="ctr"/>
+          <a:lstStyle/>
+          <a:p/>
+        </p:txBody>
+      </p:sp>
+      <p:pic>
+        <p:nvPicPr>
+          <p:cNvPr id="8" name="Picture 7" descr="Aperçu : écran recto (à remplacer par la vidéo de démonstration)"/>
+          <p:cNvPicPr>
+            <a:picLocks noChangeAspect="1"/>
+          </p:cNvPicPr>
+          <p:nvPr/>
+        </p:nvPicPr>
+        <p:blipFill>
+          <a:blip r:embed="rId2"/>
+          <a:stretch>
+            <a:fillRect/>
+          </a:stretch>
+        </p:blipFill>
+        <p:spPr>
+          <a:xfrm>
+            <a:off x="932688" y="1892807"/>
+            <a:ext cx="2201453" cy="3941063"/>
+          </a:xfrm>
+          <a:prstGeom prst="rect">
+            <a:avLst/>
+          </a:prstGeom>
+          <a:ln w="9525">
+            <a:solidFill>
+              <a:srgbClr val="CBD3DB"/>
+            </a:solidFill>
+          </a:ln>
+        </p:spPr>
+      </p:pic>
+      <p:sp>
+        <p:nvSpPr>
+          <p:cNvPr id="9" name="TextBox 8"/>
+          <p:cNvSpPr txBox="1"/>
+          <p:nvPr/>
+        </p:nvSpPr>
+        <p:spPr>
+          <a:xfrm>
+            <a:off x="822959" y="6016752"/>
+            <a:ext cx="3792509" cy="274320"/>
+          </a:xfrm>
+          <a:prstGeom prst="rect">
+            <a:avLst/>
+          </a:prstGeom>
+          <a:noFill/>
+        </p:spPr>
+        <p:txBody>
+          <a:bodyPr wrap="square" lIns="0" rIns="0" tIns="0" bIns="0" anchor="t">
+            <a:spAutoFit/>
+          </a:bodyPr>
+          <a:lstStyle/>
+          <a:p>
+            <a:pPr algn="l"/>
+            <a:r>
+              <a:rPr sz="1200" b="1" i="0">
+                <a:solidFill>
+                  <a:srgbClr val="B84A12"/>
+                </a:solidFill>
+                <a:latin typeface="Arial"/>
+              </a:rPr>
+              <a:t>Vidéo à insérer ici (Insertion → Vidéo)</a:t>
+            </a:r>
+          </a:p>
+        </p:txBody>
+      </p:sp>
+      <p:sp>
+        <p:nvSpPr>
+          <p:cNvPr id="10" name="TextBox 9"/>
+          <p:cNvSpPr txBox="1"/>
+          <p:nvPr/>
+        </p:nvSpPr>
+        <p:spPr>
+          <a:xfrm>
+            <a:off x="4480560" y="1965960"/>
+            <a:ext cx="457200" cy="548640"/>
+          </a:xfrm>
+          <a:prstGeom prst="rect">
+            <a:avLst/>
+          </a:prstGeom>
+          <a:noFill/>
+        </p:spPr>
+        <p:txBody>
+          <a:bodyPr wrap="square" lIns="0" rIns="0" tIns="0" bIns="0" anchor="t">
+            <a:spAutoFit/>
+          </a:bodyPr>
+          <a:lstStyle/>
+          <a:p>
+            <a:pPr algn="l"/>
+            <a:r>
+              <a:rPr sz="2600" b="1" i="0">
+                <a:solidFill>
+                  <a:srgbClr val="2E75B6"/>
+                </a:solidFill>
+                <a:latin typeface="Arial"/>
+              </a:rPr>
+              <a:t>1</a:t>
+            </a:r>
+          </a:p>
+        </p:txBody>
+      </p:sp>
+      <p:sp>
+        <p:nvSpPr>
+          <p:cNvPr id="11" name="TextBox 10"/>
+          <p:cNvSpPr txBox="1"/>
+          <p:nvPr/>
+        </p:nvSpPr>
+        <p:spPr>
+          <a:xfrm>
+            <a:off x="4983480" y="1984248"/>
+            <a:ext cx="6583680" cy="822960"/>
+          </a:xfrm>
+          <a:prstGeom prst="rect">
+            <a:avLst/>
+          </a:prstGeom>
+          <a:noFill/>
+        </p:spPr>
+        <p:txBody>
+          <a:bodyPr wrap="square" lIns="0" rIns="0" tIns="0" bIns="0" anchor="t">
+            <a:spAutoFit/>
+          </a:bodyPr>
+          <a:lstStyle/>
+          <a:p>
+            <a:pPr algn="l"/>
+            <a:r>
+              <a:rPr sz="1800" b="1" i="0">
+                <a:solidFill>
+                  <a:srgbClr val="1F3A5F"/>
+                </a:solidFill>
+                <a:latin typeface="Arial"/>
+              </a:rPr>
+              <a:t>Cadre rouge, puis vert</a:t>
+            </a:r>
+          </a:p>
+          <a:p>
+            <a:pPr algn="l"/>
+            <a:r>
+              <a:rPr sz="1800" b="0" i="0">
+                <a:solidFill>
+                  <a:srgbClr val="1B2530"/>
+                </a:solidFill>
+                <a:latin typeface="Arial"/>
+              </a:rPr>
+              <a:t>la carte est détectée, la qualité est guidée</a:t>
+            </a:r>
+          </a:p>
+        </p:txBody>
+      </p:sp>
+      <p:sp>
+        <p:nvSpPr>
+          <p:cNvPr id="12" name="TextBox 11"/>
+          <p:cNvSpPr txBox="1"/>
+          <p:nvPr/>
+        </p:nvSpPr>
+        <p:spPr>
+          <a:xfrm>
+            <a:off x="4480560" y="2953512"/>
+            <a:ext cx="457200" cy="548640"/>
+          </a:xfrm>
+          <a:prstGeom prst="rect">
+            <a:avLst/>
+          </a:prstGeom>
+          <a:noFill/>
+        </p:spPr>
+        <p:txBody>
+          <a:bodyPr wrap="square" lIns="0" rIns="0" tIns="0" bIns="0" anchor="t">
+            <a:spAutoFit/>
+          </a:bodyPr>
+          <a:lstStyle/>
+          <a:p>
+            <a:pPr algn="l"/>
+            <a:r>
+              <a:rPr sz="2600" b="1" i="0">
+                <a:solidFill>
+                  <a:srgbClr val="2E75B6"/>
+                </a:solidFill>
+                <a:latin typeface="Arial"/>
+              </a:rPr>
+              <a:t>2</a:t>
+            </a:r>
+          </a:p>
+        </p:txBody>
+      </p:sp>
+      <p:sp>
+        <p:nvSpPr>
+          <p:cNvPr id="13" name="TextBox 12"/>
+          <p:cNvSpPr txBox="1"/>
+          <p:nvPr/>
+        </p:nvSpPr>
+        <p:spPr>
+          <a:xfrm>
+            <a:off x="4983480" y="2971800"/>
+            <a:ext cx="6583680" cy="822960"/>
+          </a:xfrm>
+          <a:prstGeom prst="rect">
+            <a:avLst/>
+          </a:prstGeom>
+          <a:noFill/>
+        </p:spPr>
+        <p:txBody>
+          <a:bodyPr wrap="square" lIns="0" rIns="0" tIns="0" bIns="0" anchor="t">
+            <a:spAutoFit/>
+          </a:bodyPr>
+          <a:lstStyle/>
+          <a:p>
+            <a:pPr algn="l"/>
+            <a:r>
+              <a:rPr sz="1800" b="1" i="0">
+                <a:solidFill>
+                  <a:srgbClr val="1F3A5F"/>
+                </a:solidFill>
+                <a:latin typeface="Arial"/>
+              </a:rPr>
+              <a:t>Recto puis verso, capturés seuls</a:t>
+            </a:r>
+          </a:p>
+          <a:p>
+            <a:pPr algn="l"/>
+            <a:r>
+              <a:rPr sz="1800" b="0" i="0">
+                <a:solidFill>
+                  <a:srgbClr val="1B2530"/>
+                </a:solidFill>
+                <a:latin typeface="Arial"/>
+              </a:rPr>
+              <a:t>sans aucun bouton</a:t>
+            </a:r>
+          </a:p>
+        </p:txBody>
+      </p:sp>
+      <p:sp>
+        <p:nvSpPr>
+          <p:cNvPr id="14" name="TextBox 13"/>
+          <p:cNvSpPr txBox="1"/>
+          <p:nvPr/>
+        </p:nvSpPr>
+        <p:spPr>
+          <a:xfrm>
+            <a:off x="4480560" y="3941064"/>
+            <a:ext cx="457200" cy="548640"/>
+          </a:xfrm>
+          <a:prstGeom prst="rect">
+            <a:avLst/>
+          </a:prstGeom>
+          <a:noFill/>
+        </p:spPr>
+        <p:txBody>
+          <a:bodyPr wrap="square" lIns="0" rIns="0" tIns="0" bIns="0" anchor="t">
+            <a:spAutoFit/>
+          </a:bodyPr>
+          <a:lstStyle/>
+          <a:p>
+            <a:pPr algn="l"/>
+            <a:r>
+              <a:rPr sz="2600" b="1" i="0">
+                <a:solidFill>
+                  <a:srgbClr val="2E75B6"/>
+                </a:solidFill>
+                <a:latin typeface="Arial"/>
+              </a:rPr>
+              <a:t>3</a:t>
+            </a:r>
+          </a:p>
+        </p:txBody>
+      </p:sp>
+      <p:sp>
+        <p:nvSpPr>
+          <p:cNvPr id="15" name="TextBox 14"/>
+          <p:cNvSpPr txBox="1"/>
+          <p:nvPr/>
+        </p:nvSpPr>
+        <p:spPr>
+          <a:xfrm>
+            <a:off x="4983480" y="3959352"/>
+            <a:ext cx="6583680" cy="822960"/>
+          </a:xfrm>
+          <a:prstGeom prst="rect">
+            <a:avLst/>
+          </a:prstGeom>
+          <a:noFill/>
+        </p:spPr>
+        <p:txBody>
+          <a:bodyPr wrap="square" lIns="0" rIns="0" tIns="0" bIns="0" anchor="t">
+            <a:spAutoFit/>
+          </a:bodyPr>
+          <a:lstStyle/>
+          <a:p>
+            <a:pPr algn="l"/>
+            <a:r>
+              <a:rPr sz="1800" b="1" i="0">
+                <a:solidFill>
+                  <a:srgbClr val="1F3A5F"/>
+                </a:solidFill>
+                <a:latin typeface="Arial"/>
+              </a:rPr>
+              <a:t>Vérification et ajustement</a:t>
+            </a:r>
+          </a:p>
+          <a:p>
+            <a:pPr algn="l"/>
+            <a:r>
+              <a:rPr sz="1800" b="0" i="0">
+                <a:solidFill>
+                  <a:srgbClr val="1B2530"/>
+                </a:solidFill>
+                <a:latin typeface="Arial"/>
+              </a:rPr>
+              <a:t>contraste, netteté, recadrage</a:t>
+            </a:r>
+          </a:p>
+        </p:txBody>
+      </p:sp>
+      <p:sp>
+        <p:nvSpPr>
+          <p:cNvPr id="16" name="TextBox 15"/>
+          <p:cNvSpPr txBox="1"/>
+          <p:nvPr/>
+        </p:nvSpPr>
+        <p:spPr>
+          <a:xfrm>
+            <a:off x="4480560" y="4928616"/>
+            <a:ext cx="457200" cy="548640"/>
+          </a:xfrm>
+          <a:prstGeom prst="rect">
+            <a:avLst/>
+          </a:prstGeom>
+          <a:noFill/>
+        </p:spPr>
+        <p:txBody>
+          <a:bodyPr wrap="square" lIns="0" rIns="0" tIns="0" bIns="0" anchor="t">
+            <a:spAutoFit/>
+          </a:bodyPr>
+          <a:lstStyle/>
+          <a:p>
+            <a:pPr algn="l"/>
+            <a:r>
+              <a:rPr sz="2600" b="1" i="0">
+                <a:solidFill>
+                  <a:srgbClr val="2E75B6"/>
+                </a:solidFill>
+                <a:latin typeface="Arial"/>
+              </a:rPr>
+              <a:t>4</a:t>
+            </a:r>
+          </a:p>
+        </p:txBody>
+      </p:sp>
+      <p:sp>
+        <p:nvSpPr>
+          <p:cNvPr id="17" name="TextBox 16"/>
+          <p:cNvSpPr txBox="1"/>
+          <p:nvPr/>
+        </p:nvSpPr>
+        <p:spPr>
+          <a:xfrm>
+            <a:off x="4983480" y="4946904"/>
+            <a:ext cx="6583680" cy="822960"/>
+          </a:xfrm>
+          <a:prstGeom prst="rect">
+            <a:avLst/>
+          </a:prstGeom>
+          <a:noFill/>
+        </p:spPr>
+        <p:txBody>
+          <a:bodyPr wrap="square" lIns="0" rIns="0" tIns="0" bIns="0" anchor="t">
+            <a:spAutoFit/>
+          </a:bodyPr>
+          <a:lstStyle/>
+          <a:p>
+            <a:pPr algn="l"/>
+            <a:r>
+              <a:rPr sz="1800" b="1" i="0">
+                <a:solidFill>
+                  <a:srgbClr val="1F3A5F"/>
+                </a:solidFill>
+                <a:latin typeface="Arial"/>
+              </a:rPr>
+              <a:t>Export</a:t>
+            </a:r>
+          </a:p>
+          <a:p>
+            <a:pPr algn="l"/>
+            <a:r>
+              <a:rPr sz="1800" b="0" i="0">
+                <a:solidFill>
+                  <a:srgbClr val="1B2530"/>
+                </a:solidFill>
+                <a:latin typeface="Arial"/>
+              </a:rPr>
+              <a:t>recto, verso et page A4</a:t>
+            </a:r>
+          </a:p>
+        </p:txBody>
+      </p:sp>
+    </p:spTree>
+  </p:cSld>
+  <p:clrMapOvr>
+    <a:masterClrMapping/>
+  </p:clrMapOvr>
+  <p:transition spd="med">
+    <p:fade/>
+  </p:transition>
 </p:sld>
 </file>
 

</xml_diff>

<commit_message>
Embed masked demo video (autoplay) in slide 12; add video masking tool
Co-Authored-By: Claude Opus 5.5 <noreply@anthropic.com>
Claude-Session: https://claude.ai/code/session_01AnZDiX8uz3hSw1L6vhKaQS
</commit_message>
<xml_diff>
--- a/Soutenance_Stage_ENSI_Final.pptx
+++ b/Soutenance_Stage_ENSI_Final.pptx
@@ -839,7 +839,7 @@
           <a:p/>
           <a:p>
             <a:r>
-              <a:t>VIDÉO — 40 s environ. Lancer la vidéo dès l'arrivée sur la diapositive (clic sur la vidéo). Pour l'intégrer : déposer le fichier dans build/assets/demo.mp4 puis relancer le script, ou dans PowerPoint : Insertion → Vidéo → Cet appareil, à la place du cadre, puis Lecture → Démarrer « Automatiquement ».</a:t>
+              <a:t>VIDÉO — 40 s, muette, démarre automatiquement à l'arrivée sur la diapositive (données masquées). Pour l'intégrer : déposer le fichier dans build/assets/demo.mp4 puis relancer le script, ou dans PowerPoint : Insertion → Vidéo → Cet appareil, à la place du cadre, puis Lecture → Démarrer « Automatiquement ».</a:t>
             </a:r>
           </a:p>
           <a:p/>
@@ -8637,76 +8637,54 @@
           </a:p>
         </p:txBody>
       </p:sp>
-      <p:sp>
-        <p:nvSpPr>
-          <p:cNvPr id="7" name="Rounded Rectangle 6"/>
-          <p:cNvSpPr/>
-          <p:nvPr/>
-        </p:nvSpPr>
+      <p:pic>
+        <p:nvPicPr>
+          <p:cNvPr id="7" name="demo.mp4" descr="Vidéo de démonstration ; données personnelles masquées">
+            <a:hlinkClick r:id="" action="ppaction://media"/>
+          </p:cNvPr>
+          <p:cNvPicPr>
+            <a:picLocks noChangeAspect="1"/>
+          </p:cNvPicPr>
+          <p:nvPr>
+            <a:videoFile r:link="rId3"/>
+            <p:extLst>
+              <p:ext uri="{DAA4B4D4-6D71-4841-9C94-3DE7FCFB9230}">
+                <p14:media xmlns:p14="http://schemas.microsoft.com/office/powerpoint/2010/main" r:embed="rId2"/>
+              </p:ext>
+            </p:extLst>
+          </p:nvPr>
+        </p:nvPicPr>
+        <p:blipFill>
+          <a:blip r:embed="rId4"/>
+          <a:stretch>
+            <a:fillRect/>
+          </a:stretch>
+        </p:blipFill>
         <p:spPr>
           <a:xfrm>
             <a:off x="822959" y="1783080"/>
-            <a:ext cx="2420909" cy="4160520"/>
-          </a:xfrm>
-          <a:prstGeom prst="roundRect">
-            <a:avLst>
-              <a:gd name="adj" fmla="val 8000"/>
-            </a:avLst>
-          </a:prstGeom>
-          <a:solidFill>
-            <a:srgbClr val="EEF2F6"/>
-          </a:solidFill>
-          <a:ln w="25400">
+            <a:ext cx="2340292" cy="4160520"/>
+          </a:xfrm>
+          <a:prstGeom prst="rect">
+            <a:avLst/>
+          </a:prstGeom>
+          <a:ln w="19050">
             <a:solidFill>
               <a:srgbClr val="1F3A5F"/>
             </a:solidFill>
           </a:ln>
         </p:spPr>
-        <p:txBody>
-          <a:bodyPr rtlCol="0" anchor="ctr"/>
-          <a:lstStyle/>
-          <a:p/>
-        </p:txBody>
-      </p:sp>
-      <p:pic>
-        <p:nvPicPr>
-          <p:cNvPr id="8" name="Picture 7" descr="Aperçu : écran recto (à remplacer par la vidéo de démonstration)"/>
-          <p:cNvPicPr>
-            <a:picLocks noChangeAspect="1"/>
-          </p:cNvPicPr>
-          <p:nvPr/>
-        </p:nvPicPr>
-        <p:blipFill>
-          <a:blip r:embed="rId2"/>
-          <a:stretch>
-            <a:fillRect/>
-          </a:stretch>
-        </p:blipFill>
-        <p:spPr>
-          <a:xfrm>
-            <a:off x="932688" y="1892807"/>
-            <a:ext cx="2201453" cy="3941063"/>
-          </a:xfrm>
-          <a:prstGeom prst="rect">
-            <a:avLst/>
-          </a:prstGeom>
-          <a:ln w="9525">
-            <a:solidFill>
-              <a:srgbClr val="CBD3DB"/>
-            </a:solidFill>
-          </a:ln>
-        </p:spPr>
       </p:pic>
       <p:sp>
         <p:nvSpPr>
-          <p:cNvPr id="9" name="TextBox 8"/>
+          <p:cNvPr id="8" name="TextBox 7"/>
           <p:cNvSpPr txBox="1"/>
           <p:nvPr/>
         </p:nvSpPr>
         <p:spPr>
           <a:xfrm>
-            <a:off x="822959" y="6016752"/>
-            <a:ext cx="3792509" cy="274320"/>
+            <a:off x="4480560" y="1965960"/>
+            <a:ext cx="457200" cy="548640"/>
           </a:xfrm>
           <a:prstGeom prst="rect">
             <a:avLst/>
@@ -8721,27 +8699,27 @@
           <a:p>
             <a:pPr algn="l"/>
             <a:r>
-              <a:rPr sz="1200" b="1" i="0">
-                <a:solidFill>
-                  <a:srgbClr val="B84A12"/>
-                </a:solidFill>
-                <a:latin typeface="Arial"/>
-              </a:rPr>
-              <a:t>Vidéo à insérer ici (Insertion → Vidéo)</a:t>
-            </a:r>
-          </a:p>
-        </p:txBody>
-      </p:sp>
-      <p:sp>
-        <p:nvSpPr>
-          <p:cNvPr id="10" name="TextBox 9"/>
+              <a:rPr sz="2600" b="1" i="0">
+                <a:solidFill>
+                  <a:srgbClr val="2E75B6"/>
+                </a:solidFill>
+                <a:latin typeface="Arial"/>
+              </a:rPr>
+              <a:t>1</a:t>
+            </a:r>
+          </a:p>
+        </p:txBody>
+      </p:sp>
+      <p:sp>
+        <p:nvSpPr>
+          <p:cNvPr id="9" name="TextBox 8"/>
           <p:cNvSpPr txBox="1"/>
           <p:nvPr/>
         </p:nvSpPr>
         <p:spPr>
           <a:xfrm>
-            <a:off x="4480560" y="1965960"/>
-            <a:ext cx="457200" cy="548640"/>
+            <a:off x="4983480" y="1984248"/>
+            <a:ext cx="6583680" cy="822960"/>
           </a:xfrm>
           <a:prstGeom prst="rect">
             <a:avLst/>
@@ -8756,27 +8734,39 @@
           <a:p>
             <a:pPr algn="l"/>
             <a:r>
-              <a:rPr sz="2600" b="1" i="0">
-                <a:solidFill>
-                  <a:srgbClr val="2E75B6"/>
-                </a:solidFill>
-                <a:latin typeface="Arial"/>
-              </a:rPr>
-              <a:t>1</a:t>
-            </a:r>
-          </a:p>
-        </p:txBody>
-      </p:sp>
-      <p:sp>
-        <p:nvSpPr>
-          <p:cNvPr id="11" name="TextBox 10"/>
+              <a:rPr sz="1800" b="1" i="0">
+                <a:solidFill>
+                  <a:srgbClr val="1F3A5F"/>
+                </a:solidFill>
+                <a:latin typeface="Arial"/>
+              </a:rPr>
+              <a:t>Cadre rouge, puis vert</a:t>
+            </a:r>
+          </a:p>
+          <a:p>
+            <a:pPr algn="l"/>
+            <a:r>
+              <a:rPr sz="1800" b="0" i="0">
+                <a:solidFill>
+                  <a:srgbClr val="1B2530"/>
+                </a:solidFill>
+                <a:latin typeface="Arial"/>
+              </a:rPr>
+              <a:t>la carte est détectée, la qualité est guidée</a:t>
+            </a:r>
+          </a:p>
+        </p:txBody>
+      </p:sp>
+      <p:sp>
+        <p:nvSpPr>
+          <p:cNvPr id="10" name="TextBox 9"/>
           <p:cNvSpPr txBox="1"/>
           <p:nvPr/>
         </p:nvSpPr>
         <p:spPr>
           <a:xfrm>
-            <a:off x="4983480" y="1984248"/>
-            <a:ext cx="6583680" cy="822960"/>
+            <a:off x="4480560" y="2953512"/>
+            <a:ext cx="457200" cy="548640"/>
           </a:xfrm>
           <a:prstGeom prst="rect">
             <a:avLst/>
@@ -8791,39 +8781,27 @@
           <a:p>
             <a:pPr algn="l"/>
             <a:r>
-              <a:rPr sz="1800" b="1" i="0">
-                <a:solidFill>
-                  <a:srgbClr val="1F3A5F"/>
-                </a:solidFill>
-                <a:latin typeface="Arial"/>
-              </a:rPr>
-              <a:t>Cadre rouge, puis vert</a:t>
-            </a:r>
-          </a:p>
-          <a:p>
-            <a:pPr algn="l"/>
-            <a:r>
-              <a:rPr sz="1800" b="0" i="0">
-                <a:solidFill>
-                  <a:srgbClr val="1B2530"/>
-                </a:solidFill>
-                <a:latin typeface="Arial"/>
-              </a:rPr>
-              <a:t>la carte est détectée, la qualité est guidée</a:t>
-            </a:r>
-          </a:p>
-        </p:txBody>
-      </p:sp>
-      <p:sp>
-        <p:nvSpPr>
-          <p:cNvPr id="12" name="TextBox 11"/>
+              <a:rPr sz="2600" b="1" i="0">
+                <a:solidFill>
+                  <a:srgbClr val="2E75B6"/>
+                </a:solidFill>
+                <a:latin typeface="Arial"/>
+              </a:rPr>
+              <a:t>2</a:t>
+            </a:r>
+          </a:p>
+        </p:txBody>
+      </p:sp>
+      <p:sp>
+        <p:nvSpPr>
+          <p:cNvPr id="11" name="TextBox 10"/>
           <p:cNvSpPr txBox="1"/>
           <p:nvPr/>
         </p:nvSpPr>
         <p:spPr>
           <a:xfrm>
-            <a:off x="4480560" y="2953512"/>
-            <a:ext cx="457200" cy="548640"/>
+            <a:off x="4983480" y="2971800"/>
+            <a:ext cx="6583680" cy="822960"/>
           </a:xfrm>
           <a:prstGeom prst="rect">
             <a:avLst/>
@@ -8838,27 +8816,39 @@
           <a:p>
             <a:pPr algn="l"/>
             <a:r>
-              <a:rPr sz="2600" b="1" i="0">
-                <a:solidFill>
-                  <a:srgbClr val="2E75B6"/>
-                </a:solidFill>
-                <a:latin typeface="Arial"/>
-              </a:rPr>
-              <a:t>2</a:t>
-            </a:r>
-          </a:p>
-        </p:txBody>
-      </p:sp>
-      <p:sp>
-        <p:nvSpPr>
-          <p:cNvPr id="13" name="TextBox 12"/>
+              <a:rPr sz="1800" b="1" i="0">
+                <a:solidFill>
+                  <a:srgbClr val="1F3A5F"/>
+                </a:solidFill>
+                <a:latin typeface="Arial"/>
+              </a:rPr>
+              <a:t>Recto puis verso, capturés seuls</a:t>
+            </a:r>
+          </a:p>
+          <a:p>
+            <a:pPr algn="l"/>
+            <a:r>
+              <a:rPr sz="1800" b="0" i="0">
+                <a:solidFill>
+                  <a:srgbClr val="1B2530"/>
+                </a:solidFill>
+                <a:latin typeface="Arial"/>
+              </a:rPr>
+              <a:t>sans aucun bouton</a:t>
+            </a:r>
+          </a:p>
+        </p:txBody>
+      </p:sp>
+      <p:sp>
+        <p:nvSpPr>
+          <p:cNvPr id="12" name="TextBox 11"/>
           <p:cNvSpPr txBox="1"/>
           <p:nvPr/>
         </p:nvSpPr>
         <p:spPr>
           <a:xfrm>
-            <a:off x="4983480" y="2971800"/>
-            <a:ext cx="6583680" cy="822960"/>
+            <a:off x="4480560" y="3941064"/>
+            <a:ext cx="457200" cy="548640"/>
           </a:xfrm>
           <a:prstGeom prst="rect">
             <a:avLst/>
@@ -8873,39 +8863,27 @@
           <a:p>
             <a:pPr algn="l"/>
             <a:r>
-              <a:rPr sz="1800" b="1" i="0">
-                <a:solidFill>
-                  <a:srgbClr val="1F3A5F"/>
-                </a:solidFill>
-                <a:latin typeface="Arial"/>
-              </a:rPr>
-              <a:t>Recto puis verso, capturés seuls</a:t>
-            </a:r>
-          </a:p>
-          <a:p>
-            <a:pPr algn="l"/>
-            <a:r>
-              <a:rPr sz="1800" b="0" i="0">
-                <a:solidFill>
-                  <a:srgbClr val="1B2530"/>
-                </a:solidFill>
-                <a:latin typeface="Arial"/>
-              </a:rPr>
-              <a:t>sans aucun bouton</a:t>
-            </a:r>
-          </a:p>
-        </p:txBody>
-      </p:sp>
-      <p:sp>
-        <p:nvSpPr>
-          <p:cNvPr id="14" name="TextBox 13"/>
+              <a:rPr sz="2600" b="1" i="0">
+                <a:solidFill>
+                  <a:srgbClr val="2E75B6"/>
+                </a:solidFill>
+                <a:latin typeface="Arial"/>
+              </a:rPr>
+              <a:t>3</a:t>
+            </a:r>
+          </a:p>
+        </p:txBody>
+      </p:sp>
+      <p:sp>
+        <p:nvSpPr>
+          <p:cNvPr id="13" name="TextBox 12"/>
           <p:cNvSpPr txBox="1"/>
           <p:nvPr/>
         </p:nvSpPr>
         <p:spPr>
           <a:xfrm>
-            <a:off x="4480560" y="3941064"/>
-            <a:ext cx="457200" cy="548640"/>
+            <a:off x="4983480" y="3959352"/>
+            <a:ext cx="6583680" cy="822960"/>
           </a:xfrm>
           <a:prstGeom prst="rect">
             <a:avLst/>
@@ -8920,27 +8898,39 @@
           <a:p>
             <a:pPr algn="l"/>
             <a:r>
-              <a:rPr sz="2600" b="1" i="0">
-                <a:solidFill>
-                  <a:srgbClr val="2E75B6"/>
-                </a:solidFill>
-                <a:latin typeface="Arial"/>
-              </a:rPr>
-              <a:t>3</a:t>
-            </a:r>
-          </a:p>
-        </p:txBody>
-      </p:sp>
-      <p:sp>
-        <p:nvSpPr>
-          <p:cNvPr id="15" name="TextBox 14"/>
+              <a:rPr sz="1800" b="1" i="0">
+                <a:solidFill>
+                  <a:srgbClr val="1F3A5F"/>
+                </a:solidFill>
+                <a:latin typeface="Arial"/>
+              </a:rPr>
+              <a:t>Vérification et ajustement</a:t>
+            </a:r>
+          </a:p>
+          <a:p>
+            <a:pPr algn="l"/>
+            <a:r>
+              <a:rPr sz="1800" b="0" i="0">
+                <a:solidFill>
+                  <a:srgbClr val="1B2530"/>
+                </a:solidFill>
+                <a:latin typeface="Arial"/>
+              </a:rPr>
+              <a:t>contraste, netteté, recadrage</a:t>
+            </a:r>
+          </a:p>
+        </p:txBody>
+      </p:sp>
+      <p:sp>
+        <p:nvSpPr>
+          <p:cNvPr id="14" name="TextBox 13"/>
           <p:cNvSpPr txBox="1"/>
           <p:nvPr/>
         </p:nvSpPr>
         <p:spPr>
           <a:xfrm>
-            <a:off x="4983480" y="3959352"/>
-            <a:ext cx="6583680" cy="822960"/>
+            <a:off x="4480560" y="4928616"/>
+            <a:ext cx="457200" cy="548640"/>
           </a:xfrm>
           <a:prstGeom prst="rect">
             <a:avLst/>
@@ -8955,53 +8945,6 @@
           <a:p>
             <a:pPr algn="l"/>
             <a:r>
-              <a:rPr sz="1800" b="1" i="0">
-                <a:solidFill>
-                  <a:srgbClr val="1F3A5F"/>
-                </a:solidFill>
-                <a:latin typeface="Arial"/>
-              </a:rPr>
-              <a:t>Vérification et ajustement</a:t>
-            </a:r>
-          </a:p>
-          <a:p>
-            <a:pPr algn="l"/>
-            <a:r>
-              <a:rPr sz="1800" b="0" i="0">
-                <a:solidFill>
-                  <a:srgbClr val="1B2530"/>
-                </a:solidFill>
-                <a:latin typeface="Arial"/>
-              </a:rPr>
-              <a:t>contraste, netteté, recadrage</a:t>
-            </a:r>
-          </a:p>
-        </p:txBody>
-      </p:sp>
-      <p:sp>
-        <p:nvSpPr>
-          <p:cNvPr id="16" name="TextBox 15"/>
-          <p:cNvSpPr txBox="1"/>
-          <p:nvPr/>
-        </p:nvSpPr>
-        <p:spPr>
-          <a:xfrm>
-            <a:off x="4480560" y="4928616"/>
-            <a:ext cx="457200" cy="548640"/>
-          </a:xfrm>
-          <a:prstGeom prst="rect">
-            <a:avLst/>
-          </a:prstGeom>
-          <a:noFill/>
-        </p:spPr>
-        <p:txBody>
-          <a:bodyPr wrap="square" lIns="0" rIns="0" tIns="0" bIns="0" anchor="t">
-            <a:spAutoFit/>
-          </a:bodyPr>
-          <a:lstStyle/>
-          <a:p>
-            <a:pPr algn="l"/>
-            <a:r>
               <a:rPr sz="2600" b="1" i="0">
                 <a:solidFill>
                   <a:srgbClr val="2E75B6"/>
@@ -9015,7 +8958,7 @@
       </p:sp>
       <p:sp>
         <p:nvSpPr>
-          <p:cNvPr id="17" name="TextBox 16"/>
+          <p:cNvPr id="15" name="TextBox 14"/>
           <p:cNvSpPr txBox="1"/>
           <p:nvPr/>
         </p:nvSpPr>
@@ -9068,6 +9011,86 @@
   <p:transition spd="med">
     <p:fade/>
   </p:transition>
+  <p:timing>
+    <p:tnLst>
+      <p:par>
+        <p:cTn id="1" dur="indefinite" restart="never" nodeType="tmRoot">
+          <p:childTnLst>
+            <p:seq concurrent="1" nextAc="seek">
+              <p:cTn id="2" dur="indefinite" nodeType="mainSeq">
+                <p:childTnLst>
+                  <p:par>
+                    <p:cTn id="3" fill="hold">
+                      <p:stCondLst>
+                        <p:cond delay="indefinite"/>
+                        <p:cond evt="onBegin" delay="0">
+                          <p:tn val="2"/>
+                        </p:cond>
+                      </p:stCondLst>
+                      <p:childTnLst>
+                        <p:par>
+                          <p:cTn id="4" fill="hold">
+                            <p:stCondLst>
+                              <p:cond delay="0"/>
+                            </p:stCondLst>
+                            <p:childTnLst>
+                              <p:par>
+                                <p:cTn id="5" presetID="1" presetClass="mediacall" presetSubtype="0" fill="hold" nodeType="afterEffect">
+                                  <p:stCondLst>
+                                    <p:cond delay="0"/>
+                                  </p:stCondLst>
+                                  <p:childTnLst>
+                                    <p:cmd type="call" cmd="playFrom(0.0)">
+                                      <p:cBhvr>
+                                        <p:cTn id="6" dur="39733" fill="hold"/>
+                                        <p:tgtEl>
+                                          <p:spTgt spid="7"/>
+                                        </p:tgtEl>
+                                      </p:cBhvr>
+                                    </p:cmd>
+                                  </p:childTnLst>
+                                </p:cTn>
+                              </p:par>
+                            </p:childTnLst>
+                          </p:cTn>
+                        </p:par>
+                      </p:childTnLst>
+                    </p:cTn>
+                  </p:par>
+                </p:childTnLst>
+              </p:cTn>
+              <p:prevCondLst>
+                <p:cond evt="onPrev" delay="0">
+                  <p:tgtEl>
+                    <p:sldTgt/>
+                  </p:tgtEl>
+                </p:cond>
+              </p:prevCondLst>
+              <p:nextCondLst>
+                <p:cond evt="onNext" delay="0">
+                  <p:tgtEl>
+                    <p:sldTgt/>
+                  </p:tgtEl>
+                </p:cond>
+              </p:nextCondLst>
+            </p:seq>
+            <p:video>
+              <p:cMediaNode vol="80000" mute="1">
+                <p:cTn id="7" fill="hold" display="0">
+                  <p:stCondLst>
+                    <p:cond delay="indefinite"/>
+                  </p:stCondLst>
+                </p:cTn>
+                <p:tgtEl>
+                  <p:spTgt spid="7"/>
+                </p:tgtEl>
+              </p:cMediaNode>
+            </p:video>
+          </p:childTnLst>
+        </p:cTn>
+      </p:par>
+    </p:tnLst>
+  </p:timing>
 </p:sld>
 </file>
 

</xml_diff>